<commit_message>
docs: vẽ lại sơ đồ pipeline 3 pha trong slide Huyền (native, có Mapper/Reducer từng pha)
Slide 3.1: thay hàng ô đơn giản bằng sơ đồ vẽ tay đầy đủ — ĐẦU VÀO →
Pha 1/2/3 (mỗi pha có ô Mapper + Reducer + đầu ra) → PHỤC VỤ, bằng shape
gốc (sắc nét, sửa được).

Co-Authored-By: Claude Opus 4.8 <noreply@anthropic.com>
Claude-Session: https://claude.ai/code/session_01FrxD6iyiu71sw2RmUtSxFy
</commit_message>
<xml_diff>
--- a/docs/slides/Slide_Huyen_theo_mau.pptx
+++ b/docs/slides/Slide_Huyen_theo_mau.pptx
@@ -595,7 +595,7 @@
           <a:p>
             <a:r>
               <a:rPr lang="en-US" dirty="0"/>
-              <a:t>Sơ đồ pipeline: Đầu vào → Pha1 → Pha2 → Pha3 → đầu ra. Mapper = biến đổi từng dòng (withColumn); Reducer = gom theo key (groupBy.agg). Là ánh xạ khái niệm, cài bằng Spark; batch+stream chung aqi_core.</a:t>
+              <a:t>Sơ đồ pipeline 3 pha: ĐẦU VÀO → Pha1(Mapper: gắn key (trạm,giờ) / Reducer: khử trùng lặp, nội suy → /clean) → Pha2(Mapper: IAQI + NowCast / Reducer: AQI=max → /aqi) → Pha3(Mapper: key (thành phố,ngày) / Reducer: trung bình, xếp hạng → /agg,HBase) → PHỤC VỤ. Mapper↔withColumn, Reducer↔groupBy().agg(); batch+stream chung aqi_core.</a:t>
             </a:r>
             <a:endParaRPr lang="en-US" dirty="0"/>
           </a:p>
@@ -2085,7 +2085,7 @@
                 <a:ea typeface="Arial" pitchFamily="34" charset="-122"/>
                 <a:cs typeface="Arial" pitchFamily="34" charset="-120"/>
               </a:rPr>
-              <a:t>Kiến trúc xử lý &amp; pipeline ba pha</a:t>
+              <a:t>Pipeline ba pha (Spark)</a:t>
             </a:r>
             <a:endParaRPr lang="en-US" sz="2300" dirty="0"/>
           </a:p>
@@ -2124,7 +2124,7 @@
                 <a:ea typeface="Arial" pitchFamily="34" charset="-122"/>
                 <a:cs typeface="Arial" pitchFamily="34" charset="-120"/>
               </a:rPr>
-              <a:t>Spark đứng giữa HDFS/Kafka và HBase; ba pha nối tiếp, mỗi pha thêm một lớp thông tin.</a:t>
+              <a:t>Mỗi pha là một job Map → Reduce, đọc đầu ra pha trước rồi thêm một lớp thông tin.</a:t>
             </a:r>
             <a:endParaRPr lang="en-US" sz="1350" dirty="0"/>
           </a:p>
@@ -2138,16 +2138,16 @@
         </p:nvSpPr>
         <p:spPr>
           <a:xfrm>
-            <a:off x="640080" y="1783080"/>
-            <a:ext cx="2468880" cy="1051560"/>
+            <a:off x="457200" y="2761488"/>
+            <a:ext cx="1554480" cy="1325880"/>
           </a:xfrm>
           <a:prstGeom prst="roundRect">
             <a:avLst>
-              <a:gd name="adj" fmla="val 6087"/>
+              <a:gd name="adj" fmla="val 5517"/>
             </a:avLst>
           </a:prstGeom>
           <a:solidFill>
-            <a:srgbClr val="6B7280"/>
+            <a:srgbClr val="F4F7FC"/>
           </a:solidFill>
           <a:ln/>
           <a:effectLst>
@@ -2167,8 +2167,8 @@
         </p:nvSpPr>
         <p:spPr>
           <a:xfrm>
-            <a:off x="640080" y="1783080"/>
-            <a:ext cx="2468880" cy="1051560"/>
+            <a:off x="457200" y="2761488"/>
+            <a:ext cx="1554480" cy="1325880"/>
           </a:xfrm>
           <a:prstGeom prst="rect">
             <a:avLst/>
@@ -2181,35 +2181,59 @@
           <a:lstStyle/>
           <a:p>
             <a:pPr algn="ctr" indent="0" marL="0">
-              <a:buNone/>
-            </a:pPr>
-            <a:r>
-              <a:rPr lang="en-US" sz="1250" b="1" dirty="0">
-                <a:solidFill>
-                  <a:srgbClr val="FFFFFF"/>
-                </a:solidFill>
-                <a:latin typeface="Arial" pitchFamily="34" charset="0"/>
-                <a:ea typeface="Arial" pitchFamily="34" charset="-122"/>
-                <a:cs typeface="Arial" pitchFamily="34" charset="-120"/>
-              </a:rPr>
-              <a:t>Đầu vào
+              <a:lnSpc>
+                <a:spcPct val="105000"/>
+              </a:lnSpc>
+              <a:buNone/>
+            </a:pPr>
+            <a:r>
+              <a:rPr lang="en-US" sz="1150" b="1" dirty="0">
+                <a:solidFill>
+                  <a:srgbClr val="1F3864"/>
+                </a:solidFill>
+                <a:latin typeface="Arial" pitchFamily="34" charset="0"/>
+                <a:ea typeface="Arial" pitchFamily="34" charset="-122"/>
+                <a:cs typeface="Arial" pitchFamily="34" charset="-120"/>
+              </a:rPr>
+              <a:t>ĐẦU VÀO
 </a:t>
             </a:r>
             <a:pPr algn="ctr" indent="0" marL="0">
-              <a:buNone/>
-            </a:pPr>
-            <a:r>
-              <a:rPr lang="en-US" sz="950" dirty="0">
-                <a:solidFill>
-                  <a:srgbClr val="EAF1FB"/>
-                </a:solidFill>
-                <a:latin typeface="Arial" pitchFamily="34" charset="0"/>
-                <a:ea typeface="Arial" pitchFamily="34" charset="-122"/>
-                <a:cs typeface="Arial" pitchFamily="34" charset="-120"/>
-              </a:rPr>
-              <a:t>HDFS /raw · Kafka</a:t>
-            </a:r>
-            <a:endParaRPr lang="en-US" sz="1250" dirty="0"/>
+              <a:lnSpc>
+                <a:spcPct val="105000"/>
+              </a:lnSpc>
+              <a:buNone/>
+            </a:pPr>
+            <a:r>
+              <a:rPr lang="en-US" sz="1000" dirty="0">
+                <a:solidFill>
+                  <a:srgbClr val="1F3864"/>
+                </a:solidFill>
+                <a:latin typeface="Arial" pitchFamily="34" charset="0"/>
+                <a:ea typeface="Arial" pitchFamily="34" charset="-122"/>
+                <a:cs typeface="Arial" pitchFamily="34" charset="-120"/>
+              </a:rPr>
+              <a:t>HDFS /raw
+</a:t>
+            </a:r>
+            <a:pPr algn="ctr" indent="0" marL="0">
+              <a:lnSpc>
+                <a:spcPct val="105000"/>
+              </a:lnSpc>
+              <a:buNone/>
+            </a:pPr>
+            <a:r>
+              <a:rPr lang="en-US" sz="1000" dirty="0">
+                <a:solidFill>
+                  <a:srgbClr val="1F3864"/>
+                </a:solidFill>
+                <a:latin typeface="Arial" pitchFamily="34" charset="0"/>
+                <a:ea typeface="Arial" pitchFamily="34" charset="-122"/>
+                <a:cs typeface="Arial" pitchFamily="34" charset="-120"/>
+              </a:rPr>
+              <a:t>Kafka (live)</a:t>
+            </a:r>
+            <a:endParaRPr lang="en-US" sz="1150" dirty="0"/>
           </a:p>
         </p:txBody>
       </p:sp>
@@ -2221,14 +2245,14 @@
         </p:nvSpPr>
         <p:spPr>
           <a:xfrm>
-            <a:off x="3127248" y="2189988"/>
-            <a:ext cx="329184" cy="237744"/>
-          </a:xfrm>
-          <a:prstGeom prst="chevron">
+            <a:off x="2029968" y="3310128"/>
+            <a:ext cx="274320" cy="237744"/>
+          </a:xfrm>
+          <a:prstGeom prst="rightArrow">
             <a:avLst/>
           </a:prstGeom>
           <a:solidFill>
-            <a:srgbClr val="AEBCD2"/>
+            <a:srgbClr val="9AA9C4"/>
           </a:solidFill>
           <a:ln/>
         </p:spPr>
@@ -2241,301 +2265,12 @@
         </p:nvSpPr>
         <p:spPr>
           <a:xfrm>
-            <a:off x="3474720" y="1783080"/>
-            <a:ext cx="2468880" cy="1051560"/>
+            <a:off x="2304288" y="1572768"/>
+            <a:ext cx="2331720" cy="3566160"/>
           </a:xfrm>
           <a:prstGeom prst="roundRect">
             <a:avLst>
-              <a:gd name="adj" fmla="val 6087"/>
-            </a:avLst>
-          </a:prstGeom>
-          <a:solidFill>
-            <a:srgbClr val="2E9BA6"/>
-          </a:solidFill>
-          <a:ln/>
-          <a:effectLst>
-            <a:outerShdw sx="100000" sy="100000" kx="0" ky="0" algn="bl" rotWithShape="0" blurRad="88900" dist="25400" dir="5400000">
-              <a:srgbClr val="9AA6B8">
-                <a:alpha val="32000"/>
-              </a:srgbClr>
-            </a:outerShdw>
-          </a:effectLst>
-        </p:spPr>
-      </p:sp>
-      <p:sp>
-        <p:nvSpPr>
-          <p:cNvPr id="11" name="Text 9"/>
-          <p:cNvSpPr txBox="1"/>
-          <p:nvPr/>
-        </p:nvSpPr>
-        <p:spPr>
-          <a:xfrm>
-            <a:off x="3474720" y="1783080"/>
-            <a:ext cx="2468880" cy="1051560"/>
-          </a:xfrm>
-          <a:prstGeom prst="rect">
-            <a:avLst/>
-          </a:prstGeom>
-          <a:noFill/>
-          <a:ln/>
-        </p:spPr>
-        <p:txBody>
-          <a:bodyPr wrap="square" lIns="38100" tIns="38100" rIns="38100" bIns="38100" rtlCol="0" anchor="ctr"/>
-          <a:lstStyle/>
-          <a:p>
-            <a:pPr algn="ctr" indent="0" marL="0">
-              <a:buNone/>
-            </a:pPr>
-            <a:r>
-              <a:rPr lang="en-US" sz="1250" b="1" dirty="0">
-                <a:solidFill>
-                  <a:srgbClr val="FFFFFF"/>
-                </a:solidFill>
-                <a:latin typeface="Arial" pitchFamily="34" charset="0"/>
-                <a:ea typeface="Arial" pitchFamily="34" charset="-122"/>
-                <a:cs typeface="Arial" pitchFamily="34" charset="-120"/>
-              </a:rPr>
-              <a:t>Pha 1 · Làm sạch
-</a:t>
-            </a:r>
-            <a:pPr algn="ctr" indent="0" marL="0">
-              <a:buNone/>
-            </a:pPr>
-            <a:r>
-              <a:rPr lang="en-US" sz="950" dirty="0">
-                <a:solidFill>
-                  <a:srgbClr val="EAF1FB"/>
-                </a:solidFill>
-                <a:latin typeface="Arial" pitchFamily="34" charset="0"/>
-                <a:ea typeface="Arial" pitchFamily="34" charset="-122"/>
-                <a:cs typeface="Arial" pitchFamily="34" charset="-120"/>
-              </a:rPr>
-              <a:t>→ /clean</a:t>
-            </a:r>
-            <a:endParaRPr lang="en-US" sz="1250" dirty="0"/>
-          </a:p>
-        </p:txBody>
-      </p:sp>
-      <p:sp>
-        <p:nvSpPr>
-          <p:cNvPr id="12" name="Shape 10"/>
-          <p:cNvSpPr/>
-          <p:nvPr/>
-        </p:nvSpPr>
-        <p:spPr>
-          <a:xfrm>
-            <a:off x="5961888" y="2189988"/>
-            <a:ext cx="329184" cy="237744"/>
-          </a:xfrm>
-          <a:prstGeom prst="chevron">
-            <a:avLst/>
-          </a:prstGeom>
-          <a:solidFill>
-            <a:srgbClr val="AEBCD2"/>
-          </a:solidFill>
-          <a:ln/>
-        </p:spPr>
-      </p:sp>
-      <p:sp>
-        <p:nvSpPr>
-          <p:cNvPr id="13" name="Shape 11"/>
-          <p:cNvSpPr/>
-          <p:nvPr/>
-        </p:nvSpPr>
-        <p:spPr>
-          <a:xfrm>
-            <a:off x="6309360" y="1783080"/>
-            <a:ext cx="2468880" cy="1051560"/>
-          </a:xfrm>
-          <a:prstGeom prst="roundRect">
-            <a:avLst>
-              <a:gd name="adj" fmla="val 6087"/>
-            </a:avLst>
-          </a:prstGeom>
-          <a:solidFill>
-            <a:srgbClr val="2E5AAC"/>
-          </a:solidFill>
-          <a:ln/>
-          <a:effectLst>
-            <a:outerShdw sx="100000" sy="100000" kx="0" ky="0" algn="bl" rotWithShape="0" blurRad="88900" dist="25400" dir="5400000">
-              <a:srgbClr val="9AA6B8">
-                <a:alpha val="32000"/>
-              </a:srgbClr>
-            </a:outerShdw>
-          </a:effectLst>
-        </p:spPr>
-      </p:sp>
-      <p:sp>
-        <p:nvSpPr>
-          <p:cNvPr id="14" name="Text 12"/>
-          <p:cNvSpPr txBox="1"/>
-          <p:nvPr/>
-        </p:nvSpPr>
-        <p:spPr>
-          <a:xfrm>
-            <a:off x="6309360" y="1783080"/>
-            <a:ext cx="2468880" cy="1051560"/>
-          </a:xfrm>
-          <a:prstGeom prst="rect">
-            <a:avLst/>
-          </a:prstGeom>
-          <a:noFill/>
-          <a:ln/>
-        </p:spPr>
-        <p:txBody>
-          <a:bodyPr wrap="square" lIns="38100" tIns="38100" rIns="38100" bIns="38100" rtlCol="0" anchor="ctr"/>
-          <a:lstStyle/>
-          <a:p>
-            <a:pPr algn="ctr" indent="0" marL="0">
-              <a:buNone/>
-            </a:pPr>
-            <a:r>
-              <a:rPr lang="en-US" sz="1250" b="1" dirty="0">
-                <a:solidFill>
-                  <a:srgbClr val="FFFFFF"/>
-                </a:solidFill>
-                <a:latin typeface="Arial" pitchFamily="34" charset="0"/>
-                <a:ea typeface="Arial" pitchFamily="34" charset="-122"/>
-                <a:cs typeface="Arial" pitchFamily="34" charset="-120"/>
-              </a:rPr>
-              <a:t>Pha 2 · Tính AQI
-</a:t>
-            </a:r>
-            <a:pPr algn="ctr" indent="0" marL="0">
-              <a:buNone/>
-            </a:pPr>
-            <a:r>
-              <a:rPr lang="en-US" sz="950" dirty="0">
-                <a:solidFill>
-                  <a:srgbClr val="EAF1FB"/>
-                </a:solidFill>
-                <a:latin typeface="Arial" pitchFamily="34" charset="0"/>
-                <a:ea typeface="Arial" pitchFamily="34" charset="-122"/>
-                <a:cs typeface="Arial" pitchFamily="34" charset="-120"/>
-              </a:rPr>
-              <a:t>→ /aqi</a:t>
-            </a:r>
-            <a:endParaRPr lang="en-US" sz="1250" dirty="0"/>
-          </a:p>
-        </p:txBody>
-      </p:sp>
-      <p:sp>
-        <p:nvSpPr>
-          <p:cNvPr id="15" name="Shape 13"/>
-          <p:cNvSpPr/>
-          <p:nvPr/>
-        </p:nvSpPr>
-        <p:spPr>
-          <a:xfrm>
-            <a:off x="8796528" y="2189988"/>
-            <a:ext cx="329184" cy="237744"/>
-          </a:xfrm>
-          <a:prstGeom prst="chevron">
-            <a:avLst/>
-          </a:prstGeom>
-          <a:solidFill>
-            <a:srgbClr val="AEBCD2"/>
-          </a:solidFill>
-          <a:ln/>
-        </p:spPr>
-      </p:sp>
-      <p:sp>
-        <p:nvSpPr>
-          <p:cNvPr id="16" name="Shape 14"/>
-          <p:cNvSpPr/>
-          <p:nvPr/>
-        </p:nvSpPr>
-        <p:spPr>
-          <a:xfrm>
-            <a:off x="9144000" y="1783080"/>
-            <a:ext cx="2468880" cy="1051560"/>
-          </a:xfrm>
-          <a:prstGeom prst="roundRect">
-            <a:avLst>
-              <a:gd name="adj" fmla="val 6087"/>
-            </a:avLst>
-          </a:prstGeom>
-          <a:solidFill>
-            <a:srgbClr val="4F9D5D"/>
-          </a:solidFill>
-          <a:ln/>
-          <a:effectLst>
-            <a:outerShdw sx="100000" sy="100000" kx="0" ky="0" algn="bl" rotWithShape="0" blurRad="88900" dist="25400" dir="5400000">
-              <a:srgbClr val="9AA6B8">
-                <a:alpha val="32000"/>
-              </a:srgbClr>
-            </a:outerShdw>
-          </a:effectLst>
-        </p:spPr>
-      </p:sp>
-      <p:sp>
-        <p:nvSpPr>
-          <p:cNvPr id="17" name="Text 15"/>
-          <p:cNvSpPr txBox="1"/>
-          <p:nvPr/>
-        </p:nvSpPr>
-        <p:spPr>
-          <a:xfrm>
-            <a:off x="9144000" y="1783080"/>
-            <a:ext cx="2468880" cy="1051560"/>
-          </a:xfrm>
-          <a:prstGeom prst="rect">
-            <a:avLst/>
-          </a:prstGeom>
-          <a:noFill/>
-          <a:ln/>
-        </p:spPr>
-        <p:txBody>
-          <a:bodyPr wrap="square" lIns="38100" tIns="38100" rIns="38100" bIns="38100" rtlCol="0" anchor="ctr"/>
-          <a:lstStyle/>
-          <a:p>
-            <a:pPr algn="ctr" indent="0" marL="0">
-              <a:buNone/>
-            </a:pPr>
-            <a:r>
-              <a:rPr lang="en-US" sz="1250" b="1" dirty="0">
-                <a:solidFill>
-                  <a:srgbClr val="FFFFFF"/>
-                </a:solidFill>
-                <a:latin typeface="Arial" pitchFamily="34" charset="0"/>
-                <a:ea typeface="Arial" pitchFamily="34" charset="-122"/>
-                <a:cs typeface="Arial" pitchFamily="34" charset="-120"/>
-              </a:rPr>
-              <a:t>Pha 3 · Tổng hợp
-</a:t>
-            </a:r>
-            <a:pPr algn="ctr" indent="0" marL="0">
-              <a:buNone/>
-            </a:pPr>
-            <a:r>
-              <a:rPr lang="en-US" sz="950" dirty="0">
-                <a:solidFill>
-                  <a:srgbClr val="EAF1FB"/>
-                </a:solidFill>
-                <a:latin typeface="Arial" pitchFamily="34" charset="0"/>
-                <a:ea typeface="Arial" pitchFamily="34" charset="-122"/>
-                <a:cs typeface="Arial" pitchFamily="34" charset="-120"/>
-              </a:rPr>
-              <a:t>→ /agg · HBase</a:t>
-            </a:r>
-            <a:endParaRPr lang="en-US" sz="1250" dirty="0"/>
-          </a:p>
-        </p:txBody>
-      </p:sp>
-      <p:sp>
-        <p:nvSpPr>
-          <p:cNvPr id="18" name="Shape 16"/>
-          <p:cNvSpPr/>
-          <p:nvPr/>
-        </p:nvSpPr>
-        <p:spPr>
-          <a:xfrm>
-            <a:off x="640080" y="3246120"/>
-            <a:ext cx="5440680" cy="914400"/>
-          </a:xfrm>
-          <a:prstGeom prst="roundRect">
-            <a:avLst>
-              <a:gd name="adj" fmla="val 7000"/>
+              <a:gd name="adj" fmla="val 2745"/>
             </a:avLst>
           </a:prstGeom>
           <a:solidFill>
@@ -2558,17 +2293,19 @@
       </p:sp>
       <p:sp>
         <p:nvSpPr>
-          <p:cNvPr id="19" name="Shape 17"/>
+          <p:cNvPr id="11" name="Shape 9"/>
           <p:cNvSpPr/>
           <p:nvPr/>
         </p:nvSpPr>
         <p:spPr>
           <a:xfrm>
-            <a:off x="640080" y="3246120"/>
-            <a:ext cx="109728" cy="914400"/>
+            <a:off x="2304288" y="1572768"/>
+            <a:ext cx="2331720" cy="475488"/>
           </a:xfrm>
           <a:prstGeom prst="roundRect">
-            <a:avLst/>
+            <a:avLst>
+              <a:gd name="adj" fmla="val 15385"/>
+            </a:avLst>
           </a:prstGeom>
           <a:solidFill>
             <a:srgbClr val="2E9BA6"/>
@@ -2578,14 +2315,14 @@
       </p:sp>
       <p:sp>
         <p:nvSpPr>
-          <p:cNvPr id="20" name="Text 18"/>
+          <p:cNvPr id="12" name="Text 10"/>
           <p:cNvSpPr txBox="1"/>
           <p:nvPr/>
         </p:nvSpPr>
         <p:spPr>
           <a:xfrm>
-            <a:off x="896112" y="3246120"/>
-            <a:ext cx="5029200" cy="914400"/>
+            <a:off x="2304288" y="1572768"/>
+            <a:ext cx="2331720" cy="475488"/>
           </a:xfrm>
           <a:prstGeom prst="rect">
             <a:avLst/>
@@ -2594,36 +2331,22 @@
           <a:ln/>
         </p:spPr>
         <p:txBody>
-          <a:bodyPr wrap="square" rtlCol="0" anchor="ctr"/>
-          <a:lstStyle/>
-          <a:p>
-            <a:pPr indent="0" marL="0">
+          <a:bodyPr wrap="square" lIns="25400" tIns="25400" rIns="25400" bIns="25400" rtlCol="0" anchor="ctr"/>
+          <a:lstStyle/>
+          <a:p>
+            <a:pPr algn="ctr" indent="0" marL="0">
               <a:buNone/>
             </a:pPr>
             <a:r>
               <a:rPr lang="en-US" sz="1250" b="1" dirty="0">
                 <a:solidFill>
-                  <a:srgbClr val="2E9BA6"/>
-                </a:solidFill>
-                <a:latin typeface="Arial" pitchFamily="34" charset="0"/>
-                <a:ea typeface="Arial" pitchFamily="34" charset="-122"/>
-                <a:cs typeface="Arial" pitchFamily="34" charset="-120"/>
-              </a:rPr>
-              <a:t>Mapper  </a:t>
-            </a:r>
-            <a:pPr indent="0" marL="0">
-              <a:buNone/>
-            </a:pPr>
-            <a:r>
-              <a:rPr lang="en-US" sz="1250" dirty="0">
-                <a:solidFill>
-                  <a:srgbClr val="253044"/>
-                </a:solidFill>
-                <a:latin typeface="Arial" pitchFamily="34" charset="0"/>
-                <a:ea typeface="Arial" pitchFamily="34" charset="-122"/>
-                <a:cs typeface="Arial" pitchFamily="34" charset="-120"/>
-              </a:rPr>
-              <a:t>biến đổi TỪNG DÒNG  ·  Spark: withColumn() / map()</a:t>
+                  <a:srgbClr val="FFFFFF"/>
+                </a:solidFill>
+                <a:latin typeface="Arial" pitchFamily="34" charset="0"/>
+                <a:ea typeface="Arial" pitchFamily="34" charset="-122"/>
+                <a:cs typeface="Arial" pitchFamily="34" charset="-120"/>
+              </a:rPr>
+              <a:t>PHA 1 · Làm sạch</a:t>
             </a:r>
             <a:endParaRPr lang="en-US" sz="1250" dirty="0"/>
           </a:p>
@@ -2631,18 +2354,271 @@
       </p:sp>
       <p:sp>
         <p:nvSpPr>
-          <p:cNvPr id="21" name="Shape 19"/>
+          <p:cNvPr id="13" name="Shape 11"/>
           <p:cNvSpPr/>
           <p:nvPr/>
         </p:nvSpPr>
         <p:spPr>
           <a:xfrm>
-            <a:off x="6263640" y="3246120"/>
-            <a:ext cx="5257800" cy="914400"/>
+            <a:off x="2414016" y="2157984"/>
+            <a:ext cx="2112264" cy="1207008"/>
           </a:xfrm>
           <a:prstGeom prst="roundRect">
             <a:avLst>
-              <a:gd name="adj" fmla="val 7000"/>
+              <a:gd name="adj" fmla="val 3788"/>
+            </a:avLst>
+          </a:prstGeom>
+          <a:solidFill>
+            <a:srgbClr val="E9F0FB"/>
+          </a:solidFill>
+          <a:ln w="12700">
+            <a:solidFill>
+              <a:srgbClr val="C7D6EE"/>
+            </a:solidFill>
+            <a:prstDash val="solid"/>
+          </a:ln>
+        </p:spPr>
+      </p:sp>
+      <p:sp>
+        <p:nvSpPr>
+          <p:cNvPr id="14" name="Text 12"/>
+          <p:cNvSpPr txBox="1"/>
+          <p:nvPr/>
+        </p:nvSpPr>
+        <p:spPr>
+          <a:xfrm>
+            <a:off x="2487168" y="2194560"/>
+            <a:ext cx="1965960" cy="1133856"/>
+          </a:xfrm>
+          <a:prstGeom prst="rect">
+            <a:avLst/>
+          </a:prstGeom>
+          <a:noFill/>
+          <a:ln/>
+        </p:spPr>
+        <p:txBody>
+          <a:bodyPr wrap="square" lIns="0" tIns="0" rIns="0" bIns="0" rtlCol="0" anchor="ctr"/>
+          <a:lstStyle/>
+          <a:p>
+            <a:pPr algn="l" indent="0" marL="0">
+              <a:lnSpc>
+                <a:spcPct val="102000"/>
+              </a:lnSpc>
+              <a:buNone/>
+            </a:pPr>
+            <a:r>
+              <a:rPr lang="en-US" sz="900" b="1" spc="100" kern="0" dirty="0">
+                <a:solidFill>
+                  <a:srgbClr val="2E5AAC"/>
+                </a:solidFill>
+                <a:latin typeface="Arial" pitchFamily="34" charset="0"/>
+                <a:ea typeface="Arial" pitchFamily="34" charset="-122"/>
+                <a:cs typeface="Arial" pitchFamily="34" charset="-120"/>
+              </a:rPr>
+              <a:t>MAPPER
+</a:t>
+            </a:r>
+            <a:pPr algn="l" indent="0" marL="0">
+              <a:lnSpc>
+                <a:spcPct val="102000"/>
+              </a:lnSpc>
+              <a:buNone/>
+            </a:pPr>
+            <a:r>
+              <a:rPr lang="en-US" sz="950" dirty="0">
+                <a:solidFill>
+                  <a:srgbClr val="253044"/>
+                </a:solidFill>
+                <a:latin typeface="Arial" pitchFamily="34" charset="0"/>
+                <a:ea typeface="Arial" pitchFamily="34" charset="-122"/>
+                <a:cs typeface="Arial" pitchFamily="34" charset="-120"/>
+              </a:rPr>
+              <a:t>key = (trạm, giờ)</a:t>
+            </a:r>
+            <a:endParaRPr lang="en-US" sz="900" dirty="0"/>
+          </a:p>
+          <a:p>
+            <a:pPr algn="l" indent="0" marL="0">
+              <a:lnSpc>
+                <a:spcPct val="102000"/>
+              </a:lnSpc>
+              <a:buNone/>
+            </a:pPr>
+            <a:r>
+              <a:rPr lang="en-US" sz="950" dirty="0">
+                <a:solidFill>
+                  <a:srgbClr val="253044"/>
+                </a:solidFill>
+                <a:latin typeface="Arial" pitchFamily="34" charset="0"/>
+                <a:ea typeface="Arial" pitchFamily="34" charset="-122"/>
+                <a:cs typeface="Arial" pitchFamily="34" charset="-120"/>
+              </a:rPr>
+              <a:t>value = bản ghi thô</a:t>
+            </a:r>
+            <a:endParaRPr lang="en-US" sz="900" dirty="0"/>
+          </a:p>
+        </p:txBody>
+      </p:sp>
+      <p:sp>
+        <p:nvSpPr>
+          <p:cNvPr id="15" name="Shape 13"/>
+          <p:cNvSpPr/>
+          <p:nvPr/>
+        </p:nvSpPr>
+        <p:spPr>
+          <a:xfrm>
+            <a:off x="2414016" y="3438144"/>
+            <a:ext cx="2112264" cy="1207008"/>
+          </a:xfrm>
+          <a:prstGeom prst="roundRect">
+            <a:avLst>
+              <a:gd name="adj" fmla="val 3788"/>
+            </a:avLst>
+          </a:prstGeom>
+          <a:solidFill>
+            <a:srgbClr val="FBEBDC"/>
+          </a:solidFill>
+          <a:ln w="12700">
+            <a:solidFill>
+              <a:srgbClr val="E8C9A6"/>
+            </a:solidFill>
+            <a:prstDash val="solid"/>
+          </a:ln>
+        </p:spPr>
+      </p:sp>
+      <p:sp>
+        <p:nvSpPr>
+          <p:cNvPr id="16" name="Text 14"/>
+          <p:cNvSpPr txBox="1"/>
+          <p:nvPr/>
+        </p:nvSpPr>
+        <p:spPr>
+          <a:xfrm>
+            <a:off x="2487168" y="3474720"/>
+            <a:ext cx="1965960" cy="1133856"/>
+          </a:xfrm>
+          <a:prstGeom prst="rect">
+            <a:avLst/>
+          </a:prstGeom>
+          <a:noFill/>
+          <a:ln/>
+        </p:spPr>
+        <p:txBody>
+          <a:bodyPr wrap="square" lIns="0" tIns="0" rIns="0" bIns="0" rtlCol="0" anchor="ctr"/>
+          <a:lstStyle/>
+          <a:p>
+            <a:pPr algn="l" indent="0" marL="0">
+              <a:lnSpc>
+                <a:spcPct val="102000"/>
+              </a:lnSpc>
+              <a:buNone/>
+            </a:pPr>
+            <a:r>
+              <a:rPr lang="en-US" sz="900" b="1" spc="100" kern="0" dirty="0">
+                <a:solidFill>
+                  <a:srgbClr val="C06A1E"/>
+                </a:solidFill>
+                <a:latin typeface="Arial" pitchFamily="34" charset="0"/>
+                <a:ea typeface="Arial" pitchFamily="34" charset="-122"/>
+                <a:cs typeface="Arial" pitchFamily="34" charset="-120"/>
+              </a:rPr>
+              <a:t>REDUCER
+</a:t>
+            </a:r>
+            <a:pPr algn="l" indent="0" marL="0">
+              <a:lnSpc>
+                <a:spcPct val="102000"/>
+              </a:lnSpc>
+              <a:buNone/>
+            </a:pPr>
+            <a:r>
+              <a:rPr lang="en-US" sz="950" dirty="0">
+                <a:solidFill>
+                  <a:srgbClr val="253044"/>
+                </a:solidFill>
+                <a:latin typeface="Arial" pitchFamily="34" charset="0"/>
+                <a:ea typeface="Arial" pitchFamily="34" charset="-122"/>
+                <a:cs typeface="Arial" pitchFamily="34" charset="-120"/>
+              </a:rPr>
+              <a:t>khử trùng lặp · loại ngoại lai · nội suy khe ≤ 3h</a:t>
+            </a:r>
+            <a:endParaRPr lang="en-US" sz="900" dirty="0"/>
+          </a:p>
+        </p:txBody>
+      </p:sp>
+      <p:sp>
+        <p:nvSpPr>
+          <p:cNvPr id="17" name="Text 15"/>
+          <p:cNvSpPr txBox="1"/>
+          <p:nvPr/>
+        </p:nvSpPr>
+        <p:spPr>
+          <a:xfrm>
+            <a:off x="2304288" y="4700016"/>
+            <a:ext cx="2331720" cy="384048"/>
+          </a:xfrm>
+          <a:prstGeom prst="rect">
+            <a:avLst/>
+          </a:prstGeom>
+          <a:noFill/>
+          <a:ln/>
+        </p:spPr>
+        <p:txBody>
+          <a:bodyPr wrap="square" lIns="0" tIns="0" rIns="0" bIns="0" rtlCol="0" anchor="ctr"/>
+          <a:lstStyle/>
+          <a:p>
+            <a:pPr algn="ctr" indent="0" marL="0">
+              <a:buNone/>
+            </a:pPr>
+            <a:r>
+              <a:rPr lang="en-US" sz="1050" b="1" dirty="0">
+                <a:solidFill>
+                  <a:srgbClr val="2E9BA6"/>
+                </a:solidFill>
+                <a:latin typeface="Arial" pitchFamily="34" charset="0"/>
+                <a:ea typeface="Arial" pitchFamily="34" charset="-122"/>
+                <a:cs typeface="Arial" pitchFamily="34" charset="-120"/>
+              </a:rPr>
+              <a:t>↓  /clean</a:t>
+            </a:r>
+            <a:endParaRPr lang="en-US" sz="1050" dirty="0"/>
+          </a:p>
+        </p:txBody>
+      </p:sp>
+      <p:sp>
+        <p:nvSpPr>
+          <p:cNvPr id="18" name="Shape 16"/>
+          <p:cNvSpPr/>
+          <p:nvPr/>
+        </p:nvSpPr>
+        <p:spPr>
+          <a:xfrm>
+            <a:off x="4654296" y="3310128"/>
+            <a:ext cx="274320" cy="237744"/>
+          </a:xfrm>
+          <a:prstGeom prst="rightArrow">
+            <a:avLst/>
+          </a:prstGeom>
+          <a:solidFill>
+            <a:srgbClr val="9AA9C4"/>
+          </a:solidFill>
+          <a:ln/>
+        </p:spPr>
+      </p:sp>
+      <p:sp>
+        <p:nvSpPr>
+          <p:cNvPr id="19" name="Shape 17"/>
+          <p:cNvSpPr/>
+          <p:nvPr/>
+        </p:nvSpPr>
+        <p:spPr>
+          <a:xfrm>
+            <a:off x="4928616" y="1572768"/>
+            <a:ext cx="2331720" cy="3566160"/>
+          </a:xfrm>
+          <a:prstGeom prst="roundRect">
+            <a:avLst>
+              <a:gd name="adj" fmla="val 2745"/>
             </a:avLst>
           </a:prstGeom>
           <a:solidFill>
@@ -2665,17 +2641,19 @@
       </p:sp>
       <p:sp>
         <p:nvSpPr>
-          <p:cNvPr id="22" name="Shape 20"/>
+          <p:cNvPr id="20" name="Shape 18"/>
           <p:cNvSpPr/>
           <p:nvPr/>
         </p:nvSpPr>
         <p:spPr>
           <a:xfrm>
-            <a:off x="6263640" y="3246120"/>
-            <a:ext cx="109728" cy="914400"/>
+            <a:off x="4928616" y="1572768"/>
+            <a:ext cx="2331720" cy="475488"/>
           </a:xfrm>
           <a:prstGeom prst="roundRect">
-            <a:avLst/>
+            <a:avLst>
+              <a:gd name="adj" fmla="val 15385"/>
+            </a:avLst>
           </a:prstGeom>
           <a:solidFill>
             <a:srgbClr val="2E5AAC"/>
@@ -2685,14 +2663,80 @@
       </p:sp>
       <p:sp>
         <p:nvSpPr>
+          <p:cNvPr id="21" name="Text 19"/>
+          <p:cNvSpPr txBox="1"/>
+          <p:nvPr/>
+        </p:nvSpPr>
+        <p:spPr>
+          <a:xfrm>
+            <a:off x="4928616" y="1572768"/>
+            <a:ext cx="2331720" cy="475488"/>
+          </a:xfrm>
+          <a:prstGeom prst="rect">
+            <a:avLst/>
+          </a:prstGeom>
+          <a:noFill/>
+          <a:ln/>
+        </p:spPr>
+        <p:txBody>
+          <a:bodyPr wrap="square" lIns="25400" tIns="25400" rIns="25400" bIns="25400" rtlCol="0" anchor="ctr"/>
+          <a:lstStyle/>
+          <a:p>
+            <a:pPr algn="ctr" indent="0" marL="0">
+              <a:buNone/>
+            </a:pPr>
+            <a:r>
+              <a:rPr lang="en-US" sz="1250" b="1" dirty="0">
+                <a:solidFill>
+                  <a:srgbClr val="FFFFFF"/>
+                </a:solidFill>
+                <a:latin typeface="Arial" pitchFamily="34" charset="0"/>
+                <a:ea typeface="Arial" pitchFamily="34" charset="-122"/>
+                <a:cs typeface="Arial" pitchFamily="34" charset="-120"/>
+              </a:rPr>
+              <a:t>PHA 2 · Tính AQI</a:t>
+            </a:r>
+            <a:endParaRPr lang="en-US" sz="1250" dirty="0"/>
+          </a:p>
+        </p:txBody>
+      </p:sp>
+      <p:sp>
+        <p:nvSpPr>
+          <p:cNvPr id="22" name="Shape 20"/>
+          <p:cNvSpPr/>
+          <p:nvPr/>
+        </p:nvSpPr>
+        <p:spPr>
+          <a:xfrm>
+            <a:off x="5038344" y="2157984"/>
+            <a:ext cx="2112264" cy="1207008"/>
+          </a:xfrm>
+          <a:prstGeom prst="roundRect">
+            <a:avLst>
+              <a:gd name="adj" fmla="val 3788"/>
+            </a:avLst>
+          </a:prstGeom>
+          <a:solidFill>
+            <a:srgbClr val="E9F0FB"/>
+          </a:solidFill>
+          <a:ln w="12700">
+            <a:solidFill>
+              <a:srgbClr val="C7D6EE"/>
+            </a:solidFill>
+            <a:prstDash val="solid"/>
+          </a:ln>
+        </p:spPr>
+      </p:sp>
+      <p:sp>
+        <p:nvSpPr>
           <p:cNvPr id="23" name="Text 21"/>
           <p:cNvSpPr txBox="1"/>
           <p:nvPr/>
         </p:nvSpPr>
         <p:spPr>
           <a:xfrm>
-            <a:off x="6519672" y="3246120"/>
-            <a:ext cx="4846320" cy="914400"/>
+            <a:off x="5111496" y="2194560"/>
+            <a:ext cx="1965960" cy="1133856"/>
           </a:xfrm>
           <a:prstGeom prst="rect">
             <a:avLst/>
@@ -2701,14 +2745,17 @@
           <a:ln/>
         </p:spPr>
         <p:txBody>
-          <a:bodyPr wrap="square" rtlCol="0" anchor="ctr"/>
-          <a:lstStyle/>
-          <a:p>
-            <a:pPr indent="0" marL="0">
-              <a:buNone/>
-            </a:pPr>
-            <a:r>
-              <a:rPr lang="en-US" sz="1250" b="1" dirty="0">
+          <a:bodyPr wrap="square" lIns="0" tIns="0" rIns="0" bIns="0" rtlCol="0" anchor="ctr"/>
+          <a:lstStyle/>
+          <a:p>
+            <a:pPr algn="l" indent="0" marL="0">
+              <a:lnSpc>
+                <a:spcPct val="102000"/>
+              </a:lnSpc>
+              <a:buNone/>
+            </a:pPr>
+            <a:r>
+              <a:rPr lang="en-US" sz="900" b="1" spc="100" kern="0" dirty="0">
                 <a:solidFill>
                   <a:srgbClr val="2E5AAC"/>
                 </a:solidFill>
@@ -2716,13 +2763,17 @@
                 <a:ea typeface="Arial" pitchFamily="34" charset="-122"/>
                 <a:cs typeface="Arial" pitchFamily="34" charset="-120"/>
               </a:rPr>
-              <a:t>Reducer  </a:t>
-            </a:r>
-            <a:pPr indent="0" marL="0">
-              <a:buNone/>
-            </a:pPr>
-            <a:r>
-              <a:rPr lang="en-US" sz="1250" dirty="0">
+              <a:t>MAPPER
+</a:t>
+            </a:r>
+            <a:pPr algn="l" indent="0" marL="0">
+              <a:lnSpc>
+                <a:spcPct val="102000"/>
+              </a:lnSpc>
+              <a:buNone/>
+            </a:pPr>
+            <a:r>
+              <a:rPr lang="en-US" sz="950" dirty="0">
                 <a:solidFill>
                   <a:srgbClr val="253044"/>
                 </a:solidFill>
@@ -2730,9 +2781,29 @@
                 <a:ea typeface="Arial" pitchFamily="34" charset="-122"/>
                 <a:cs typeface="Arial" pitchFamily="34" charset="-120"/>
               </a:rPr>
-              <a:t>GOM theo key  ·  Spark: groupBy().agg()</a:t>
-            </a:r>
-            <a:endParaRPr lang="en-US" sz="1250" dirty="0"/>
+              <a:t>IAQI từng chất</a:t>
+            </a:r>
+            <a:endParaRPr lang="en-US" sz="900" dirty="0"/>
+          </a:p>
+          <a:p>
+            <a:pPr algn="l" indent="0" marL="0">
+              <a:lnSpc>
+                <a:spcPct val="102000"/>
+              </a:lnSpc>
+              <a:buNone/>
+            </a:pPr>
+            <a:r>
+              <a:rPr lang="en-US" sz="950" dirty="0">
+                <a:solidFill>
+                  <a:srgbClr val="253044"/>
+                </a:solidFill>
+                <a:latin typeface="Arial" pitchFamily="34" charset="0"/>
+                <a:ea typeface="Arial" pitchFamily="34" charset="-122"/>
+                <a:cs typeface="Arial" pitchFamily="34" charset="-120"/>
+              </a:rPr>
+              <a:t>(NowCast 12h cho PM)</a:t>
+            </a:r>
+            <a:endParaRPr lang="en-US" sz="900" dirty="0"/>
           </a:p>
         </p:txBody>
       </p:sp>
@@ -2744,12 +2815,633 @@
         </p:nvSpPr>
         <p:spPr>
           <a:xfrm>
-            <a:off x="640080" y="4389120"/>
-            <a:ext cx="10881360" cy="1371600"/>
+            <a:off x="5038344" y="3438144"/>
+            <a:ext cx="2112264" cy="1207008"/>
           </a:xfrm>
           <a:prstGeom prst="roundRect">
             <a:avLst>
-              <a:gd name="adj" fmla="val 4667"/>
+              <a:gd name="adj" fmla="val 3788"/>
+            </a:avLst>
+          </a:prstGeom>
+          <a:solidFill>
+            <a:srgbClr val="FBEBDC"/>
+          </a:solidFill>
+          <a:ln w="12700">
+            <a:solidFill>
+              <a:srgbClr val="E8C9A6"/>
+            </a:solidFill>
+            <a:prstDash val="solid"/>
+          </a:ln>
+        </p:spPr>
+      </p:sp>
+      <p:sp>
+        <p:nvSpPr>
+          <p:cNvPr id="25" name="Text 23"/>
+          <p:cNvSpPr txBox="1"/>
+          <p:nvPr/>
+        </p:nvSpPr>
+        <p:spPr>
+          <a:xfrm>
+            <a:off x="5111496" y="3474720"/>
+            <a:ext cx="1965960" cy="1133856"/>
+          </a:xfrm>
+          <a:prstGeom prst="rect">
+            <a:avLst/>
+          </a:prstGeom>
+          <a:noFill/>
+          <a:ln/>
+        </p:spPr>
+        <p:txBody>
+          <a:bodyPr wrap="square" lIns="0" tIns="0" rIns="0" bIns="0" rtlCol="0" anchor="ctr"/>
+          <a:lstStyle/>
+          <a:p>
+            <a:pPr algn="l" indent="0" marL="0">
+              <a:lnSpc>
+                <a:spcPct val="102000"/>
+              </a:lnSpc>
+              <a:buNone/>
+            </a:pPr>
+            <a:r>
+              <a:rPr lang="en-US" sz="900" b="1" spc="100" kern="0" dirty="0">
+                <a:solidFill>
+                  <a:srgbClr val="C06A1E"/>
+                </a:solidFill>
+                <a:latin typeface="Arial" pitchFamily="34" charset="0"/>
+                <a:ea typeface="Arial" pitchFamily="34" charset="-122"/>
+                <a:cs typeface="Arial" pitchFamily="34" charset="-120"/>
+              </a:rPr>
+              <a:t>REDUCER
+</a:t>
+            </a:r>
+            <a:pPr algn="l" indent="0" marL="0">
+              <a:lnSpc>
+                <a:spcPct val="102000"/>
+              </a:lnSpc>
+              <a:buNone/>
+            </a:pPr>
+            <a:r>
+              <a:rPr lang="en-US" sz="950" dirty="0">
+                <a:solidFill>
+                  <a:srgbClr val="253044"/>
+                </a:solidFill>
+                <a:latin typeface="Arial" pitchFamily="34" charset="0"/>
+                <a:ea typeface="Arial" pitchFamily="34" charset="-122"/>
+                <a:cs typeface="Arial" pitchFamily="34" charset="-120"/>
+              </a:rPr>
+              <a:t>AQI = max(IAQI)</a:t>
+            </a:r>
+            <a:endParaRPr lang="en-US" sz="900" dirty="0"/>
+          </a:p>
+          <a:p>
+            <a:pPr algn="l" indent="0" marL="0">
+              <a:lnSpc>
+                <a:spcPct val="102000"/>
+              </a:lnSpc>
+              <a:buNone/>
+            </a:pPr>
+            <a:r>
+              <a:rPr lang="en-US" sz="950" dirty="0">
+                <a:solidFill>
+                  <a:srgbClr val="253044"/>
+                </a:solidFill>
+                <a:latin typeface="Arial" pitchFamily="34" charset="0"/>
+                <a:ea typeface="Arial" pitchFamily="34" charset="-122"/>
+                <a:cs typeface="Arial" pitchFamily="34" charset="-120"/>
+              </a:rPr>
+              <a:t>gán mức + chất trội</a:t>
+            </a:r>
+            <a:endParaRPr lang="en-US" sz="900" dirty="0"/>
+          </a:p>
+        </p:txBody>
+      </p:sp>
+      <p:sp>
+        <p:nvSpPr>
+          <p:cNvPr id="26" name="Text 24"/>
+          <p:cNvSpPr txBox="1"/>
+          <p:nvPr/>
+        </p:nvSpPr>
+        <p:spPr>
+          <a:xfrm>
+            <a:off x="4928616" y="4700016"/>
+            <a:ext cx="2331720" cy="384048"/>
+          </a:xfrm>
+          <a:prstGeom prst="rect">
+            <a:avLst/>
+          </a:prstGeom>
+          <a:noFill/>
+          <a:ln/>
+        </p:spPr>
+        <p:txBody>
+          <a:bodyPr wrap="square" lIns="0" tIns="0" rIns="0" bIns="0" rtlCol="0" anchor="ctr"/>
+          <a:lstStyle/>
+          <a:p>
+            <a:pPr algn="ctr" indent="0" marL="0">
+              <a:buNone/>
+            </a:pPr>
+            <a:r>
+              <a:rPr lang="en-US" sz="1050" b="1" dirty="0">
+                <a:solidFill>
+                  <a:srgbClr val="2E5AAC"/>
+                </a:solidFill>
+                <a:latin typeface="Arial" pitchFamily="34" charset="0"/>
+                <a:ea typeface="Arial" pitchFamily="34" charset="-122"/>
+                <a:cs typeface="Arial" pitchFamily="34" charset="-120"/>
+              </a:rPr>
+              <a:t>↓  /aqi</a:t>
+            </a:r>
+            <a:endParaRPr lang="en-US" sz="1050" dirty="0"/>
+          </a:p>
+        </p:txBody>
+      </p:sp>
+      <p:sp>
+        <p:nvSpPr>
+          <p:cNvPr id="27" name="Shape 25"/>
+          <p:cNvSpPr/>
+          <p:nvPr/>
+        </p:nvSpPr>
+        <p:spPr>
+          <a:xfrm>
+            <a:off x="7278624" y="3310128"/>
+            <a:ext cx="274320" cy="237744"/>
+          </a:xfrm>
+          <a:prstGeom prst="rightArrow">
+            <a:avLst/>
+          </a:prstGeom>
+          <a:solidFill>
+            <a:srgbClr val="9AA9C4"/>
+          </a:solidFill>
+          <a:ln/>
+        </p:spPr>
+      </p:sp>
+      <p:sp>
+        <p:nvSpPr>
+          <p:cNvPr id="28" name="Shape 26"/>
+          <p:cNvSpPr/>
+          <p:nvPr/>
+        </p:nvSpPr>
+        <p:spPr>
+          <a:xfrm>
+            <a:off x="7552944" y="1572768"/>
+            <a:ext cx="2331720" cy="3566160"/>
+          </a:xfrm>
+          <a:prstGeom prst="roundRect">
+            <a:avLst>
+              <a:gd name="adj" fmla="val 2745"/>
+            </a:avLst>
+          </a:prstGeom>
+          <a:solidFill>
+            <a:srgbClr val="FFFFFF"/>
+          </a:solidFill>
+          <a:ln w="12700">
+            <a:solidFill>
+              <a:srgbClr val="D6DEEA"/>
+            </a:solidFill>
+            <a:prstDash val="solid"/>
+          </a:ln>
+          <a:effectLst>
+            <a:outerShdw sx="100000" sy="100000" kx="0" ky="0" algn="bl" rotWithShape="0" blurRad="88900" dist="25400" dir="5400000">
+              <a:srgbClr val="9AA6B8">
+                <a:alpha val="32000"/>
+              </a:srgbClr>
+            </a:outerShdw>
+          </a:effectLst>
+        </p:spPr>
+      </p:sp>
+      <p:sp>
+        <p:nvSpPr>
+          <p:cNvPr id="29" name="Shape 27"/>
+          <p:cNvSpPr/>
+          <p:nvPr/>
+        </p:nvSpPr>
+        <p:spPr>
+          <a:xfrm>
+            <a:off x="7552944" y="1572768"/>
+            <a:ext cx="2331720" cy="475488"/>
+          </a:xfrm>
+          <a:prstGeom prst="roundRect">
+            <a:avLst>
+              <a:gd name="adj" fmla="val 15385"/>
+            </a:avLst>
+          </a:prstGeom>
+          <a:solidFill>
+            <a:srgbClr val="4F9D5D"/>
+          </a:solidFill>
+          <a:ln/>
+        </p:spPr>
+      </p:sp>
+      <p:sp>
+        <p:nvSpPr>
+          <p:cNvPr id="30" name="Text 28"/>
+          <p:cNvSpPr txBox="1"/>
+          <p:nvPr/>
+        </p:nvSpPr>
+        <p:spPr>
+          <a:xfrm>
+            <a:off x="7552944" y="1572768"/>
+            <a:ext cx="2331720" cy="475488"/>
+          </a:xfrm>
+          <a:prstGeom prst="rect">
+            <a:avLst/>
+          </a:prstGeom>
+          <a:noFill/>
+          <a:ln/>
+        </p:spPr>
+        <p:txBody>
+          <a:bodyPr wrap="square" lIns="25400" tIns="25400" rIns="25400" bIns="25400" rtlCol="0" anchor="ctr"/>
+          <a:lstStyle/>
+          <a:p>
+            <a:pPr algn="ctr" indent="0" marL="0">
+              <a:buNone/>
+            </a:pPr>
+            <a:r>
+              <a:rPr lang="en-US" sz="1250" b="1" dirty="0">
+                <a:solidFill>
+                  <a:srgbClr val="FFFFFF"/>
+                </a:solidFill>
+                <a:latin typeface="Arial" pitchFamily="34" charset="0"/>
+                <a:ea typeface="Arial" pitchFamily="34" charset="-122"/>
+                <a:cs typeface="Arial" pitchFamily="34" charset="-120"/>
+              </a:rPr>
+              <a:t>PHA 3 · Tổng hợp</a:t>
+            </a:r>
+            <a:endParaRPr lang="en-US" sz="1250" dirty="0"/>
+          </a:p>
+        </p:txBody>
+      </p:sp>
+      <p:sp>
+        <p:nvSpPr>
+          <p:cNvPr id="31" name="Shape 29"/>
+          <p:cNvSpPr/>
+          <p:nvPr/>
+        </p:nvSpPr>
+        <p:spPr>
+          <a:xfrm>
+            <a:off x="7662672" y="2157984"/>
+            <a:ext cx="2112264" cy="1207008"/>
+          </a:xfrm>
+          <a:prstGeom prst="roundRect">
+            <a:avLst>
+              <a:gd name="adj" fmla="val 3788"/>
+            </a:avLst>
+          </a:prstGeom>
+          <a:solidFill>
+            <a:srgbClr val="E9F0FB"/>
+          </a:solidFill>
+          <a:ln w="12700">
+            <a:solidFill>
+              <a:srgbClr val="C7D6EE"/>
+            </a:solidFill>
+            <a:prstDash val="solid"/>
+          </a:ln>
+        </p:spPr>
+      </p:sp>
+      <p:sp>
+        <p:nvSpPr>
+          <p:cNvPr id="32" name="Text 30"/>
+          <p:cNvSpPr txBox="1"/>
+          <p:nvPr/>
+        </p:nvSpPr>
+        <p:spPr>
+          <a:xfrm>
+            <a:off x="7735824" y="2194560"/>
+            <a:ext cx="1965960" cy="1133856"/>
+          </a:xfrm>
+          <a:prstGeom prst="rect">
+            <a:avLst/>
+          </a:prstGeom>
+          <a:noFill/>
+          <a:ln/>
+        </p:spPr>
+        <p:txBody>
+          <a:bodyPr wrap="square" lIns="0" tIns="0" rIns="0" bIns="0" rtlCol="0" anchor="ctr"/>
+          <a:lstStyle/>
+          <a:p>
+            <a:pPr algn="l" indent="0" marL="0">
+              <a:lnSpc>
+                <a:spcPct val="102000"/>
+              </a:lnSpc>
+              <a:buNone/>
+            </a:pPr>
+            <a:r>
+              <a:rPr lang="en-US" sz="900" b="1" spc="100" kern="0" dirty="0">
+                <a:solidFill>
+                  <a:srgbClr val="2E5AAC"/>
+                </a:solidFill>
+                <a:latin typeface="Arial" pitchFamily="34" charset="0"/>
+                <a:ea typeface="Arial" pitchFamily="34" charset="-122"/>
+                <a:cs typeface="Arial" pitchFamily="34" charset="-120"/>
+              </a:rPr>
+              <a:t>MAPPER
+</a:t>
+            </a:r>
+            <a:pPr algn="l" indent="0" marL="0">
+              <a:lnSpc>
+                <a:spcPct val="102000"/>
+              </a:lnSpc>
+              <a:buNone/>
+            </a:pPr>
+            <a:r>
+              <a:rPr lang="en-US" sz="950" dirty="0">
+                <a:solidFill>
+                  <a:srgbClr val="253044"/>
+                </a:solidFill>
+                <a:latin typeface="Arial" pitchFamily="34" charset="0"/>
+                <a:ea typeface="Arial" pitchFamily="34" charset="-122"/>
+                <a:cs typeface="Arial" pitchFamily="34" charset="-120"/>
+              </a:rPr>
+              <a:t>key = (thành phố, ngày)</a:t>
+            </a:r>
+            <a:endParaRPr lang="en-US" sz="900" dirty="0"/>
+          </a:p>
+          <a:p>
+            <a:pPr algn="l" indent="0" marL="0">
+              <a:lnSpc>
+                <a:spcPct val="102000"/>
+              </a:lnSpc>
+              <a:buNone/>
+            </a:pPr>
+            <a:r>
+              <a:rPr lang="en-US" sz="950" dirty="0">
+                <a:solidFill>
+                  <a:srgbClr val="253044"/>
+                </a:solidFill>
+                <a:latin typeface="Arial" pitchFamily="34" charset="0"/>
+                <a:ea typeface="Arial" pitchFamily="34" charset="-122"/>
+                <a:cs typeface="Arial" pitchFamily="34" charset="-120"/>
+              </a:rPr>
+              <a:t>value = AQI</a:t>
+            </a:r>
+            <a:endParaRPr lang="en-US" sz="900" dirty="0"/>
+          </a:p>
+        </p:txBody>
+      </p:sp>
+      <p:sp>
+        <p:nvSpPr>
+          <p:cNvPr id="33" name="Shape 31"/>
+          <p:cNvSpPr/>
+          <p:nvPr/>
+        </p:nvSpPr>
+        <p:spPr>
+          <a:xfrm>
+            <a:off x="7662672" y="3438144"/>
+            <a:ext cx="2112264" cy="1207008"/>
+          </a:xfrm>
+          <a:prstGeom prst="roundRect">
+            <a:avLst>
+              <a:gd name="adj" fmla="val 3788"/>
+            </a:avLst>
+          </a:prstGeom>
+          <a:solidFill>
+            <a:srgbClr val="FBEBDC"/>
+          </a:solidFill>
+          <a:ln w="12700">
+            <a:solidFill>
+              <a:srgbClr val="E8C9A6"/>
+            </a:solidFill>
+            <a:prstDash val="solid"/>
+          </a:ln>
+        </p:spPr>
+      </p:sp>
+      <p:sp>
+        <p:nvSpPr>
+          <p:cNvPr id="34" name="Text 32"/>
+          <p:cNvSpPr txBox="1"/>
+          <p:nvPr/>
+        </p:nvSpPr>
+        <p:spPr>
+          <a:xfrm>
+            <a:off x="7735824" y="3474720"/>
+            <a:ext cx="1965960" cy="1133856"/>
+          </a:xfrm>
+          <a:prstGeom prst="rect">
+            <a:avLst/>
+          </a:prstGeom>
+          <a:noFill/>
+          <a:ln/>
+        </p:spPr>
+        <p:txBody>
+          <a:bodyPr wrap="square" lIns="0" tIns="0" rIns="0" bIns="0" rtlCol="0" anchor="ctr"/>
+          <a:lstStyle/>
+          <a:p>
+            <a:pPr algn="l" indent="0" marL="0">
+              <a:lnSpc>
+                <a:spcPct val="102000"/>
+              </a:lnSpc>
+              <a:buNone/>
+            </a:pPr>
+            <a:r>
+              <a:rPr lang="en-US" sz="900" b="1" spc="100" kern="0" dirty="0">
+                <a:solidFill>
+                  <a:srgbClr val="C06A1E"/>
+                </a:solidFill>
+                <a:latin typeface="Arial" pitchFamily="34" charset="0"/>
+                <a:ea typeface="Arial" pitchFamily="34" charset="-122"/>
+                <a:cs typeface="Arial" pitchFamily="34" charset="-120"/>
+              </a:rPr>
+              <a:t>REDUCER
+</a:t>
+            </a:r>
+            <a:pPr algn="l" indent="0" marL="0">
+              <a:lnSpc>
+                <a:spcPct val="102000"/>
+              </a:lnSpc>
+              <a:buNone/>
+            </a:pPr>
+            <a:r>
+              <a:rPr lang="en-US" sz="950" dirty="0">
+                <a:solidFill>
+                  <a:srgbClr val="253044"/>
+                </a:solidFill>
+                <a:latin typeface="Arial" pitchFamily="34" charset="0"/>
+                <a:ea typeface="Arial" pitchFamily="34" charset="-122"/>
+                <a:cs typeface="Arial" pitchFamily="34" charset="-120"/>
+              </a:rPr>
+              <a:t>trung bình/max · đếm mức · xếp hạng</a:t>
+            </a:r>
+            <a:endParaRPr lang="en-US" sz="900" dirty="0"/>
+          </a:p>
+        </p:txBody>
+      </p:sp>
+      <p:sp>
+        <p:nvSpPr>
+          <p:cNvPr id="35" name="Text 33"/>
+          <p:cNvSpPr txBox="1"/>
+          <p:nvPr/>
+        </p:nvSpPr>
+        <p:spPr>
+          <a:xfrm>
+            <a:off x="7552944" y="4700016"/>
+            <a:ext cx="2331720" cy="384048"/>
+          </a:xfrm>
+          <a:prstGeom prst="rect">
+            <a:avLst/>
+          </a:prstGeom>
+          <a:noFill/>
+          <a:ln/>
+        </p:spPr>
+        <p:txBody>
+          <a:bodyPr wrap="square" lIns="0" tIns="0" rIns="0" bIns="0" rtlCol="0" anchor="ctr"/>
+          <a:lstStyle/>
+          <a:p>
+            <a:pPr algn="ctr" indent="0" marL="0">
+              <a:buNone/>
+            </a:pPr>
+            <a:r>
+              <a:rPr lang="en-US" sz="1050" b="1" dirty="0">
+                <a:solidFill>
+                  <a:srgbClr val="4F9D5D"/>
+                </a:solidFill>
+                <a:latin typeface="Arial" pitchFamily="34" charset="0"/>
+                <a:ea typeface="Arial" pitchFamily="34" charset="-122"/>
+                <a:cs typeface="Arial" pitchFamily="34" charset="-120"/>
+              </a:rPr>
+              <a:t>↓  /agg · HBase</a:t>
+            </a:r>
+            <a:endParaRPr lang="en-US" sz="1050" dirty="0"/>
+          </a:p>
+        </p:txBody>
+      </p:sp>
+      <p:sp>
+        <p:nvSpPr>
+          <p:cNvPr id="36" name="Shape 34"/>
+          <p:cNvSpPr/>
+          <p:nvPr/>
+        </p:nvSpPr>
+        <p:spPr>
+          <a:xfrm>
+            <a:off x="9902952" y="3310128"/>
+            <a:ext cx="274320" cy="237744"/>
+          </a:xfrm>
+          <a:prstGeom prst="rightArrow">
+            <a:avLst/>
+          </a:prstGeom>
+          <a:solidFill>
+            <a:srgbClr val="9AA9C4"/>
+          </a:solidFill>
+          <a:ln/>
+        </p:spPr>
+      </p:sp>
+      <p:sp>
+        <p:nvSpPr>
+          <p:cNvPr id="37" name="Shape 35"/>
+          <p:cNvSpPr/>
+          <p:nvPr/>
+        </p:nvSpPr>
+        <p:spPr>
+          <a:xfrm>
+            <a:off x="10177272" y="2761488"/>
+            <a:ext cx="1554480" cy="1325880"/>
+          </a:xfrm>
+          <a:prstGeom prst="roundRect">
+            <a:avLst>
+              <a:gd name="adj" fmla="val 5517"/>
+            </a:avLst>
+          </a:prstGeom>
+          <a:solidFill>
+            <a:srgbClr val="1F3864"/>
+          </a:solidFill>
+          <a:ln/>
+          <a:effectLst>
+            <a:outerShdw sx="100000" sy="100000" kx="0" ky="0" algn="bl" rotWithShape="0" blurRad="88900" dist="25400" dir="5400000">
+              <a:srgbClr val="9AA6B8">
+                <a:alpha val="32000"/>
+              </a:srgbClr>
+            </a:outerShdw>
+          </a:effectLst>
+        </p:spPr>
+      </p:sp>
+      <p:sp>
+        <p:nvSpPr>
+          <p:cNvPr id="38" name="Text 36"/>
+          <p:cNvSpPr txBox="1"/>
+          <p:nvPr/>
+        </p:nvSpPr>
+        <p:spPr>
+          <a:xfrm>
+            <a:off x="10177272" y="2761488"/>
+            <a:ext cx="1554480" cy="1325880"/>
+          </a:xfrm>
+          <a:prstGeom prst="rect">
+            <a:avLst/>
+          </a:prstGeom>
+          <a:noFill/>
+          <a:ln/>
+        </p:spPr>
+        <p:txBody>
+          <a:bodyPr wrap="square" lIns="38100" tIns="38100" rIns="38100" bIns="38100" rtlCol="0" anchor="ctr"/>
+          <a:lstStyle/>
+          <a:p>
+            <a:pPr algn="ctr" indent="0" marL="0">
+              <a:lnSpc>
+                <a:spcPct val="105000"/>
+              </a:lnSpc>
+              <a:buNone/>
+            </a:pPr>
+            <a:r>
+              <a:rPr lang="en-US" sz="1150" b="1" dirty="0">
+                <a:solidFill>
+                  <a:srgbClr val="FFFFFF"/>
+                </a:solidFill>
+                <a:latin typeface="Arial" pitchFamily="34" charset="0"/>
+                <a:ea typeface="Arial" pitchFamily="34" charset="-122"/>
+                <a:cs typeface="Arial" pitchFamily="34" charset="-120"/>
+              </a:rPr>
+              <a:t>PHỤC VỤ
+</a:t>
+            </a:r>
+            <a:pPr algn="ctr" indent="0" marL="0">
+              <a:lnSpc>
+                <a:spcPct val="105000"/>
+              </a:lnSpc>
+              <a:buNone/>
+            </a:pPr>
+            <a:r>
+              <a:rPr lang="en-US" sz="1000" dirty="0">
+                <a:solidFill>
+                  <a:srgbClr val="FFFFFF"/>
+                </a:solidFill>
+                <a:latin typeface="Arial" pitchFamily="34" charset="0"/>
+                <a:ea typeface="Arial" pitchFamily="34" charset="-122"/>
+                <a:cs typeface="Arial" pitchFamily="34" charset="-120"/>
+              </a:rPr>
+              <a:t>HBase
+</a:t>
+            </a:r>
+            <a:pPr algn="ctr" indent="0" marL="0">
+              <a:lnSpc>
+                <a:spcPct val="105000"/>
+              </a:lnSpc>
+              <a:buNone/>
+            </a:pPr>
+            <a:r>
+              <a:rPr lang="en-US" sz="1000" dirty="0">
+                <a:solidFill>
+                  <a:srgbClr val="FFFFFF"/>
+                </a:solidFill>
+                <a:latin typeface="Arial" pitchFamily="34" charset="0"/>
+                <a:ea typeface="Arial" pitchFamily="34" charset="-122"/>
+                <a:cs typeface="Arial" pitchFamily="34" charset="-120"/>
+              </a:rPr>
+              <a:t>→ Dashboard</a:t>
+            </a:r>
+            <a:endParaRPr lang="en-US" sz="1150" dirty="0"/>
+          </a:p>
+        </p:txBody>
+      </p:sp>
+      <p:sp>
+        <p:nvSpPr>
+          <p:cNvPr id="39" name="Shape 37"/>
+          <p:cNvSpPr/>
+          <p:nvPr/>
+        </p:nvSpPr>
+        <p:spPr>
+          <a:xfrm>
+            <a:off x="457200" y="5230368"/>
+            <a:ext cx="11274552" cy="896112"/>
+          </a:xfrm>
+          <a:prstGeom prst="roundRect">
+            <a:avLst>
+              <a:gd name="adj" fmla="val 7143"/>
             </a:avLst>
           </a:prstGeom>
           <a:solidFill>
@@ -2772,14 +3464,14 @@
       </p:sp>
       <p:sp>
         <p:nvSpPr>
-          <p:cNvPr id="25" name="Text 23"/>
+          <p:cNvPr id="40" name="Text 38"/>
           <p:cNvSpPr txBox="1"/>
           <p:nvPr/>
         </p:nvSpPr>
         <p:spPr>
           <a:xfrm>
-            <a:off x="914400" y="4389120"/>
-            <a:ext cx="10332720" cy="1371600"/>
+            <a:off x="777240" y="5230368"/>
+            <a:ext cx="10607040" cy="896112"/>
           </a:xfrm>
           <a:prstGeom prst="rect">
             <a:avLst/>
@@ -2795,7 +3487,7 @@
               <a:buNone/>
             </a:pPr>
             <a:r>
-              <a:rPr lang="en-US" sz="1400" b="1" dirty="0">
+              <a:rPr lang="en-US" sz="1250" b="1" dirty="0">
                 <a:solidFill>
                   <a:srgbClr val="1F3864"/>
                 </a:solidFill>
@@ -2803,13 +3495,13 @@
                 <a:ea typeface="Arial" pitchFamily="34" charset="-122"/>
                 <a:cs typeface="Arial" pitchFamily="34" charset="-120"/>
               </a:rPr>
-              <a:t>Mô hình MapReduce — cài bằng Spark.  </a:t>
+              <a:t>Mapper ↔ withColumn/map · Reducer ↔ groupBy().agg().  </a:t>
             </a:r>
             <a:pPr indent="0" marL="0">
               <a:buNone/>
             </a:pPr>
             <a:r>
-              <a:rPr lang="en-US" sz="1350" dirty="0">
+              <a:rPr lang="en-US" sz="1250" dirty="0">
                 <a:solidFill>
                   <a:srgbClr val="253044"/>
                 </a:solidFill>
@@ -2817,9 +3509,9 @@
                 <a:ea typeface="Arial" pitchFamily="34" charset="-122"/>
                 <a:cs typeface="Arial" pitchFamily="34" charset="-120"/>
               </a:rPr>
-              <a:t>Nhóm mượn khung tư duy Map/Reduce (El Fazziki 2015) nhưng hiện thực bằng Spark DataFrame. Batch và streaming dùng CHUNG một lõi aqi_core nên không lệch kết quả.</a:t>
-            </a:r>
-            <a:endParaRPr lang="en-US" sz="1400" dirty="0"/>
+              <a:t>Mô hình MapReduce, cài bằng Spark; batch &amp; streaming dùng chung lõi aqi_core nên không lệch kết quả.</a:t>
+            </a:r>
+            <a:endParaRPr lang="en-US" sz="1250" dirty="0"/>
           </a:p>
         </p:txBody>
       </p:sp>

</xml_diff>

<commit_message>
docs: thêm nhánh phân cụm & dự báo vào sơ đồ pipeline slide Huyền
Slide 3.1: rút gọn phần lõi, PHỤC VỤ thành cột cao bên phải; thêm dải
MỞ RỘNG (ngoài lõi) gồm 2 nhánh Phân cụm vùng & Dự báo AQI 24h, lấy đầu
vào từ /aqi và cùng đổ về HBase/Dashboard.

Co-Authored-By: Claude Opus 4.8 <noreply@anthropic.com>
Claude-Session: https://claude.ai/code/session_01FrxD6iyiu71sw2RmUtSxFy
</commit_message>
<xml_diff>
--- a/docs/slides/Slide_Huyen_theo_mau.pptx
+++ b/docs/slides/Slide_Huyen_theo_mau.pptx
@@ -595,7 +595,7 @@
           <a:p>
             <a:r>
               <a:rPr lang="en-US" dirty="0"/>
-              <a:t>Sơ đồ pipeline 3 pha: ĐẦU VÀO → Pha1(Mapper: gắn key (trạm,giờ) / Reducer: khử trùng lặp, nội suy → /clean) → Pha2(Mapper: IAQI + NowCast / Reducer: AQI=max → /aqi) → Pha3(Mapper: key (thành phố,ngày) / Reducer: trung bình, xếp hạng → /agg,HBase) → PHỤC VỤ. Mapper↔withColumn, Reducer↔groupBy().agg(); batch+stream chung aqi_core.</a:t>
+              <a:t>Sơ đồ: ĐẦU VÀO → Pha1(/clean) → Pha2(/aqi) → Pha3(/agg,HBase) → PHỤC VỤ. Hai NHÁNH MỞ RỘNG chạy NGOÀI lõi, lấy đầu vào từ /aqi (sau Pha 2): (1) Phân cụm vùng — 5 thuật toán, chọn theo silhouette, K-means k=3; (2) Dự báo AQI 24h — SGD/Random Forest/CNN-LSTM, Random Forest thắng. Kết quả cũng đổ về HBase/Dashboard. Đây là phần Khôi/Diệp trình bày sâu; Huyền chỉ giới thiệu vị trí.</a:t>
             </a:r>
             <a:endParaRPr lang="en-US" dirty="0"/>
           </a:p>
@@ -2085,7 +2085,7 @@
                 <a:ea typeface="Arial" pitchFamily="34" charset="-122"/>
                 <a:cs typeface="Arial" pitchFamily="34" charset="-120"/>
               </a:rPr>
-              <a:t>Pipeline ba pha (Spark)</a:t>
+              <a:t>Pipeline ba pha + hai nhánh mở rộng</a:t>
             </a:r>
             <a:endParaRPr lang="en-US" sz="2300" dirty="0"/>
           </a:p>
@@ -2124,7 +2124,7 @@
                 <a:ea typeface="Arial" pitchFamily="34" charset="-122"/>
                 <a:cs typeface="Arial" pitchFamily="34" charset="-120"/>
               </a:rPr>
-              <a:t>Mỗi pha là một job Map → Reduce, đọc đầu ra pha trước rồi thêm một lớp thông tin.</a:t>
+              <a:t>Ba pha lõi (làm sạch → tính AQI → tổng hợp); phân cụm &amp; dự báo chạy ngoài lõi trên /aqi.</a:t>
             </a:r>
             <a:endParaRPr lang="en-US" sz="1350" dirty="0"/>
           </a:p>
@@ -2138,18 +2138,23 @@
         </p:nvSpPr>
         <p:spPr>
           <a:xfrm>
-            <a:off x="457200" y="2761488"/>
-            <a:ext cx="1554480" cy="1325880"/>
+            <a:off x="457200" y="1965960"/>
+            <a:ext cx="1463040" cy="1371600"/>
           </a:xfrm>
           <a:prstGeom prst="roundRect">
             <a:avLst>
-              <a:gd name="adj" fmla="val 5517"/>
+              <a:gd name="adj" fmla="val 5333"/>
             </a:avLst>
           </a:prstGeom>
           <a:solidFill>
             <a:srgbClr val="F4F7FC"/>
           </a:solidFill>
-          <a:ln/>
+          <a:ln w="12700">
+            <a:solidFill>
+              <a:srgbClr val="D6DEEA"/>
+            </a:solidFill>
+            <a:prstDash val="solid"/>
+          </a:ln>
           <a:effectLst>
             <a:outerShdw sx="100000" sy="100000" kx="0" ky="0" algn="bl" rotWithShape="0" blurRad="88900" dist="25400" dir="5400000">
               <a:srgbClr val="9AA6B8">
@@ -2167,8 +2172,8 @@
         </p:nvSpPr>
         <p:spPr>
           <a:xfrm>
-            <a:off x="457200" y="2761488"/>
-            <a:ext cx="1554480" cy="1325880"/>
+            <a:off x="457200" y="1965960"/>
+            <a:ext cx="1463040" cy="1371600"/>
           </a:xfrm>
           <a:prstGeom prst="rect">
             <a:avLst/>
@@ -2182,12 +2187,12 @@
           <a:p>
             <a:pPr algn="ctr" indent="0" marL="0">
               <a:lnSpc>
-                <a:spcPct val="105000"/>
+                <a:spcPct val="110000"/>
               </a:lnSpc>
               <a:buNone/>
             </a:pPr>
             <a:r>
-              <a:rPr lang="en-US" sz="1150" b="1" dirty="0">
+              <a:rPr lang="en-US" sz="1100" b="1" dirty="0">
                 <a:solidFill>
                   <a:srgbClr val="1F3864"/>
                 </a:solidFill>
@@ -2200,12 +2205,12 @@
             </a:r>
             <a:pPr algn="ctr" indent="0" marL="0">
               <a:lnSpc>
-                <a:spcPct val="105000"/>
+                <a:spcPct val="110000"/>
               </a:lnSpc>
               <a:buNone/>
             </a:pPr>
             <a:r>
-              <a:rPr lang="en-US" sz="1000" dirty="0">
+              <a:rPr lang="en-US" sz="950" dirty="0">
                 <a:solidFill>
                   <a:srgbClr val="1F3864"/>
                 </a:solidFill>
@@ -2213,17 +2218,19 @@
                 <a:ea typeface="Arial" pitchFamily="34" charset="-122"/>
                 <a:cs typeface="Arial" pitchFamily="34" charset="-120"/>
               </a:rPr>
-              <a:t>HDFS /raw
-</a:t>
-            </a:r>
+              <a:t>HDFS /raw</a:t>
+            </a:r>
+            <a:endParaRPr lang="en-US" sz="1100" dirty="0"/>
+          </a:p>
+          <a:p>
             <a:pPr algn="ctr" indent="0" marL="0">
               <a:lnSpc>
-                <a:spcPct val="105000"/>
+                <a:spcPct val="110000"/>
               </a:lnSpc>
               <a:buNone/>
             </a:pPr>
             <a:r>
-              <a:rPr lang="en-US" sz="1000" dirty="0">
+              <a:rPr lang="en-US" sz="950" dirty="0">
                 <a:solidFill>
                   <a:srgbClr val="1F3864"/>
                 </a:solidFill>
@@ -2233,7 +2240,7 @@
               </a:rPr>
               <a:t>Kafka (live)</a:t>
             </a:r>
-            <a:endParaRPr lang="en-US" sz="1150" dirty="0"/>
+            <a:endParaRPr lang="en-US" sz="1100" dirty="0"/>
           </a:p>
         </p:txBody>
       </p:sp>
@@ -2245,8 +2252,8 @@
         </p:nvSpPr>
         <p:spPr>
           <a:xfrm>
-            <a:off x="2029968" y="3310128"/>
-            <a:ext cx="274320" cy="237744"/>
+            <a:off x="1938528" y="2487168"/>
+            <a:ext cx="256032" cy="219456"/>
           </a:xfrm>
           <a:prstGeom prst="rightArrow">
             <a:avLst/>
@@ -2265,12 +2272,12 @@
         </p:nvSpPr>
         <p:spPr>
           <a:xfrm>
-            <a:off x="2304288" y="1572768"/>
-            <a:ext cx="2331720" cy="3566160"/>
+            <a:off x="2212848" y="1444752"/>
+            <a:ext cx="2286000" cy="2432304"/>
           </a:xfrm>
           <a:prstGeom prst="roundRect">
             <a:avLst>
-              <a:gd name="adj" fmla="val 2745"/>
+              <a:gd name="adj" fmla="val 2800"/>
             </a:avLst>
           </a:prstGeom>
           <a:solidFill>
@@ -2299,12 +2306,12 @@
         </p:nvSpPr>
         <p:spPr>
           <a:xfrm>
-            <a:off x="2304288" y="1572768"/>
-            <a:ext cx="2331720" cy="475488"/>
+            <a:off x="2212848" y="1444752"/>
+            <a:ext cx="2286000" cy="420624"/>
           </a:xfrm>
           <a:prstGeom prst="roundRect">
             <a:avLst>
-              <a:gd name="adj" fmla="val 15385"/>
+              <a:gd name="adj" fmla="val 17391"/>
             </a:avLst>
           </a:prstGeom>
           <a:solidFill>
@@ -2321,8 +2328,8 @@
         </p:nvSpPr>
         <p:spPr>
           <a:xfrm>
-            <a:off x="2304288" y="1572768"/>
-            <a:ext cx="2331720" cy="475488"/>
+            <a:off x="2212848" y="1444752"/>
+            <a:ext cx="2286000" cy="420624"/>
           </a:xfrm>
           <a:prstGeom prst="rect">
             <a:avLst/>
@@ -2338,7 +2345,7 @@
               <a:buNone/>
             </a:pPr>
             <a:r>
-              <a:rPr lang="en-US" sz="1250" b="1" dirty="0">
+              <a:rPr lang="en-US" sz="1200" b="1" dirty="0">
                 <a:solidFill>
                   <a:srgbClr val="FFFFFF"/>
                 </a:solidFill>
@@ -2348,7 +2355,7 @@
               </a:rPr>
               <a:t>PHA 1 · Làm sạch</a:t>
             </a:r>
-            <a:endParaRPr lang="en-US" sz="1250" dirty="0"/>
+            <a:endParaRPr lang="en-US" sz="1200" dirty="0"/>
           </a:p>
         </p:txBody>
       </p:sp>
@@ -2360,12 +2367,12 @@
         </p:nvSpPr>
         <p:spPr>
           <a:xfrm>
-            <a:off x="2414016" y="2157984"/>
-            <a:ext cx="2112264" cy="1207008"/>
+            <a:off x="2322576" y="1938528"/>
+            <a:ext cx="2066544" cy="749808"/>
           </a:xfrm>
           <a:prstGeom prst="roundRect">
             <a:avLst>
-              <a:gd name="adj" fmla="val 3788"/>
+              <a:gd name="adj" fmla="val 6098"/>
             </a:avLst>
           </a:prstGeom>
           <a:solidFill>
@@ -2387,8 +2394,8 @@
         </p:nvSpPr>
         <p:spPr>
           <a:xfrm>
-            <a:off x="2487168" y="2194560"/>
-            <a:ext cx="1965960" cy="1133856"/>
+            <a:off x="2395728" y="1956816"/>
+            <a:ext cx="1920240" cy="713232"/>
           </a:xfrm>
           <a:prstGeom prst="rect">
             <a:avLst/>
@@ -2402,12 +2409,12 @@
           <a:p>
             <a:pPr algn="l" indent="0" marL="0">
               <a:lnSpc>
-                <a:spcPct val="102000"/>
+                <a:spcPct val="100000"/>
               </a:lnSpc>
               <a:buNone/>
             </a:pPr>
             <a:r>
-              <a:rPr lang="en-US" sz="900" b="1" spc="100" kern="0" dirty="0">
+              <a:rPr lang="en-US" sz="850" b="1" spc="100" kern="0" dirty="0">
                 <a:solidFill>
                   <a:srgbClr val="2E5AAC"/>
                 </a:solidFill>
@@ -2415,17 +2422,16 @@
                 <a:ea typeface="Arial" pitchFamily="34" charset="-122"/>
                 <a:cs typeface="Arial" pitchFamily="34" charset="-120"/>
               </a:rPr>
-              <a:t>MAPPER
-</a:t>
+              <a:t>MAPPER  </a:t>
             </a:r>
             <a:pPr algn="l" indent="0" marL="0">
               <a:lnSpc>
-                <a:spcPct val="102000"/>
+                <a:spcPct val="100000"/>
               </a:lnSpc>
               <a:buNone/>
             </a:pPr>
             <a:r>
-              <a:rPr lang="en-US" sz="950" dirty="0">
+              <a:rPr lang="en-US" sz="900" dirty="0">
                 <a:solidFill>
                   <a:srgbClr val="253044"/>
                 </a:solidFill>
@@ -2433,19 +2439,19 @@
                 <a:ea typeface="Arial" pitchFamily="34" charset="-122"/>
                 <a:cs typeface="Arial" pitchFamily="34" charset="-120"/>
               </a:rPr>
-              <a:t>key = (trạm, giờ)</a:t>
-            </a:r>
-            <a:endParaRPr lang="en-US" sz="900" dirty="0"/>
+              <a:t>key=(trạm,giờ)</a:t>
+            </a:r>
+            <a:endParaRPr lang="en-US" sz="850" dirty="0"/>
           </a:p>
           <a:p>
             <a:pPr algn="l" indent="0" marL="0">
               <a:lnSpc>
-                <a:spcPct val="102000"/>
+                <a:spcPct val="100000"/>
               </a:lnSpc>
               <a:buNone/>
             </a:pPr>
             <a:r>
-              <a:rPr lang="en-US" sz="950" dirty="0">
+              <a:rPr lang="en-US" sz="900" dirty="0">
                 <a:solidFill>
                   <a:srgbClr val="253044"/>
                 </a:solidFill>
@@ -2453,9 +2459,9 @@
                 <a:ea typeface="Arial" pitchFamily="34" charset="-122"/>
                 <a:cs typeface="Arial" pitchFamily="34" charset="-120"/>
               </a:rPr>
-              <a:t>value = bản ghi thô</a:t>
-            </a:r>
-            <a:endParaRPr lang="en-US" sz="900" dirty="0"/>
+              <a:t>bản ghi thô</a:t>
+            </a:r>
+            <a:endParaRPr lang="en-US" sz="850" dirty="0"/>
           </a:p>
         </p:txBody>
       </p:sp>
@@ -2467,12 +2473,12 @@
         </p:nvSpPr>
         <p:spPr>
           <a:xfrm>
-            <a:off x="2414016" y="3438144"/>
-            <a:ext cx="2112264" cy="1207008"/>
+            <a:off x="2322576" y="2743200"/>
+            <a:ext cx="2066544" cy="749808"/>
           </a:xfrm>
           <a:prstGeom prst="roundRect">
             <a:avLst>
-              <a:gd name="adj" fmla="val 3788"/>
+              <a:gd name="adj" fmla="val 6098"/>
             </a:avLst>
           </a:prstGeom>
           <a:solidFill>
@@ -2494,8 +2500,8 @@
         </p:nvSpPr>
         <p:spPr>
           <a:xfrm>
-            <a:off x="2487168" y="3474720"/>
-            <a:ext cx="1965960" cy="1133856"/>
+            <a:off x="2395728" y="2761488"/>
+            <a:ext cx="1920240" cy="713232"/>
           </a:xfrm>
           <a:prstGeom prst="rect">
             <a:avLst/>
@@ -2509,12 +2515,12 @@
           <a:p>
             <a:pPr algn="l" indent="0" marL="0">
               <a:lnSpc>
-                <a:spcPct val="102000"/>
+                <a:spcPct val="100000"/>
               </a:lnSpc>
               <a:buNone/>
             </a:pPr>
             <a:r>
-              <a:rPr lang="en-US" sz="900" b="1" spc="100" kern="0" dirty="0">
+              <a:rPr lang="en-US" sz="850" b="1" spc="100" kern="0" dirty="0">
                 <a:solidFill>
                   <a:srgbClr val="C06A1E"/>
                 </a:solidFill>
@@ -2522,17 +2528,16 @@
                 <a:ea typeface="Arial" pitchFamily="34" charset="-122"/>
                 <a:cs typeface="Arial" pitchFamily="34" charset="-120"/>
               </a:rPr>
-              <a:t>REDUCER
-</a:t>
+              <a:t>REDUCER  </a:t>
             </a:r>
             <a:pPr algn="l" indent="0" marL="0">
               <a:lnSpc>
-                <a:spcPct val="102000"/>
+                <a:spcPct val="100000"/>
               </a:lnSpc>
               <a:buNone/>
             </a:pPr>
             <a:r>
-              <a:rPr lang="en-US" sz="950" dirty="0">
+              <a:rPr lang="en-US" sz="900" dirty="0">
                 <a:solidFill>
                   <a:srgbClr val="253044"/>
                 </a:solidFill>
@@ -2540,9 +2545,9 @@
                 <a:ea typeface="Arial" pitchFamily="34" charset="-122"/>
                 <a:cs typeface="Arial" pitchFamily="34" charset="-120"/>
               </a:rPr>
-              <a:t>khử trùng lặp · loại ngoại lai · nội suy khe ≤ 3h</a:t>
-            </a:r>
-            <a:endParaRPr lang="en-US" sz="900" dirty="0"/>
+              <a:t>khử trùng lặp · loại ngoại lai · nội suy ≤3h</a:t>
+            </a:r>
+            <a:endParaRPr lang="en-US" sz="850" dirty="0"/>
           </a:p>
         </p:txBody>
       </p:sp>
@@ -2554,8 +2559,8 @@
         </p:nvSpPr>
         <p:spPr>
           <a:xfrm>
-            <a:off x="2304288" y="4700016"/>
-            <a:ext cx="2331720" cy="384048"/>
+            <a:off x="2212848" y="3529584"/>
+            <a:ext cx="2286000" cy="292608"/>
           </a:xfrm>
           <a:prstGeom prst="rect">
             <a:avLst/>
@@ -2571,7 +2576,7 @@
               <a:buNone/>
             </a:pPr>
             <a:r>
-              <a:rPr lang="en-US" sz="1050" b="1" dirty="0">
+              <a:rPr lang="en-US" sz="1000" b="1" dirty="0">
                 <a:solidFill>
                   <a:srgbClr val="2E9BA6"/>
                 </a:solidFill>
@@ -2581,7 +2586,7 @@
               </a:rPr>
               <a:t>↓  /clean</a:t>
             </a:r>
-            <a:endParaRPr lang="en-US" sz="1050" dirty="0"/>
+            <a:endParaRPr lang="en-US" sz="1000" dirty="0"/>
           </a:p>
         </p:txBody>
       </p:sp>
@@ -2593,8 +2598,8 @@
         </p:nvSpPr>
         <p:spPr>
           <a:xfrm>
-            <a:off x="4654296" y="3310128"/>
-            <a:ext cx="274320" cy="237744"/>
+            <a:off x="4517136" y="2487168"/>
+            <a:ext cx="256032" cy="219456"/>
           </a:xfrm>
           <a:prstGeom prst="rightArrow">
             <a:avLst/>
@@ -2613,12 +2618,12 @@
         </p:nvSpPr>
         <p:spPr>
           <a:xfrm>
-            <a:off x="4928616" y="1572768"/>
-            <a:ext cx="2331720" cy="3566160"/>
+            <a:off x="4791456" y="1444752"/>
+            <a:ext cx="2286000" cy="2432304"/>
           </a:xfrm>
           <a:prstGeom prst="roundRect">
             <a:avLst>
-              <a:gd name="adj" fmla="val 2745"/>
+              <a:gd name="adj" fmla="val 2800"/>
             </a:avLst>
           </a:prstGeom>
           <a:solidFill>
@@ -2647,12 +2652,12 @@
         </p:nvSpPr>
         <p:spPr>
           <a:xfrm>
-            <a:off x="4928616" y="1572768"/>
-            <a:ext cx="2331720" cy="475488"/>
+            <a:off x="4791456" y="1444752"/>
+            <a:ext cx="2286000" cy="420624"/>
           </a:xfrm>
           <a:prstGeom prst="roundRect">
             <a:avLst>
-              <a:gd name="adj" fmla="val 15385"/>
+              <a:gd name="adj" fmla="val 17391"/>
             </a:avLst>
           </a:prstGeom>
           <a:solidFill>
@@ -2669,8 +2674,8 @@
         </p:nvSpPr>
         <p:spPr>
           <a:xfrm>
-            <a:off x="4928616" y="1572768"/>
-            <a:ext cx="2331720" cy="475488"/>
+            <a:off x="4791456" y="1444752"/>
+            <a:ext cx="2286000" cy="420624"/>
           </a:xfrm>
           <a:prstGeom prst="rect">
             <a:avLst/>
@@ -2686,7 +2691,7 @@
               <a:buNone/>
             </a:pPr>
             <a:r>
-              <a:rPr lang="en-US" sz="1250" b="1" dirty="0">
+              <a:rPr lang="en-US" sz="1200" b="1" dirty="0">
                 <a:solidFill>
                   <a:srgbClr val="FFFFFF"/>
                 </a:solidFill>
@@ -2696,7 +2701,7 @@
               </a:rPr>
               <a:t>PHA 2 · Tính AQI</a:t>
             </a:r>
-            <a:endParaRPr lang="en-US" sz="1250" dirty="0"/>
+            <a:endParaRPr lang="en-US" sz="1200" dirty="0"/>
           </a:p>
         </p:txBody>
       </p:sp>
@@ -2708,12 +2713,12 @@
         </p:nvSpPr>
         <p:spPr>
           <a:xfrm>
-            <a:off x="5038344" y="2157984"/>
-            <a:ext cx="2112264" cy="1207008"/>
+            <a:off x="4901184" y="1938528"/>
+            <a:ext cx="2066544" cy="749808"/>
           </a:xfrm>
           <a:prstGeom prst="roundRect">
             <a:avLst>
-              <a:gd name="adj" fmla="val 3788"/>
+              <a:gd name="adj" fmla="val 6098"/>
             </a:avLst>
           </a:prstGeom>
           <a:solidFill>
@@ -2735,8 +2740,8 @@
         </p:nvSpPr>
         <p:spPr>
           <a:xfrm>
-            <a:off x="5111496" y="2194560"/>
-            <a:ext cx="1965960" cy="1133856"/>
+            <a:off x="4974336" y="1956816"/>
+            <a:ext cx="1920240" cy="713232"/>
           </a:xfrm>
           <a:prstGeom prst="rect">
             <a:avLst/>
@@ -2750,12 +2755,12 @@
           <a:p>
             <a:pPr algn="l" indent="0" marL="0">
               <a:lnSpc>
-                <a:spcPct val="102000"/>
+                <a:spcPct val="100000"/>
               </a:lnSpc>
               <a:buNone/>
             </a:pPr>
             <a:r>
-              <a:rPr lang="en-US" sz="900" b="1" spc="100" kern="0" dirty="0">
+              <a:rPr lang="en-US" sz="850" b="1" spc="100" kern="0" dirty="0">
                 <a:solidFill>
                   <a:srgbClr val="2E5AAC"/>
                 </a:solidFill>
@@ -2763,17 +2768,16 @@
                 <a:ea typeface="Arial" pitchFamily="34" charset="-122"/>
                 <a:cs typeface="Arial" pitchFamily="34" charset="-120"/>
               </a:rPr>
-              <a:t>MAPPER
-</a:t>
+              <a:t>MAPPER  </a:t>
             </a:r>
             <a:pPr algn="l" indent="0" marL="0">
               <a:lnSpc>
-                <a:spcPct val="102000"/>
+                <a:spcPct val="100000"/>
               </a:lnSpc>
               <a:buNone/>
             </a:pPr>
             <a:r>
-              <a:rPr lang="en-US" sz="950" dirty="0">
+              <a:rPr lang="en-US" sz="900" dirty="0">
                 <a:solidFill>
                   <a:srgbClr val="253044"/>
                 </a:solidFill>
@@ -2783,17 +2787,17 @@
               </a:rPr>
               <a:t>IAQI từng chất</a:t>
             </a:r>
-            <a:endParaRPr lang="en-US" sz="900" dirty="0"/>
+            <a:endParaRPr lang="en-US" sz="850" dirty="0"/>
           </a:p>
           <a:p>
             <a:pPr algn="l" indent="0" marL="0">
               <a:lnSpc>
-                <a:spcPct val="102000"/>
+                <a:spcPct val="100000"/>
               </a:lnSpc>
               <a:buNone/>
             </a:pPr>
             <a:r>
-              <a:rPr lang="en-US" sz="950" dirty="0">
+              <a:rPr lang="en-US" sz="900" dirty="0">
                 <a:solidFill>
                   <a:srgbClr val="253044"/>
                 </a:solidFill>
@@ -2801,9 +2805,9 @@
                 <a:ea typeface="Arial" pitchFamily="34" charset="-122"/>
                 <a:cs typeface="Arial" pitchFamily="34" charset="-120"/>
               </a:rPr>
-              <a:t>(NowCast 12h cho PM)</a:t>
-            </a:r>
-            <a:endParaRPr lang="en-US" sz="900" dirty="0"/>
+              <a:t>(NowCast 12h PM)</a:t>
+            </a:r>
+            <a:endParaRPr lang="en-US" sz="850" dirty="0"/>
           </a:p>
         </p:txBody>
       </p:sp>
@@ -2815,12 +2819,12 @@
         </p:nvSpPr>
         <p:spPr>
           <a:xfrm>
-            <a:off x="5038344" y="3438144"/>
-            <a:ext cx="2112264" cy="1207008"/>
+            <a:off x="4901184" y="2743200"/>
+            <a:ext cx="2066544" cy="749808"/>
           </a:xfrm>
           <a:prstGeom prst="roundRect">
             <a:avLst>
-              <a:gd name="adj" fmla="val 3788"/>
+              <a:gd name="adj" fmla="val 6098"/>
             </a:avLst>
           </a:prstGeom>
           <a:solidFill>
@@ -2842,8 +2846,8 @@
         </p:nvSpPr>
         <p:spPr>
           <a:xfrm>
-            <a:off x="5111496" y="3474720"/>
-            <a:ext cx="1965960" cy="1133856"/>
+            <a:off x="4974336" y="2761488"/>
+            <a:ext cx="1920240" cy="713232"/>
           </a:xfrm>
           <a:prstGeom prst="rect">
             <a:avLst/>
@@ -2857,12 +2861,12 @@
           <a:p>
             <a:pPr algn="l" indent="0" marL="0">
               <a:lnSpc>
-                <a:spcPct val="102000"/>
+                <a:spcPct val="100000"/>
               </a:lnSpc>
               <a:buNone/>
             </a:pPr>
             <a:r>
-              <a:rPr lang="en-US" sz="900" b="1" spc="100" kern="0" dirty="0">
+              <a:rPr lang="en-US" sz="850" b="1" spc="100" kern="0" dirty="0">
                 <a:solidFill>
                   <a:srgbClr val="C06A1E"/>
                 </a:solidFill>
@@ -2870,17 +2874,16 @@
                 <a:ea typeface="Arial" pitchFamily="34" charset="-122"/>
                 <a:cs typeface="Arial" pitchFamily="34" charset="-120"/>
               </a:rPr>
-              <a:t>REDUCER
-</a:t>
+              <a:t>REDUCER  </a:t>
             </a:r>
             <a:pPr algn="l" indent="0" marL="0">
               <a:lnSpc>
-                <a:spcPct val="102000"/>
+                <a:spcPct val="100000"/>
               </a:lnSpc>
               <a:buNone/>
             </a:pPr>
             <a:r>
-              <a:rPr lang="en-US" sz="950" dirty="0">
+              <a:rPr lang="en-US" sz="900" dirty="0">
                 <a:solidFill>
                   <a:srgbClr val="253044"/>
                 </a:solidFill>
@@ -2888,19 +2891,19 @@
                 <a:ea typeface="Arial" pitchFamily="34" charset="-122"/>
                 <a:cs typeface="Arial" pitchFamily="34" charset="-120"/>
               </a:rPr>
-              <a:t>AQI = max(IAQI)</a:t>
-            </a:r>
-            <a:endParaRPr lang="en-US" sz="900" dirty="0"/>
+              <a:t>AQI=max(IAQI)</a:t>
+            </a:r>
+            <a:endParaRPr lang="en-US" sz="850" dirty="0"/>
           </a:p>
           <a:p>
             <a:pPr algn="l" indent="0" marL="0">
               <a:lnSpc>
-                <a:spcPct val="102000"/>
+                <a:spcPct val="100000"/>
               </a:lnSpc>
               <a:buNone/>
             </a:pPr>
             <a:r>
-              <a:rPr lang="en-US" sz="950" dirty="0">
+              <a:rPr lang="en-US" sz="900" dirty="0">
                 <a:solidFill>
                   <a:srgbClr val="253044"/>
                 </a:solidFill>
@@ -2908,9 +2911,9 @@
                 <a:ea typeface="Arial" pitchFamily="34" charset="-122"/>
                 <a:cs typeface="Arial" pitchFamily="34" charset="-120"/>
               </a:rPr>
-              <a:t>gán mức + chất trội</a:t>
-            </a:r>
-            <a:endParaRPr lang="en-US" sz="900" dirty="0"/>
+              <a:t>gán mức+chất trội</a:t>
+            </a:r>
+            <a:endParaRPr lang="en-US" sz="850" dirty="0"/>
           </a:p>
         </p:txBody>
       </p:sp>
@@ -2922,8 +2925,8 @@
         </p:nvSpPr>
         <p:spPr>
           <a:xfrm>
-            <a:off x="4928616" y="4700016"/>
-            <a:ext cx="2331720" cy="384048"/>
+            <a:off x="4791456" y="3529584"/>
+            <a:ext cx="2286000" cy="292608"/>
           </a:xfrm>
           <a:prstGeom prst="rect">
             <a:avLst/>
@@ -2939,7 +2942,7 @@
               <a:buNone/>
             </a:pPr>
             <a:r>
-              <a:rPr lang="en-US" sz="1050" b="1" dirty="0">
+              <a:rPr lang="en-US" sz="1000" b="1" dirty="0">
                 <a:solidFill>
                   <a:srgbClr val="2E5AAC"/>
                 </a:solidFill>
@@ -2949,7 +2952,7 @@
               </a:rPr>
               <a:t>↓  /aqi</a:t>
             </a:r>
-            <a:endParaRPr lang="en-US" sz="1050" dirty="0"/>
+            <a:endParaRPr lang="en-US" sz="1000" dirty="0"/>
           </a:p>
         </p:txBody>
       </p:sp>
@@ -2961,8 +2964,8 @@
         </p:nvSpPr>
         <p:spPr>
           <a:xfrm>
-            <a:off x="7278624" y="3310128"/>
-            <a:ext cx="274320" cy="237744"/>
+            <a:off x="7095744" y="2487168"/>
+            <a:ext cx="256032" cy="219456"/>
           </a:xfrm>
           <a:prstGeom prst="rightArrow">
             <a:avLst/>
@@ -2981,12 +2984,12 @@
         </p:nvSpPr>
         <p:spPr>
           <a:xfrm>
-            <a:off x="7552944" y="1572768"/>
-            <a:ext cx="2331720" cy="3566160"/>
+            <a:off x="7370064" y="1444752"/>
+            <a:ext cx="2286000" cy="2432304"/>
           </a:xfrm>
           <a:prstGeom prst="roundRect">
             <a:avLst>
-              <a:gd name="adj" fmla="val 2745"/>
+              <a:gd name="adj" fmla="val 2800"/>
             </a:avLst>
           </a:prstGeom>
           <a:solidFill>
@@ -3015,12 +3018,12 @@
         </p:nvSpPr>
         <p:spPr>
           <a:xfrm>
-            <a:off x="7552944" y="1572768"/>
-            <a:ext cx="2331720" cy="475488"/>
+            <a:off x="7370064" y="1444752"/>
+            <a:ext cx="2286000" cy="420624"/>
           </a:xfrm>
           <a:prstGeom prst="roundRect">
             <a:avLst>
-              <a:gd name="adj" fmla="val 15385"/>
+              <a:gd name="adj" fmla="val 17391"/>
             </a:avLst>
           </a:prstGeom>
           <a:solidFill>
@@ -3037,8 +3040,8 @@
         </p:nvSpPr>
         <p:spPr>
           <a:xfrm>
-            <a:off x="7552944" y="1572768"/>
-            <a:ext cx="2331720" cy="475488"/>
+            <a:off x="7370064" y="1444752"/>
+            <a:ext cx="2286000" cy="420624"/>
           </a:xfrm>
           <a:prstGeom prst="rect">
             <a:avLst/>
@@ -3054,7 +3057,7 @@
               <a:buNone/>
             </a:pPr>
             <a:r>
-              <a:rPr lang="en-US" sz="1250" b="1" dirty="0">
+              <a:rPr lang="en-US" sz="1200" b="1" dirty="0">
                 <a:solidFill>
                   <a:srgbClr val="FFFFFF"/>
                 </a:solidFill>
@@ -3064,7 +3067,7 @@
               </a:rPr>
               <a:t>PHA 3 · Tổng hợp</a:t>
             </a:r>
-            <a:endParaRPr lang="en-US" sz="1250" dirty="0"/>
+            <a:endParaRPr lang="en-US" sz="1200" dirty="0"/>
           </a:p>
         </p:txBody>
       </p:sp>
@@ -3076,12 +3079,12 @@
         </p:nvSpPr>
         <p:spPr>
           <a:xfrm>
-            <a:off x="7662672" y="2157984"/>
-            <a:ext cx="2112264" cy="1207008"/>
+            <a:off x="7479792" y="1938528"/>
+            <a:ext cx="2066544" cy="749808"/>
           </a:xfrm>
           <a:prstGeom prst="roundRect">
             <a:avLst>
-              <a:gd name="adj" fmla="val 3788"/>
+              <a:gd name="adj" fmla="val 6098"/>
             </a:avLst>
           </a:prstGeom>
           <a:solidFill>
@@ -3103,8 +3106,8 @@
         </p:nvSpPr>
         <p:spPr>
           <a:xfrm>
-            <a:off x="7735824" y="2194560"/>
-            <a:ext cx="1965960" cy="1133856"/>
+            <a:off x="7552944" y="1956816"/>
+            <a:ext cx="1920240" cy="713232"/>
           </a:xfrm>
           <a:prstGeom prst="rect">
             <a:avLst/>
@@ -3118,12 +3121,12 @@
           <a:p>
             <a:pPr algn="l" indent="0" marL="0">
               <a:lnSpc>
-                <a:spcPct val="102000"/>
+                <a:spcPct val="100000"/>
               </a:lnSpc>
               <a:buNone/>
             </a:pPr>
             <a:r>
-              <a:rPr lang="en-US" sz="900" b="1" spc="100" kern="0" dirty="0">
+              <a:rPr lang="en-US" sz="850" b="1" spc="100" kern="0" dirty="0">
                 <a:solidFill>
                   <a:srgbClr val="2E5AAC"/>
                 </a:solidFill>
@@ -3131,17 +3134,16 @@
                 <a:ea typeface="Arial" pitchFamily="34" charset="-122"/>
                 <a:cs typeface="Arial" pitchFamily="34" charset="-120"/>
               </a:rPr>
-              <a:t>MAPPER
-</a:t>
+              <a:t>MAPPER  </a:t>
             </a:r>
             <a:pPr algn="l" indent="0" marL="0">
               <a:lnSpc>
-                <a:spcPct val="102000"/>
+                <a:spcPct val="100000"/>
               </a:lnSpc>
               <a:buNone/>
             </a:pPr>
             <a:r>
-              <a:rPr lang="en-US" sz="950" dirty="0">
+              <a:rPr lang="en-US" sz="900" dirty="0">
                 <a:solidFill>
                   <a:srgbClr val="253044"/>
                 </a:solidFill>
@@ -3149,29 +3151,9 @@
                 <a:ea typeface="Arial" pitchFamily="34" charset="-122"/>
                 <a:cs typeface="Arial" pitchFamily="34" charset="-120"/>
               </a:rPr>
-              <a:t>key = (thành phố, ngày)</a:t>
-            </a:r>
-            <a:endParaRPr lang="en-US" sz="900" dirty="0"/>
-          </a:p>
-          <a:p>
-            <a:pPr algn="l" indent="0" marL="0">
-              <a:lnSpc>
-                <a:spcPct val="102000"/>
-              </a:lnSpc>
-              <a:buNone/>
-            </a:pPr>
-            <a:r>
-              <a:rPr lang="en-US" sz="950" dirty="0">
-                <a:solidFill>
-                  <a:srgbClr val="253044"/>
-                </a:solidFill>
-                <a:latin typeface="Arial" pitchFamily="34" charset="0"/>
-                <a:ea typeface="Arial" pitchFamily="34" charset="-122"/>
-                <a:cs typeface="Arial" pitchFamily="34" charset="-120"/>
-              </a:rPr>
-              <a:t>value = AQI</a:t>
-            </a:r>
-            <a:endParaRPr lang="en-US" sz="900" dirty="0"/>
+              <a:t>key=(thành phố,ngày)</a:t>
+            </a:r>
+            <a:endParaRPr lang="en-US" sz="850" dirty="0"/>
           </a:p>
         </p:txBody>
       </p:sp>
@@ -3183,12 +3165,12 @@
         </p:nvSpPr>
         <p:spPr>
           <a:xfrm>
-            <a:off x="7662672" y="3438144"/>
-            <a:ext cx="2112264" cy="1207008"/>
+            <a:off x="7479792" y="2743200"/>
+            <a:ext cx="2066544" cy="749808"/>
           </a:xfrm>
           <a:prstGeom prst="roundRect">
             <a:avLst>
-              <a:gd name="adj" fmla="val 3788"/>
+              <a:gd name="adj" fmla="val 6098"/>
             </a:avLst>
           </a:prstGeom>
           <a:solidFill>
@@ -3210,8 +3192,8 @@
         </p:nvSpPr>
         <p:spPr>
           <a:xfrm>
-            <a:off x="7735824" y="3474720"/>
-            <a:ext cx="1965960" cy="1133856"/>
+            <a:off x="7552944" y="2761488"/>
+            <a:ext cx="1920240" cy="713232"/>
           </a:xfrm>
           <a:prstGeom prst="rect">
             <a:avLst/>
@@ -3225,12 +3207,12 @@
           <a:p>
             <a:pPr algn="l" indent="0" marL="0">
               <a:lnSpc>
-                <a:spcPct val="102000"/>
+                <a:spcPct val="100000"/>
               </a:lnSpc>
               <a:buNone/>
             </a:pPr>
             <a:r>
-              <a:rPr lang="en-US" sz="900" b="1" spc="100" kern="0" dirty="0">
+              <a:rPr lang="en-US" sz="850" b="1" spc="100" kern="0" dirty="0">
                 <a:solidFill>
                   <a:srgbClr val="C06A1E"/>
                 </a:solidFill>
@@ -3238,17 +3220,16 @@
                 <a:ea typeface="Arial" pitchFamily="34" charset="-122"/>
                 <a:cs typeface="Arial" pitchFamily="34" charset="-120"/>
               </a:rPr>
-              <a:t>REDUCER
-</a:t>
+              <a:t>REDUCER  </a:t>
             </a:r>
             <a:pPr algn="l" indent="0" marL="0">
               <a:lnSpc>
-                <a:spcPct val="102000"/>
+                <a:spcPct val="100000"/>
               </a:lnSpc>
               <a:buNone/>
             </a:pPr>
             <a:r>
-              <a:rPr lang="en-US" sz="950" dirty="0">
+              <a:rPr lang="en-US" sz="900" dirty="0">
                 <a:solidFill>
                   <a:srgbClr val="253044"/>
                 </a:solidFill>
@@ -3258,7 +3239,7 @@
               </a:rPr>
               <a:t>trung bình/max · đếm mức · xếp hạng</a:t>
             </a:r>
-            <a:endParaRPr lang="en-US" sz="900" dirty="0"/>
+            <a:endParaRPr lang="en-US" sz="850" dirty="0"/>
           </a:p>
         </p:txBody>
       </p:sp>
@@ -3270,8 +3251,8 @@
         </p:nvSpPr>
         <p:spPr>
           <a:xfrm>
-            <a:off x="7552944" y="4700016"/>
-            <a:ext cx="2331720" cy="384048"/>
+            <a:off x="7370064" y="3529584"/>
+            <a:ext cx="2286000" cy="292608"/>
           </a:xfrm>
           <a:prstGeom prst="rect">
             <a:avLst/>
@@ -3287,7 +3268,7 @@
               <a:buNone/>
             </a:pPr>
             <a:r>
-              <a:rPr lang="en-US" sz="1050" b="1" dirty="0">
+              <a:rPr lang="en-US" sz="1000" b="1" dirty="0">
                 <a:solidFill>
                   <a:srgbClr val="4F9D5D"/>
                 </a:solidFill>
@@ -3297,7 +3278,7 @@
               </a:rPr>
               <a:t>↓  /agg · HBase</a:t>
             </a:r>
-            <a:endParaRPr lang="en-US" sz="1050" dirty="0"/>
+            <a:endParaRPr lang="en-US" sz="1000" dirty="0"/>
           </a:p>
         </p:txBody>
       </p:sp>
@@ -3309,8 +3290,8 @@
         </p:nvSpPr>
         <p:spPr>
           <a:xfrm>
-            <a:off x="9902952" y="3310128"/>
-            <a:ext cx="274320" cy="237744"/>
+            <a:off x="9674352" y="2487168"/>
+            <a:ext cx="256032" cy="219456"/>
           </a:xfrm>
           <a:prstGeom prst="rightArrow">
             <a:avLst/>
@@ -3329,12 +3310,12 @@
         </p:nvSpPr>
         <p:spPr>
           <a:xfrm>
-            <a:off x="10177272" y="2761488"/>
-            <a:ext cx="1554480" cy="1325880"/>
+            <a:off x="9930384" y="1444752"/>
+            <a:ext cx="1801368" cy="4315968"/>
           </a:xfrm>
           <a:prstGeom prst="roundRect">
             <a:avLst>
-              <a:gd name="adj" fmla="val 5517"/>
+              <a:gd name="adj" fmla="val 4061"/>
             </a:avLst>
           </a:prstGeom>
           <a:solidFill>
@@ -3358,8 +3339,8 @@
         </p:nvSpPr>
         <p:spPr>
           <a:xfrm>
-            <a:off x="10177272" y="2761488"/>
-            <a:ext cx="1554480" cy="1325880"/>
+            <a:off x="9930384" y="2194560"/>
+            <a:ext cx="1801368" cy="1188720"/>
           </a:xfrm>
           <a:prstGeom prst="rect">
             <a:avLst/>
@@ -3373,12 +3354,12 @@
           <a:p>
             <a:pPr algn="ctr" indent="0" marL="0">
               <a:lnSpc>
-                <a:spcPct val="105000"/>
+                <a:spcPct val="110000"/>
               </a:lnSpc>
               <a:buNone/>
             </a:pPr>
             <a:r>
-              <a:rPr lang="en-US" sz="1150" b="1" dirty="0">
+              <a:rPr lang="en-US" sz="1200" b="1" dirty="0">
                 <a:solidFill>
                   <a:srgbClr val="FFFFFF"/>
                 </a:solidFill>
@@ -3391,32 +3372,34 @@
             </a:r>
             <a:pPr algn="ctr" indent="0" marL="0">
               <a:lnSpc>
-                <a:spcPct val="105000"/>
+                <a:spcPct val="110000"/>
               </a:lnSpc>
               <a:buNone/>
             </a:pPr>
             <a:r>
               <a:rPr lang="en-US" sz="1000" dirty="0">
                 <a:solidFill>
-                  <a:srgbClr val="FFFFFF"/>
-                </a:solidFill>
-                <a:latin typeface="Arial" pitchFamily="34" charset="0"/>
-                <a:ea typeface="Arial" pitchFamily="34" charset="-122"/>
-                <a:cs typeface="Arial" pitchFamily="34" charset="-120"/>
-              </a:rPr>
-              <a:t>HBase
-</a:t>
-            </a:r>
+                  <a:srgbClr val="CFE0F5"/>
+                </a:solidFill>
+                <a:latin typeface="Arial" pitchFamily="34" charset="0"/>
+                <a:ea typeface="Arial" pitchFamily="34" charset="-122"/>
+                <a:cs typeface="Arial" pitchFamily="34" charset="-120"/>
+              </a:rPr>
+              <a:t>HBase</a:t>
+            </a:r>
+            <a:endParaRPr lang="en-US" sz="1200" dirty="0"/>
+          </a:p>
+          <a:p>
             <a:pPr algn="ctr" indent="0" marL="0">
               <a:lnSpc>
-                <a:spcPct val="105000"/>
+                <a:spcPct val="110000"/>
               </a:lnSpc>
               <a:buNone/>
             </a:pPr>
             <a:r>
               <a:rPr lang="en-US" sz="1000" dirty="0">
                 <a:solidFill>
-                  <a:srgbClr val="FFFFFF"/>
+                  <a:srgbClr val="CFE0F5"/>
                 </a:solidFill>
                 <a:latin typeface="Arial" pitchFamily="34" charset="0"/>
                 <a:ea typeface="Arial" pitchFamily="34" charset="-122"/>
@@ -3424,7 +3407,7 @@
               </a:rPr>
               <a:t>→ Dashboard</a:t>
             </a:r>
-            <a:endParaRPr lang="en-US" sz="1150" dirty="0"/>
+            <a:endParaRPr lang="en-US" sz="1200" dirty="0"/>
           </a:p>
         </p:txBody>
       </p:sp>
@@ -3436,20 +3419,106 @@
         </p:nvSpPr>
         <p:spPr>
           <a:xfrm>
-            <a:off x="457200" y="5230368"/>
-            <a:ext cx="11274552" cy="896112"/>
+            <a:off x="2212848" y="4114800"/>
+            <a:ext cx="7443216" cy="1627632"/>
           </a:xfrm>
           <a:prstGeom prst="roundRect">
             <a:avLst>
-              <a:gd name="adj" fmla="val 7143"/>
+              <a:gd name="adj" fmla="val 4494"/>
             </a:avLst>
           </a:prstGeom>
           <a:solidFill>
-            <a:srgbClr val="E9F0FB"/>
+            <a:srgbClr val="FAFBFE"/>
           </a:solidFill>
-          <a:ln w="12700">
+          <a:ln w="15875">
             <a:solidFill>
-              <a:srgbClr val="D6DEEA"/>
+              <a:srgbClr val="7A5BA6"/>
+            </a:solidFill>
+            <a:prstDash val="dash"/>
+          </a:ln>
+        </p:spPr>
+      </p:sp>
+      <p:sp>
+        <p:nvSpPr>
+          <p:cNvPr id="40" name="Text 38"/>
+          <p:cNvSpPr txBox="1"/>
+          <p:nvPr/>
+        </p:nvSpPr>
+        <p:spPr>
+          <a:xfrm>
+            <a:off x="2377440" y="4169664"/>
+            <a:ext cx="7132320" cy="292608"/>
+          </a:xfrm>
+          <a:prstGeom prst="rect">
+            <a:avLst/>
+          </a:prstGeom>
+          <a:noFill/>
+          <a:ln/>
+        </p:spPr>
+        <p:txBody>
+          <a:bodyPr wrap="square" lIns="0" tIns="0" rIns="0" bIns="0" rtlCol="0" anchor="ctr"/>
+          <a:lstStyle/>
+          <a:p>
+            <a:pPr indent="0" marL="0">
+              <a:buNone/>
+            </a:pPr>
+            <a:r>
+              <a:rPr lang="en-US" sz="1050" b="1" dirty="0">
+                <a:solidFill>
+                  <a:srgbClr val="7A5BA6"/>
+                </a:solidFill>
+                <a:latin typeface="Arial" pitchFamily="34" charset="0"/>
+                <a:ea typeface="Arial" pitchFamily="34" charset="-122"/>
+                <a:cs typeface="Arial" pitchFamily="34" charset="-120"/>
+              </a:rPr>
+              <a:t>MỞ RỘNG · ngoài lõi — chạy trên /aqi, máy tự chọn mô hình</a:t>
+            </a:r>
+            <a:endParaRPr lang="en-US" sz="1050" dirty="0"/>
+          </a:p>
+        </p:txBody>
+      </p:sp>
+      <p:sp>
+        <p:nvSpPr>
+          <p:cNvPr id="41" name="Shape 39"/>
+          <p:cNvSpPr/>
+          <p:nvPr/>
+        </p:nvSpPr>
+        <p:spPr>
+          <a:xfrm>
+            <a:off x="5824728" y="3840480"/>
+            <a:ext cx="219456" cy="256032"/>
+          </a:xfrm>
+          <a:prstGeom prst="downArrow">
+            <a:avLst/>
+          </a:prstGeom>
+          <a:solidFill>
+            <a:srgbClr val="7A5BA6"/>
+          </a:solidFill>
+          <a:ln/>
+        </p:spPr>
+      </p:sp>
+      <p:sp>
+        <p:nvSpPr>
+          <p:cNvPr id="42" name="Shape 40"/>
+          <p:cNvSpPr/>
+          <p:nvPr/>
+        </p:nvSpPr>
+        <p:spPr>
+          <a:xfrm>
+            <a:off x="2432304" y="4572000"/>
+            <a:ext cx="3520440" cy="1024128"/>
+          </a:xfrm>
+          <a:prstGeom prst="roundRect">
+            <a:avLst>
+              <a:gd name="adj" fmla="val 5357"/>
+            </a:avLst>
+          </a:prstGeom>
+          <a:solidFill>
+            <a:srgbClr val="FFFFFF"/>
+          </a:solidFill>
+          <a:ln w="15240">
+            <a:solidFill>
+              <a:srgbClr val="7A5BA6"/>
             </a:solidFill>
             <a:prstDash val="solid"/>
           </a:ln>
@@ -3464,14 +3533,14 @@
       </p:sp>
       <p:sp>
         <p:nvSpPr>
-          <p:cNvPr id="40" name="Text 38"/>
+          <p:cNvPr id="43" name="Text 41"/>
           <p:cNvSpPr txBox="1"/>
           <p:nvPr/>
         </p:nvSpPr>
         <p:spPr>
           <a:xfrm>
-            <a:off x="777240" y="5230368"/>
-            <a:ext cx="10607040" cy="896112"/>
+            <a:off x="2569464" y="4572000"/>
+            <a:ext cx="3246120" cy="1024128"/>
           </a:xfrm>
           <a:prstGeom prst="rect">
             <a:avLst/>
@@ -3480,14 +3549,228 @@
           <a:ln/>
         </p:spPr>
         <p:txBody>
-          <a:bodyPr wrap="square" rtlCol="0" anchor="ctr"/>
+          <a:bodyPr wrap="square" lIns="25400" tIns="25400" rIns="25400" bIns="25400" rtlCol="0" anchor="ctr"/>
+          <a:lstStyle/>
+          <a:p>
+            <a:pPr algn="l" indent="0" marL="0">
+              <a:lnSpc>
+                <a:spcPct val="105000"/>
+              </a:lnSpc>
+              <a:buNone/>
+            </a:pPr>
+            <a:r>
+              <a:rPr lang="en-US" sz="1200" b="1" dirty="0">
+                <a:solidFill>
+                  <a:srgbClr val="7A5BA6"/>
+                </a:solidFill>
+                <a:latin typeface="Arial" pitchFamily="34" charset="0"/>
+                <a:ea typeface="Arial" pitchFamily="34" charset="-122"/>
+                <a:cs typeface="Arial" pitchFamily="34" charset="-120"/>
+              </a:rPr>
+              <a:t>Phân cụm vùng
+</a:t>
+            </a:r>
+            <a:pPr algn="l" indent="0" marL="0">
+              <a:lnSpc>
+                <a:spcPct val="105000"/>
+              </a:lnSpc>
+              <a:buNone/>
+            </a:pPr>
+            <a:r>
+              <a:rPr lang="en-US" sz="950" dirty="0">
+                <a:solidFill>
+                  <a:srgbClr val="253044"/>
+                </a:solidFill>
+                <a:latin typeface="Arial" pitchFamily="34" charset="0"/>
+                <a:ea typeface="Arial" pitchFamily="34" charset="-122"/>
+                <a:cs typeface="Arial" pitchFamily="34" charset="-120"/>
+              </a:rPr>
+              <a:t>5 thuật toán · chọn theo silhouette</a:t>
+            </a:r>
+            <a:endParaRPr lang="en-US" sz="1200" dirty="0"/>
+          </a:p>
+          <a:p>
+            <a:pPr algn="l" indent="0" marL="0">
+              <a:lnSpc>
+                <a:spcPct val="105000"/>
+              </a:lnSpc>
+              <a:buNone/>
+            </a:pPr>
+            <a:r>
+              <a:rPr lang="en-US" sz="950" dirty="0">
+                <a:solidFill>
+                  <a:srgbClr val="253044"/>
+                </a:solidFill>
+                <a:latin typeface="Arial" pitchFamily="34" charset="0"/>
+                <a:ea typeface="Arial" pitchFamily="34" charset="-122"/>
+                <a:cs typeface="Arial" pitchFamily="34" charset="-120"/>
+              </a:rPr>
+              <a:t>→ K-means, k=3 (0,3547)</a:t>
+            </a:r>
+            <a:endParaRPr lang="en-US" sz="1200" dirty="0"/>
+          </a:p>
+        </p:txBody>
+      </p:sp>
+      <p:sp>
+        <p:nvSpPr>
+          <p:cNvPr id="44" name="Shape 42"/>
+          <p:cNvSpPr/>
+          <p:nvPr/>
+        </p:nvSpPr>
+        <p:spPr>
+          <a:xfrm>
+            <a:off x="6053328" y="4572000"/>
+            <a:ext cx="3474720" cy="1024128"/>
+          </a:xfrm>
+          <a:prstGeom prst="roundRect">
+            <a:avLst>
+              <a:gd name="adj" fmla="val 5357"/>
+            </a:avLst>
+          </a:prstGeom>
+          <a:solidFill>
+            <a:srgbClr val="FFFFFF"/>
+          </a:solidFill>
+          <a:ln w="15240">
+            <a:solidFill>
+              <a:srgbClr val="2E9BA6"/>
+            </a:solidFill>
+            <a:prstDash val="solid"/>
+          </a:ln>
+          <a:effectLst>
+            <a:outerShdw sx="100000" sy="100000" kx="0" ky="0" algn="bl" rotWithShape="0" blurRad="88900" dist="25400" dir="5400000">
+              <a:srgbClr val="9AA6B8">
+                <a:alpha val="32000"/>
+              </a:srgbClr>
+            </a:outerShdw>
+          </a:effectLst>
+        </p:spPr>
+      </p:sp>
+      <p:sp>
+        <p:nvSpPr>
+          <p:cNvPr id="45" name="Text 43"/>
+          <p:cNvSpPr txBox="1"/>
+          <p:nvPr/>
+        </p:nvSpPr>
+        <p:spPr>
+          <a:xfrm>
+            <a:off x="6190488" y="4572000"/>
+            <a:ext cx="3200400" cy="1024128"/>
+          </a:xfrm>
+          <a:prstGeom prst="rect">
+            <a:avLst/>
+          </a:prstGeom>
+          <a:noFill/>
+          <a:ln/>
+        </p:spPr>
+        <p:txBody>
+          <a:bodyPr wrap="square" lIns="25400" tIns="25400" rIns="25400" bIns="25400" rtlCol="0" anchor="ctr"/>
+          <a:lstStyle/>
+          <a:p>
+            <a:pPr algn="l" indent="0" marL="0">
+              <a:lnSpc>
+                <a:spcPct val="105000"/>
+              </a:lnSpc>
+              <a:buNone/>
+            </a:pPr>
+            <a:r>
+              <a:rPr lang="en-US" sz="1200" b="1" dirty="0">
+                <a:solidFill>
+                  <a:srgbClr val="2E9BA6"/>
+                </a:solidFill>
+                <a:latin typeface="Arial" pitchFamily="34" charset="0"/>
+                <a:ea typeface="Arial" pitchFamily="34" charset="-122"/>
+                <a:cs typeface="Arial" pitchFamily="34" charset="-120"/>
+              </a:rPr>
+              <a:t>Dự báo AQI 24h
+</a:t>
+            </a:r>
+            <a:pPr algn="l" indent="0" marL="0">
+              <a:lnSpc>
+                <a:spcPct val="105000"/>
+              </a:lnSpc>
+              <a:buNone/>
+            </a:pPr>
+            <a:r>
+              <a:rPr lang="en-US" sz="950" dirty="0">
+                <a:solidFill>
+                  <a:srgbClr val="253044"/>
+                </a:solidFill>
+                <a:latin typeface="Arial" pitchFamily="34" charset="0"/>
+                <a:ea typeface="Arial" pitchFamily="34" charset="-122"/>
+                <a:cs typeface="Arial" pitchFamily="34" charset="-120"/>
+              </a:rPr>
+              <a:t>SGD · Random Forest · CNN-LSTM</a:t>
+            </a:r>
+            <a:endParaRPr lang="en-US" sz="1200" dirty="0"/>
+          </a:p>
+          <a:p>
+            <a:pPr algn="l" indent="0" marL="0">
+              <a:lnSpc>
+                <a:spcPct val="105000"/>
+              </a:lnSpc>
+              <a:buNone/>
+            </a:pPr>
+            <a:r>
+              <a:rPr lang="en-US" sz="950" dirty="0">
+                <a:solidFill>
+                  <a:srgbClr val="253044"/>
+                </a:solidFill>
+                <a:latin typeface="Arial" pitchFamily="34" charset="0"/>
+                <a:ea typeface="Arial" pitchFamily="34" charset="-122"/>
+                <a:cs typeface="Arial" pitchFamily="34" charset="-120"/>
+              </a:rPr>
+              <a:t>→ Random Forest (RMSE 20,10)</a:t>
+            </a:r>
+            <a:endParaRPr lang="en-US" sz="1200" dirty="0"/>
+          </a:p>
+        </p:txBody>
+      </p:sp>
+      <p:sp>
+        <p:nvSpPr>
+          <p:cNvPr id="46" name="Shape 44"/>
+          <p:cNvSpPr/>
+          <p:nvPr/>
+        </p:nvSpPr>
+        <p:spPr>
+          <a:xfrm>
+            <a:off x="9674352" y="4974336"/>
+            <a:ext cx="256032" cy="219456"/>
+          </a:xfrm>
+          <a:prstGeom prst="rightArrow">
+            <a:avLst/>
+          </a:prstGeom>
+          <a:solidFill>
+            <a:srgbClr val="7A5BA6"/>
+          </a:solidFill>
+          <a:ln/>
+        </p:spPr>
+      </p:sp>
+      <p:sp>
+        <p:nvSpPr>
+          <p:cNvPr id="47" name="Text 45"/>
+          <p:cNvSpPr txBox="1"/>
+          <p:nvPr/>
+        </p:nvSpPr>
+        <p:spPr>
+          <a:xfrm>
+            <a:off x="457200" y="5852160"/>
+            <a:ext cx="9326880" cy="320040"/>
+          </a:xfrm>
+          <a:prstGeom prst="rect">
+            <a:avLst/>
+          </a:prstGeom>
+          <a:noFill/>
+          <a:ln/>
+        </p:spPr>
+        <p:txBody>
+          <a:bodyPr wrap="square" lIns="0" tIns="0" rIns="0" bIns="0" rtlCol="0" anchor="ctr"/>
           <a:lstStyle/>
           <a:p>
             <a:pPr indent="0" marL="0">
               <a:buNone/>
             </a:pPr>
             <a:r>
-              <a:rPr lang="en-US" sz="1250" b="1" dirty="0">
+              <a:rPr lang="en-US" sz="1100" b="1" dirty="0">
                 <a:solidFill>
                   <a:srgbClr val="1F3864"/>
                 </a:solidFill>
@@ -3501,17 +3784,17 @@
               <a:buNone/>
             </a:pPr>
             <a:r>
-              <a:rPr lang="en-US" sz="1250" dirty="0">
-                <a:solidFill>
-                  <a:srgbClr val="253044"/>
-                </a:solidFill>
-                <a:latin typeface="Arial" pitchFamily="34" charset="0"/>
-                <a:ea typeface="Arial" pitchFamily="34" charset="-122"/>
-                <a:cs typeface="Arial" pitchFamily="34" charset="-120"/>
-              </a:rPr>
-              <a:t>Mô hình MapReduce, cài bằng Spark; batch &amp; streaming dùng chung lõi aqi_core nên không lệch kết quả.</a:t>
-            </a:r>
-            <a:endParaRPr lang="en-US" sz="1250" dirty="0"/>
+              <a:rPr lang="en-US" sz="1100" dirty="0">
+                <a:solidFill>
+                  <a:srgbClr val="6B7280"/>
+                </a:solidFill>
+                <a:latin typeface="Arial" pitchFamily="34" charset="0"/>
+                <a:ea typeface="Arial" pitchFamily="34" charset="-122"/>
+                <a:cs typeface="Arial" pitchFamily="34" charset="-120"/>
+              </a:rPr>
+              <a:t>MapReduce cài bằng Spark; batch &amp; streaming dùng chung lõi aqi_core.</a:t>
+            </a:r>
+            <a:endParaRPr lang="en-US" sz="1100" dirty="0"/>
           </a:p>
         </p:txBody>
       </p:sp>

</xml_diff>

<commit_message>
docs: slide Huyền - ghi rõ 3 tầng trong sơ đồ + thêm slide 3.6 bảng kết quả mở rộng
- Sơ đồ 3.1: 2 ô nhánh mở rộng ghi rõ 3 tầng (T1/T2/T3) và mô hình thắng.
- Thêm slide 3.6: bảng phân cụm (5 thuật toán, gạch K-means k=3) và bảng
  dự báo (SGD/RF/CNN-LSTM, gạch Random Forest), kèm nhận xét.

Co-Authored-By: Claude Opus 4.8 <noreply@anthropic.com>
Claude-Session: https://claude.ai/code/session_01FrxD6iyiu71sw2RmUtSxFy
</commit_message>
<xml_diff>
--- a/docs/slides/Slide_Huyen_theo_mau.pptx
+++ b/docs/slides/Slide_Huyen_theo_mau.pptx
@@ -11,9 +11,10 @@
     <p:sldId id="259" r:id="rId5"/>
     <p:sldId id="260" r:id="rId6"/>
     <p:sldId id="261" r:id="rId7"/>
+    <p:sldId id="262" r:id="rId8"/>
   </p:sldIdLst>
   <p:notesMasterIdLst>
-    <p:notesMasterId r:id="rId8"/>
+    <p:notesMasterId r:id="rId9"/>
   </p:notesMasterIdLst>
   <p:sldSz cx="12192000" cy="6858000"/>
   <p:notesSz cx="6858000" cy="12192000"/>
@@ -971,6 +972,94 @@
             <a:fld id="{F7021451-1387-4CA6-816F-3879F97B5CBC}" type="slidenum">
               <a:rPr lang="en-US"/>
               <a:t>6</a:t>
+            </a:fld>
+            <a:endParaRPr lang="en-US"/>
+          </a:p>
+        </p:txBody>
+      </p:sp>
+    </p:spTree>
+    <p:extLst>
+      <p:ext uri="{BB962C8B-B14F-4D97-AF65-F5344CB8AC3E}">
+        <p14:creationId xmlns:p14="http://schemas.microsoft.com/office/powerpoint/2010/main" val="1024086991"/>
+      </p:ext>
+    </p:extLst>
+  </p:cSld>
+  <p:clrMapOvr>
+    <a:masterClrMapping/>
+  </p:clrMapOvr>
+</p:notes>
+</file>
+
+<file path=ppt/notesSlides/notesSlide7.xml><?xml version="1.0" encoding="utf-8"?>
+<p:notes xmlns:a="http://schemas.openxmlformats.org/drawingml/2006/main" xmlns:r="http://schemas.openxmlformats.org/officeDocument/2006/relationships" xmlns:p="http://schemas.openxmlformats.org/presentationml/2006/main">
+  <p:cSld>
+    <p:spTree>
+      <p:nvGrpSpPr>
+        <p:cNvPr id="1" name=""/>
+        <p:cNvGrpSpPr/>
+        <p:nvPr/>
+      </p:nvGrpSpPr>
+      <p:grpSpPr>
+        <a:xfrm>
+          <a:off x="0" y="0"/>
+          <a:ext cx="0" cy="0"/>
+          <a:chOff x="0" y="0"/>
+          <a:chExt cx="0" cy="0"/>
+        </a:xfrm>
+      </p:grpSpPr>
+      <p:sp>
+        <p:nvSpPr>
+          <p:cNvPr id="2" name="Slide Image Placeholder 1"/>
+          <p:cNvSpPr>
+            <a:spLocks noGrp="1" noRot="1" noChangeAspect="1"/>
+          </p:cNvSpPr>
+          <p:nvPr>
+            <p:ph type="sldImg"/>
+          </p:nvPr>
+        </p:nvSpPr>
+        <p:spPr/>
+      </p:sp>
+      <p:sp>
+        <p:nvSpPr>
+          <p:cNvPr id="3" name="Notes Placeholder 2"/>
+          <p:cNvSpPr>
+            <a:spLocks noGrp="1"/>
+          </p:cNvSpPr>
+          <p:nvPr>
+            <p:ph type="body" idx="1"/>
+          </p:nvPr>
+        </p:nvSpPr>
+        <p:spPr/>
+        <p:txBody>
+          <a:bodyPr/>
+          <a:lstStyle/>
+          <a:p>
+            <a:r>
+              <a:rPr lang="en-US" dirty="0"/>
+              <a:t>Nhánh mở rộng — máy tự chọn. Phân cụm: 5 thuật toán 3 tầng, chọn theo silhouette → K-means k=3 (0,3547), thắng sát Bisecting, HDBSCAN loại, cấu trúc yếu. Dự báo: 3 tầng SGD/Random Forest/CNN-LSTM, chọn theo RMSE/R² → Random Forest (20,10; 0,7297); SGD thắng MAE; CNN-LSTM ít mẫu test.</a:t>
+            </a:r>
+            <a:endParaRPr lang="en-US" dirty="0"/>
+          </a:p>
+        </p:txBody>
+      </p:sp>
+      <p:sp>
+        <p:nvSpPr>
+          <p:cNvPr id="4" name="Slide Number Placeholder 3"/>
+          <p:cNvSpPr>
+            <a:spLocks noGrp="1"/>
+          </p:cNvSpPr>
+          <p:nvPr>
+            <p:ph type="sldNum" sz="quarter" idx="10"/>
+          </p:nvPr>
+        </p:nvSpPr>
+        <p:spPr/>
+        <p:txBody>
+          <a:bodyPr/>
+          <a:lstStyle/>
+          <a:p>
+            <a:fld id="{F7021451-1387-4CA6-816F-3879F97B5CBC}" type="slidenum">
+              <a:rPr lang="en-US"/>
+              <a:t>7</a:t>
             </a:fld>
             <a:endParaRPr lang="en-US"/>
           </a:p>
@@ -3585,7 +3674,7 @@
                 <a:ea typeface="Arial" pitchFamily="34" charset="-122"/>
                 <a:cs typeface="Arial" pitchFamily="34" charset="-120"/>
               </a:rPr>
-              <a:t>5 thuật toán · chọn theo silhouette</a:t>
+              <a:t>T1 K-means · T2 GMM, Bisecting KM · T3 DBSCAN, HDBSCAN</a:t>
             </a:r>
             <a:endParaRPr lang="en-US" sz="1200" dirty="0"/>
           </a:p>
@@ -3605,7 +3694,7 @@
                 <a:ea typeface="Arial" pitchFamily="34" charset="-122"/>
                 <a:cs typeface="Arial" pitchFamily="34" charset="-120"/>
               </a:rPr>
-              <a:t>→ K-means, k=3 (0,3547)</a:t>
+              <a:t>→ thắng: K-means k=3 (silhouette 0,3547)</a:t>
             </a:r>
             <a:endParaRPr lang="en-US" sz="1200" dirty="0"/>
           </a:p>
@@ -3699,7 +3788,7 @@
                 <a:ea typeface="Arial" pitchFamily="34" charset="-122"/>
                 <a:cs typeface="Arial" pitchFamily="34" charset="-120"/>
               </a:rPr>
-              <a:t>SGD · Random Forest · CNN-LSTM</a:t>
+              <a:t>T1 SGD · T2 Random Forest · T3 CNN-LSTM</a:t>
             </a:r>
             <a:endParaRPr lang="en-US" sz="1200" dirty="0"/>
           </a:p>
@@ -3719,7 +3808,7 @@
                 <a:ea typeface="Arial" pitchFamily="34" charset="-122"/>
                 <a:cs typeface="Arial" pitchFamily="34" charset="-120"/>
               </a:rPr>
-              <a:t>→ Random Forest (RMSE 20,10)</a:t>
+              <a:t>→ thắng: Random Forest (RMSE 20,10; R² 0,73)</a:t>
             </a:r>
             <a:endParaRPr lang="en-US" sz="1200" dirty="0"/>
           </a:p>
@@ -8675,6 +8764,3547 @@
                 <a:cs typeface="Arial" pitchFamily="34" charset="-120"/>
               </a:rPr>
               <a:t>100K: 4 exec còn chậm hơn 2 exec (overhead lấn át). Dưới tuyến tính do Python UDF serialize + shuffle. Hạn chế: 4 worker trên MỘT máy Docker — chưa phải cụm nhiều node.</a:t>
+            </a:r>
+            <a:endParaRPr lang="en-US" sz="1250" dirty="0"/>
+          </a:p>
+        </p:txBody>
+      </p:sp>
+    </p:spTree>
+  </p:cSld>
+  <p:clrMapOvr>
+    <a:masterClrMapping/>
+  </p:clrMapOvr>
+</p:sld>
+</file>
+
+<file path=ppt/slides/slide7.xml><?xml version="1.0" encoding="utf-8"?>
+<p:sld xmlns:a="http://schemas.openxmlformats.org/drawingml/2006/main" xmlns:r="http://schemas.openxmlformats.org/officeDocument/2006/relationships" xmlns:p="http://schemas.openxmlformats.org/presentationml/2006/main">
+  <p:cSld name="Slide 7">
+    <p:bg>
+      <p:bgPr>
+        <a:solidFill>
+          <a:srgbClr val="FFFFFF"/>
+        </a:solidFill>
+      </p:bgPr>
+    </p:bg>
+    <p:spTree>
+      <p:nvGrpSpPr>
+        <p:cNvPr id="1" name=""/>
+        <p:cNvGrpSpPr/>
+        <p:nvPr/>
+      </p:nvGrpSpPr>
+      <p:grpSpPr>
+        <a:xfrm>
+          <a:off x="0" y="0"/>
+          <a:ext cx="0" cy="0"/>
+          <a:chOff x="0" y="0"/>
+          <a:chExt cx="0" cy="0"/>
+        </a:xfrm>
+      </p:grpSpPr>
+      <p:sp>
+        <p:nvSpPr>
+          <p:cNvPr id="2" name="Text 0"/>
+          <p:cNvSpPr txBox="1"/>
+          <p:nvPr/>
+        </p:nvSpPr>
+        <p:spPr>
+          <a:xfrm>
+            <a:off x="457200" y="6492240"/>
+            <a:ext cx="8229600" cy="274320"/>
+          </a:xfrm>
+          <a:prstGeom prst="rect">
+            <a:avLst/>
+          </a:prstGeom>
+          <a:noFill/>
+          <a:ln/>
+        </p:spPr>
+        <p:txBody>
+          <a:bodyPr wrap="square" lIns="0" tIns="0" rIns="0" bIns="0" rtlCol="0" anchor="ctr"/>
+          <a:lstStyle/>
+          <a:p>
+            <a:pPr indent="0" marL="0">
+              <a:buNone/>
+            </a:pPr>
+            <a:r>
+              <a:rPr lang="en-US" sz="900" dirty="0">
+                <a:solidFill>
+                  <a:srgbClr val="9AA6B8"/>
+                </a:solidFill>
+                <a:latin typeface="Arial" pitchFamily="34" charset="0"/>
+                <a:ea typeface="Arial" pitchFamily="34" charset="-122"/>
+                <a:cs typeface="Arial" pitchFamily="34" charset="-120"/>
+              </a:rPr>
+              <a:t>Trường Đại học Công nghệ Thông tin, ĐHQG-HCM</a:t>
+            </a:r>
+            <a:endParaRPr lang="en-US" sz="900" dirty="0"/>
+          </a:p>
+        </p:txBody>
+      </p:sp>
+      <p:sp>
+        <p:nvSpPr>
+          <p:cNvPr id="3" name="Text 1"/>
+          <p:cNvSpPr txBox="1"/>
+          <p:nvPr/>
+        </p:nvSpPr>
+        <p:spPr>
+          <a:xfrm>
+            <a:off x="11368735" y="6492240"/>
+            <a:ext cx="365760" cy="274320"/>
+          </a:xfrm>
+          <a:prstGeom prst="rect">
+            <a:avLst/>
+          </a:prstGeom>
+          <a:noFill/>
+          <a:ln/>
+        </p:spPr>
+        <p:txBody>
+          <a:bodyPr wrap="square" lIns="0" tIns="0" rIns="0" bIns="0" rtlCol="0" anchor="ctr"/>
+          <a:lstStyle/>
+          <a:p>
+            <a:pPr algn="r" indent="0" marL="0">
+              <a:buNone/>
+            </a:pPr>
+            <a:r>
+              <a:rPr lang="en-US" sz="900" dirty="0">
+                <a:solidFill>
+                  <a:srgbClr val="9AA6B8"/>
+                </a:solidFill>
+                <a:latin typeface="Arial" pitchFamily="34" charset="0"/>
+                <a:ea typeface="Arial" pitchFamily="34" charset="-122"/>
+                <a:cs typeface="Arial" pitchFamily="34" charset="-120"/>
+              </a:rPr>
+              <a:t>7</a:t>
+            </a:r>
+            <a:endParaRPr lang="en-US" sz="900" dirty="0"/>
+          </a:p>
+        </p:txBody>
+      </p:sp>
+      <p:sp>
+        <p:nvSpPr>
+          <p:cNvPr id="4" name="Shape 2"/>
+          <p:cNvSpPr/>
+          <p:nvPr/>
+        </p:nvSpPr>
+        <p:spPr>
+          <a:xfrm>
+            <a:off x="548640" y="457200"/>
+            <a:ext cx="128016" cy="566928"/>
+          </a:xfrm>
+          <a:prstGeom prst="rect">
+            <a:avLst/>
+          </a:prstGeom>
+          <a:solidFill>
+            <a:srgbClr val="2E5AAC"/>
+          </a:solidFill>
+          <a:ln/>
+        </p:spPr>
+      </p:sp>
+      <p:sp>
+        <p:nvSpPr>
+          <p:cNvPr id="5" name="Text 3"/>
+          <p:cNvSpPr txBox="1"/>
+          <p:nvPr/>
+        </p:nvSpPr>
+        <p:spPr>
+          <a:xfrm>
+            <a:off x="777240" y="402336"/>
+            <a:ext cx="10881360" cy="566928"/>
+          </a:xfrm>
+          <a:prstGeom prst="rect">
+            <a:avLst/>
+          </a:prstGeom>
+          <a:noFill/>
+          <a:ln/>
+        </p:spPr>
+        <p:txBody>
+          <a:bodyPr wrap="square" rtlCol="0" anchor="ctr"/>
+          <a:lstStyle/>
+          <a:p>
+            <a:pPr indent="0" marL="0">
+              <a:buNone/>
+            </a:pPr>
+            <a:r>
+              <a:rPr lang="en-US" sz="2300" b="1" dirty="0">
+                <a:solidFill>
+                  <a:srgbClr val="2E5AAC"/>
+                </a:solidFill>
+                <a:latin typeface="Arial" pitchFamily="34" charset="0"/>
+                <a:ea typeface="Arial" pitchFamily="34" charset="-122"/>
+                <a:cs typeface="Arial" pitchFamily="34" charset="-120"/>
+              </a:rPr>
+              <a:t>3.6   </a:t>
+            </a:r>
+            <a:pPr indent="0" marL="0">
+              <a:buNone/>
+            </a:pPr>
+            <a:r>
+              <a:rPr lang="en-US" sz="2300" b="1" dirty="0">
+                <a:solidFill>
+                  <a:srgbClr val="1F3864"/>
+                </a:solidFill>
+                <a:latin typeface="Arial" pitchFamily="34" charset="0"/>
+                <a:ea typeface="Arial" pitchFamily="34" charset="-122"/>
+                <a:cs typeface="Arial" pitchFamily="34" charset="-120"/>
+              </a:rPr>
+              <a:t>Nhánh mở rộng — máy tự chọn mô hình</a:t>
+            </a:r>
+            <a:endParaRPr lang="en-US" sz="2300" dirty="0"/>
+          </a:p>
+        </p:txBody>
+      </p:sp>
+      <p:sp>
+        <p:nvSpPr>
+          <p:cNvPr id="6" name="Text 4"/>
+          <p:cNvSpPr txBox="1"/>
+          <p:nvPr/>
+        </p:nvSpPr>
+        <p:spPr>
+          <a:xfrm>
+            <a:off x="777240" y="1024128"/>
+            <a:ext cx="10881360" cy="365760"/>
+          </a:xfrm>
+          <a:prstGeom prst="rect">
+            <a:avLst/>
+          </a:prstGeom>
+          <a:noFill/>
+          <a:ln/>
+        </p:spPr>
+        <p:txBody>
+          <a:bodyPr wrap="square" rtlCol="0" anchor="ctr"/>
+          <a:lstStyle/>
+          <a:p>
+            <a:pPr indent="0" marL="0">
+              <a:buNone/>
+            </a:pPr>
+            <a:r>
+              <a:rPr lang="en-US" sz="1350" i="1" dirty="0">
+                <a:solidFill>
+                  <a:srgbClr val="6B7280"/>
+                </a:solidFill>
+                <a:latin typeface="Arial" pitchFamily="34" charset="0"/>
+                <a:ea typeface="Arial" pitchFamily="34" charset="-122"/>
+                <a:cs typeface="Arial" pitchFamily="34" charset="-120"/>
+              </a:rPr>
+              <a:t>Chạy nhiều mô hình theo 3 tầng, chọn tự động: phân cụm theo silhouette, dự báo theo RMSE/R².</a:t>
+            </a:r>
+            <a:endParaRPr lang="en-US" sz="1350" dirty="0"/>
+          </a:p>
+        </p:txBody>
+      </p:sp>
+      <p:sp>
+        <p:nvSpPr>
+          <p:cNvPr id="7" name="Text 5"/>
+          <p:cNvSpPr txBox="1"/>
+          <p:nvPr/>
+        </p:nvSpPr>
+        <p:spPr>
+          <a:xfrm>
+            <a:off x="548640" y="1481328"/>
+            <a:ext cx="5577840" cy="320040"/>
+          </a:xfrm>
+          <a:prstGeom prst="rect">
+            <a:avLst/>
+          </a:prstGeom>
+          <a:noFill/>
+          <a:ln/>
+        </p:spPr>
+        <p:txBody>
+          <a:bodyPr wrap="square" rtlCol="0" anchor="ctr"/>
+          <a:lstStyle/>
+          <a:p>
+            <a:pPr indent="0" marL="0">
+              <a:buNone/>
+            </a:pPr>
+            <a:r>
+              <a:rPr lang="en-US" sz="1400" b="1" dirty="0">
+                <a:solidFill>
+                  <a:srgbClr val="7A5BA6"/>
+                </a:solidFill>
+                <a:latin typeface="Arial" pitchFamily="34" charset="0"/>
+                <a:ea typeface="Arial" pitchFamily="34" charset="-122"/>
+                <a:cs typeface="Arial" pitchFamily="34" charset="-120"/>
+              </a:rPr>
+              <a:t>Phân cụm vùng  </a:t>
+            </a:r>
+            <a:pPr indent="0" marL="0">
+              <a:buNone/>
+            </a:pPr>
+            <a:r>
+              <a:rPr lang="en-US" sz="1100" dirty="0">
+                <a:solidFill>
+                  <a:srgbClr val="6B7280"/>
+                </a:solidFill>
+                <a:latin typeface="Arial" pitchFamily="34" charset="0"/>
+                <a:ea typeface="Arial" pitchFamily="34" charset="-122"/>
+                <a:cs typeface="Arial" pitchFamily="34" charset="-120"/>
+              </a:rPr>
+              <a:t>· 2.400 điểm (thành phố × tháng)</a:t>
+            </a:r>
+            <a:endParaRPr lang="en-US" sz="1400" dirty="0"/>
+          </a:p>
+        </p:txBody>
+      </p:sp>
+      <p:graphicFrame>
+        <p:nvGraphicFramePr>
+          <p:cNvPr id="8" name="Table 0"/>
+          <p:cNvGraphicFramePr>
+            <a:graphicFrameLocks noGrp="1"/>
+          </p:cNvGraphicFramePr>
+          <p:nvPr>
+            <p:extLst>
+              <p:ext uri="{D42A27DB-BD31-4B8C-83A1-F6EECF244321}">
+                <p14:modId xmlns:p14="http://schemas.microsoft.com/office/powerpoint/2010/main" val="1579011935"/>
+              </p:ext>
+            </p:extLst>
+          </p:nvPr>
+        </p:nvGraphicFramePr>
+        <p:xfrm>
+          <a:off x="548640" y="1828800"/>
+          <a:ext cx="5577840" cy="914400"/>
+        </p:xfrm>
+        <a:graphic>
+          <a:graphicData uri="http://schemas.openxmlformats.org/drawingml/2006/table">
+            <a:tbl>
+              <a:tblPr/>
+              <a:tblGrid>
+                <a:gridCol w="2423160"/>
+                <a:gridCol w="685800"/>
+                <a:gridCol w="822960"/>
+                <a:gridCol w="1645920"/>
+              </a:tblGrid>
+              <a:tr h="457200">
+                <a:tc>
+                  <a:txBody>
+                    <a:bodyPr/>
+                    <a:lstStyle/>
+                    <a:p>
+                      <a:pPr algn="ctr" indent="0" marL="0">
+                        <a:buNone/>
+                      </a:pPr>
+                      <a:r>
+                        <a:rPr lang="en-US" sz="1150" b="1" dirty="0">
+                          <a:solidFill>
+                            <a:srgbClr val="FFFFFF"/>
+                          </a:solidFill>
+                          <a:latin typeface="Arial" pitchFamily="34" charset="0"/>
+                          <a:ea typeface="Arial" pitchFamily="34" charset="-122"/>
+                          <a:cs typeface="Arial" pitchFamily="34" charset="-120"/>
+                        </a:rPr>
+                        <a:t>Thuật toán</a:t>
+                      </a:r>
+                      <a:endParaRPr lang="en-US" sz="1150" dirty="0">
+                        <a:latin typeface="Arial" charset="0"/>
+                        <a:ea typeface="Arial" charset="0"/>
+                        <a:cs typeface="Arial" charset="0"/>
+                      </a:endParaRPr>
+                    </a:p>
+                  </a:txBody>
+                  <a:tcPr marL="50800" marR="50800" marT="50800" marB="50800" anchor="ctr">
+                    <a:lnL w="12700" cap="flat" cmpd="sng" algn="ctr">
+                      <a:solidFill>
+                        <a:srgbClr val="D6DEEA"/>
+                      </a:solidFill>
+                      <a:prstDash val="solid"/>
+                      <a:round/>
+                      <a:headEnd type="none" w="med" len="med"/>
+                      <a:tailEnd type="none" w="med" len="med"/>
+                    </a:lnL>
+                    <a:lnR w="12700" cap="flat" cmpd="sng" algn="ctr">
+                      <a:solidFill>
+                        <a:srgbClr val="D6DEEA"/>
+                      </a:solidFill>
+                      <a:prstDash val="solid"/>
+                      <a:round/>
+                      <a:headEnd type="none" w="med" len="med"/>
+                      <a:tailEnd type="none" w="med" len="med"/>
+                    </a:lnR>
+                    <a:lnT w="12700" cap="flat" cmpd="sng" algn="ctr">
+                      <a:solidFill>
+                        <a:srgbClr val="D6DEEA"/>
+                      </a:solidFill>
+                      <a:prstDash val="solid"/>
+                      <a:round/>
+                      <a:headEnd type="none" w="med" len="med"/>
+                      <a:tailEnd type="none" w="med" len="med"/>
+                    </a:lnT>
+                    <a:lnB w="12700" cap="flat" cmpd="sng" algn="ctr">
+                      <a:solidFill>
+                        <a:srgbClr val="D6DEEA"/>
+                      </a:solidFill>
+                      <a:prstDash val="solid"/>
+                      <a:round/>
+                      <a:headEnd type="none" w="med" len="med"/>
+                      <a:tailEnd type="none" w="med" len="med"/>
+                    </a:lnB>
+                    <a:solidFill>
+                      <a:srgbClr val="1F3864"/>
+                    </a:solidFill>
+                  </a:tcPr>
+                </a:tc>
+                <a:tc>
+                  <a:txBody>
+                    <a:bodyPr/>
+                    <a:lstStyle/>
+                    <a:p>
+                      <a:pPr algn="ctr" indent="0" marL="0">
+                        <a:buNone/>
+                      </a:pPr>
+                      <a:r>
+                        <a:rPr lang="en-US" sz="1150" b="1" dirty="0">
+                          <a:solidFill>
+                            <a:srgbClr val="FFFFFF"/>
+                          </a:solidFill>
+                          <a:latin typeface="Arial" pitchFamily="34" charset="0"/>
+                          <a:ea typeface="Arial" pitchFamily="34" charset="-122"/>
+                          <a:cs typeface="Arial" pitchFamily="34" charset="-120"/>
+                        </a:rPr>
+                        <a:t>Tầng</a:t>
+                      </a:r>
+                      <a:endParaRPr lang="en-US" sz="1150" dirty="0">
+                        <a:latin typeface="Arial" charset="0"/>
+                        <a:ea typeface="Arial" charset="0"/>
+                        <a:cs typeface="Arial" charset="0"/>
+                      </a:endParaRPr>
+                    </a:p>
+                  </a:txBody>
+                  <a:tcPr marL="50800" marR="50800" marT="50800" marB="50800" anchor="ctr">
+                    <a:lnL w="12700" cap="flat" cmpd="sng" algn="ctr">
+                      <a:solidFill>
+                        <a:srgbClr val="D6DEEA"/>
+                      </a:solidFill>
+                      <a:prstDash val="solid"/>
+                      <a:round/>
+                      <a:headEnd type="none" w="med" len="med"/>
+                      <a:tailEnd type="none" w="med" len="med"/>
+                    </a:lnL>
+                    <a:lnR w="12700" cap="flat" cmpd="sng" algn="ctr">
+                      <a:solidFill>
+                        <a:srgbClr val="D6DEEA"/>
+                      </a:solidFill>
+                      <a:prstDash val="solid"/>
+                      <a:round/>
+                      <a:headEnd type="none" w="med" len="med"/>
+                      <a:tailEnd type="none" w="med" len="med"/>
+                    </a:lnR>
+                    <a:lnT w="12700" cap="flat" cmpd="sng" algn="ctr">
+                      <a:solidFill>
+                        <a:srgbClr val="D6DEEA"/>
+                      </a:solidFill>
+                      <a:prstDash val="solid"/>
+                      <a:round/>
+                      <a:headEnd type="none" w="med" len="med"/>
+                      <a:tailEnd type="none" w="med" len="med"/>
+                    </a:lnT>
+                    <a:lnB w="12700" cap="flat" cmpd="sng" algn="ctr">
+                      <a:solidFill>
+                        <a:srgbClr val="D6DEEA"/>
+                      </a:solidFill>
+                      <a:prstDash val="solid"/>
+                      <a:round/>
+                      <a:headEnd type="none" w="med" len="med"/>
+                      <a:tailEnd type="none" w="med" len="med"/>
+                    </a:lnB>
+                    <a:solidFill>
+                      <a:srgbClr val="1F3864"/>
+                    </a:solidFill>
+                  </a:tcPr>
+                </a:tc>
+                <a:tc>
+                  <a:txBody>
+                    <a:bodyPr/>
+                    <a:lstStyle/>
+                    <a:p>
+                      <a:pPr algn="ctr" indent="0" marL="0">
+                        <a:buNone/>
+                      </a:pPr>
+                      <a:r>
+                        <a:rPr lang="en-US" sz="1150" b="1" dirty="0">
+                          <a:solidFill>
+                            <a:srgbClr val="FFFFFF"/>
+                          </a:solidFill>
+                          <a:latin typeface="Arial" pitchFamily="34" charset="0"/>
+                          <a:ea typeface="Arial" pitchFamily="34" charset="-122"/>
+                          <a:cs typeface="Arial" pitchFamily="34" charset="-120"/>
+                        </a:rPr>
+                        <a:t>Số cụm</a:t>
+                      </a:r>
+                      <a:endParaRPr lang="en-US" sz="1150" dirty="0">
+                        <a:latin typeface="Arial" charset="0"/>
+                        <a:ea typeface="Arial" charset="0"/>
+                        <a:cs typeface="Arial" charset="0"/>
+                      </a:endParaRPr>
+                    </a:p>
+                  </a:txBody>
+                  <a:tcPr marL="50800" marR="50800" marT="50800" marB="50800" anchor="ctr">
+                    <a:lnL w="12700" cap="flat" cmpd="sng" algn="ctr">
+                      <a:solidFill>
+                        <a:srgbClr val="D6DEEA"/>
+                      </a:solidFill>
+                      <a:prstDash val="solid"/>
+                      <a:round/>
+                      <a:headEnd type="none" w="med" len="med"/>
+                      <a:tailEnd type="none" w="med" len="med"/>
+                    </a:lnL>
+                    <a:lnR w="12700" cap="flat" cmpd="sng" algn="ctr">
+                      <a:solidFill>
+                        <a:srgbClr val="D6DEEA"/>
+                      </a:solidFill>
+                      <a:prstDash val="solid"/>
+                      <a:round/>
+                      <a:headEnd type="none" w="med" len="med"/>
+                      <a:tailEnd type="none" w="med" len="med"/>
+                    </a:lnR>
+                    <a:lnT w="12700" cap="flat" cmpd="sng" algn="ctr">
+                      <a:solidFill>
+                        <a:srgbClr val="D6DEEA"/>
+                      </a:solidFill>
+                      <a:prstDash val="solid"/>
+                      <a:round/>
+                      <a:headEnd type="none" w="med" len="med"/>
+                      <a:tailEnd type="none" w="med" len="med"/>
+                    </a:lnT>
+                    <a:lnB w="12700" cap="flat" cmpd="sng" algn="ctr">
+                      <a:solidFill>
+                        <a:srgbClr val="D6DEEA"/>
+                      </a:solidFill>
+                      <a:prstDash val="solid"/>
+                      <a:round/>
+                      <a:headEnd type="none" w="med" len="med"/>
+                      <a:tailEnd type="none" w="med" len="med"/>
+                    </a:lnB>
+                    <a:solidFill>
+                      <a:srgbClr val="1F3864"/>
+                    </a:solidFill>
+                  </a:tcPr>
+                </a:tc>
+                <a:tc>
+                  <a:txBody>
+                    <a:bodyPr/>
+                    <a:lstStyle/>
+                    <a:p>
+                      <a:pPr algn="ctr" indent="0" marL="0">
+                        <a:buNone/>
+                      </a:pPr>
+                      <a:r>
+                        <a:rPr lang="en-US" sz="1150" b="1" dirty="0">
+                          <a:solidFill>
+                            <a:srgbClr val="FFFFFF"/>
+                          </a:solidFill>
+                          <a:latin typeface="Arial" pitchFamily="34" charset="0"/>
+                          <a:ea typeface="Arial" pitchFamily="34" charset="-122"/>
+                          <a:cs typeface="Arial" pitchFamily="34" charset="-120"/>
+                        </a:rPr>
+                        <a:t>Silhouette</a:t>
+                      </a:r>
+                      <a:endParaRPr lang="en-US" sz="1150" dirty="0">
+                        <a:latin typeface="Arial" charset="0"/>
+                        <a:ea typeface="Arial" charset="0"/>
+                        <a:cs typeface="Arial" charset="0"/>
+                      </a:endParaRPr>
+                    </a:p>
+                  </a:txBody>
+                  <a:tcPr marL="50800" marR="50800" marT="50800" marB="50800" anchor="ctr">
+                    <a:lnL w="12700" cap="flat" cmpd="sng" algn="ctr">
+                      <a:solidFill>
+                        <a:srgbClr val="D6DEEA"/>
+                      </a:solidFill>
+                      <a:prstDash val="solid"/>
+                      <a:round/>
+                      <a:headEnd type="none" w="med" len="med"/>
+                      <a:tailEnd type="none" w="med" len="med"/>
+                    </a:lnL>
+                    <a:lnR w="12700" cap="flat" cmpd="sng" algn="ctr">
+                      <a:solidFill>
+                        <a:srgbClr val="D6DEEA"/>
+                      </a:solidFill>
+                      <a:prstDash val="solid"/>
+                      <a:round/>
+                      <a:headEnd type="none" w="med" len="med"/>
+                      <a:tailEnd type="none" w="med" len="med"/>
+                    </a:lnR>
+                    <a:lnT w="12700" cap="flat" cmpd="sng" algn="ctr">
+                      <a:solidFill>
+                        <a:srgbClr val="D6DEEA"/>
+                      </a:solidFill>
+                      <a:prstDash val="solid"/>
+                      <a:round/>
+                      <a:headEnd type="none" w="med" len="med"/>
+                      <a:tailEnd type="none" w="med" len="med"/>
+                    </a:lnT>
+                    <a:lnB w="12700" cap="flat" cmpd="sng" algn="ctr">
+                      <a:solidFill>
+                        <a:srgbClr val="D6DEEA"/>
+                      </a:solidFill>
+                      <a:prstDash val="solid"/>
+                      <a:round/>
+                      <a:headEnd type="none" w="med" len="med"/>
+                      <a:tailEnd type="none" w="med" len="med"/>
+                    </a:lnB>
+                    <a:solidFill>
+                      <a:srgbClr val="1F3864"/>
+                    </a:solidFill>
+                  </a:tcPr>
+                </a:tc>
+              </a:tr>
+              <a:tr h="457200">
+                <a:tc>
+                  <a:txBody>
+                    <a:bodyPr/>
+                    <a:lstStyle/>
+                    <a:p>
+                      <a:pPr algn="l" indent="0" marL="0">
+                        <a:buNone/>
+                      </a:pPr>
+                      <a:r>
+                        <a:rPr lang="en-US" sz="1150" b="1" dirty="0">
+                          <a:solidFill>
+                            <a:srgbClr val="253044"/>
+                          </a:solidFill>
+                          <a:latin typeface="Arial" pitchFamily="34" charset="0"/>
+                          <a:ea typeface="Arial" pitchFamily="34" charset="-122"/>
+                          <a:cs typeface="Arial" pitchFamily="34" charset="-120"/>
+                        </a:rPr>
+                        <a:t>K-means (k=3)  ★</a:t>
+                      </a:r>
+                      <a:endParaRPr lang="en-US" sz="1150" dirty="0">
+                        <a:latin typeface="Arial" charset="0"/>
+                        <a:ea typeface="Arial" charset="0"/>
+                        <a:cs typeface="Arial" charset="0"/>
+                      </a:endParaRPr>
+                    </a:p>
+                  </a:txBody>
+                  <a:tcPr marL="50800" marR="50800" marT="50800" marB="50800" anchor="ctr">
+                    <a:lnL w="12700" cap="flat" cmpd="sng" algn="ctr">
+                      <a:solidFill>
+                        <a:srgbClr val="D6DEEA"/>
+                      </a:solidFill>
+                      <a:prstDash val="solid"/>
+                      <a:round/>
+                      <a:headEnd type="none" w="med" len="med"/>
+                      <a:tailEnd type="none" w="med" len="med"/>
+                    </a:lnL>
+                    <a:lnR w="12700" cap="flat" cmpd="sng" algn="ctr">
+                      <a:solidFill>
+                        <a:srgbClr val="D6DEEA"/>
+                      </a:solidFill>
+                      <a:prstDash val="solid"/>
+                      <a:round/>
+                      <a:headEnd type="none" w="med" len="med"/>
+                      <a:tailEnd type="none" w="med" len="med"/>
+                    </a:lnR>
+                    <a:lnT w="12700" cap="flat" cmpd="sng" algn="ctr">
+                      <a:solidFill>
+                        <a:srgbClr val="D6DEEA"/>
+                      </a:solidFill>
+                      <a:prstDash val="solid"/>
+                      <a:round/>
+                      <a:headEnd type="none" w="med" len="med"/>
+                      <a:tailEnd type="none" w="med" len="med"/>
+                    </a:lnT>
+                    <a:lnB w="12700" cap="flat" cmpd="sng" algn="ctr">
+                      <a:solidFill>
+                        <a:srgbClr val="D6DEEA"/>
+                      </a:solidFill>
+                      <a:prstDash val="solid"/>
+                      <a:round/>
+                      <a:headEnd type="none" w="med" len="med"/>
+                      <a:tailEnd type="none" w="med" len="med"/>
+                    </a:lnB>
+                    <a:solidFill>
+                      <a:srgbClr val="F1E7FA"/>
+                    </a:solidFill>
+                  </a:tcPr>
+                </a:tc>
+                <a:tc>
+                  <a:txBody>
+                    <a:bodyPr/>
+                    <a:lstStyle/>
+                    <a:p>
+                      <a:pPr algn="ctr" indent="0" marL="0">
+                        <a:buNone/>
+                      </a:pPr>
+                      <a:r>
+                        <a:rPr lang="en-US" sz="1150" dirty="0">
+                          <a:solidFill>
+                            <a:srgbClr val="253044"/>
+                          </a:solidFill>
+                          <a:latin typeface="Arial" pitchFamily="34" charset="0"/>
+                          <a:ea typeface="Arial" pitchFamily="34" charset="-122"/>
+                          <a:cs typeface="Arial" pitchFamily="34" charset="-120"/>
+                        </a:rPr>
+                        <a:t>1</a:t>
+                      </a:r>
+                      <a:endParaRPr lang="en-US" sz="1150" dirty="0">
+                        <a:latin typeface="Arial" charset="0"/>
+                        <a:ea typeface="Arial" charset="0"/>
+                        <a:cs typeface="Arial" charset="0"/>
+                      </a:endParaRPr>
+                    </a:p>
+                  </a:txBody>
+                  <a:tcPr marL="50800" marR="50800" marT="50800" marB="50800" anchor="ctr">
+                    <a:lnL w="12700" cap="flat" cmpd="sng" algn="ctr">
+                      <a:solidFill>
+                        <a:srgbClr val="D6DEEA"/>
+                      </a:solidFill>
+                      <a:prstDash val="solid"/>
+                      <a:round/>
+                      <a:headEnd type="none" w="med" len="med"/>
+                      <a:tailEnd type="none" w="med" len="med"/>
+                    </a:lnL>
+                    <a:lnR w="12700" cap="flat" cmpd="sng" algn="ctr">
+                      <a:solidFill>
+                        <a:srgbClr val="D6DEEA"/>
+                      </a:solidFill>
+                      <a:prstDash val="solid"/>
+                      <a:round/>
+                      <a:headEnd type="none" w="med" len="med"/>
+                      <a:tailEnd type="none" w="med" len="med"/>
+                    </a:lnR>
+                    <a:lnT w="12700" cap="flat" cmpd="sng" algn="ctr">
+                      <a:solidFill>
+                        <a:srgbClr val="D6DEEA"/>
+                      </a:solidFill>
+                      <a:prstDash val="solid"/>
+                      <a:round/>
+                      <a:headEnd type="none" w="med" len="med"/>
+                      <a:tailEnd type="none" w="med" len="med"/>
+                    </a:lnT>
+                    <a:lnB w="12700" cap="flat" cmpd="sng" algn="ctr">
+                      <a:solidFill>
+                        <a:srgbClr val="D6DEEA"/>
+                      </a:solidFill>
+                      <a:prstDash val="solid"/>
+                      <a:round/>
+                      <a:headEnd type="none" w="med" len="med"/>
+                      <a:tailEnd type="none" w="med" len="med"/>
+                    </a:lnB>
+                    <a:solidFill>
+                      <a:srgbClr val="F1E7FA"/>
+                    </a:solidFill>
+                  </a:tcPr>
+                </a:tc>
+                <a:tc>
+                  <a:txBody>
+                    <a:bodyPr/>
+                    <a:lstStyle/>
+                    <a:p>
+                      <a:pPr algn="ctr" indent="0" marL="0">
+                        <a:buNone/>
+                      </a:pPr>
+                      <a:r>
+                        <a:rPr lang="en-US" sz="1150" dirty="0">
+                          <a:solidFill>
+                            <a:srgbClr val="253044"/>
+                          </a:solidFill>
+                          <a:latin typeface="Arial" pitchFamily="34" charset="0"/>
+                          <a:ea typeface="Arial" pitchFamily="34" charset="-122"/>
+                          <a:cs typeface="Arial" pitchFamily="34" charset="-120"/>
+                        </a:rPr>
+                        <a:t>3</a:t>
+                      </a:r>
+                      <a:endParaRPr lang="en-US" sz="1150" dirty="0">
+                        <a:latin typeface="Arial" charset="0"/>
+                        <a:ea typeface="Arial" charset="0"/>
+                        <a:cs typeface="Arial" charset="0"/>
+                      </a:endParaRPr>
+                    </a:p>
+                  </a:txBody>
+                  <a:tcPr marL="50800" marR="50800" marT="50800" marB="50800" anchor="ctr">
+                    <a:lnL w="12700" cap="flat" cmpd="sng" algn="ctr">
+                      <a:solidFill>
+                        <a:srgbClr val="D6DEEA"/>
+                      </a:solidFill>
+                      <a:prstDash val="solid"/>
+                      <a:round/>
+                      <a:headEnd type="none" w="med" len="med"/>
+                      <a:tailEnd type="none" w="med" len="med"/>
+                    </a:lnL>
+                    <a:lnR w="12700" cap="flat" cmpd="sng" algn="ctr">
+                      <a:solidFill>
+                        <a:srgbClr val="D6DEEA"/>
+                      </a:solidFill>
+                      <a:prstDash val="solid"/>
+                      <a:round/>
+                      <a:headEnd type="none" w="med" len="med"/>
+                      <a:tailEnd type="none" w="med" len="med"/>
+                    </a:lnR>
+                    <a:lnT w="12700" cap="flat" cmpd="sng" algn="ctr">
+                      <a:solidFill>
+                        <a:srgbClr val="D6DEEA"/>
+                      </a:solidFill>
+                      <a:prstDash val="solid"/>
+                      <a:round/>
+                      <a:headEnd type="none" w="med" len="med"/>
+                      <a:tailEnd type="none" w="med" len="med"/>
+                    </a:lnT>
+                    <a:lnB w="12700" cap="flat" cmpd="sng" algn="ctr">
+                      <a:solidFill>
+                        <a:srgbClr val="D6DEEA"/>
+                      </a:solidFill>
+                      <a:prstDash val="solid"/>
+                      <a:round/>
+                      <a:headEnd type="none" w="med" len="med"/>
+                      <a:tailEnd type="none" w="med" len="med"/>
+                    </a:lnB>
+                    <a:solidFill>
+                      <a:srgbClr val="F1E7FA"/>
+                    </a:solidFill>
+                  </a:tcPr>
+                </a:tc>
+                <a:tc>
+                  <a:txBody>
+                    <a:bodyPr/>
+                    <a:lstStyle/>
+                    <a:p>
+                      <a:pPr algn="ctr" indent="0" marL="0">
+                        <a:buNone/>
+                      </a:pPr>
+                      <a:r>
+                        <a:rPr lang="en-US" sz="1150" b="1" dirty="0">
+                          <a:solidFill>
+                            <a:srgbClr val="7A5BA6"/>
+                          </a:solidFill>
+                          <a:latin typeface="Arial" pitchFamily="34" charset="0"/>
+                          <a:ea typeface="Arial" pitchFamily="34" charset="-122"/>
+                          <a:cs typeface="Arial" pitchFamily="34" charset="-120"/>
+                        </a:rPr>
+                        <a:t>0,3547</a:t>
+                      </a:r>
+                      <a:endParaRPr lang="en-US" sz="1150" dirty="0">
+                        <a:latin typeface="Arial" charset="0"/>
+                        <a:ea typeface="Arial" charset="0"/>
+                        <a:cs typeface="Arial" charset="0"/>
+                      </a:endParaRPr>
+                    </a:p>
+                  </a:txBody>
+                  <a:tcPr marL="50800" marR="50800" marT="50800" marB="50800" anchor="ctr">
+                    <a:lnL w="12700" cap="flat" cmpd="sng" algn="ctr">
+                      <a:solidFill>
+                        <a:srgbClr val="D6DEEA"/>
+                      </a:solidFill>
+                      <a:prstDash val="solid"/>
+                      <a:round/>
+                      <a:headEnd type="none" w="med" len="med"/>
+                      <a:tailEnd type="none" w="med" len="med"/>
+                    </a:lnL>
+                    <a:lnR w="12700" cap="flat" cmpd="sng" algn="ctr">
+                      <a:solidFill>
+                        <a:srgbClr val="D6DEEA"/>
+                      </a:solidFill>
+                      <a:prstDash val="solid"/>
+                      <a:round/>
+                      <a:headEnd type="none" w="med" len="med"/>
+                      <a:tailEnd type="none" w="med" len="med"/>
+                    </a:lnR>
+                    <a:lnT w="12700" cap="flat" cmpd="sng" algn="ctr">
+                      <a:solidFill>
+                        <a:srgbClr val="D6DEEA"/>
+                      </a:solidFill>
+                      <a:prstDash val="solid"/>
+                      <a:round/>
+                      <a:headEnd type="none" w="med" len="med"/>
+                      <a:tailEnd type="none" w="med" len="med"/>
+                    </a:lnT>
+                    <a:lnB w="12700" cap="flat" cmpd="sng" algn="ctr">
+                      <a:solidFill>
+                        <a:srgbClr val="D6DEEA"/>
+                      </a:solidFill>
+                      <a:prstDash val="solid"/>
+                      <a:round/>
+                      <a:headEnd type="none" w="med" len="med"/>
+                      <a:tailEnd type="none" w="med" len="med"/>
+                    </a:lnB>
+                    <a:solidFill>
+                      <a:srgbClr val="F1E7FA"/>
+                    </a:solidFill>
+                  </a:tcPr>
+                </a:tc>
+              </a:tr>
+              <a:tr h="457200">
+                <a:tc>
+                  <a:txBody>
+                    <a:bodyPr/>
+                    <a:lstStyle/>
+                    <a:p>
+                      <a:pPr algn="l" indent="0" marL="0">
+                        <a:buNone/>
+                      </a:pPr>
+                      <a:r>
+                        <a:rPr lang="en-US" sz="1150" dirty="0">
+                          <a:solidFill>
+                            <a:srgbClr val="253044"/>
+                          </a:solidFill>
+                          <a:latin typeface="Arial" pitchFamily="34" charset="0"/>
+                          <a:ea typeface="Arial" pitchFamily="34" charset="-122"/>
+                          <a:cs typeface="Arial" pitchFamily="34" charset="-120"/>
+                        </a:rPr>
+                        <a:t>Bisecting K-means</a:t>
+                      </a:r>
+                      <a:endParaRPr lang="en-US" sz="1150" dirty="0">
+                        <a:latin typeface="Arial" charset="0"/>
+                        <a:ea typeface="Arial" charset="0"/>
+                        <a:cs typeface="Arial" charset="0"/>
+                      </a:endParaRPr>
+                    </a:p>
+                  </a:txBody>
+                  <a:tcPr marL="50800" marR="50800" marT="50800" marB="50800" anchor="ctr">
+                    <a:lnL w="12700" cap="flat" cmpd="sng" algn="ctr">
+                      <a:solidFill>
+                        <a:srgbClr val="D6DEEA"/>
+                      </a:solidFill>
+                      <a:prstDash val="solid"/>
+                      <a:round/>
+                      <a:headEnd type="none" w="med" len="med"/>
+                      <a:tailEnd type="none" w="med" len="med"/>
+                    </a:lnL>
+                    <a:lnR w="12700" cap="flat" cmpd="sng" algn="ctr">
+                      <a:solidFill>
+                        <a:srgbClr val="D6DEEA"/>
+                      </a:solidFill>
+                      <a:prstDash val="solid"/>
+                      <a:round/>
+                      <a:headEnd type="none" w="med" len="med"/>
+                      <a:tailEnd type="none" w="med" len="med"/>
+                    </a:lnR>
+                    <a:lnT w="12700" cap="flat" cmpd="sng" algn="ctr">
+                      <a:solidFill>
+                        <a:srgbClr val="D6DEEA"/>
+                      </a:solidFill>
+                      <a:prstDash val="solid"/>
+                      <a:round/>
+                      <a:headEnd type="none" w="med" len="med"/>
+                      <a:tailEnd type="none" w="med" len="med"/>
+                    </a:lnT>
+                    <a:lnB w="12700" cap="flat" cmpd="sng" algn="ctr">
+                      <a:solidFill>
+                        <a:srgbClr val="D6DEEA"/>
+                      </a:solidFill>
+                      <a:prstDash val="solid"/>
+                      <a:round/>
+                      <a:headEnd type="none" w="med" len="med"/>
+                      <a:tailEnd type="none" w="med" len="med"/>
+                    </a:lnB>
+                  </a:tcPr>
+                </a:tc>
+                <a:tc>
+                  <a:txBody>
+                    <a:bodyPr/>
+                    <a:lstStyle/>
+                    <a:p>
+                      <a:pPr algn="ctr" indent="0" marL="0">
+                        <a:buNone/>
+                      </a:pPr>
+                      <a:r>
+                        <a:rPr lang="en-US" sz="1150" dirty="0">
+                          <a:solidFill>
+                            <a:srgbClr val="253044"/>
+                          </a:solidFill>
+                          <a:latin typeface="Arial" pitchFamily="34" charset="0"/>
+                          <a:ea typeface="Arial" pitchFamily="34" charset="-122"/>
+                          <a:cs typeface="Arial" pitchFamily="34" charset="-120"/>
+                        </a:rPr>
+                        <a:t>2</a:t>
+                      </a:r>
+                      <a:endParaRPr lang="en-US" sz="1150" dirty="0">
+                        <a:latin typeface="Arial" charset="0"/>
+                        <a:ea typeface="Arial" charset="0"/>
+                        <a:cs typeface="Arial" charset="0"/>
+                      </a:endParaRPr>
+                    </a:p>
+                  </a:txBody>
+                  <a:tcPr marL="50800" marR="50800" marT="50800" marB="50800" anchor="ctr">
+                    <a:lnL w="12700" cap="flat" cmpd="sng" algn="ctr">
+                      <a:solidFill>
+                        <a:srgbClr val="D6DEEA"/>
+                      </a:solidFill>
+                      <a:prstDash val="solid"/>
+                      <a:round/>
+                      <a:headEnd type="none" w="med" len="med"/>
+                      <a:tailEnd type="none" w="med" len="med"/>
+                    </a:lnL>
+                    <a:lnR w="12700" cap="flat" cmpd="sng" algn="ctr">
+                      <a:solidFill>
+                        <a:srgbClr val="D6DEEA"/>
+                      </a:solidFill>
+                      <a:prstDash val="solid"/>
+                      <a:round/>
+                      <a:headEnd type="none" w="med" len="med"/>
+                      <a:tailEnd type="none" w="med" len="med"/>
+                    </a:lnR>
+                    <a:lnT w="12700" cap="flat" cmpd="sng" algn="ctr">
+                      <a:solidFill>
+                        <a:srgbClr val="D6DEEA"/>
+                      </a:solidFill>
+                      <a:prstDash val="solid"/>
+                      <a:round/>
+                      <a:headEnd type="none" w="med" len="med"/>
+                      <a:tailEnd type="none" w="med" len="med"/>
+                    </a:lnT>
+                    <a:lnB w="12700" cap="flat" cmpd="sng" algn="ctr">
+                      <a:solidFill>
+                        <a:srgbClr val="D6DEEA"/>
+                      </a:solidFill>
+                      <a:prstDash val="solid"/>
+                      <a:round/>
+                      <a:headEnd type="none" w="med" len="med"/>
+                      <a:tailEnd type="none" w="med" len="med"/>
+                    </a:lnB>
+                  </a:tcPr>
+                </a:tc>
+                <a:tc>
+                  <a:txBody>
+                    <a:bodyPr/>
+                    <a:lstStyle/>
+                    <a:p>
+                      <a:pPr algn="ctr" indent="0" marL="0">
+                        <a:buNone/>
+                      </a:pPr>
+                      <a:r>
+                        <a:rPr lang="en-US" sz="1150" dirty="0">
+                          <a:solidFill>
+                            <a:srgbClr val="253044"/>
+                          </a:solidFill>
+                          <a:latin typeface="Arial" pitchFamily="34" charset="0"/>
+                          <a:ea typeface="Arial" pitchFamily="34" charset="-122"/>
+                          <a:cs typeface="Arial" pitchFamily="34" charset="-120"/>
+                        </a:rPr>
+                        <a:t>2</a:t>
+                      </a:r>
+                      <a:endParaRPr lang="en-US" sz="1150" dirty="0">
+                        <a:latin typeface="Arial" charset="0"/>
+                        <a:ea typeface="Arial" charset="0"/>
+                        <a:cs typeface="Arial" charset="0"/>
+                      </a:endParaRPr>
+                    </a:p>
+                  </a:txBody>
+                  <a:tcPr marL="50800" marR="50800" marT="50800" marB="50800" anchor="ctr">
+                    <a:lnL w="12700" cap="flat" cmpd="sng" algn="ctr">
+                      <a:solidFill>
+                        <a:srgbClr val="D6DEEA"/>
+                      </a:solidFill>
+                      <a:prstDash val="solid"/>
+                      <a:round/>
+                      <a:headEnd type="none" w="med" len="med"/>
+                      <a:tailEnd type="none" w="med" len="med"/>
+                    </a:lnL>
+                    <a:lnR w="12700" cap="flat" cmpd="sng" algn="ctr">
+                      <a:solidFill>
+                        <a:srgbClr val="D6DEEA"/>
+                      </a:solidFill>
+                      <a:prstDash val="solid"/>
+                      <a:round/>
+                      <a:headEnd type="none" w="med" len="med"/>
+                      <a:tailEnd type="none" w="med" len="med"/>
+                    </a:lnR>
+                    <a:lnT w="12700" cap="flat" cmpd="sng" algn="ctr">
+                      <a:solidFill>
+                        <a:srgbClr val="D6DEEA"/>
+                      </a:solidFill>
+                      <a:prstDash val="solid"/>
+                      <a:round/>
+                      <a:headEnd type="none" w="med" len="med"/>
+                      <a:tailEnd type="none" w="med" len="med"/>
+                    </a:lnT>
+                    <a:lnB w="12700" cap="flat" cmpd="sng" algn="ctr">
+                      <a:solidFill>
+                        <a:srgbClr val="D6DEEA"/>
+                      </a:solidFill>
+                      <a:prstDash val="solid"/>
+                      <a:round/>
+                      <a:headEnd type="none" w="med" len="med"/>
+                      <a:tailEnd type="none" w="med" len="med"/>
+                    </a:lnB>
+                  </a:tcPr>
+                </a:tc>
+                <a:tc>
+                  <a:txBody>
+                    <a:bodyPr/>
+                    <a:lstStyle/>
+                    <a:p>
+                      <a:pPr algn="ctr" indent="0" marL="0">
+                        <a:buNone/>
+                      </a:pPr>
+                      <a:r>
+                        <a:rPr lang="en-US" sz="1150" dirty="0">
+                          <a:solidFill>
+                            <a:srgbClr val="253044"/>
+                          </a:solidFill>
+                          <a:latin typeface="Arial" pitchFamily="34" charset="0"/>
+                          <a:ea typeface="Arial" pitchFamily="34" charset="-122"/>
+                          <a:cs typeface="Arial" pitchFamily="34" charset="-120"/>
+                        </a:rPr>
+                        <a:t>0,3398</a:t>
+                      </a:r>
+                      <a:endParaRPr lang="en-US" sz="1150" dirty="0">
+                        <a:latin typeface="Arial" charset="0"/>
+                        <a:ea typeface="Arial" charset="0"/>
+                        <a:cs typeface="Arial" charset="0"/>
+                      </a:endParaRPr>
+                    </a:p>
+                  </a:txBody>
+                  <a:tcPr marL="50800" marR="50800" marT="50800" marB="50800" anchor="ctr">
+                    <a:lnL w="12700" cap="flat" cmpd="sng" algn="ctr">
+                      <a:solidFill>
+                        <a:srgbClr val="D6DEEA"/>
+                      </a:solidFill>
+                      <a:prstDash val="solid"/>
+                      <a:round/>
+                      <a:headEnd type="none" w="med" len="med"/>
+                      <a:tailEnd type="none" w="med" len="med"/>
+                    </a:lnL>
+                    <a:lnR w="12700" cap="flat" cmpd="sng" algn="ctr">
+                      <a:solidFill>
+                        <a:srgbClr val="D6DEEA"/>
+                      </a:solidFill>
+                      <a:prstDash val="solid"/>
+                      <a:round/>
+                      <a:headEnd type="none" w="med" len="med"/>
+                      <a:tailEnd type="none" w="med" len="med"/>
+                    </a:lnR>
+                    <a:lnT w="12700" cap="flat" cmpd="sng" algn="ctr">
+                      <a:solidFill>
+                        <a:srgbClr val="D6DEEA"/>
+                      </a:solidFill>
+                      <a:prstDash val="solid"/>
+                      <a:round/>
+                      <a:headEnd type="none" w="med" len="med"/>
+                      <a:tailEnd type="none" w="med" len="med"/>
+                    </a:lnT>
+                    <a:lnB w="12700" cap="flat" cmpd="sng" algn="ctr">
+                      <a:solidFill>
+                        <a:srgbClr val="D6DEEA"/>
+                      </a:solidFill>
+                      <a:prstDash val="solid"/>
+                      <a:round/>
+                      <a:headEnd type="none" w="med" len="med"/>
+                      <a:tailEnd type="none" w="med" len="med"/>
+                    </a:lnB>
+                  </a:tcPr>
+                </a:tc>
+              </a:tr>
+              <a:tr h="457200">
+                <a:tc>
+                  <a:txBody>
+                    <a:bodyPr/>
+                    <a:lstStyle/>
+                    <a:p>
+                      <a:pPr algn="l" indent="0" marL="0">
+                        <a:buNone/>
+                      </a:pPr>
+                      <a:r>
+                        <a:rPr lang="en-US" sz="1150" dirty="0">
+                          <a:solidFill>
+                            <a:srgbClr val="253044"/>
+                          </a:solidFill>
+                          <a:latin typeface="Arial" pitchFamily="34" charset="0"/>
+                          <a:ea typeface="Arial" pitchFamily="34" charset="-122"/>
+                          <a:cs typeface="Arial" pitchFamily="34" charset="-120"/>
+                        </a:rPr>
+                        <a:t>GMM</a:t>
+                      </a:r>
+                      <a:endParaRPr lang="en-US" sz="1150" dirty="0">
+                        <a:latin typeface="Arial" charset="0"/>
+                        <a:ea typeface="Arial" charset="0"/>
+                        <a:cs typeface="Arial" charset="0"/>
+                      </a:endParaRPr>
+                    </a:p>
+                  </a:txBody>
+                  <a:tcPr marL="50800" marR="50800" marT="50800" marB="50800" anchor="ctr">
+                    <a:lnL w="12700" cap="flat" cmpd="sng" algn="ctr">
+                      <a:solidFill>
+                        <a:srgbClr val="D6DEEA"/>
+                      </a:solidFill>
+                      <a:prstDash val="solid"/>
+                      <a:round/>
+                      <a:headEnd type="none" w="med" len="med"/>
+                      <a:tailEnd type="none" w="med" len="med"/>
+                    </a:lnL>
+                    <a:lnR w="12700" cap="flat" cmpd="sng" algn="ctr">
+                      <a:solidFill>
+                        <a:srgbClr val="D6DEEA"/>
+                      </a:solidFill>
+                      <a:prstDash val="solid"/>
+                      <a:round/>
+                      <a:headEnd type="none" w="med" len="med"/>
+                      <a:tailEnd type="none" w="med" len="med"/>
+                    </a:lnR>
+                    <a:lnT w="12700" cap="flat" cmpd="sng" algn="ctr">
+                      <a:solidFill>
+                        <a:srgbClr val="D6DEEA"/>
+                      </a:solidFill>
+                      <a:prstDash val="solid"/>
+                      <a:round/>
+                      <a:headEnd type="none" w="med" len="med"/>
+                      <a:tailEnd type="none" w="med" len="med"/>
+                    </a:lnT>
+                    <a:lnB w="12700" cap="flat" cmpd="sng" algn="ctr">
+                      <a:solidFill>
+                        <a:srgbClr val="D6DEEA"/>
+                      </a:solidFill>
+                      <a:prstDash val="solid"/>
+                      <a:round/>
+                      <a:headEnd type="none" w="med" len="med"/>
+                      <a:tailEnd type="none" w="med" len="med"/>
+                    </a:lnB>
+                  </a:tcPr>
+                </a:tc>
+                <a:tc>
+                  <a:txBody>
+                    <a:bodyPr/>
+                    <a:lstStyle/>
+                    <a:p>
+                      <a:pPr algn="ctr" indent="0" marL="0">
+                        <a:buNone/>
+                      </a:pPr>
+                      <a:r>
+                        <a:rPr lang="en-US" sz="1150" dirty="0">
+                          <a:solidFill>
+                            <a:srgbClr val="253044"/>
+                          </a:solidFill>
+                          <a:latin typeface="Arial" pitchFamily="34" charset="0"/>
+                          <a:ea typeface="Arial" pitchFamily="34" charset="-122"/>
+                          <a:cs typeface="Arial" pitchFamily="34" charset="-120"/>
+                        </a:rPr>
+                        <a:t>2</a:t>
+                      </a:r>
+                      <a:endParaRPr lang="en-US" sz="1150" dirty="0">
+                        <a:latin typeface="Arial" charset="0"/>
+                        <a:ea typeface="Arial" charset="0"/>
+                        <a:cs typeface="Arial" charset="0"/>
+                      </a:endParaRPr>
+                    </a:p>
+                  </a:txBody>
+                  <a:tcPr marL="50800" marR="50800" marT="50800" marB="50800" anchor="ctr">
+                    <a:lnL w="12700" cap="flat" cmpd="sng" algn="ctr">
+                      <a:solidFill>
+                        <a:srgbClr val="D6DEEA"/>
+                      </a:solidFill>
+                      <a:prstDash val="solid"/>
+                      <a:round/>
+                      <a:headEnd type="none" w="med" len="med"/>
+                      <a:tailEnd type="none" w="med" len="med"/>
+                    </a:lnL>
+                    <a:lnR w="12700" cap="flat" cmpd="sng" algn="ctr">
+                      <a:solidFill>
+                        <a:srgbClr val="D6DEEA"/>
+                      </a:solidFill>
+                      <a:prstDash val="solid"/>
+                      <a:round/>
+                      <a:headEnd type="none" w="med" len="med"/>
+                      <a:tailEnd type="none" w="med" len="med"/>
+                    </a:lnR>
+                    <a:lnT w="12700" cap="flat" cmpd="sng" algn="ctr">
+                      <a:solidFill>
+                        <a:srgbClr val="D6DEEA"/>
+                      </a:solidFill>
+                      <a:prstDash val="solid"/>
+                      <a:round/>
+                      <a:headEnd type="none" w="med" len="med"/>
+                      <a:tailEnd type="none" w="med" len="med"/>
+                    </a:lnT>
+                    <a:lnB w="12700" cap="flat" cmpd="sng" algn="ctr">
+                      <a:solidFill>
+                        <a:srgbClr val="D6DEEA"/>
+                      </a:solidFill>
+                      <a:prstDash val="solid"/>
+                      <a:round/>
+                      <a:headEnd type="none" w="med" len="med"/>
+                      <a:tailEnd type="none" w="med" len="med"/>
+                    </a:lnB>
+                  </a:tcPr>
+                </a:tc>
+                <a:tc>
+                  <a:txBody>
+                    <a:bodyPr/>
+                    <a:lstStyle/>
+                    <a:p>
+                      <a:pPr algn="ctr" indent="0" marL="0">
+                        <a:buNone/>
+                      </a:pPr>
+                      <a:r>
+                        <a:rPr lang="en-US" sz="1150" dirty="0">
+                          <a:solidFill>
+                            <a:srgbClr val="253044"/>
+                          </a:solidFill>
+                          <a:latin typeface="Arial" pitchFamily="34" charset="0"/>
+                          <a:ea typeface="Arial" pitchFamily="34" charset="-122"/>
+                          <a:cs typeface="Arial" pitchFamily="34" charset="-120"/>
+                        </a:rPr>
+                        <a:t>2</a:t>
+                      </a:r>
+                      <a:endParaRPr lang="en-US" sz="1150" dirty="0">
+                        <a:latin typeface="Arial" charset="0"/>
+                        <a:ea typeface="Arial" charset="0"/>
+                        <a:cs typeface="Arial" charset="0"/>
+                      </a:endParaRPr>
+                    </a:p>
+                  </a:txBody>
+                  <a:tcPr marL="50800" marR="50800" marT="50800" marB="50800" anchor="ctr">
+                    <a:lnL w="12700" cap="flat" cmpd="sng" algn="ctr">
+                      <a:solidFill>
+                        <a:srgbClr val="D6DEEA"/>
+                      </a:solidFill>
+                      <a:prstDash val="solid"/>
+                      <a:round/>
+                      <a:headEnd type="none" w="med" len="med"/>
+                      <a:tailEnd type="none" w="med" len="med"/>
+                    </a:lnL>
+                    <a:lnR w="12700" cap="flat" cmpd="sng" algn="ctr">
+                      <a:solidFill>
+                        <a:srgbClr val="D6DEEA"/>
+                      </a:solidFill>
+                      <a:prstDash val="solid"/>
+                      <a:round/>
+                      <a:headEnd type="none" w="med" len="med"/>
+                      <a:tailEnd type="none" w="med" len="med"/>
+                    </a:lnR>
+                    <a:lnT w="12700" cap="flat" cmpd="sng" algn="ctr">
+                      <a:solidFill>
+                        <a:srgbClr val="D6DEEA"/>
+                      </a:solidFill>
+                      <a:prstDash val="solid"/>
+                      <a:round/>
+                      <a:headEnd type="none" w="med" len="med"/>
+                      <a:tailEnd type="none" w="med" len="med"/>
+                    </a:lnT>
+                    <a:lnB w="12700" cap="flat" cmpd="sng" algn="ctr">
+                      <a:solidFill>
+                        <a:srgbClr val="D6DEEA"/>
+                      </a:solidFill>
+                      <a:prstDash val="solid"/>
+                      <a:round/>
+                      <a:headEnd type="none" w="med" len="med"/>
+                      <a:tailEnd type="none" w="med" len="med"/>
+                    </a:lnB>
+                  </a:tcPr>
+                </a:tc>
+                <a:tc>
+                  <a:txBody>
+                    <a:bodyPr/>
+                    <a:lstStyle/>
+                    <a:p>
+                      <a:pPr algn="ctr" indent="0" marL="0">
+                        <a:buNone/>
+                      </a:pPr>
+                      <a:r>
+                        <a:rPr lang="en-US" sz="1150" dirty="0">
+                          <a:solidFill>
+                            <a:srgbClr val="253044"/>
+                          </a:solidFill>
+                          <a:latin typeface="Arial" pitchFamily="34" charset="0"/>
+                          <a:ea typeface="Arial" pitchFamily="34" charset="-122"/>
+                          <a:cs typeface="Arial" pitchFamily="34" charset="-120"/>
+                        </a:rPr>
+                        <a:t>0,2354</a:t>
+                      </a:r>
+                      <a:endParaRPr lang="en-US" sz="1150" dirty="0">
+                        <a:latin typeface="Arial" charset="0"/>
+                        <a:ea typeface="Arial" charset="0"/>
+                        <a:cs typeface="Arial" charset="0"/>
+                      </a:endParaRPr>
+                    </a:p>
+                  </a:txBody>
+                  <a:tcPr marL="50800" marR="50800" marT="50800" marB="50800" anchor="ctr">
+                    <a:lnL w="12700" cap="flat" cmpd="sng" algn="ctr">
+                      <a:solidFill>
+                        <a:srgbClr val="D6DEEA"/>
+                      </a:solidFill>
+                      <a:prstDash val="solid"/>
+                      <a:round/>
+                      <a:headEnd type="none" w="med" len="med"/>
+                      <a:tailEnd type="none" w="med" len="med"/>
+                    </a:lnL>
+                    <a:lnR w="12700" cap="flat" cmpd="sng" algn="ctr">
+                      <a:solidFill>
+                        <a:srgbClr val="D6DEEA"/>
+                      </a:solidFill>
+                      <a:prstDash val="solid"/>
+                      <a:round/>
+                      <a:headEnd type="none" w="med" len="med"/>
+                      <a:tailEnd type="none" w="med" len="med"/>
+                    </a:lnR>
+                    <a:lnT w="12700" cap="flat" cmpd="sng" algn="ctr">
+                      <a:solidFill>
+                        <a:srgbClr val="D6DEEA"/>
+                      </a:solidFill>
+                      <a:prstDash val="solid"/>
+                      <a:round/>
+                      <a:headEnd type="none" w="med" len="med"/>
+                      <a:tailEnd type="none" w="med" len="med"/>
+                    </a:lnT>
+                    <a:lnB w="12700" cap="flat" cmpd="sng" algn="ctr">
+                      <a:solidFill>
+                        <a:srgbClr val="D6DEEA"/>
+                      </a:solidFill>
+                      <a:prstDash val="solid"/>
+                      <a:round/>
+                      <a:headEnd type="none" w="med" len="med"/>
+                      <a:tailEnd type="none" w="med" len="med"/>
+                    </a:lnB>
+                  </a:tcPr>
+                </a:tc>
+              </a:tr>
+              <a:tr h="457200">
+                <a:tc>
+                  <a:txBody>
+                    <a:bodyPr/>
+                    <a:lstStyle/>
+                    <a:p>
+                      <a:pPr algn="l" indent="0" marL="0">
+                        <a:buNone/>
+                      </a:pPr>
+                      <a:r>
+                        <a:rPr lang="en-US" sz="1150" dirty="0">
+                          <a:solidFill>
+                            <a:srgbClr val="253044"/>
+                          </a:solidFill>
+                          <a:latin typeface="Arial" pitchFamily="34" charset="0"/>
+                          <a:ea typeface="Arial" pitchFamily="34" charset="-122"/>
+                          <a:cs typeface="Arial" pitchFamily="34" charset="-120"/>
+                        </a:rPr>
+                        <a:t>DBSCAN</a:t>
+                      </a:r>
+                      <a:endParaRPr lang="en-US" sz="1150" dirty="0">
+                        <a:latin typeface="Arial" charset="0"/>
+                        <a:ea typeface="Arial" charset="0"/>
+                        <a:cs typeface="Arial" charset="0"/>
+                      </a:endParaRPr>
+                    </a:p>
+                  </a:txBody>
+                  <a:tcPr marL="50800" marR="50800" marT="50800" marB="50800" anchor="ctr">
+                    <a:lnL w="12700" cap="flat" cmpd="sng" algn="ctr">
+                      <a:solidFill>
+                        <a:srgbClr val="D6DEEA"/>
+                      </a:solidFill>
+                      <a:prstDash val="solid"/>
+                      <a:round/>
+                      <a:headEnd type="none" w="med" len="med"/>
+                      <a:tailEnd type="none" w="med" len="med"/>
+                    </a:lnL>
+                    <a:lnR w="12700" cap="flat" cmpd="sng" algn="ctr">
+                      <a:solidFill>
+                        <a:srgbClr val="D6DEEA"/>
+                      </a:solidFill>
+                      <a:prstDash val="solid"/>
+                      <a:round/>
+                      <a:headEnd type="none" w="med" len="med"/>
+                      <a:tailEnd type="none" w="med" len="med"/>
+                    </a:lnR>
+                    <a:lnT w="12700" cap="flat" cmpd="sng" algn="ctr">
+                      <a:solidFill>
+                        <a:srgbClr val="D6DEEA"/>
+                      </a:solidFill>
+                      <a:prstDash val="solid"/>
+                      <a:round/>
+                      <a:headEnd type="none" w="med" len="med"/>
+                      <a:tailEnd type="none" w="med" len="med"/>
+                    </a:lnT>
+                    <a:lnB w="12700" cap="flat" cmpd="sng" algn="ctr">
+                      <a:solidFill>
+                        <a:srgbClr val="D6DEEA"/>
+                      </a:solidFill>
+                      <a:prstDash val="solid"/>
+                      <a:round/>
+                      <a:headEnd type="none" w="med" len="med"/>
+                      <a:tailEnd type="none" w="med" len="med"/>
+                    </a:lnB>
+                  </a:tcPr>
+                </a:tc>
+                <a:tc>
+                  <a:txBody>
+                    <a:bodyPr/>
+                    <a:lstStyle/>
+                    <a:p>
+                      <a:pPr algn="ctr" indent="0" marL="0">
+                        <a:buNone/>
+                      </a:pPr>
+                      <a:r>
+                        <a:rPr lang="en-US" sz="1150" dirty="0">
+                          <a:solidFill>
+                            <a:srgbClr val="253044"/>
+                          </a:solidFill>
+                          <a:latin typeface="Arial" pitchFamily="34" charset="0"/>
+                          <a:ea typeface="Arial" pitchFamily="34" charset="-122"/>
+                          <a:cs typeface="Arial" pitchFamily="34" charset="-120"/>
+                        </a:rPr>
+                        <a:t>3</a:t>
+                      </a:r>
+                      <a:endParaRPr lang="en-US" sz="1150" dirty="0">
+                        <a:latin typeface="Arial" charset="0"/>
+                        <a:ea typeface="Arial" charset="0"/>
+                        <a:cs typeface="Arial" charset="0"/>
+                      </a:endParaRPr>
+                    </a:p>
+                  </a:txBody>
+                  <a:tcPr marL="50800" marR="50800" marT="50800" marB="50800" anchor="ctr">
+                    <a:lnL w="12700" cap="flat" cmpd="sng" algn="ctr">
+                      <a:solidFill>
+                        <a:srgbClr val="D6DEEA"/>
+                      </a:solidFill>
+                      <a:prstDash val="solid"/>
+                      <a:round/>
+                      <a:headEnd type="none" w="med" len="med"/>
+                      <a:tailEnd type="none" w="med" len="med"/>
+                    </a:lnL>
+                    <a:lnR w="12700" cap="flat" cmpd="sng" algn="ctr">
+                      <a:solidFill>
+                        <a:srgbClr val="D6DEEA"/>
+                      </a:solidFill>
+                      <a:prstDash val="solid"/>
+                      <a:round/>
+                      <a:headEnd type="none" w="med" len="med"/>
+                      <a:tailEnd type="none" w="med" len="med"/>
+                    </a:lnR>
+                    <a:lnT w="12700" cap="flat" cmpd="sng" algn="ctr">
+                      <a:solidFill>
+                        <a:srgbClr val="D6DEEA"/>
+                      </a:solidFill>
+                      <a:prstDash val="solid"/>
+                      <a:round/>
+                      <a:headEnd type="none" w="med" len="med"/>
+                      <a:tailEnd type="none" w="med" len="med"/>
+                    </a:lnT>
+                    <a:lnB w="12700" cap="flat" cmpd="sng" algn="ctr">
+                      <a:solidFill>
+                        <a:srgbClr val="D6DEEA"/>
+                      </a:solidFill>
+                      <a:prstDash val="solid"/>
+                      <a:round/>
+                      <a:headEnd type="none" w="med" len="med"/>
+                      <a:tailEnd type="none" w="med" len="med"/>
+                    </a:lnB>
+                  </a:tcPr>
+                </a:tc>
+                <a:tc>
+                  <a:txBody>
+                    <a:bodyPr/>
+                    <a:lstStyle/>
+                    <a:p>
+                      <a:pPr algn="ctr" indent="0" marL="0">
+                        <a:buNone/>
+                      </a:pPr>
+                      <a:r>
+                        <a:rPr lang="en-US" sz="1150" dirty="0">
+                          <a:solidFill>
+                            <a:srgbClr val="253044"/>
+                          </a:solidFill>
+                          <a:latin typeface="Arial" pitchFamily="34" charset="0"/>
+                          <a:ea typeface="Arial" pitchFamily="34" charset="-122"/>
+                          <a:cs typeface="Arial" pitchFamily="34" charset="-120"/>
+                        </a:rPr>
+                        <a:t>6</a:t>
+                      </a:r>
+                      <a:endParaRPr lang="en-US" sz="1150" dirty="0">
+                        <a:latin typeface="Arial" charset="0"/>
+                        <a:ea typeface="Arial" charset="0"/>
+                        <a:cs typeface="Arial" charset="0"/>
+                      </a:endParaRPr>
+                    </a:p>
+                  </a:txBody>
+                  <a:tcPr marL="50800" marR="50800" marT="50800" marB="50800" anchor="ctr">
+                    <a:lnL w="12700" cap="flat" cmpd="sng" algn="ctr">
+                      <a:solidFill>
+                        <a:srgbClr val="D6DEEA"/>
+                      </a:solidFill>
+                      <a:prstDash val="solid"/>
+                      <a:round/>
+                      <a:headEnd type="none" w="med" len="med"/>
+                      <a:tailEnd type="none" w="med" len="med"/>
+                    </a:lnL>
+                    <a:lnR w="12700" cap="flat" cmpd="sng" algn="ctr">
+                      <a:solidFill>
+                        <a:srgbClr val="D6DEEA"/>
+                      </a:solidFill>
+                      <a:prstDash val="solid"/>
+                      <a:round/>
+                      <a:headEnd type="none" w="med" len="med"/>
+                      <a:tailEnd type="none" w="med" len="med"/>
+                    </a:lnR>
+                    <a:lnT w="12700" cap="flat" cmpd="sng" algn="ctr">
+                      <a:solidFill>
+                        <a:srgbClr val="D6DEEA"/>
+                      </a:solidFill>
+                      <a:prstDash val="solid"/>
+                      <a:round/>
+                      <a:headEnd type="none" w="med" len="med"/>
+                      <a:tailEnd type="none" w="med" len="med"/>
+                    </a:lnT>
+                    <a:lnB w="12700" cap="flat" cmpd="sng" algn="ctr">
+                      <a:solidFill>
+                        <a:srgbClr val="D6DEEA"/>
+                      </a:solidFill>
+                      <a:prstDash val="solid"/>
+                      <a:round/>
+                      <a:headEnd type="none" w="med" len="med"/>
+                      <a:tailEnd type="none" w="med" len="med"/>
+                    </a:lnB>
+                  </a:tcPr>
+                </a:tc>
+                <a:tc>
+                  <a:txBody>
+                    <a:bodyPr/>
+                    <a:lstStyle/>
+                    <a:p>
+                      <a:pPr algn="ctr" indent="0" marL="0">
+                        <a:buNone/>
+                      </a:pPr>
+                      <a:r>
+                        <a:rPr lang="en-US" sz="1150" dirty="0">
+                          <a:solidFill>
+                            <a:srgbClr val="253044"/>
+                          </a:solidFill>
+                          <a:latin typeface="Arial" pitchFamily="34" charset="0"/>
+                          <a:ea typeface="Arial" pitchFamily="34" charset="-122"/>
+                          <a:cs typeface="Arial" pitchFamily="34" charset="-120"/>
+                        </a:rPr>
+                        <a:t>0,3140</a:t>
+                      </a:r>
+                      <a:endParaRPr lang="en-US" sz="1150" dirty="0">
+                        <a:latin typeface="Arial" charset="0"/>
+                        <a:ea typeface="Arial" charset="0"/>
+                        <a:cs typeface="Arial" charset="0"/>
+                      </a:endParaRPr>
+                    </a:p>
+                  </a:txBody>
+                  <a:tcPr marL="50800" marR="50800" marT="50800" marB="50800" anchor="ctr">
+                    <a:lnL w="12700" cap="flat" cmpd="sng" algn="ctr">
+                      <a:solidFill>
+                        <a:srgbClr val="D6DEEA"/>
+                      </a:solidFill>
+                      <a:prstDash val="solid"/>
+                      <a:round/>
+                      <a:headEnd type="none" w="med" len="med"/>
+                      <a:tailEnd type="none" w="med" len="med"/>
+                    </a:lnL>
+                    <a:lnR w="12700" cap="flat" cmpd="sng" algn="ctr">
+                      <a:solidFill>
+                        <a:srgbClr val="D6DEEA"/>
+                      </a:solidFill>
+                      <a:prstDash val="solid"/>
+                      <a:round/>
+                      <a:headEnd type="none" w="med" len="med"/>
+                      <a:tailEnd type="none" w="med" len="med"/>
+                    </a:lnR>
+                    <a:lnT w="12700" cap="flat" cmpd="sng" algn="ctr">
+                      <a:solidFill>
+                        <a:srgbClr val="D6DEEA"/>
+                      </a:solidFill>
+                      <a:prstDash val="solid"/>
+                      <a:round/>
+                      <a:headEnd type="none" w="med" len="med"/>
+                      <a:tailEnd type="none" w="med" len="med"/>
+                    </a:lnT>
+                    <a:lnB w="12700" cap="flat" cmpd="sng" algn="ctr">
+                      <a:solidFill>
+                        <a:srgbClr val="D6DEEA"/>
+                      </a:solidFill>
+                      <a:prstDash val="solid"/>
+                      <a:round/>
+                      <a:headEnd type="none" w="med" len="med"/>
+                      <a:tailEnd type="none" w="med" len="med"/>
+                    </a:lnB>
+                  </a:tcPr>
+                </a:tc>
+              </a:tr>
+              <a:tr h="457200">
+                <a:tc>
+                  <a:txBody>
+                    <a:bodyPr/>
+                    <a:lstStyle/>
+                    <a:p>
+                      <a:pPr algn="l" indent="0" marL="0">
+                        <a:buNone/>
+                      </a:pPr>
+                      <a:r>
+                        <a:rPr lang="en-US" sz="1150" dirty="0">
+                          <a:solidFill>
+                            <a:srgbClr val="253044"/>
+                          </a:solidFill>
+                          <a:latin typeface="Arial" pitchFamily="34" charset="0"/>
+                          <a:ea typeface="Arial" pitchFamily="34" charset="-122"/>
+                          <a:cs typeface="Arial" pitchFamily="34" charset="-120"/>
+                        </a:rPr>
+                        <a:t>HDBSCAN</a:t>
+                      </a:r>
+                      <a:endParaRPr lang="en-US" sz="1150" dirty="0">
+                        <a:latin typeface="Arial" charset="0"/>
+                        <a:ea typeface="Arial" charset="0"/>
+                        <a:cs typeface="Arial" charset="0"/>
+                      </a:endParaRPr>
+                    </a:p>
+                  </a:txBody>
+                  <a:tcPr marL="50800" marR="50800" marT="50800" marB="50800" anchor="ctr">
+                    <a:lnL w="12700" cap="flat" cmpd="sng" algn="ctr">
+                      <a:solidFill>
+                        <a:srgbClr val="D6DEEA"/>
+                      </a:solidFill>
+                      <a:prstDash val="solid"/>
+                      <a:round/>
+                      <a:headEnd type="none" w="med" len="med"/>
+                      <a:tailEnd type="none" w="med" len="med"/>
+                    </a:lnL>
+                    <a:lnR w="12700" cap="flat" cmpd="sng" algn="ctr">
+                      <a:solidFill>
+                        <a:srgbClr val="D6DEEA"/>
+                      </a:solidFill>
+                      <a:prstDash val="solid"/>
+                      <a:round/>
+                      <a:headEnd type="none" w="med" len="med"/>
+                      <a:tailEnd type="none" w="med" len="med"/>
+                    </a:lnR>
+                    <a:lnT w="12700" cap="flat" cmpd="sng" algn="ctr">
+                      <a:solidFill>
+                        <a:srgbClr val="D6DEEA"/>
+                      </a:solidFill>
+                      <a:prstDash val="solid"/>
+                      <a:round/>
+                      <a:headEnd type="none" w="med" len="med"/>
+                      <a:tailEnd type="none" w="med" len="med"/>
+                    </a:lnT>
+                    <a:lnB w="12700" cap="flat" cmpd="sng" algn="ctr">
+                      <a:solidFill>
+                        <a:srgbClr val="D6DEEA"/>
+                      </a:solidFill>
+                      <a:prstDash val="solid"/>
+                      <a:round/>
+                      <a:headEnd type="none" w="med" len="med"/>
+                      <a:tailEnd type="none" w="med" len="med"/>
+                    </a:lnB>
+                  </a:tcPr>
+                </a:tc>
+                <a:tc>
+                  <a:txBody>
+                    <a:bodyPr/>
+                    <a:lstStyle/>
+                    <a:p>
+                      <a:pPr algn="ctr" indent="0" marL="0">
+                        <a:buNone/>
+                      </a:pPr>
+                      <a:r>
+                        <a:rPr lang="en-US" sz="1150" dirty="0">
+                          <a:solidFill>
+                            <a:srgbClr val="253044"/>
+                          </a:solidFill>
+                          <a:latin typeface="Arial" pitchFamily="34" charset="0"/>
+                          <a:ea typeface="Arial" pitchFamily="34" charset="-122"/>
+                          <a:cs typeface="Arial" pitchFamily="34" charset="-120"/>
+                        </a:rPr>
+                        <a:t>3</a:t>
+                      </a:r>
+                      <a:endParaRPr lang="en-US" sz="1150" dirty="0">
+                        <a:latin typeface="Arial" charset="0"/>
+                        <a:ea typeface="Arial" charset="0"/>
+                        <a:cs typeface="Arial" charset="0"/>
+                      </a:endParaRPr>
+                    </a:p>
+                  </a:txBody>
+                  <a:tcPr marL="50800" marR="50800" marT="50800" marB="50800" anchor="ctr">
+                    <a:lnL w="12700" cap="flat" cmpd="sng" algn="ctr">
+                      <a:solidFill>
+                        <a:srgbClr val="D6DEEA"/>
+                      </a:solidFill>
+                      <a:prstDash val="solid"/>
+                      <a:round/>
+                      <a:headEnd type="none" w="med" len="med"/>
+                      <a:tailEnd type="none" w="med" len="med"/>
+                    </a:lnL>
+                    <a:lnR w="12700" cap="flat" cmpd="sng" algn="ctr">
+                      <a:solidFill>
+                        <a:srgbClr val="D6DEEA"/>
+                      </a:solidFill>
+                      <a:prstDash val="solid"/>
+                      <a:round/>
+                      <a:headEnd type="none" w="med" len="med"/>
+                      <a:tailEnd type="none" w="med" len="med"/>
+                    </a:lnR>
+                    <a:lnT w="12700" cap="flat" cmpd="sng" algn="ctr">
+                      <a:solidFill>
+                        <a:srgbClr val="D6DEEA"/>
+                      </a:solidFill>
+                      <a:prstDash val="solid"/>
+                      <a:round/>
+                      <a:headEnd type="none" w="med" len="med"/>
+                      <a:tailEnd type="none" w="med" len="med"/>
+                    </a:lnT>
+                    <a:lnB w="12700" cap="flat" cmpd="sng" algn="ctr">
+                      <a:solidFill>
+                        <a:srgbClr val="D6DEEA"/>
+                      </a:solidFill>
+                      <a:prstDash val="solid"/>
+                      <a:round/>
+                      <a:headEnd type="none" w="med" len="med"/>
+                      <a:tailEnd type="none" w="med" len="med"/>
+                    </a:lnB>
+                  </a:tcPr>
+                </a:tc>
+                <a:tc>
+                  <a:txBody>
+                    <a:bodyPr/>
+                    <a:lstStyle/>
+                    <a:p>
+                      <a:pPr algn="ctr" indent="0" marL="0">
+                        <a:buNone/>
+                      </a:pPr>
+                      <a:r>
+                        <a:rPr lang="en-US" sz="1150" dirty="0">
+                          <a:solidFill>
+                            <a:srgbClr val="253044"/>
+                          </a:solidFill>
+                          <a:latin typeface="Arial" pitchFamily="34" charset="0"/>
+                          <a:ea typeface="Arial" pitchFamily="34" charset="-122"/>
+                          <a:cs typeface="Arial" pitchFamily="34" charset="-120"/>
+                        </a:rPr>
+                        <a:t>–</a:t>
+                      </a:r>
+                      <a:endParaRPr lang="en-US" sz="1150" dirty="0">
+                        <a:latin typeface="Arial" charset="0"/>
+                        <a:ea typeface="Arial" charset="0"/>
+                        <a:cs typeface="Arial" charset="0"/>
+                      </a:endParaRPr>
+                    </a:p>
+                  </a:txBody>
+                  <a:tcPr marL="50800" marR="50800" marT="50800" marB="50800" anchor="ctr">
+                    <a:lnL w="12700" cap="flat" cmpd="sng" algn="ctr">
+                      <a:solidFill>
+                        <a:srgbClr val="D6DEEA"/>
+                      </a:solidFill>
+                      <a:prstDash val="solid"/>
+                      <a:round/>
+                      <a:headEnd type="none" w="med" len="med"/>
+                      <a:tailEnd type="none" w="med" len="med"/>
+                    </a:lnL>
+                    <a:lnR w="12700" cap="flat" cmpd="sng" algn="ctr">
+                      <a:solidFill>
+                        <a:srgbClr val="D6DEEA"/>
+                      </a:solidFill>
+                      <a:prstDash val="solid"/>
+                      <a:round/>
+                      <a:headEnd type="none" w="med" len="med"/>
+                      <a:tailEnd type="none" w="med" len="med"/>
+                    </a:lnR>
+                    <a:lnT w="12700" cap="flat" cmpd="sng" algn="ctr">
+                      <a:solidFill>
+                        <a:srgbClr val="D6DEEA"/>
+                      </a:solidFill>
+                      <a:prstDash val="solid"/>
+                      <a:round/>
+                      <a:headEnd type="none" w="med" len="med"/>
+                      <a:tailEnd type="none" w="med" len="med"/>
+                    </a:lnT>
+                    <a:lnB w="12700" cap="flat" cmpd="sng" algn="ctr">
+                      <a:solidFill>
+                        <a:srgbClr val="D6DEEA"/>
+                      </a:solidFill>
+                      <a:prstDash val="solid"/>
+                      <a:round/>
+                      <a:headEnd type="none" w="med" len="med"/>
+                      <a:tailEnd type="none" w="med" len="med"/>
+                    </a:lnB>
+                  </a:tcPr>
+                </a:tc>
+                <a:tc>
+                  <a:txBody>
+                    <a:bodyPr/>
+                    <a:lstStyle/>
+                    <a:p>
+                      <a:pPr algn="ctr" indent="0" marL="0">
+                        <a:buNone/>
+                      </a:pPr>
+                      <a:r>
+                        <a:rPr lang="en-US" sz="1150" dirty="0">
+                          <a:solidFill>
+                            <a:srgbClr val="C0504D"/>
+                          </a:solidFill>
+                          <a:latin typeface="Arial" pitchFamily="34" charset="0"/>
+                          <a:ea typeface="Arial" pitchFamily="34" charset="-122"/>
+                          <a:cs typeface="Arial" pitchFamily="34" charset="-120"/>
+                        </a:rPr>
+                        <a:t>bị loại</a:t>
+                      </a:r>
+                      <a:endParaRPr lang="en-US" sz="1150" dirty="0">
+                        <a:latin typeface="Arial" charset="0"/>
+                        <a:ea typeface="Arial" charset="0"/>
+                        <a:cs typeface="Arial" charset="0"/>
+                      </a:endParaRPr>
+                    </a:p>
+                  </a:txBody>
+                  <a:tcPr marL="50800" marR="50800" marT="50800" marB="50800" anchor="ctr">
+                    <a:lnL w="12700" cap="flat" cmpd="sng" algn="ctr">
+                      <a:solidFill>
+                        <a:srgbClr val="D6DEEA"/>
+                      </a:solidFill>
+                      <a:prstDash val="solid"/>
+                      <a:round/>
+                      <a:headEnd type="none" w="med" len="med"/>
+                      <a:tailEnd type="none" w="med" len="med"/>
+                    </a:lnL>
+                    <a:lnR w="12700" cap="flat" cmpd="sng" algn="ctr">
+                      <a:solidFill>
+                        <a:srgbClr val="D6DEEA"/>
+                      </a:solidFill>
+                      <a:prstDash val="solid"/>
+                      <a:round/>
+                      <a:headEnd type="none" w="med" len="med"/>
+                      <a:tailEnd type="none" w="med" len="med"/>
+                    </a:lnR>
+                    <a:lnT w="12700" cap="flat" cmpd="sng" algn="ctr">
+                      <a:solidFill>
+                        <a:srgbClr val="D6DEEA"/>
+                      </a:solidFill>
+                      <a:prstDash val="solid"/>
+                      <a:round/>
+                      <a:headEnd type="none" w="med" len="med"/>
+                      <a:tailEnd type="none" w="med" len="med"/>
+                    </a:lnT>
+                    <a:lnB w="12700" cap="flat" cmpd="sng" algn="ctr">
+                      <a:solidFill>
+                        <a:srgbClr val="D6DEEA"/>
+                      </a:solidFill>
+                      <a:prstDash val="solid"/>
+                      <a:round/>
+                      <a:headEnd type="none" w="med" len="med"/>
+                      <a:tailEnd type="none" w="med" len="med"/>
+                    </a:lnB>
+                  </a:tcPr>
+                </a:tc>
+              </a:tr>
+            </a:tbl>
+          </a:graphicData>
+        </a:graphic>
+      </p:graphicFrame>
+      <p:sp>
+        <p:nvSpPr>
+          <p:cNvPr id="9" name="Shape 6"/>
+          <p:cNvSpPr/>
+          <p:nvPr/>
+        </p:nvSpPr>
+        <p:spPr>
+          <a:xfrm>
+            <a:off x="548640" y="4892040"/>
+            <a:ext cx="5577840" cy="1143000"/>
+          </a:xfrm>
+          <a:prstGeom prst="roundRect">
+            <a:avLst>
+              <a:gd name="adj" fmla="val 5600"/>
+            </a:avLst>
+          </a:prstGeom>
+          <a:solidFill>
+            <a:srgbClr val="FFFFFF"/>
+          </a:solidFill>
+          <a:ln w="12700">
+            <a:solidFill>
+              <a:srgbClr val="D6DEEA"/>
+            </a:solidFill>
+            <a:prstDash val="solid"/>
+          </a:ln>
+          <a:effectLst>
+            <a:outerShdw sx="100000" sy="100000" kx="0" ky="0" algn="bl" rotWithShape="0" blurRad="88900" dist="25400" dir="5400000">
+              <a:srgbClr val="9AA6B8">
+                <a:alpha val="32000"/>
+              </a:srgbClr>
+            </a:outerShdw>
+          </a:effectLst>
+        </p:spPr>
+      </p:sp>
+      <p:sp>
+        <p:nvSpPr>
+          <p:cNvPr id="10" name="Shape 7"/>
+          <p:cNvSpPr/>
+          <p:nvPr/>
+        </p:nvSpPr>
+        <p:spPr>
+          <a:xfrm>
+            <a:off x="548640" y="4892040"/>
+            <a:ext cx="109728" cy="1143000"/>
+          </a:xfrm>
+          <a:prstGeom prst="roundRect">
+            <a:avLst/>
+          </a:prstGeom>
+          <a:solidFill>
+            <a:srgbClr val="7A5BA6"/>
+          </a:solidFill>
+          <a:ln/>
+        </p:spPr>
+      </p:sp>
+      <p:sp>
+        <p:nvSpPr>
+          <p:cNvPr id="11" name="Text 8"/>
+          <p:cNvSpPr txBox="1"/>
+          <p:nvPr/>
+        </p:nvSpPr>
+        <p:spPr>
+          <a:xfrm>
+            <a:off x="804672" y="4892040"/>
+            <a:ext cx="5166360" cy="1143000"/>
+          </a:xfrm>
+          <a:prstGeom prst="rect">
+            <a:avLst/>
+          </a:prstGeom>
+          <a:noFill/>
+          <a:ln/>
+        </p:spPr>
+        <p:txBody>
+          <a:bodyPr wrap="square" rtlCol="0" anchor="ctr"/>
+          <a:lstStyle/>
+          <a:p>
+            <a:pPr indent="0" marL="0">
+              <a:buNone/>
+            </a:pPr>
+            <a:r>
+              <a:rPr lang="en-US" sz="1250" b="1" dirty="0">
+                <a:solidFill>
+                  <a:srgbClr val="7A5BA6"/>
+                </a:solidFill>
+                <a:latin typeface="Arial" pitchFamily="34" charset="0"/>
+                <a:ea typeface="Arial" pitchFamily="34" charset="-122"/>
+                <a:cs typeface="Arial" pitchFamily="34" charset="-120"/>
+              </a:rPr>
+              <a:t>Nhận xét  </a:t>
+            </a:r>
+            <a:pPr indent="0" marL="0">
+              <a:buNone/>
+            </a:pPr>
+            <a:r>
+              <a:rPr lang="en-US" sz="1250" dirty="0">
+                <a:solidFill>
+                  <a:srgbClr val="253044"/>
+                </a:solidFill>
+                <a:latin typeface="Arial" pitchFamily="34" charset="0"/>
+                <a:ea typeface="Arial" pitchFamily="34" charset="-122"/>
+                <a:cs typeface="Arial" pitchFamily="34" charset="-120"/>
+              </a:rPr>
+              <a:t>K-means thắng nhưng chỉ hơn Bisecting 0,015; silhouette 0,35 = cấu trúc yếu. HDBSCAN bị loại (không thoả ≤6 cụm &amp; nhiễu ≤20%).</a:t>
+            </a:r>
+            <a:endParaRPr lang="en-US" sz="1250" dirty="0"/>
+          </a:p>
+        </p:txBody>
+      </p:sp>
+      <p:sp>
+        <p:nvSpPr>
+          <p:cNvPr id="12" name="Text 9"/>
+          <p:cNvSpPr txBox="1"/>
+          <p:nvPr/>
+        </p:nvSpPr>
+        <p:spPr>
+          <a:xfrm>
+            <a:off x="6355080" y="1481328"/>
+            <a:ext cx="5303520" cy="320040"/>
+          </a:xfrm>
+          <a:prstGeom prst="rect">
+            <a:avLst/>
+          </a:prstGeom>
+          <a:noFill/>
+          <a:ln/>
+        </p:spPr>
+        <p:txBody>
+          <a:bodyPr wrap="square" rtlCol="0" anchor="ctr"/>
+          <a:lstStyle/>
+          <a:p>
+            <a:pPr indent="0" marL="0">
+              <a:buNone/>
+            </a:pPr>
+            <a:r>
+              <a:rPr lang="en-US" sz="1400" b="1" dirty="0">
+                <a:solidFill>
+                  <a:srgbClr val="2E9BA6"/>
+                </a:solidFill>
+                <a:latin typeface="Arial" pitchFamily="34" charset="0"/>
+                <a:ea typeface="Arial" pitchFamily="34" charset="-122"/>
+                <a:cs typeface="Arial" pitchFamily="34" charset="-120"/>
+              </a:rPr>
+              <a:t>Dự báo AQI 24h  </a:t>
+            </a:r>
+            <a:pPr indent="0" marL="0">
+              <a:buNone/>
+            </a:pPr>
+            <a:r>
+              <a:rPr lang="en-US" sz="1100" dirty="0">
+                <a:solidFill>
+                  <a:srgbClr val="6B7280"/>
+                </a:solidFill>
+                <a:latin typeface="Arial" pitchFamily="34" charset="0"/>
+                <a:ea typeface="Arial" pitchFamily="34" charset="-122"/>
+                <a:cs typeface="Arial" pitchFamily="34" charset="-120"/>
+              </a:rPr>
+              <a:t>· 10 tháng train / 2 tháng test</a:t>
+            </a:r>
+            <a:endParaRPr lang="en-US" sz="1400" dirty="0"/>
+          </a:p>
+        </p:txBody>
+      </p:sp>
+      <p:graphicFrame>
+        <p:nvGraphicFramePr>
+          <p:cNvPr id="15" name="Table 1"/>
+          <p:cNvGraphicFramePr>
+            <a:graphicFrameLocks noGrp="1"/>
+          </p:cNvGraphicFramePr>
+          <p:nvPr>
+            <p:extLst>
+              <p:ext uri="{D42A27DB-BD31-4B8C-83A1-F6EECF244321}">
+                <p14:modId xmlns:p14="http://schemas.microsoft.com/office/powerpoint/2010/main" val="1579011935"/>
+              </p:ext>
+            </p:extLst>
+          </p:nvPr>
+        </p:nvGraphicFramePr>
+        <p:xfrm>
+          <a:off x="6355080" y="1828800"/>
+          <a:ext cx="5303520" cy="914400"/>
+        </p:xfrm>
+        <a:graphic>
+          <a:graphicData uri="http://schemas.openxmlformats.org/drawingml/2006/table">
+            <a:tbl>
+              <a:tblPr/>
+              <a:tblGrid>
+                <a:gridCol w="2011680"/>
+                <a:gridCol w="548640"/>
+                <a:gridCol w="914400"/>
+                <a:gridCol w="914400"/>
+                <a:gridCol w="914400"/>
+              </a:tblGrid>
+              <a:tr h="502920">
+                <a:tc>
+                  <a:txBody>
+                    <a:bodyPr/>
+                    <a:lstStyle/>
+                    <a:p>
+                      <a:pPr algn="ctr" indent="0" marL="0">
+                        <a:buNone/>
+                      </a:pPr>
+                      <a:r>
+                        <a:rPr lang="en-US" sz="1150" b="1" dirty="0">
+                          <a:solidFill>
+                            <a:srgbClr val="FFFFFF"/>
+                          </a:solidFill>
+                          <a:latin typeface="Arial" pitchFamily="34" charset="0"/>
+                          <a:ea typeface="Arial" pitchFamily="34" charset="-122"/>
+                          <a:cs typeface="Arial" pitchFamily="34" charset="-120"/>
+                        </a:rPr>
+                        <a:t>Mô hình</a:t>
+                      </a:r>
+                      <a:endParaRPr lang="en-US" sz="1150" dirty="0">
+                        <a:latin typeface="Arial" charset="0"/>
+                        <a:ea typeface="Arial" charset="0"/>
+                        <a:cs typeface="Arial" charset="0"/>
+                      </a:endParaRPr>
+                    </a:p>
+                  </a:txBody>
+                  <a:tcPr marL="50800" marR="50800" marT="50800" marB="50800" anchor="ctr">
+                    <a:lnL w="12700" cap="flat" cmpd="sng" algn="ctr">
+                      <a:solidFill>
+                        <a:srgbClr val="D6DEEA"/>
+                      </a:solidFill>
+                      <a:prstDash val="solid"/>
+                      <a:round/>
+                      <a:headEnd type="none" w="med" len="med"/>
+                      <a:tailEnd type="none" w="med" len="med"/>
+                    </a:lnL>
+                    <a:lnR w="12700" cap="flat" cmpd="sng" algn="ctr">
+                      <a:solidFill>
+                        <a:srgbClr val="D6DEEA"/>
+                      </a:solidFill>
+                      <a:prstDash val="solid"/>
+                      <a:round/>
+                      <a:headEnd type="none" w="med" len="med"/>
+                      <a:tailEnd type="none" w="med" len="med"/>
+                    </a:lnR>
+                    <a:lnT w="12700" cap="flat" cmpd="sng" algn="ctr">
+                      <a:solidFill>
+                        <a:srgbClr val="D6DEEA"/>
+                      </a:solidFill>
+                      <a:prstDash val="solid"/>
+                      <a:round/>
+                      <a:headEnd type="none" w="med" len="med"/>
+                      <a:tailEnd type="none" w="med" len="med"/>
+                    </a:lnT>
+                    <a:lnB w="12700" cap="flat" cmpd="sng" algn="ctr">
+                      <a:solidFill>
+                        <a:srgbClr val="D6DEEA"/>
+                      </a:solidFill>
+                      <a:prstDash val="solid"/>
+                      <a:round/>
+                      <a:headEnd type="none" w="med" len="med"/>
+                      <a:tailEnd type="none" w="med" len="med"/>
+                    </a:lnB>
+                    <a:solidFill>
+                      <a:srgbClr val="1F3864"/>
+                    </a:solidFill>
+                  </a:tcPr>
+                </a:tc>
+                <a:tc>
+                  <a:txBody>
+                    <a:bodyPr/>
+                    <a:lstStyle/>
+                    <a:p>
+                      <a:pPr algn="ctr" indent="0" marL="0">
+                        <a:buNone/>
+                      </a:pPr>
+                      <a:r>
+                        <a:rPr lang="en-US" sz="1150" b="1" dirty="0">
+                          <a:solidFill>
+                            <a:srgbClr val="FFFFFF"/>
+                          </a:solidFill>
+                          <a:latin typeface="Arial" pitchFamily="34" charset="0"/>
+                          <a:ea typeface="Arial" pitchFamily="34" charset="-122"/>
+                          <a:cs typeface="Arial" pitchFamily="34" charset="-120"/>
+                        </a:rPr>
+                        <a:t>Tầng</a:t>
+                      </a:r>
+                      <a:endParaRPr lang="en-US" sz="1150" dirty="0">
+                        <a:latin typeface="Arial" charset="0"/>
+                        <a:ea typeface="Arial" charset="0"/>
+                        <a:cs typeface="Arial" charset="0"/>
+                      </a:endParaRPr>
+                    </a:p>
+                  </a:txBody>
+                  <a:tcPr marL="50800" marR="50800" marT="50800" marB="50800" anchor="ctr">
+                    <a:lnL w="12700" cap="flat" cmpd="sng" algn="ctr">
+                      <a:solidFill>
+                        <a:srgbClr val="D6DEEA"/>
+                      </a:solidFill>
+                      <a:prstDash val="solid"/>
+                      <a:round/>
+                      <a:headEnd type="none" w="med" len="med"/>
+                      <a:tailEnd type="none" w="med" len="med"/>
+                    </a:lnL>
+                    <a:lnR w="12700" cap="flat" cmpd="sng" algn="ctr">
+                      <a:solidFill>
+                        <a:srgbClr val="D6DEEA"/>
+                      </a:solidFill>
+                      <a:prstDash val="solid"/>
+                      <a:round/>
+                      <a:headEnd type="none" w="med" len="med"/>
+                      <a:tailEnd type="none" w="med" len="med"/>
+                    </a:lnR>
+                    <a:lnT w="12700" cap="flat" cmpd="sng" algn="ctr">
+                      <a:solidFill>
+                        <a:srgbClr val="D6DEEA"/>
+                      </a:solidFill>
+                      <a:prstDash val="solid"/>
+                      <a:round/>
+                      <a:headEnd type="none" w="med" len="med"/>
+                      <a:tailEnd type="none" w="med" len="med"/>
+                    </a:lnT>
+                    <a:lnB w="12700" cap="flat" cmpd="sng" algn="ctr">
+                      <a:solidFill>
+                        <a:srgbClr val="D6DEEA"/>
+                      </a:solidFill>
+                      <a:prstDash val="solid"/>
+                      <a:round/>
+                      <a:headEnd type="none" w="med" len="med"/>
+                      <a:tailEnd type="none" w="med" len="med"/>
+                    </a:lnB>
+                    <a:solidFill>
+                      <a:srgbClr val="1F3864"/>
+                    </a:solidFill>
+                  </a:tcPr>
+                </a:tc>
+                <a:tc>
+                  <a:txBody>
+                    <a:bodyPr/>
+                    <a:lstStyle/>
+                    <a:p>
+                      <a:pPr algn="ctr" indent="0" marL="0">
+                        <a:buNone/>
+                      </a:pPr>
+                      <a:r>
+                        <a:rPr lang="en-US" sz="1150" b="1" dirty="0">
+                          <a:solidFill>
+                            <a:srgbClr val="FFFFFF"/>
+                          </a:solidFill>
+                          <a:latin typeface="Arial" pitchFamily="34" charset="0"/>
+                          <a:ea typeface="Arial" pitchFamily="34" charset="-122"/>
+                          <a:cs typeface="Arial" pitchFamily="34" charset="-120"/>
+                        </a:rPr>
+                        <a:t>RMSE</a:t>
+                      </a:r>
+                      <a:endParaRPr lang="en-US" sz="1150" dirty="0">
+                        <a:latin typeface="Arial" charset="0"/>
+                        <a:ea typeface="Arial" charset="0"/>
+                        <a:cs typeface="Arial" charset="0"/>
+                      </a:endParaRPr>
+                    </a:p>
+                  </a:txBody>
+                  <a:tcPr marL="50800" marR="50800" marT="50800" marB="50800" anchor="ctr">
+                    <a:lnL w="12700" cap="flat" cmpd="sng" algn="ctr">
+                      <a:solidFill>
+                        <a:srgbClr val="D6DEEA"/>
+                      </a:solidFill>
+                      <a:prstDash val="solid"/>
+                      <a:round/>
+                      <a:headEnd type="none" w="med" len="med"/>
+                      <a:tailEnd type="none" w="med" len="med"/>
+                    </a:lnL>
+                    <a:lnR w="12700" cap="flat" cmpd="sng" algn="ctr">
+                      <a:solidFill>
+                        <a:srgbClr val="D6DEEA"/>
+                      </a:solidFill>
+                      <a:prstDash val="solid"/>
+                      <a:round/>
+                      <a:headEnd type="none" w="med" len="med"/>
+                      <a:tailEnd type="none" w="med" len="med"/>
+                    </a:lnR>
+                    <a:lnT w="12700" cap="flat" cmpd="sng" algn="ctr">
+                      <a:solidFill>
+                        <a:srgbClr val="D6DEEA"/>
+                      </a:solidFill>
+                      <a:prstDash val="solid"/>
+                      <a:round/>
+                      <a:headEnd type="none" w="med" len="med"/>
+                      <a:tailEnd type="none" w="med" len="med"/>
+                    </a:lnT>
+                    <a:lnB w="12700" cap="flat" cmpd="sng" algn="ctr">
+                      <a:solidFill>
+                        <a:srgbClr val="D6DEEA"/>
+                      </a:solidFill>
+                      <a:prstDash val="solid"/>
+                      <a:round/>
+                      <a:headEnd type="none" w="med" len="med"/>
+                      <a:tailEnd type="none" w="med" len="med"/>
+                    </a:lnB>
+                    <a:solidFill>
+                      <a:srgbClr val="1F3864"/>
+                    </a:solidFill>
+                  </a:tcPr>
+                </a:tc>
+                <a:tc>
+                  <a:txBody>
+                    <a:bodyPr/>
+                    <a:lstStyle/>
+                    <a:p>
+                      <a:pPr algn="ctr" indent="0" marL="0">
+                        <a:buNone/>
+                      </a:pPr>
+                      <a:r>
+                        <a:rPr lang="en-US" sz="1150" b="1" dirty="0">
+                          <a:solidFill>
+                            <a:srgbClr val="FFFFFF"/>
+                          </a:solidFill>
+                          <a:latin typeface="Arial" pitchFamily="34" charset="0"/>
+                          <a:ea typeface="Arial" pitchFamily="34" charset="-122"/>
+                          <a:cs typeface="Arial" pitchFamily="34" charset="-120"/>
+                        </a:rPr>
+                        <a:t>MAE</a:t>
+                      </a:r>
+                      <a:endParaRPr lang="en-US" sz="1150" dirty="0">
+                        <a:latin typeface="Arial" charset="0"/>
+                        <a:ea typeface="Arial" charset="0"/>
+                        <a:cs typeface="Arial" charset="0"/>
+                      </a:endParaRPr>
+                    </a:p>
+                  </a:txBody>
+                  <a:tcPr marL="50800" marR="50800" marT="50800" marB="50800" anchor="ctr">
+                    <a:lnL w="12700" cap="flat" cmpd="sng" algn="ctr">
+                      <a:solidFill>
+                        <a:srgbClr val="D6DEEA"/>
+                      </a:solidFill>
+                      <a:prstDash val="solid"/>
+                      <a:round/>
+                      <a:headEnd type="none" w="med" len="med"/>
+                      <a:tailEnd type="none" w="med" len="med"/>
+                    </a:lnL>
+                    <a:lnR w="12700" cap="flat" cmpd="sng" algn="ctr">
+                      <a:solidFill>
+                        <a:srgbClr val="D6DEEA"/>
+                      </a:solidFill>
+                      <a:prstDash val="solid"/>
+                      <a:round/>
+                      <a:headEnd type="none" w="med" len="med"/>
+                      <a:tailEnd type="none" w="med" len="med"/>
+                    </a:lnR>
+                    <a:lnT w="12700" cap="flat" cmpd="sng" algn="ctr">
+                      <a:solidFill>
+                        <a:srgbClr val="D6DEEA"/>
+                      </a:solidFill>
+                      <a:prstDash val="solid"/>
+                      <a:round/>
+                      <a:headEnd type="none" w="med" len="med"/>
+                      <a:tailEnd type="none" w="med" len="med"/>
+                    </a:lnT>
+                    <a:lnB w="12700" cap="flat" cmpd="sng" algn="ctr">
+                      <a:solidFill>
+                        <a:srgbClr val="D6DEEA"/>
+                      </a:solidFill>
+                      <a:prstDash val="solid"/>
+                      <a:round/>
+                      <a:headEnd type="none" w="med" len="med"/>
+                      <a:tailEnd type="none" w="med" len="med"/>
+                    </a:lnB>
+                    <a:solidFill>
+                      <a:srgbClr val="1F3864"/>
+                    </a:solidFill>
+                  </a:tcPr>
+                </a:tc>
+                <a:tc>
+                  <a:txBody>
+                    <a:bodyPr/>
+                    <a:lstStyle/>
+                    <a:p>
+                      <a:pPr algn="ctr" indent="0" marL="0">
+                        <a:buNone/>
+                      </a:pPr>
+                      <a:r>
+                        <a:rPr lang="en-US" sz="1150" b="1" dirty="0">
+                          <a:solidFill>
+                            <a:srgbClr val="FFFFFF"/>
+                          </a:solidFill>
+                          <a:latin typeface="Arial" pitchFamily="34" charset="0"/>
+                          <a:ea typeface="Arial" pitchFamily="34" charset="-122"/>
+                          <a:cs typeface="Arial" pitchFamily="34" charset="-120"/>
+                        </a:rPr>
+                        <a:t>R²</a:t>
+                      </a:r>
+                      <a:endParaRPr lang="en-US" sz="1150" dirty="0">
+                        <a:latin typeface="Arial" charset="0"/>
+                        <a:ea typeface="Arial" charset="0"/>
+                        <a:cs typeface="Arial" charset="0"/>
+                      </a:endParaRPr>
+                    </a:p>
+                  </a:txBody>
+                  <a:tcPr marL="50800" marR="50800" marT="50800" marB="50800" anchor="ctr">
+                    <a:lnL w="12700" cap="flat" cmpd="sng" algn="ctr">
+                      <a:solidFill>
+                        <a:srgbClr val="D6DEEA"/>
+                      </a:solidFill>
+                      <a:prstDash val="solid"/>
+                      <a:round/>
+                      <a:headEnd type="none" w="med" len="med"/>
+                      <a:tailEnd type="none" w="med" len="med"/>
+                    </a:lnL>
+                    <a:lnR w="12700" cap="flat" cmpd="sng" algn="ctr">
+                      <a:solidFill>
+                        <a:srgbClr val="D6DEEA"/>
+                      </a:solidFill>
+                      <a:prstDash val="solid"/>
+                      <a:round/>
+                      <a:headEnd type="none" w="med" len="med"/>
+                      <a:tailEnd type="none" w="med" len="med"/>
+                    </a:lnR>
+                    <a:lnT w="12700" cap="flat" cmpd="sng" algn="ctr">
+                      <a:solidFill>
+                        <a:srgbClr val="D6DEEA"/>
+                      </a:solidFill>
+                      <a:prstDash val="solid"/>
+                      <a:round/>
+                      <a:headEnd type="none" w="med" len="med"/>
+                      <a:tailEnd type="none" w="med" len="med"/>
+                    </a:lnT>
+                    <a:lnB w="12700" cap="flat" cmpd="sng" algn="ctr">
+                      <a:solidFill>
+                        <a:srgbClr val="D6DEEA"/>
+                      </a:solidFill>
+                      <a:prstDash val="solid"/>
+                      <a:round/>
+                      <a:headEnd type="none" w="med" len="med"/>
+                      <a:tailEnd type="none" w="med" len="med"/>
+                    </a:lnB>
+                    <a:solidFill>
+                      <a:srgbClr val="1F3864"/>
+                    </a:solidFill>
+                  </a:tcPr>
+                </a:tc>
+              </a:tr>
+              <a:tr h="502920">
+                <a:tc>
+                  <a:txBody>
+                    <a:bodyPr/>
+                    <a:lstStyle/>
+                    <a:p>
+                      <a:pPr algn="l" indent="0" marL="0">
+                        <a:buNone/>
+                      </a:pPr>
+                      <a:r>
+                        <a:rPr lang="en-US" sz="1150" dirty="0">
+                          <a:solidFill>
+                            <a:srgbClr val="253044"/>
+                          </a:solidFill>
+                          <a:latin typeface="Arial" pitchFamily="34" charset="0"/>
+                          <a:ea typeface="Arial" pitchFamily="34" charset="-122"/>
+                          <a:cs typeface="Arial" pitchFamily="34" charset="-120"/>
+                        </a:rPr>
+                        <a:t>SGD online</a:t>
+                      </a:r>
+                      <a:endParaRPr lang="en-US" sz="1150" dirty="0">
+                        <a:latin typeface="Arial" charset="0"/>
+                        <a:ea typeface="Arial" charset="0"/>
+                        <a:cs typeface="Arial" charset="0"/>
+                      </a:endParaRPr>
+                    </a:p>
+                  </a:txBody>
+                  <a:tcPr marL="50800" marR="50800" marT="50800" marB="50800" anchor="ctr">
+                    <a:lnL w="12700" cap="flat" cmpd="sng" algn="ctr">
+                      <a:solidFill>
+                        <a:srgbClr val="D6DEEA"/>
+                      </a:solidFill>
+                      <a:prstDash val="solid"/>
+                      <a:round/>
+                      <a:headEnd type="none" w="med" len="med"/>
+                      <a:tailEnd type="none" w="med" len="med"/>
+                    </a:lnL>
+                    <a:lnR w="12700" cap="flat" cmpd="sng" algn="ctr">
+                      <a:solidFill>
+                        <a:srgbClr val="D6DEEA"/>
+                      </a:solidFill>
+                      <a:prstDash val="solid"/>
+                      <a:round/>
+                      <a:headEnd type="none" w="med" len="med"/>
+                      <a:tailEnd type="none" w="med" len="med"/>
+                    </a:lnR>
+                    <a:lnT w="12700" cap="flat" cmpd="sng" algn="ctr">
+                      <a:solidFill>
+                        <a:srgbClr val="D6DEEA"/>
+                      </a:solidFill>
+                      <a:prstDash val="solid"/>
+                      <a:round/>
+                      <a:headEnd type="none" w="med" len="med"/>
+                      <a:tailEnd type="none" w="med" len="med"/>
+                    </a:lnT>
+                    <a:lnB w="12700" cap="flat" cmpd="sng" algn="ctr">
+                      <a:solidFill>
+                        <a:srgbClr val="D6DEEA"/>
+                      </a:solidFill>
+                      <a:prstDash val="solid"/>
+                      <a:round/>
+                      <a:headEnd type="none" w="med" len="med"/>
+                      <a:tailEnd type="none" w="med" len="med"/>
+                    </a:lnB>
+                  </a:tcPr>
+                </a:tc>
+                <a:tc>
+                  <a:txBody>
+                    <a:bodyPr/>
+                    <a:lstStyle/>
+                    <a:p>
+                      <a:pPr algn="ctr" indent="0" marL="0">
+                        <a:buNone/>
+                      </a:pPr>
+                      <a:r>
+                        <a:rPr lang="en-US" sz="1150" dirty="0">
+                          <a:solidFill>
+                            <a:srgbClr val="253044"/>
+                          </a:solidFill>
+                          <a:latin typeface="Arial" pitchFamily="34" charset="0"/>
+                          <a:ea typeface="Arial" pitchFamily="34" charset="-122"/>
+                          <a:cs typeface="Arial" pitchFamily="34" charset="-120"/>
+                        </a:rPr>
+                        <a:t>1</a:t>
+                      </a:r>
+                      <a:endParaRPr lang="en-US" sz="1150" dirty="0">
+                        <a:latin typeface="Arial" charset="0"/>
+                        <a:ea typeface="Arial" charset="0"/>
+                        <a:cs typeface="Arial" charset="0"/>
+                      </a:endParaRPr>
+                    </a:p>
+                  </a:txBody>
+                  <a:tcPr marL="50800" marR="50800" marT="50800" marB="50800" anchor="ctr">
+                    <a:lnL w="12700" cap="flat" cmpd="sng" algn="ctr">
+                      <a:solidFill>
+                        <a:srgbClr val="D6DEEA"/>
+                      </a:solidFill>
+                      <a:prstDash val="solid"/>
+                      <a:round/>
+                      <a:headEnd type="none" w="med" len="med"/>
+                      <a:tailEnd type="none" w="med" len="med"/>
+                    </a:lnL>
+                    <a:lnR w="12700" cap="flat" cmpd="sng" algn="ctr">
+                      <a:solidFill>
+                        <a:srgbClr val="D6DEEA"/>
+                      </a:solidFill>
+                      <a:prstDash val="solid"/>
+                      <a:round/>
+                      <a:headEnd type="none" w="med" len="med"/>
+                      <a:tailEnd type="none" w="med" len="med"/>
+                    </a:lnR>
+                    <a:lnT w="12700" cap="flat" cmpd="sng" algn="ctr">
+                      <a:solidFill>
+                        <a:srgbClr val="D6DEEA"/>
+                      </a:solidFill>
+                      <a:prstDash val="solid"/>
+                      <a:round/>
+                      <a:headEnd type="none" w="med" len="med"/>
+                      <a:tailEnd type="none" w="med" len="med"/>
+                    </a:lnT>
+                    <a:lnB w="12700" cap="flat" cmpd="sng" algn="ctr">
+                      <a:solidFill>
+                        <a:srgbClr val="D6DEEA"/>
+                      </a:solidFill>
+                      <a:prstDash val="solid"/>
+                      <a:round/>
+                      <a:headEnd type="none" w="med" len="med"/>
+                      <a:tailEnd type="none" w="med" len="med"/>
+                    </a:lnB>
+                  </a:tcPr>
+                </a:tc>
+                <a:tc>
+                  <a:txBody>
+                    <a:bodyPr/>
+                    <a:lstStyle/>
+                    <a:p>
+                      <a:pPr algn="ctr" indent="0" marL="0">
+                        <a:buNone/>
+                      </a:pPr>
+                      <a:r>
+                        <a:rPr lang="en-US" sz="1150" dirty="0">
+                          <a:solidFill>
+                            <a:srgbClr val="253044"/>
+                          </a:solidFill>
+                          <a:latin typeface="Arial" pitchFamily="34" charset="0"/>
+                          <a:ea typeface="Arial" pitchFamily="34" charset="-122"/>
+                          <a:cs typeface="Arial" pitchFamily="34" charset="-120"/>
+                        </a:rPr>
+                        <a:t>20,29</a:t>
+                      </a:r>
+                      <a:endParaRPr lang="en-US" sz="1150" dirty="0">
+                        <a:latin typeface="Arial" charset="0"/>
+                        <a:ea typeface="Arial" charset="0"/>
+                        <a:cs typeface="Arial" charset="0"/>
+                      </a:endParaRPr>
+                    </a:p>
+                  </a:txBody>
+                  <a:tcPr marL="50800" marR="50800" marT="50800" marB="50800" anchor="ctr">
+                    <a:lnL w="12700" cap="flat" cmpd="sng" algn="ctr">
+                      <a:solidFill>
+                        <a:srgbClr val="D6DEEA"/>
+                      </a:solidFill>
+                      <a:prstDash val="solid"/>
+                      <a:round/>
+                      <a:headEnd type="none" w="med" len="med"/>
+                      <a:tailEnd type="none" w="med" len="med"/>
+                    </a:lnL>
+                    <a:lnR w="12700" cap="flat" cmpd="sng" algn="ctr">
+                      <a:solidFill>
+                        <a:srgbClr val="D6DEEA"/>
+                      </a:solidFill>
+                      <a:prstDash val="solid"/>
+                      <a:round/>
+                      <a:headEnd type="none" w="med" len="med"/>
+                      <a:tailEnd type="none" w="med" len="med"/>
+                    </a:lnR>
+                    <a:lnT w="12700" cap="flat" cmpd="sng" algn="ctr">
+                      <a:solidFill>
+                        <a:srgbClr val="D6DEEA"/>
+                      </a:solidFill>
+                      <a:prstDash val="solid"/>
+                      <a:round/>
+                      <a:headEnd type="none" w="med" len="med"/>
+                      <a:tailEnd type="none" w="med" len="med"/>
+                    </a:lnT>
+                    <a:lnB w="12700" cap="flat" cmpd="sng" algn="ctr">
+                      <a:solidFill>
+                        <a:srgbClr val="D6DEEA"/>
+                      </a:solidFill>
+                      <a:prstDash val="solid"/>
+                      <a:round/>
+                      <a:headEnd type="none" w="med" len="med"/>
+                      <a:tailEnd type="none" w="med" len="med"/>
+                    </a:lnB>
+                  </a:tcPr>
+                </a:tc>
+                <a:tc>
+                  <a:txBody>
+                    <a:bodyPr/>
+                    <a:lstStyle/>
+                    <a:p>
+                      <a:pPr algn="ctr" indent="0" marL="0">
+                        <a:buNone/>
+                      </a:pPr>
+                      <a:r>
+                        <a:rPr lang="en-US" sz="1150" b="1" dirty="0">
+                          <a:solidFill>
+                            <a:srgbClr val="253044"/>
+                          </a:solidFill>
+                          <a:latin typeface="Arial" pitchFamily="34" charset="0"/>
+                          <a:ea typeface="Arial" pitchFamily="34" charset="-122"/>
+                          <a:cs typeface="Arial" pitchFamily="34" charset="-120"/>
+                        </a:rPr>
+                        <a:t>9,99</a:t>
+                      </a:r>
+                      <a:endParaRPr lang="en-US" sz="1150" dirty="0">
+                        <a:latin typeface="Arial" charset="0"/>
+                        <a:ea typeface="Arial" charset="0"/>
+                        <a:cs typeface="Arial" charset="0"/>
+                      </a:endParaRPr>
+                    </a:p>
+                  </a:txBody>
+                  <a:tcPr marL="50800" marR="50800" marT="50800" marB="50800" anchor="ctr">
+                    <a:lnL w="12700" cap="flat" cmpd="sng" algn="ctr">
+                      <a:solidFill>
+                        <a:srgbClr val="D6DEEA"/>
+                      </a:solidFill>
+                      <a:prstDash val="solid"/>
+                      <a:round/>
+                      <a:headEnd type="none" w="med" len="med"/>
+                      <a:tailEnd type="none" w="med" len="med"/>
+                    </a:lnL>
+                    <a:lnR w="12700" cap="flat" cmpd="sng" algn="ctr">
+                      <a:solidFill>
+                        <a:srgbClr val="D6DEEA"/>
+                      </a:solidFill>
+                      <a:prstDash val="solid"/>
+                      <a:round/>
+                      <a:headEnd type="none" w="med" len="med"/>
+                      <a:tailEnd type="none" w="med" len="med"/>
+                    </a:lnR>
+                    <a:lnT w="12700" cap="flat" cmpd="sng" algn="ctr">
+                      <a:solidFill>
+                        <a:srgbClr val="D6DEEA"/>
+                      </a:solidFill>
+                      <a:prstDash val="solid"/>
+                      <a:round/>
+                      <a:headEnd type="none" w="med" len="med"/>
+                      <a:tailEnd type="none" w="med" len="med"/>
+                    </a:lnT>
+                    <a:lnB w="12700" cap="flat" cmpd="sng" algn="ctr">
+                      <a:solidFill>
+                        <a:srgbClr val="D6DEEA"/>
+                      </a:solidFill>
+                      <a:prstDash val="solid"/>
+                      <a:round/>
+                      <a:headEnd type="none" w="med" len="med"/>
+                      <a:tailEnd type="none" w="med" len="med"/>
+                    </a:lnB>
+                  </a:tcPr>
+                </a:tc>
+                <a:tc>
+                  <a:txBody>
+                    <a:bodyPr/>
+                    <a:lstStyle/>
+                    <a:p>
+                      <a:pPr algn="ctr" indent="0" marL="0">
+                        <a:buNone/>
+                      </a:pPr>
+                      <a:r>
+                        <a:rPr lang="en-US" sz="1150" dirty="0">
+                          <a:solidFill>
+                            <a:srgbClr val="253044"/>
+                          </a:solidFill>
+                          <a:latin typeface="Arial" pitchFamily="34" charset="0"/>
+                          <a:ea typeface="Arial" pitchFamily="34" charset="-122"/>
+                          <a:cs typeface="Arial" pitchFamily="34" charset="-120"/>
+                        </a:rPr>
+                        <a:t>0,7243</a:t>
+                      </a:r>
+                      <a:endParaRPr lang="en-US" sz="1150" dirty="0">
+                        <a:latin typeface="Arial" charset="0"/>
+                        <a:ea typeface="Arial" charset="0"/>
+                        <a:cs typeface="Arial" charset="0"/>
+                      </a:endParaRPr>
+                    </a:p>
+                  </a:txBody>
+                  <a:tcPr marL="50800" marR="50800" marT="50800" marB="50800" anchor="ctr">
+                    <a:lnL w="12700" cap="flat" cmpd="sng" algn="ctr">
+                      <a:solidFill>
+                        <a:srgbClr val="D6DEEA"/>
+                      </a:solidFill>
+                      <a:prstDash val="solid"/>
+                      <a:round/>
+                      <a:headEnd type="none" w="med" len="med"/>
+                      <a:tailEnd type="none" w="med" len="med"/>
+                    </a:lnL>
+                    <a:lnR w="12700" cap="flat" cmpd="sng" algn="ctr">
+                      <a:solidFill>
+                        <a:srgbClr val="D6DEEA"/>
+                      </a:solidFill>
+                      <a:prstDash val="solid"/>
+                      <a:round/>
+                      <a:headEnd type="none" w="med" len="med"/>
+                      <a:tailEnd type="none" w="med" len="med"/>
+                    </a:lnR>
+                    <a:lnT w="12700" cap="flat" cmpd="sng" algn="ctr">
+                      <a:solidFill>
+                        <a:srgbClr val="D6DEEA"/>
+                      </a:solidFill>
+                      <a:prstDash val="solid"/>
+                      <a:round/>
+                      <a:headEnd type="none" w="med" len="med"/>
+                      <a:tailEnd type="none" w="med" len="med"/>
+                    </a:lnT>
+                    <a:lnB w="12700" cap="flat" cmpd="sng" algn="ctr">
+                      <a:solidFill>
+                        <a:srgbClr val="D6DEEA"/>
+                      </a:solidFill>
+                      <a:prstDash val="solid"/>
+                      <a:round/>
+                      <a:headEnd type="none" w="med" len="med"/>
+                      <a:tailEnd type="none" w="med" len="med"/>
+                    </a:lnB>
+                  </a:tcPr>
+                </a:tc>
+              </a:tr>
+              <a:tr h="502920">
+                <a:tc>
+                  <a:txBody>
+                    <a:bodyPr/>
+                    <a:lstStyle/>
+                    <a:p>
+                      <a:pPr algn="l" indent="0" marL="0">
+                        <a:buNone/>
+                      </a:pPr>
+                      <a:r>
+                        <a:rPr lang="en-US" sz="1150" b="1" dirty="0">
+                          <a:solidFill>
+                            <a:srgbClr val="253044"/>
+                          </a:solidFill>
+                          <a:latin typeface="Arial" pitchFamily="34" charset="0"/>
+                          <a:ea typeface="Arial" pitchFamily="34" charset="-122"/>
+                          <a:cs typeface="Arial" pitchFamily="34" charset="-120"/>
+                        </a:rPr>
+                        <a:t>Random Forest  ★</a:t>
+                      </a:r>
+                      <a:endParaRPr lang="en-US" sz="1150" dirty="0">
+                        <a:latin typeface="Arial" charset="0"/>
+                        <a:ea typeface="Arial" charset="0"/>
+                        <a:cs typeface="Arial" charset="0"/>
+                      </a:endParaRPr>
+                    </a:p>
+                  </a:txBody>
+                  <a:tcPr marL="50800" marR="50800" marT="50800" marB="50800" anchor="ctr">
+                    <a:lnL w="12700" cap="flat" cmpd="sng" algn="ctr">
+                      <a:solidFill>
+                        <a:srgbClr val="D6DEEA"/>
+                      </a:solidFill>
+                      <a:prstDash val="solid"/>
+                      <a:round/>
+                      <a:headEnd type="none" w="med" len="med"/>
+                      <a:tailEnd type="none" w="med" len="med"/>
+                    </a:lnL>
+                    <a:lnR w="12700" cap="flat" cmpd="sng" algn="ctr">
+                      <a:solidFill>
+                        <a:srgbClr val="D6DEEA"/>
+                      </a:solidFill>
+                      <a:prstDash val="solid"/>
+                      <a:round/>
+                      <a:headEnd type="none" w="med" len="med"/>
+                      <a:tailEnd type="none" w="med" len="med"/>
+                    </a:lnR>
+                    <a:lnT w="12700" cap="flat" cmpd="sng" algn="ctr">
+                      <a:solidFill>
+                        <a:srgbClr val="D6DEEA"/>
+                      </a:solidFill>
+                      <a:prstDash val="solid"/>
+                      <a:round/>
+                      <a:headEnd type="none" w="med" len="med"/>
+                      <a:tailEnd type="none" w="med" len="med"/>
+                    </a:lnT>
+                    <a:lnB w="12700" cap="flat" cmpd="sng" algn="ctr">
+                      <a:solidFill>
+                        <a:srgbClr val="D6DEEA"/>
+                      </a:solidFill>
+                      <a:prstDash val="solid"/>
+                      <a:round/>
+                      <a:headEnd type="none" w="med" len="med"/>
+                      <a:tailEnd type="none" w="med" len="med"/>
+                    </a:lnB>
+                    <a:solidFill>
+                      <a:srgbClr val="E4F3F3"/>
+                    </a:solidFill>
+                  </a:tcPr>
+                </a:tc>
+                <a:tc>
+                  <a:txBody>
+                    <a:bodyPr/>
+                    <a:lstStyle/>
+                    <a:p>
+                      <a:pPr algn="ctr" indent="0" marL="0">
+                        <a:buNone/>
+                      </a:pPr>
+                      <a:r>
+                        <a:rPr lang="en-US" sz="1150" dirty="0">
+                          <a:solidFill>
+                            <a:srgbClr val="253044"/>
+                          </a:solidFill>
+                          <a:latin typeface="Arial" pitchFamily="34" charset="0"/>
+                          <a:ea typeface="Arial" pitchFamily="34" charset="-122"/>
+                          <a:cs typeface="Arial" pitchFamily="34" charset="-120"/>
+                        </a:rPr>
+                        <a:t>2</a:t>
+                      </a:r>
+                      <a:endParaRPr lang="en-US" sz="1150" dirty="0">
+                        <a:latin typeface="Arial" charset="0"/>
+                        <a:ea typeface="Arial" charset="0"/>
+                        <a:cs typeface="Arial" charset="0"/>
+                      </a:endParaRPr>
+                    </a:p>
+                  </a:txBody>
+                  <a:tcPr marL="50800" marR="50800" marT="50800" marB="50800" anchor="ctr">
+                    <a:lnL w="12700" cap="flat" cmpd="sng" algn="ctr">
+                      <a:solidFill>
+                        <a:srgbClr val="D6DEEA"/>
+                      </a:solidFill>
+                      <a:prstDash val="solid"/>
+                      <a:round/>
+                      <a:headEnd type="none" w="med" len="med"/>
+                      <a:tailEnd type="none" w="med" len="med"/>
+                    </a:lnL>
+                    <a:lnR w="12700" cap="flat" cmpd="sng" algn="ctr">
+                      <a:solidFill>
+                        <a:srgbClr val="D6DEEA"/>
+                      </a:solidFill>
+                      <a:prstDash val="solid"/>
+                      <a:round/>
+                      <a:headEnd type="none" w="med" len="med"/>
+                      <a:tailEnd type="none" w="med" len="med"/>
+                    </a:lnR>
+                    <a:lnT w="12700" cap="flat" cmpd="sng" algn="ctr">
+                      <a:solidFill>
+                        <a:srgbClr val="D6DEEA"/>
+                      </a:solidFill>
+                      <a:prstDash val="solid"/>
+                      <a:round/>
+                      <a:headEnd type="none" w="med" len="med"/>
+                      <a:tailEnd type="none" w="med" len="med"/>
+                    </a:lnT>
+                    <a:lnB w="12700" cap="flat" cmpd="sng" algn="ctr">
+                      <a:solidFill>
+                        <a:srgbClr val="D6DEEA"/>
+                      </a:solidFill>
+                      <a:prstDash val="solid"/>
+                      <a:round/>
+                      <a:headEnd type="none" w="med" len="med"/>
+                      <a:tailEnd type="none" w="med" len="med"/>
+                    </a:lnB>
+                    <a:solidFill>
+                      <a:srgbClr val="E4F3F3"/>
+                    </a:solidFill>
+                  </a:tcPr>
+                </a:tc>
+                <a:tc>
+                  <a:txBody>
+                    <a:bodyPr/>
+                    <a:lstStyle/>
+                    <a:p>
+                      <a:pPr algn="ctr" indent="0" marL="0">
+                        <a:buNone/>
+                      </a:pPr>
+                      <a:r>
+                        <a:rPr lang="en-US" sz="1150" b="1" dirty="0">
+                          <a:solidFill>
+                            <a:srgbClr val="2E9BA6"/>
+                          </a:solidFill>
+                          <a:latin typeface="Arial" pitchFamily="34" charset="0"/>
+                          <a:ea typeface="Arial" pitchFamily="34" charset="-122"/>
+                          <a:cs typeface="Arial" pitchFamily="34" charset="-120"/>
+                        </a:rPr>
+                        <a:t>20,10</a:t>
+                      </a:r>
+                      <a:endParaRPr lang="en-US" sz="1150" dirty="0">
+                        <a:latin typeface="Arial" charset="0"/>
+                        <a:ea typeface="Arial" charset="0"/>
+                        <a:cs typeface="Arial" charset="0"/>
+                      </a:endParaRPr>
+                    </a:p>
+                  </a:txBody>
+                  <a:tcPr marL="50800" marR="50800" marT="50800" marB="50800" anchor="ctr">
+                    <a:lnL w="12700" cap="flat" cmpd="sng" algn="ctr">
+                      <a:solidFill>
+                        <a:srgbClr val="D6DEEA"/>
+                      </a:solidFill>
+                      <a:prstDash val="solid"/>
+                      <a:round/>
+                      <a:headEnd type="none" w="med" len="med"/>
+                      <a:tailEnd type="none" w="med" len="med"/>
+                    </a:lnL>
+                    <a:lnR w="12700" cap="flat" cmpd="sng" algn="ctr">
+                      <a:solidFill>
+                        <a:srgbClr val="D6DEEA"/>
+                      </a:solidFill>
+                      <a:prstDash val="solid"/>
+                      <a:round/>
+                      <a:headEnd type="none" w="med" len="med"/>
+                      <a:tailEnd type="none" w="med" len="med"/>
+                    </a:lnR>
+                    <a:lnT w="12700" cap="flat" cmpd="sng" algn="ctr">
+                      <a:solidFill>
+                        <a:srgbClr val="D6DEEA"/>
+                      </a:solidFill>
+                      <a:prstDash val="solid"/>
+                      <a:round/>
+                      <a:headEnd type="none" w="med" len="med"/>
+                      <a:tailEnd type="none" w="med" len="med"/>
+                    </a:lnT>
+                    <a:lnB w="12700" cap="flat" cmpd="sng" algn="ctr">
+                      <a:solidFill>
+                        <a:srgbClr val="D6DEEA"/>
+                      </a:solidFill>
+                      <a:prstDash val="solid"/>
+                      <a:round/>
+                      <a:headEnd type="none" w="med" len="med"/>
+                      <a:tailEnd type="none" w="med" len="med"/>
+                    </a:lnB>
+                    <a:solidFill>
+                      <a:srgbClr val="E4F3F3"/>
+                    </a:solidFill>
+                  </a:tcPr>
+                </a:tc>
+                <a:tc>
+                  <a:txBody>
+                    <a:bodyPr/>
+                    <a:lstStyle/>
+                    <a:p>
+                      <a:pPr algn="ctr" indent="0" marL="0">
+                        <a:buNone/>
+                      </a:pPr>
+                      <a:r>
+                        <a:rPr lang="en-US" sz="1150" dirty="0">
+                          <a:solidFill>
+                            <a:srgbClr val="253044"/>
+                          </a:solidFill>
+                          <a:latin typeface="Arial" pitchFamily="34" charset="0"/>
+                          <a:ea typeface="Arial" pitchFamily="34" charset="-122"/>
+                          <a:cs typeface="Arial" pitchFamily="34" charset="-120"/>
+                        </a:rPr>
+                        <a:t>10,65</a:t>
+                      </a:r>
+                      <a:endParaRPr lang="en-US" sz="1150" dirty="0">
+                        <a:latin typeface="Arial" charset="0"/>
+                        <a:ea typeface="Arial" charset="0"/>
+                        <a:cs typeface="Arial" charset="0"/>
+                      </a:endParaRPr>
+                    </a:p>
+                  </a:txBody>
+                  <a:tcPr marL="50800" marR="50800" marT="50800" marB="50800" anchor="ctr">
+                    <a:lnL w="12700" cap="flat" cmpd="sng" algn="ctr">
+                      <a:solidFill>
+                        <a:srgbClr val="D6DEEA"/>
+                      </a:solidFill>
+                      <a:prstDash val="solid"/>
+                      <a:round/>
+                      <a:headEnd type="none" w="med" len="med"/>
+                      <a:tailEnd type="none" w="med" len="med"/>
+                    </a:lnL>
+                    <a:lnR w="12700" cap="flat" cmpd="sng" algn="ctr">
+                      <a:solidFill>
+                        <a:srgbClr val="D6DEEA"/>
+                      </a:solidFill>
+                      <a:prstDash val="solid"/>
+                      <a:round/>
+                      <a:headEnd type="none" w="med" len="med"/>
+                      <a:tailEnd type="none" w="med" len="med"/>
+                    </a:lnR>
+                    <a:lnT w="12700" cap="flat" cmpd="sng" algn="ctr">
+                      <a:solidFill>
+                        <a:srgbClr val="D6DEEA"/>
+                      </a:solidFill>
+                      <a:prstDash val="solid"/>
+                      <a:round/>
+                      <a:headEnd type="none" w="med" len="med"/>
+                      <a:tailEnd type="none" w="med" len="med"/>
+                    </a:lnT>
+                    <a:lnB w="12700" cap="flat" cmpd="sng" algn="ctr">
+                      <a:solidFill>
+                        <a:srgbClr val="D6DEEA"/>
+                      </a:solidFill>
+                      <a:prstDash val="solid"/>
+                      <a:round/>
+                      <a:headEnd type="none" w="med" len="med"/>
+                      <a:tailEnd type="none" w="med" len="med"/>
+                    </a:lnB>
+                    <a:solidFill>
+                      <a:srgbClr val="E4F3F3"/>
+                    </a:solidFill>
+                  </a:tcPr>
+                </a:tc>
+                <a:tc>
+                  <a:txBody>
+                    <a:bodyPr/>
+                    <a:lstStyle/>
+                    <a:p>
+                      <a:pPr algn="ctr" indent="0" marL="0">
+                        <a:buNone/>
+                      </a:pPr>
+                      <a:r>
+                        <a:rPr lang="en-US" sz="1150" b="1" dirty="0">
+                          <a:solidFill>
+                            <a:srgbClr val="2E9BA6"/>
+                          </a:solidFill>
+                          <a:latin typeface="Arial" pitchFamily="34" charset="0"/>
+                          <a:ea typeface="Arial" pitchFamily="34" charset="-122"/>
+                          <a:cs typeface="Arial" pitchFamily="34" charset="-120"/>
+                        </a:rPr>
+                        <a:t>0,7297</a:t>
+                      </a:r>
+                      <a:endParaRPr lang="en-US" sz="1150" dirty="0">
+                        <a:latin typeface="Arial" charset="0"/>
+                        <a:ea typeface="Arial" charset="0"/>
+                        <a:cs typeface="Arial" charset="0"/>
+                      </a:endParaRPr>
+                    </a:p>
+                  </a:txBody>
+                  <a:tcPr marL="50800" marR="50800" marT="50800" marB="50800" anchor="ctr">
+                    <a:lnL w="12700" cap="flat" cmpd="sng" algn="ctr">
+                      <a:solidFill>
+                        <a:srgbClr val="D6DEEA"/>
+                      </a:solidFill>
+                      <a:prstDash val="solid"/>
+                      <a:round/>
+                      <a:headEnd type="none" w="med" len="med"/>
+                      <a:tailEnd type="none" w="med" len="med"/>
+                    </a:lnL>
+                    <a:lnR w="12700" cap="flat" cmpd="sng" algn="ctr">
+                      <a:solidFill>
+                        <a:srgbClr val="D6DEEA"/>
+                      </a:solidFill>
+                      <a:prstDash val="solid"/>
+                      <a:round/>
+                      <a:headEnd type="none" w="med" len="med"/>
+                      <a:tailEnd type="none" w="med" len="med"/>
+                    </a:lnR>
+                    <a:lnT w="12700" cap="flat" cmpd="sng" algn="ctr">
+                      <a:solidFill>
+                        <a:srgbClr val="D6DEEA"/>
+                      </a:solidFill>
+                      <a:prstDash val="solid"/>
+                      <a:round/>
+                      <a:headEnd type="none" w="med" len="med"/>
+                      <a:tailEnd type="none" w="med" len="med"/>
+                    </a:lnT>
+                    <a:lnB w="12700" cap="flat" cmpd="sng" algn="ctr">
+                      <a:solidFill>
+                        <a:srgbClr val="D6DEEA"/>
+                      </a:solidFill>
+                      <a:prstDash val="solid"/>
+                      <a:round/>
+                      <a:headEnd type="none" w="med" len="med"/>
+                      <a:tailEnd type="none" w="med" len="med"/>
+                    </a:lnB>
+                    <a:solidFill>
+                      <a:srgbClr val="E4F3F3"/>
+                    </a:solidFill>
+                  </a:tcPr>
+                </a:tc>
+              </a:tr>
+              <a:tr h="502920">
+                <a:tc>
+                  <a:txBody>
+                    <a:bodyPr/>
+                    <a:lstStyle/>
+                    <a:p>
+                      <a:pPr algn="l" indent="0" marL="0">
+                        <a:buNone/>
+                      </a:pPr>
+                      <a:r>
+                        <a:rPr lang="en-US" sz="1150" dirty="0">
+                          <a:solidFill>
+                            <a:srgbClr val="253044"/>
+                          </a:solidFill>
+                          <a:latin typeface="Arial" pitchFamily="34" charset="0"/>
+                          <a:ea typeface="Arial" pitchFamily="34" charset="-122"/>
+                          <a:cs typeface="Arial" pitchFamily="34" charset="-120"/>
+                        </a:rPr>
+                        <a:t>CNN-LSTM</a:t>
+                      </a:r>
+                      <a:endParaRPr lang="en-US" sz="1150" dirty="0">
+                        <a:latin typeface="Arial" charset="0"/>
+                        <a:ea typeface="Arial" charset="0"/>
+                        <a:cs typeface="Arial" charset="0"/>
+                      </a:endParaRPr>
+                    </a:p>
+                  </a:txBody>
+                  <a:tcPr marL="50800" marR="50800" marT="50800" marB="50800" anchor="ctr">
+                    <a:lnL w="12700" cap="flat" cmpd="sng" algn="ctr">
+                      <a:solidFill>
+                        <a:srgbClr val="D6DEEA"/>
+                      </a:solidFill>
+                      <a:prstDash val="solid"/>
+                      <a:round/>
+                      <a:headEnd type="none" w="med" len="med"/>
+                      <a:tailEnd type="none" w="med" len="med"/>
+                    </a:lnL>
+                    <a:lnR w="12700" cap="flat" cmpd="sng" algn="ctr">
+                      <a:solidFill>
+                        <a:srgbClr val="D6DEEA"/>
+                      </a:solidFill>
+                      <a:prstDash val="solid"/>
+                      <a:round/>
+                      <a:headEnd type="none" w="med" len="med"/>
+                      <a:tailEnd type="none" w="med" len="med"/>
+                    </a:lnR>
+                    <a:lnT w="12700" cap="flat" cmpd="sng" algn="ctr">
+                      <a:solidFill>
+                        <a:srgbClr val="D6DEEA"/>
+                      </a:solidFill>
+                      <a:prstDash val="solid"/>
+                      <a:round/>
+                      <a:headEnd type="none" w="med" len="med"/>
+                      <a:tailEnd type="none" w="med" len="med"/>
+                    </a:lnT>
+                    <a:lnB w="12700" cap="flat" cmpd="sng" algn="ctr">
+                      <a:solidFill>
+                        <a:srgbClr val="D6DEEA"/>
+                      </a:solidFill>
+                      <a:prstDash val="solid"/>
+                      <a:round/>
+                      <a:headEnd type="none" w="med" len="med"/>
+                      <a:tailEnd type="none" w="med" len="med"/>
+                    </a:lnB>
+                  </a:tcPr>
+                </a:tc>
+                <a:tc>
+                  <a:txBody>
+                    <a:bodyPr/>
+                    <a:lstStyle/>
+                    <a:p>
+                      <a:pPr algn="ctr" indent="0" marL="0">
+                        <a:buNone/>
+                      </a:pPr>
+                      <a:r>
+                        <a:rPr lang="en-US" sz="1150" dirty="0">
+                          <a:solidFill>
+                            <a:srgbClr val="253044"/>
+                          </a:solidFill>
+                          <a:latin typeface="Arial" pitchFamily="34" charset="0"/>
+                          <a:ea typeface="Arial" pitchFamily="34" charset="-122"/>
+                          <a:cs typeface="Arial" pitchFamily="34" charset="-120"/>
+                        </a:rPr>
+                        <a:t>3</a:t>
+                      </a:r>
+                      <a:endParaRPr lang="en-US" sz="1150" dirty="0">
+                        <a:latin typeface="Arial" charset="0"/>
+                        <a:ea typeface="Arial" charset="0"/>
+                        <a:cs typeface="Arial" charset="0"/>
+                      </a:endParaRPr>
+                    </a:p>
+                  </a:txBody>
+                  <a:tcPr marL="50800" marR="50800" marT="50800" marB="50800" anchor="ctr">
+                    <a:lnL w="12700" cap="flat" cmpd="sng" algn="ctr">
+                      <a:solidFill>
+                        <a:srgbClr val="D6DEEA"/>
+                      </a:solidFill>
+                      <a:prstDash val="solid"/>
+                      <a:round/>
+                      <a:headEnd type="none" w="med" len="med"/>
+                      <a:tailEnd type="none" w="med" len="med"/>
+                    </a:lnL>
+                    <a:lnR w="12700" cap="flat" cmpd="sng" algn="ctr">
+                      <a:solidFill>
+                        <a:srgbClr val="D6DEEA"/>
+                      </a:solidFill>
+                      <a:prstDash val="solid"/>
+                      <a:round/>
+                      <a:headEnd type="none" w="med" len="med"/>
+                      <a:tailEnd type="none" w="med" len="med"/>
+                    </a:lnR>
+                    <a:lnT w="12700" cap="flat" cmpd="sng" algn="ctr">
+                      <a:solidFill>
+                        <a:srgbClr val="D6DEEA"/>
+                      </a:solidFill>
+                      <a:prstDash val="solid"/>
+                      <a:round/>
+                      <a:headEnd type="none" w="med" len="med"/>
+                      <a:tailEnd type="none" w="med" len="med"/>
+                    </a:lnT>
+                    <a:lnB w="12700" cap="flat" cmpd="sng" algn="ctr">
+                      <a:solidFill>
+                        <a:srgbClr val="D6DEEA"/>
+                      </a:solidFill>
+                      <a:prstDash val="solid"/>
+                      <a:round/>
+                      <a:headEnd type="none" w="med" len="med"/>
+                      <a:tailEnd type="none" w="med" len="med"/>
+                    </a:lnB>
+                  </a:tcPr>
+                </a:tc>
+                <a:tc>
+                  <a:txBody>
+                    <a:bodyPr/>
+                    <a:lstStyle/>
+                    <a:p>
+                      <a:pPr algn="ctr" indent="0" marL="0">
+                        <a:buNone/>
+                      </a:pPr>
+                      <a:r>
+                        <a:rPr lang="en-US" sz="1150" dirty="0">
+                          <a:solidFill>
+                            <a:srgbClr val="253044"/>
+                          </a:solidFill>
+                          <a:latin typeface="Arial" pitchFamily="34" charset="0"/>
+                          <a:ea typeface="Arial" pitchFamily="34" charset="-122"/>
+                          <a:cs typeface="Arial" pitchFamily="34" charset="-120"/>
+                        </a:rPr>
+                        <a:t>20,37</a:t>
+                      </a:r>
+                      <a:endParaRPr lang="en-US" sz="1150" dirty="0">
+                        <a:latin typeface="Arial" charset="0"/>
+                        <a:ea typeface="Arial" charset="0"/>
+                        <a:cs typeface="Arial" charset="0"/>
+                      </a:endParaRPr>
+                    </a:p>
+                  </a:txBody>
+                  <a:tcPr marL="50800" marR="50800" marT="50800" marB="50800" anchor="ctr">
+                    <a:lnL w="12700" cap="flat" cmpd="sng" algn="ctr">
+                      <a:solidFill>
+                        <a:srgbClr val="D6DEEA"/>
+                      </a:solidFill>
+                      <a:prstDash val="solid"/>
+                      <a:round/>
+                      <a:headEnd type="none" w="med" len="med"/>
+                      <a:tailEnd type="none" w="med" len="med"/>
+                    </a:lnL>
+                    <a:lnR w="12700" cap="flat" cmpd="sng" algn="ctr">
+                      <a:solidFill>
+                        <a:srgbClr val="D6DEEA"/>
+                      </a:solidFill>
+                      <a:prstDash val="solid"/>
+                      <a:round/>
+                      <a:headEnd type="none" w="med" len="med"/>
+                      <a:tailEnd type="none" w="med" len="med"/>
+                    </a:lnR>
+                    <a:lnT w="12700" cap="flat" cmpd="sng" algn="ctr">
+                      <a:solidFill>
+                        <a:srgbClr val="D6DEEA"/>
+                      </a:solidFill>
+                      <a:prstDash val="solid"/>
+                      <a:round/>
+                      <a:headEnd type="none" w="med" len="med"/>
+                      <a:tailEnd type="none" w="med" len="med"/>
+                    </a:lnT>
+                    <a:lnB w="12700" cap="flat" cmpd="sng" algn="ctr">
+                      <a:solidFill>
+                        <a:srgbClr val="D6DEEA"/>
+                      </a:solidFill>
+                      <a:prstDash val="solid"/>
+                      <a:round/>
+                      <a:headEnd type="none" w="med" len="med"/>
+                      <a:tailEnd type="none" w="med" len="med"/>
+                    </a:lnB>
+                  </a:tcPr>
+                </a:tc>
+                <a:tc>
+                  <a:txBody>
+                    <a:bodyPr/>
+                    <a:lstStyle/>
+                    <a:p>
+                      <a:pPr algn="ctr" indent="0" marL="0">
+                        <a:buNone/>
+                      </a:pPr>
+                      <a:r>
+                        <a:rPr lang="en-US" sz="1150" dirty="0">
+                          <a:solidFill>
+                            <a:srgbClr val="253044"/>
+                          </a:solidFill>
+                          <a:latin typeface="Arial" pitchFamily="34" charset="0"/>
+                          <a:ea typeface="Arial" pitchFamily="34" charset="-122"/>
+                          <a:cs typeface="Arial" pitchFamily="34" charset="-120"/>
+                        </a:rPr>
+                        <a:t>11,18</a:t>
+                      </a:r>
+                      <a:endParaRPr lang="en-US" sz="1150" dirty="0">
+                        <a:latin typeface="Arial" charset="0"/>
+                        <a:ea typeface="Arial" charset="0"/>
+                        <a:cs typeface="Arial" charset="0"/>
+                      </a:endParaRPr>
+                    </a:p>
+                  </a:txBody>
+                  <a:tcPr marL="50800" marR="50800" marT="50800" marB="50800" anchor="ctr">
+                    <a:lnL w="12700" cap="flat" cmpd="sng" algn="ctr">
+                      <a:solidFill>
+                        <a:srgbClr val="D6DEEA"/>
+                      </a:solidFill>
+                      <a:prstDash val="solid"/>
+                      <a:round/>
+                      <a:headEnd type="none" w="med" len="med"/>
+                      <a:tailEnd type="none" w="med" len="med"/>
+                    </a:lnL>
+                    <a:lnR w="12700" cap="flat" cmpd="sng" algn="ctr">
+                      <a:solidFill>
+                        <a:srgbClr val="D6DEEA"/>
+                      </a:solidFill>
+                      <a:prstDash val="solid"/>
+                      <a:round/>
+                      <a:headEnd type="none" w="med" len="med"/>
+                      <a:tailEnd type="none" w="med" len="med"/>
+                    </a:lnR>
+                    <a:lnT w="12700" cap="flat" cmpd="sng" algn="ctr">
+                      <a:solidFill>
+                        <a:srgbClr val="D6DEEA"/>
+                      </a:solidFill>
+                      <a:prstDash val="solid"/>
+                      <a:round/>
+                      <a:headEnd type="none" w="med" len="med"/>
+                      <a:tailEnd type="none" w="med" len="med"/>
+                    </a:lnT>
+                    <a:lnB w="12700" cap="flat" cmpd="sng" algn="ctr">
+                      <a:solidFill>
+                        <a:srgbClr val="D6DEEA"/>
+                      </a:solidFill>
+                      <a:prstDash val="solid"/>
+                      <a:round/>
+                      <a:headEnd type="none" w="med" len="med"/>
+                      <a:tailEnd type="none" w="med" len="med"/>
+                    </a:lnB>
+                  </a:tcPr>
+                </a:tc>
+                <a:tc>
+                  <a:txBody>
+                    <a:bodyPr/>
+                    <a:lstStyle/>
+                    <a:p>
+                      <a:pPr algn="ctr" indent="0" marL="0">
+                        <a:buNone/>
+                      </a:pPr>
+                      <a:r>
+                        <a:rPr lang="en-US" sz="1150" dirty="0">
+                          <a:solidFill>
+                            <a:srgbClr val="253044"/>
+                          </a:solidFill>
+                          <a:latin typeface="Arial" pitchFamily="34" charset="0"/>
+                          <a:ea typeface="Arial" pitchFamily="34" charset="-122"/>
+                          <a:cs typeface="Arial" pitchFamily="34" charset="-120"/>
+                        </a:rPr>
+                        <a:t>0,7251</a:t>
+                      </a:r>
+                      <a:endParaRPr lang="en-US" sz="1150" dirty="0">
+                        <a:latin typeface="Arial" charset="0"/>
+                        <a:ea typeface="Arial" charset="0"/>
+                        <a:cs typeface="Arial" charset="0"/>
+                      </a:endParaRPr>
+                    </a:p>
+                  </a:txBody>
+                  <a:tcPr marL="50800" marR="50800" marT="50800" marB="50800" anchor="ctr">
+                    <a:lnL w="12700" cap="flat" cmpd="sng" algn="ctr">
+                      <a:solidFill>
+                        <a:srgbClr val="D6DEEA"/>
+                      </a:solidFill>
+                      <a:prstDash val="solid"/>
+                      <a:round/>
+                      <a:headEnd type="none" w="med" len="med"/>
+                      <a:tailEnd type="none" w="med" len="med"/>
+                    </a:lnL>
+                    <a:lnR w="12700" cap="flat" cmpd="sng" algn="ctr">
+                      <a:solidFill>
+                        <a:srgbClr val="D6DEEA"/>
+                      </a:solidFill>
+                      <a:prstDash val="solid"/>
+                      <a:round/>
+                      <a:headEnd type="none" w="med" len="med"/>
+                      <a:tailEnd type="none" w="med" len="med"/>
+                    </a:lnR>
+                    <a:lnT w="12700" cap="flat" cmpd="sng" algn="ctr">
+                      <a:solidFill>
+                        <a:srgbClr val="D6DEEA"/>
+                      </a:solidFill>
+                      <a:prstDash val="solid"/>
+                      <a:round/>
+                      <a:headEnd type="none" w="med" len="med"/>
+                      <a:tailEnd type="none" w="med" len="med"/>
+                    </a:lnT>
+                    <a:lnB w="12700" cap="flat" cmpd="sng" algn="ctr">
+                      <a:solidFill>
+                        <a:srgbClr val="D6DEEA"/>
+                      </a:solidFill>
+                      <a:prstDash val="solid"/>
+                      <a:round/>
+                      <a:headEnd type="none" w="med" len="med"/>
+                      <a:tailEnd type="none" w="med" len="med"/>
+                    </a:lnB>
+                  </a:tcPr>
+                </a:tc>
+              </a:tr>
+            </a:tbl>
+          </a:graphicData>
+        </a:graphic>
+      </p:graphicFrame>
+      <p:sp>
+        <p:nvSpPr>
+          <p:cNvPr id="14" name="Shape 10"/>
+          <p:cNvSpPr/>
+          <p:nvPr/>
+        </p:nvSpPr>
+        <p:spPr>
+          <a:xfrm>
+            <a:off x="6355080" y="4892040"/>
+            <a:ext cx="5303520" cy="1143000"/>
+          </a:xfrm>
+          <a:prstGeom prst="roundRect">
+            <a:avLst>
+              <a:gd name="adj" fmla="val 5600"/>
+            </a:avLst>
+          </a:prstGeom>
+          <a:solidFill>
+            <a:srgbClr val="FFFFFF"/>
+          </a:solidFill>
+          <a:ln w="12700">
+            <a:solidFill>
+              <a:srgbClr val="D6DEEA"/>
+            </a:solidFill>
+            <a:prstDash val="solid"/>
+          </a:ln>
+          <a:effectLst>
+            <a:outerShdw sx="100000" sy="100000" kx="0" ky="0" algn="bl" rotWithShape="0" blurRad="88900" dist="25400" dir="5400000">
+              <a:srgbClr val="9AA6B8">
+                <a:alpha val="32000"/>
+              </a:srgbClr>
+            </a:outerShdw>
+          </a:effectLst>
+        </p:spPr>
+      </p:sp>
+      <p:sp>
+        <p:nvSpPr>
+          <p:cNvPr id="15" name="Shape 11"/>
+          <p:cNvSpPr/>
+          <p:nvPr/>
+        </p:nvSpPr>
+        <p:spPr>
+          <a:xfrm>
+            <a:off x="6355080" y="4892040"/>
+            <a:ext cx="109728" cy="1143000"/>
+          </a:xfrm>
+          <a:prstGeom prst="roundRect">
+            <a:avLst/>
+          </a:prstGeom>
+          <a:solidFill>
+            <a:srgbClr val="2E9BA6"/>
+          </a:solidFill>
+          <a:ln/>
+        </p:spPr>
+      </p:sp>
+      <p:sp>
+        <p:nvSpPr>
+          <p:cNvPr id="16" name="Text 12"/>
+          <p:cNvSpPr txBox="1"/>
+          <p:nvPr/>
+        </p:nvSpPr>
+        <p:spPr>
+          <a:xfrm>
+            <a:off x="6611112" y="4892040"/>
+            <a:ext cx="4892040" cy="1143000"/>
+          </a:xfrm>
+          <a:prstGeom prst="rect">
+            <a:avLst/>
+          </a:prstGeom>
+          <a:noFill/>
+          <a:ln/>
+        </p:spPr>
+        <p:txBody>
+          <a:bodyPr wrap="square" rtlCol="0" anchor="ctr"/>
+          <a:lstStyle/>
+          <a:p>
+            <a:pPr indent="0" marL="0">
+              <a:buNone/>
+            </a:pPr>
+            <a:r>
+              <a:rPr lang="en-US" sz="1250" b="1" dirty="0">
+                <a:solidFill>
+                  <a:srgbClr val="2E9BA6"/>
+                </a:solidFill>
+                <a:latin typeface="Arial" pitchFamily="34" charset="0"/>
+                <a:ea typeface="Arial" pitchFamily="34" charset="-122"/>
+                <a:cs typeface="Arial" pitchFamily="34" charset="-120"/>
+              </a:rPr>
+              <a:t>Nhận xét  </a:t>
+            </a:r>
+            <a:pPr indent="0" marL="0">
+              <a:buNone/>
+            </a:pPr>
+            <a:r>
+              <a:rPr lang="en-US" sz="1250" dirty="0">
+                <a:solidFill>
+                  <a:srgbClr val="253044"/>
+                </a:solidFill>
+                <a:latin typeface="Arial" pitchFamily="34" charset="0"/>
+                <a:ea typeface="Arial" pitchFamily="34" charset="-122"/>
+                <a:cs typeface="Arial" pitchFamily="34" charset="-120"/>
+              </a:rPr>
+              <a:t>Random Forest thắng RMSE &amp; R²; nhưng SGD thắng MAE (9,99). CNN-LSTM test ít mẫu hơn (~120K) nên chỉ mang tính tham khảo.</a:t>
             </a:r>
             <a:endParaRPr lang="en-US" sz="1250" dirty="0"/>
           </a:p>

</xml_diff>

<commit_message>
docs: slide 3.4 - thêm giải nghĩa ký hiệu công thức AQI + ví dụ tính chi tiết
Bổ sung panel 'Ý nghĩa ký hiệu' (Cₓ, BP_low/high, I_low/high, độ dốc, max)
và panel ví dụ PM2.5=35,2 → IAQI 70,4 (tra khoảng breakpoint + nội suy);
công thức đưa lên khung đầy đủ chiều rộng, giữ thang 6 mức.

Co-Authored-By: Claude Opus 4.8 <noreply@anthropic.com>
Claude-Session: https://claude.ai/code/session_01FrxD6iyiu71sw2RmUtSxFy
</commit_message>
<xml_diff>
--- a/docs/slides/Slide_Huyen_theo_mau.pptx
+++ b/docs/slides/Slide_Huyen_theo_mau.pptx
@@ -6008,12 +6008,12 @@
         </p:nvSpPr>
         <p:spPr>
           <a:xfrm>
-            <a:off x="640080" y="1737360"/>
-            <a:ext cx="6858000" cy="1965960"/>
+            <a:off x="548640" y="1463040"/>
+            <a:ext cx="11091672" cy="1234440"/>
           </a:xfrm>
           <a:prstGeom prst="roundRect">
             <a:avLst>
-              <a:gd name="adj" fmla="val 3256"/>
+              <a:gd name="adj" fmla="val 5185"/>
             </a:avLst>
           </a:prstGeom>
           <a:solidFill>
@@ -6037,8 +6037,8 @@
         </p:nvSpPr>
         <p:spPr>
           <a:xfrm>
-            <a:off x="868680" y="1828800"/>
-            <a:ext cx="6400800" cy="320040"/>
+            <a:off x="822960" y="1517904"/>
+            <a:ext cx="10515600" cy="292608"/>
           </a:xfrm>
           <a:prstGeom prst="rect">
             <a:avLst/>
@@ -6054,7 +6054,7 @@
               <a:buNone/>
             </a:pPr>
             <a:r>
-              <a:rPr lang="en-US" sz="1300" b="1" dirty="0">
+              <a:rPr lang="en-US" sz="1250" b="1" dirty="0">
                 <a:solidFill>
                   <a:srgbClr val="9DB8E6"/>
                 </a:solidFill>
@@ -6062,9 +6062,9 @@
                 <a:ea typeface="Arial" pitchFamily="34" charset="-122"/>
                 <a:cs typeface="Arial" pitchFamily="34" charset="-120"/>
               </a:rPr>
-              <a:t>Công thức</a:t>
-            </a:r>
-            <a:endParaRPr lang="en-US" sz="1300" dirty="0"/>
+              <a:t>Công thức — nội suy tuyến tính theo bảng breakpoint (QĐ 1459)</a:t>
+            </a:r>
+            <a:endParaRPr lang="en-US" sz="1250" dirty="0"/>
           </a:p>
         </p:txBody>
       </p:sp>
@@ -6076,8 +6076,8 @@
         </p:nvSpPr>
         <p:spPr>
           <a:xfrm>
-            <a:off x="868680" y="2194560"/>
-            <a:ext cx="6400800" cy="457200"/>
+            <a:off x="822960" y="1865376"/>
+            <a:ext cx="10515600" cy="384048"/>
           </a:xfrm>
           <a:prstGeom prst="rect">
             <a:avLst/>
@@ -6093,7 +6093,7 @@
               <a:buNone/>
             </a:pPr>
             <a:r>
-              <a:rPr lang="en-US" sz="1200" dirty="0">
+              <a:rPr lang="en-US" sz="1300" dirty="0">
                 <a:solidFill>
                   <a:srgbClr val="FFFFFF"/>
                 </a:solidFill>
@@ -6103,7 +6103,7 @@
               </a:rPr>
               <a:t>IAQIₓ = (I_high − I_low) / (BP_high − BP_low) × (Cₓ − BP_low) + I_low</a:t>
             </a:r>
-            <a:endParaRPr lang="en-US" sz="1200" dirty="0"/>
+            <a:endParaRPr lang="en-US" sz="1300" dirty="0"/>
           </a:p>
         </p:txBody>
       </p:sp>
@@ -6115,8 +6115,8 @@
         </p:nvSpPr>
         <p:spPr>
           <a:xfrm>
-            <a:off x="868680" y="2697480"/>
-            <a:ext cx="6400800" cy="457200"/>
+            <a:off x="822960" y="2286000"/>
+            <a:ext cx="10515600" cy="384048"/>
           </a:xfrm>
           <a:prstGeom prst="rect">
             <a:avLst/>
@@ -6132,7 +6132,7 @@
               <a:buNone/>
             </a:pPr>
             <a:r>
-              <a:rPr lang="en-US" sz="1200" dirty="0">
+              <a:rPr lang="en-US" sz="1300" dirty="0">
                 <a:solidFill>
                   <a:srgbClr val="FFFFFF"/>
                 </a:solidFill>
@@ -6140,186 +6140,26 @@
                 <a:ea typeface="Courier New" pitchFamily="34" charset="-122"/>
                 <a:cs typeface="Courier New" pitchFamily="34" charset="-120"/>
               </a:rPr>
-              <a:t>AQI = max( IAQIₓ )   với 6 chất PM2.5, PM10, O₃, NO₂, SO₂, CO</a:t>
-            </a:r>
-            <a:endParaRPr lang="en-US" sz="1200" dirty="0"/>
+              <a:t>AQI = max( IAQIₓ )   ·   x ∈ {PM2.5, PM10, O₃, NO₂, SO₂, CO}</a:t>
+            </a:r>
+            <a:endParaRPr lang="en-US" sz="1300" dirty="0"/>
           </a:p>
         </p:txBody>
       </p:sp>
       <p:sp>
         <p:nvSpPr>
-          <p:cNvPr id="11" name="Text 9"/>
-          <p:cNvSpPr txBox="1"/>
-          <p:nvPr/>
-        </p:nvSpPr>
-        <p:spPr>
-          <a:xfrm>
-            <a:off x="868680" y="3200400"/>
-            <a:ext cx="6400800" cy="411480"/>
-          </a:xfrm>
-          <a:prstGeom prst="rect">
-            <a:avLst/>
-          </a:prstGeom>
-          <a:noFill/>
-          <a:ln/>
-        </p:spPr>
-        <p:txBody>
-          <a:bodyPr wrap="square" rtlCol="0" anchor="ctr"/>
-          <a:lstStyle/>
-          <a:p>
-            <a:pPr indent="0" marL="0">
-              <a:buNone/>
-            </a:pPr>
-            <a:r>
-              <a:rPr lang="en-US" sz="1200" dirty="0">
-                <a:solidFill>
-                  <a:srgbClr val="CADCF5"/>
-                </a:solidFill>
-                <a:latin typeface="Arial" pitchFamily="34" charset="0"/>
-                <a:ea typeface="Arial" pitchFamily="34" charset="-122"/>
-                <a:cs typeface="Arial" pitchFamily="34" charset="-120"/>
-              </a:rPr>
-              <a:t>Chất trội = </a:t>
-            </a:r>
-            <a:pPr indent="0" marL="0">
-              <a:buNone/>
-            </a:pPr>
-            <a:r>
-              <a:rPr lang="en-US" sz="1200" b="1" dirty="0">
-                <a:solidFill>
-                  <a:srgbClr val="FFFFFF"/>
-                </a:solidFill>
-                <a:latin typeface="Arial" pitchFamily="34" charset="0"/>
-                <a:ea typeface="Arial" pitchFamily="34" charset="-122"/>
-                <a:cs typeface="Arial" pitchFamily="34" charset="-120"/>
-              </a:rPr>
-              <a:t>chất cho IAQI lớn nhất.</a:t>
-            </a:r>
-            <a:endParaRPr lang="en-US" sz="1200" dirty="0"/>
-          </a:p>
-        </p:txBody>
-      </p:sp>
-      <p:sp>
-        <p:nvSpPr>
-          <p:cNvPr id="12" name="Shape 10"/>
+          <p:cNvPr id="11" name="Shape 9"/>
           <p:cNvSpPr/>
           <p:nvPr/>
         </p:nvSpPr>
         <p:spPr>
           <a:xfrm>
-            <a:off x="7680960" y="1737360"/>
-            <a:ext cx="3886200" cy="914400"/>
+            <a:off x="548640" y="2788920"/>
+            <a:ext cx="5486400" cy="1874520"/>
           </a:xfrm>
           <a:prstGeom prst="roundRect">
             <a:avLst>
-              <a:gd name="adj" fmla="val 7000"/>
-            </a:avLst>
-          </a:prstGeom>
-          <a:solidFill>
-            <a:srgbClr val="FFFFFF"/>
-          </a:solidFill>
-          <a:ln w="12700">
-            <a:solidFill>
-              <a:srgbClr val="D6DEEA"/>
-            </a:solidFill>
-            <a:prstDash val="solid"/>
-          </a:ln>
-          <a:effectLst>
-            <a:outerShdw sx="100000" sy="100000" kx="0" ky="0" algn="bl" rotWithShape="0" blurRad="88900" dist="25400" dir="5400000">
-              <a:srgbClr val="9AA6B8">
-                <a:alpha val="32000"/>
-              </a:srgbClr>
-            </a:outerShdw>
-          </a:effectLst>
-        </p:spPr>
-      </p:sp>
-      <p:sp>
-        <p:nvSpPr>
-          <p:cNvPr id="13" name="Shape 11"/>
-          <p:cNvSpPr/>
-          <p:nvPr/>
-        </p:nvSpPr>
-        <p:spPr>
-          <a:xfrm>
-            <a:off x="7680960" y="1737360"/>
-            <a:ext cx="109728" cy="914400"/>
-          </a:xfrm>
-          <a:prstGeom prst="roundRect">
-            <a:avLst/>
-          </a:prstGeom>
-          <a:solidFill>
-            <a:srgbClr val="4F9D5D"/>
-          </a:solidFill>
-          <a:ln/>
-        </p:spPr>
-      </p:sp>
-      <p:sp>
-        <p:nvSpPr>
-          <p:cNvPr id="14" name="Text 12"/>
-          <p:cNvSpPr txBox="1"/>
-          <p:nvPr/>
-        </p:nvSpPr>
-        <p:spPr>
-          <a:xfrm>
-            <a:off x="7936992" y="1737360"/>
-            <a:ext cx="3474720" cy="914400"/>
-          </a:xfrm>
-          <a:prstGeom prst="rect">
-            <a:avLst/>
-          </a:prstGeom>
-          <a:noFill/>
-          <a:ln/>
-        </p:spPr>
-        <p:txBody>
-          <a:bodyPr wrap="square" rtlCol="0" anchor="ctr"/>
-          <a:lstStyle/>
-          <a:p>
-            <a:pPr indent="0" marL="0">
-              <a:buNone/>
-            </a:pPr>
-            <a:r>
-              <a:rPr lang="en-US" sz="1250" b="1" dirty="0">
-                <a:solidFill>
-                  <a:srgbClr val="4F9D5D"/>
-                </a:solidFill>
-                <a:latin typeface="Arial" pitchFamily="34" charset="0"/>
-                <a:ea typeface="Arial" pitchFamily="34" charset="-122"/>
-                <a:cs typeface="Arial" pitchFamily="34" charset="-120"/>
-              </a:rPr>
-              <a:t>Ví dụ  </a:t>
-            </a:r>
-            <a:pPr indent="0" marL="0">
-              <a:buNone/>
-            </a:pPr>
-            <a:r>
-              <a:rPr lang="en-US" sz="1250" dirty="0">
-                <a:solidFill>
-                  <a:srgbClr val="253044"/>
-                </a:solidFill>
-                <a:latin typeface="Arial" pitchFamily="34" charset="0"/>
-                <a:ea typeface="Arial" pitchFamily="34" charset="-122"/>
-                <a:cs typeface="Arial" pitchFamily="34" charset="-120"/>
-              </a:rPr>
-              <a:t>PM2.5 24h = 35,2 → IAQI = 70,4</a:t>
-            </a:r>
-            <a:endParaRPr lang="en-US" sz="1250" dirty="0"/>
-          </a:p>
-        </p:txBody>
-      </p:sp>
-      <p:sp>
-        <p:nvSpPr>
-          <p:cNvPr id="15" name="Shape 13"/>
-          <p:cNvSpPr/>
-          <p:nvPr/>
-        </p:nvSpPr>
-        <p:spPr>
-          <a:xfrm>
-            <a:off x="7680960" y="2788920"/>
-            <a:ext cx="3886200" cy="914400"/>
-          </a:xfrm>
-          <a:prstGeom prst="roundRect">
-            <a:avLst>
-              <a:gd name="adj" fmla="val 7000"/>
+              <a:gd name="adj" fmla="val 3415"/>
             </a:avLst>
           </a:prstGeom>
           <a:solidFill>
@@ -6342,14 +6182,14 @@
       </p:sp>
       <p:sp>
         <p:nvSpPr>
-          <p:cNvPr id="16" name="Text 14"/>
+          <p:cNvPr id="12" name="Text 10"/>
           <p:cNvSpPr txBox="1"/>
           <p:nvPr/>
         </p:nvSpPr>
         <p:spPr>
           <a:xfrm>
-            <a:off x="7863840" y="2788920"/>
-            <a:ext cx="3611880" cy="914400"/>
+            <a:off x="777240" y="2926080"/>
+            <a:ext cx="5029200" cy="292608"/>
           </a:xfrm>
           <a:prstGeom prst="rect">
             <a:avLst/>
@@ -6365,7 +6205,66 @@
               <a:buNone/>
             </a:pPr>
             <a:r>
-              <a:rPr lang="en-US" sz="1200" dirty="0">
+              <a:rPr lang="en-US" sz="1300" b="1" dirty="0">
+                <a:solidFill>
+                  <a:srgbClr val="2E5AAC"/>
+                </a:solidFill>
+                <a:latin typeface="Arial" pitchFamily="34" charset="0"/>
+                <a:ea typeface="Arial" pitchFamily="34" charset="-122"/>
+                <a:cs typeface="Arial" pitchFamily="34" charset="-120"/>
+              </a:rPr>
+              <a:t>Ý nghĩa ký hiệu</a:t>
+            </a:r>
+            <a:endParaRPr lang="en-US" sz="1300" dirty="0"/>
+          </a:p>
+        </p:txBody>
+      </p:sp>
+      <p:sp>
+        <p:nvSpPr>
+          <p:cNvPr id="13" name="Text 11"/>
+          <p:cNvSpPr txBox="1"/>
+          <p:nvPr/>
+        </p:nvSpPr>
+        <p:spPr>
+          <a:xfrm>
+            <a:off x="777240" y="3218688"/>
+            <a:ext cx="5074920" cy="1417320"/>
+          </a:xfrm>
+          <a:prstGeom prst="rect">
+            <a:avLst/>
+          </a:prstGeom>
+          <a:noFill/>
+          <a:ln/>
+        </p:spPr>
+        <p:txBody>
+          <a:bodyPr wrap="square" rtlCol="0" anchor="t"/>
+          <a:lstStyle/>
+          <a:p>
+            <a:pPr indent="0" marL="0">
+              <a:lnSpc>
+                <a:spcPct val="106000"/>
+              </a:lnSpc>
+              <a:buNone/>
+            </a:pPr>
+            <a:r>
+              <a:rPr lang="en-US" sz="1100" b="1" dirty="0">
+                <a:solidFill>
+                  <a:srgbClr val="1F3864"/>
+                </a:solidFill>
+                <a:latin typeface="Arial" pitchFamily="34" charset="0"/>
+                <a:ea typeface="Arial" pitchFamily="34" charset="-122"/>
+                <a:cs typeface="Arial" pitchFamily="34" charset="-120"/>
+              </a:rPr>
+              <a:t>Cₓ</a:t>
+            </a:r>
+            <a:pPr indent="0" marL="0">
+              <a:lnSpc>
+                <a:spcPct val="106000"/>
+              </a:lnSpc>
+              <a:buNone/>
+            </a:pPr>
+            <a:r>
+              <a:rPr lang="en-US" sz="1100" dirty="0">
                 <a:solidFill>
                   <a:srgbClr val="253044"/>
                 </a:solidFill>
@@ -6373,22 +6272,201 @@
                 <a:ea typeface="Arial" pitchFamily="34" charset="-122"/>
                 <a:cs typeface="Arial" pitchFamily="34" charset="-120"/>
               </a:rPr>
-              <a:t>AQI giờ dùng NowCast 12h cho PM; AQI ngày dùng trung bình 24h.</a:t>
-            </a:r>
-            <a:endParaRPr lang="en-US" sz="1200" dirty="0"/>
+              <a:t> — nồng độ đo được (đã đúng cửa sổ)
+</a:t>
+            </a:r>
+            <a:endParaRPr lang="en-US" sz="1100" dirty="0"/>
+          </a:p>
+          <a:p>
+            <a:pPr indent="0" marL="0">
+              <a:lnSpc>
+                <a:spcPct val="106000"/>
+              </a:lnSpc>
+              <a:buNone/>
+            </a:pPr>
+            <a:r>
+              <a:rPr lang="en-US" sz="1100" b="1" dirty="0">
+                <a:solidFill>
+                  <a:srgbClr val="1F3864"/>
+                </a:solidFill>
+                <a:latin typeface="Arial" pitchFamily="34" charset="0"/>
+                <a:ea typeface="Arial" pitchFamily="34" charset="-122"/>
+                <a:cs typeface="Arial" pitchFamily="34" charset="-120"/>
+              </a:rPr>
+              <a:t>[BP_low, BP_high]</a:t>
+            </a:r>
+            <a:pPr indent="0" marL="0">
+              <a:lnSpc>
+                <a:spcPct val="106000"/>
+              </a:lnSpc>
+              <a:buNone/>
+            </a:pPr>
+            <a:r>
+              <a:rPr lang="en-US" sz="1100" dirty="0">
+                <a:solidFill>
+                  <a:srgbClr val="253044"/>
+                </a:solidFill>
+                <a:latin typeface="Arial" pitchFamily="34" charset="0"/>
+                <a:ea typeface="Arial" pitchFamily="34" charset="-122"/>
+                <a:cs typeface="Arial" pitchFamily="34" charset="-120"/>
+              </a:rPr>
+              <a:t> — khoảng nồng độ chứa Cₓ
+</a:t>
+            </a:r>
+            <a:endParaRPr lang="en-US" sz="1100" dirty="0"/>
+          </a:p>
+          <a:p>
+            <a:pPr indent="0" marL="0">
+              <a:lnSpc>
+                <a:spcPct val="106000"/>
+              </a:lnSpc>
+              <a:buNone/>
+            </a:pPr>
+            <a:r>
+              <a:rPr lang="en-US" sz="1100" b="1" dirty="0">
+                <a:solidFill>
+                  <a:srgbClr val="1F3864"/>
+                </a:solidFill>
+                <a:latin typeface="Arial" pitchFamily="34" charset="0"/>
+                <a:ea typeface="Arial" pitchFamily="34" charset="-122"/>
+                <a:cs typeface="Arial" pitchFamily="34" charset="-120"/>
+              </a:rPr>
+              <a:t>[I_low, I_high]</a:t>
+            </a:r>
+            <a:pPr indent="0" marL="0">
+              <a:lnSpc>
+                <a:spcPct val="106000"/>
+              </a:lnSpc>
+              <a:buNone/>
+            </a:pPr>
+            <a:r>
+              <a:rPr lang="en-US" sz="1100" dirty="0">
+                <a:solidFill>
+                  <a:srgbClr val="253044"/>
+                </a:solidFill>
+                <a:latin typeface="Arial" pitchFamily="34" charset="0"/>
+                <a:ea typeface="Arial" pitchFamily="34" charset="-122"/>
+                <a:cs typeface="Arial" pitchFamily="34" charset="-120"/>
+              </a:rPr>
+              <a:t> — khoảng điểm AQI tương ứng
+</a:t>
+            </a:r>
+            <a:endParaRPr lang="en-US" sz="1100" dirty="0"/>
+          </a:p>
+          <a:p>
+            <a:pPr indent="0" marL="0">
+              <a:lnSpc>
+                <a:spcPct val="106000"/>
+              </a:lnSpc>
+              <a:buNone/>
+            </a:pPr>
+            <a:r>
+              <a:rPr lang="en-US" sz="1100" b="1" dirty="0">
+                <a:solidFill>
+                  <a:srgbClr val="1F3864"/>
+                </a:solidFill>
+                <a:latin typeface="Arial" pitchFamily="34" charset="0"/>
+                <a:ea typeface="Arial" pitchFamily="34" charset="-122"/>
+                <a:cs typeface="Arial" pitchFamily="34" charset="-120"/>
+              </a:rPr>
+              <a:t>phân số đầu</a:t>
+            </a:r>
+            <a:pPr indent="0" marL="0">
+              <a:lnSpc>
+                <a:spcPct val="106000"/>
+              </a:lnSpc>
+              <a:buNone/>
+            </a:pPr>
+            <a:r>
+              <a:rPr lang="en-US" sz="1100" dirty="0">
+                <a:solidFill>
+                  <a:srgbClr val="253044"/>
+                </a:solidFill>
+                <a:latin typeface="Arial" pitchFamily="34" charset="0"/>
+                <a:ea typeface="Arial" pitchFamily="34" charset="-122"/>
+                <a:cs typeface="Arial" pitchFamily="34" charset="-120"/>
+              </a:rPr>
+              <a:t> = độ dốc (1 đơn vị nồng độ → mấy điểm)
+</a:t>
+            </a:r>
+            <a:endParaRPr lang="en-US" sz="1100" dirty="0"/>
+          </a:p>
+          <a:p>
+            <a:pPr indent="0" marL="0">
+              <a:lnSpc>
+                <a:spcPct val="106000"/>
+              </a:lnSpc>
+              <a:buNone/>
+            </a:pPr>
+            <a:r>
+              <a:rPr lang="en-US" sz="1100" b="1" dirty="0">
+                <a:solidFill>
+                  <a:srgbClr val="1F3864"/>
+                </a:solidFill>
+                <a:latin typeface="Arial" pitchFamily="34" charset="0"/>
+                <a:ea typeface="Arial" pitchFamily="34" charset="-122"/>
+                <a:cs typeface="Arial" pitchFamily="34" charset="-120"/>
+              </a:rPr>
+              <a:t>max</a:t>
+            </a:r>
+            <a:pPr indent="0" marL="0">
+              <a:lnSpc>
+                <a:spcPct val="106000"/>
+              </a:lnSpc>
+              <a:buNone/>
+            </a:pPr>
+            <a:r>
+              <a:rPr lang="en-US" sz="1100" dirty="0">
+                <a:solidFill>
+                  <a:srgbClr val="253044"/>
+                </a:solidFill>
+                <a:latin typeface="Arial" pitchFamily="34" charset="0"/>
+                <a:ea typeface="Arial" pitchFamily="34" charset="-122"/>
+                <a:cs typeface="Arial" pitchFamily="34" charset="-120"/>
+              </a:rPr>
+              <a:t> — lấy chất tệ nhất (= chất trội)</a:t>
+            </a:r>
+            <a:endParaRPr lang="en-US" sz="1100" dirty="0"/>
           </a:p>
         </p:txBody>
       </p:sp>
       <p:sp>
         <p:nvSpPr>
-          <p:cNvPr id="17" name="Text 15"/>
+          <p:cNvPr id="14" name="Shape 12"/>
+          <p:cNvSpPr/>
+          <p:nvPr/>
+        </p:nvSpPr>
+        <p:spPr>
+          <a:xfrm>
+            <a:off x="6172200" y="2788920"/>
+            <a:ext cx="5468112" cy="1874520"/>
+          </a:xfrm>
+          <a:prstGeom prst="roundRect">
+            <a:avLst>
+              <a:gd name="adj" fmla="val 3415"/>
+            </a:avLst>
+          </a:prstGeom>
+          <a:solidFill>
+            <a:srgbClr val="EAF3EC"/>
+          </a:solidFill>
+          <a:ln w="15240">
+            <a:solidFill>
+              <a:srgbClr val="4F9D5D"/>
+            </a:solidFill>
+            <a:prstDash val="solid"/>
+          </a:ln>
+        </p:spPr>
+      </p:sp>
+      <p:sp>
+        <p:nvSpPr>
+          <p:cNvPr id="15" name="Text 13"/>
           <p:cNvSpPr txBox="1"/>
           <p:nvPr/>
         </p:nvSpPr>
         <p:spPr>
           <a:xfrm>
-            <a:off x="640080" y="3931920"/>
-            <a:ext cx="10881360" cy="320040"/>
+            <a:off x="6400800" y="2926080"/>
+            <a:ext cx="5029200" cy="292608"/>
           </a:xfrm>
           <a:prstGeom prst="rect">
             <a:avLst/>
@@ -6406,15 +6484,178 @@
             <a:r>
               <a:rPr lang="en-US" sz="1300" b="1" dirty="0">
                 <a:solidFill>
+                  <a:srgbClr val="2F7D3A"/>
+                </a:solidFill>
+                <a:latin typeface="Arial" pitchFamily="34" charset="0"/>
+                <a:ea typeface="Arial" pitchFamily="34" charset="-122"/>
+                <a:cs typeface="Arial" pitchFamily="34" charset="-120"/>
+              </a:rPr>
+              <a:t>Ví dụ — PM2.5 (TB 24h) = 35,2</a:t>
+            </a:r>
+            <a:endParaRPr lang="en-US" sz="1300" dirty="0"/>
+          </a:p>
+        </p:txBody>
+      </p:sp>
+      <p:sp>
+        <p:nvSpPr>
+          <p:cNvPr id="16" name="Text 14"/>
+          <p:cNvSpPr txBox="1"/>
+          <p:nvPr/>
+        </p:nvSpPr>
+        <p:spPr>
+          <a:xfrm>
+            <a:off x="6400800" y="3218688"/>
+            <a:ext cx="5074920" cy="1417320"/>
+          </a:xfrm>
+          <a:prstGeom prst="rect">
+            <a:avLst/>
+          </a:prstGeom>
+          <a:noFill/>
+          <a:ln/>
+        </p:spPr>
+        <p:txBody>
+          <a:bodyPr wrap="square" rtlCol="0" anchor="t"/>
+          <a:lstStyle/>
+          <a:p>
+            <a:pPr indent="0" marL="0">
+              <a:lnSpc>
+                <a:spcPct val="106000"/>
+              </a:lnSpc>
+              <a:spcAft>
+                <a:spcPts val="500"/>
+              </a:spcAft>
+              <a:buNone/>
+            </a:pPr>
+            <a:r>
+              <a:rPr lang="en-US" sz="1150" dirty="0">
+                <a:solidFill>
+                  <a:srgbClr val="253044"/>
+                </a:solidFill>
+                <a:latin typeface="Arial" pitchFamily="34" charset="0"/>
+                <a:ea typeface="Arial" pitchFamily="34" charset="-122"/>
+                <a:cs typeface="Arial" pitchFamily="34" charset="-120"/>
+              </a:rPr>
+              <a:t>35,2 rơi vào khoảng [25 ; 50] → điểm [50 ; 100]
+</a:t>
+            </a:r>
+            <a:endParaRPr lang="en-US" sz="1150" dirty="0"/>
+          </a:p>
+          <a:p>
+            <a:pPr indent="0" marL="0">
+              <a:lnSpc>
+                <a:spcPct val="106000"/>
+              </a:lnSpc>
+              <a:buNone/>
+            </a:pPr>
+            <a:r>
+              <a:rPr lang="en-US" sz="1150" dirty="0">
+                <a:solidFill>
+                  <a:srgbClr val="253044"/>
+                </a:solidFill>
+                <a:latin typeface="Courier New" pitchFamily="34" charset="0"/>
+                <a:ea typeface="Courier New" pitchFamily="34" charset="-122"/>
+                <a:cs typeface="Courier New" pitchFamily="34" charset="-120"/>
+              </a:rPr>
+              <a:t>IAQI = (100−50)/(50−25) × (35,2−25) + 50
+</a:t>
+            </a:r>
+            <a:endParaRPr lang="en-US" sz="1150" dirty="0"/>
+          </a:p>
+          <a:p>
+            <a:pPr indent="0" marL="0">
+              <a:lnSpc>
+                <a:spcPct val="106000"/>
+              </a:lnSpc>
+              <a:buNone/>
+            </a:pPr>
+            <a:r>
+              <a:rPr lang="en-US" sz="1150" dirty="0">
+                <a:solidFill>
+                  <a:srgbClr val="253044"/>
+                </a:solidFill>
+                <a:latin typeface="Courier New" pitchFamily="34" charset="0"/>
+                <a:ea typeface="Courier New" pitchFamily="34" charset="-122"/>
+                <a:cs typeface="Courier New" pitchFamily="34" charset="-120"/>
+              </a:rPr>
+              <a:t>       = 2 × 10,2 + 50 = </a:t>
+            </a:r>
+            <a:pPr indent="0" marL="0">
+              <a:lnSpc>
+                <a:spcPct val="106000"/>
+              </a:lnSpc>
+              <a:buNone/>
+            </a:pPr>
+            <a:r>
+              <a:rPr lang="en-US" sz="1300" b="1" dirty="0">
+                <a:solidFill>
+                  <a:srgbClr val="2F7D3A"/>
+                </a:solidFill>
+                <a:latin typeface="Arial" pitchFamily="34" charset="0"/>
+                <a:ea typeface="Arial" pitchFamily="34" charset="-122"/>
+                <a:cs typeface="Arial" pitchFamily="34" charset="-120"/>
+              </a:rPr>
+              <a:t>70,4</a:t>
+            </a:r>
+            <a:endParaRPr lang="en-US" sz="1150" dirty="0"/>
+          </a:p>
+          <a:p>
+            <a:pPr indent="0" marL="0">
+              <a:lnSpc>
+                <a:spcPct val="106000"/>
+              </a:lnSpc>
+              <a:buNone/>
+            </a:pPr>
+            <a:r>
+              <a:rPr lang="en-US" sz="1100" i="1" dirty="0">
+                <a:solidFill>
+                  <a:srgbClr val="6B7280"/>
+                </a:solidFill>
+                <a:latin typeface="Arial" pitchFamily="34" charset="0"/>
+                <a:ea typeface="Arial" pitchFamily="34" charset="-122"/>
+                <a:cs typeface="Arial" pitchFamily="34" charset="-120"/>
+              </a:rPr>
+              <a:t>→ 35,2 nằm ~40% đoạn nồng độ nên điểm cũng ~40% đoạn AQI.</a:t>
+            </a:r>
+            <a:endParaRPr lang="en-US" sz="1150" dirty="0"/>
+          </a:p>
+        </p:txBody>
+      </p:sp>
+      <p:sp>
+        <p:nvSpPr>
+          <p:cNvPr id="17" name="Text 15"/>
+          <p:cNvSpPr txBox="1"/>
+          <p:nvPr/>
+        </p:nvSpPr>
+        <p:spPr>
+          <a:xfrm>
+            <a:off x="548640" y="4828032"/>
+            <a:ext cx="11091672" cy="274320"/>
+          </a:xfrm>
+          <a:prstGeom prst="rect">
+            <a:avLst/>
+          </a:prstGeom>
+          <a:noFill/>
+          <a:ln/>
+        </p:spPr>
+        <p:txBody>
+          <a:bodyPr wrap="square" rtlCol="0" anchor="ctr"/>
+          <a:lstStyle/>
+          <a:p>
+            <a:pPr indent="0" marL="0">
+              <a:buNone/>
+            </a:pPr>
+            <a:r>
+              <a:rPr lang="en-US" sz="1250" b="1" dirty="0">
+                <a:solidFill>
                   <a:srgbClr val="1F3864"/>
                 </a:solidFill>
                 <a:latin typeface="Arial" pitchFamily="34" charset="0"/>
                 <a:ea typeface="Arial" pitchFamily="34" charset="-122"/>
                 <a:cs typeface="Arial" pitchFamily="34" charset="-120"/>
               </a:rPr>
-              <a:t>Sáu mức AQI theo QĐ 1459</a:t>
-            </a:r>
-            <a:endParaRPr lang="en-US" sz="1300" dirty="0"/>
+              <a:t>Sáu mức AQI theo QĐ 1459 — tra nhãn/màu từ giá trị AQI cuối</a:t>
+            </a:r>
+            <a:endParaRPr lang="en-US" sz="1250" dirty="0"/>
           </a:p>
         </p:txBody>
       </p:sp>
@@ -6426,12 +6667,12 @@
         </p:nvSpPr>
         <p:spPr>
           <a:xfrm>
-            <a:off x="685800" y="4315968"/>
-            <a:ext cx="1693164" cy="1234440"/>
+            <a:off x="594360" y="5138928"/>
+            <a:ext cx="1714500" cy="932688"/>
           </a:xfrm>
           <a:prstGeom prst="roundRect">
             <a:avLst>
-              <a:gd name="adj" fmla="val 4444"/>
+              <a:gd name="adj" fmla="val 5882"/>
             </a:avLst>
           </a:prstGeom>
           <a:solidFill>
@@ -6455,8 +6696,8 @@
         </p:nvSpPr>
         <p:spPr>
           <a:xfrm>
-            <a:off x="685800" y="4315968"/>
-            <a:ext cx="1693164" cy="1234440"/>
+            <a:off x="594360" y="5138928"/>
+            <a:ext cx="1714500" cy="932688"/>
           </a:xfrm>
           <a:prstGeom prst="rect">
             <a:avLst/>
@@ -6472,7 +6713,7 @@
               <a:buNone/>
             </a:pPr>
             <a:r>
-              <a:rPr lang="en-US" sz="1800" b="1" dirty="0">
+              <a:rPr lang="en-US" sz="1600" b="1" dirty="0">
                 <a:solidFill>
                   <a:srgbClr val="1F2A37"/>
                 </a:solidFill>
@@ -6487,7 +6728,7 @@
               <a:buNone/>
             </a:pPr>
             <a:r>
-              <a:rPr lang="en-US" sz="1150" b="1" dirty="0">
+              <a:rPr lang="en-US" sz="1100" b="1" dirty="0">
                 <a:solidFill>
                   <a:srgbClr val="1F2A37"/>
                 </a:solidFill>
@@ -6502,7 +6743,7 @@
               <a:buNone/>
             </a:pPr>
             <a:r>
-              <a:rPr lang="en-US" sz="1000" dirty="0">
+              <a:rPr lang="en-US" sz="950" dirty="0">
                 <a:solidFill>
                   <a:srgbClr val="33404D"/>
                 </a:solidFill>
@@ -6512,7 +6753,7 @@
               </a:rPr>
               <a:t>0–50</a:t>
             </a:r>
-            <a:endParaRPr lang="en-US" sz="1800" dirty="0"/>
+            <a:endParaRPr lang="en-US" sz="1600" dirty="0"/>
           </a:p>
         </p:txBody>
       </p:sp>
@@ -6524,12 +6765,12 @@
         </p:nvSpPr>
         <p:spPr>
           <a:xfrm>
-            <a:off x="2506980" y="4315968"/>
-            <a:ext cx="1693164" cy="1234440"/>
+            <a:off x="2427732" y="5138928"/>
+            <a:ext cx="1714500" cy="932688"/>
           </a:xfrm>
           <a:prstGeom prst="roundRect">
             <a:avLst>
-              <a:gd name="adj" fmla="val 4444"/>
+              <a:gd name="adj" fmla="val 5882"/>
             </a:avLst>
           </a:prstGeom>
           <a:solidFill>
@@ -6553,8 +6794,8 @@
         </p:nvSpPr>
         <p:spPr>
           <a:xfrm>
-            <a:off x="2506980" y="4315968"/>
-            <a:ext cx="1693164" cy="1234440"/>
+            <a:off x="2427732" y="5138928"/>
+            <a:ext cx="1714500" cy="932688"/>
           </a:xfrm>
           <a:prstGeom prst="rect">
             <a:avLst/>
@@ -6570,7 +6811,7 @@
               <a:buNone/>
             </a:pPr>
             <a:r>
-              <a:rPr lang="en-US" sz="1800" b="1" dirty="0">
+              <a:rPr lang="en-US" sz="1600" b="1" dirty="0">
                 <a:solidFill>
                   <a:srgbClr val="1F2A37"/>
                 </a:solidFill>
@@ -6585,7 +6826,7 @@
               <a:buNone/>
             </a:pPr>
             <a:r>
-              <a:rPr lang="en-US" sz="1150" b="1" dirty="0">
+              <a:rPr lang="en-US" sz="1100" b="1" dirty="0">
                 <a:solidFill>
                   <a:srgbClr val="1F2A37"/>
                 </a:solidFill>
@@ -6600,7 +6841,7 @@
               <a:buNone/>
             </a:pPr>
             <a:r>
-              <a:rPr lang="en-US" sz="1000" dirty="0">
+              <a:rPr lang="en-US" sz="950" dirty="0">
                 <a:solidFill>
                   <a:srgbClr val="33404D"/>
                 </a:solidFill>
@@ -6610,7 +6851,7 @@
               </a:rPr>
               <a:t>51–100</a:t>
             </a:r>
-            <a:endParaRPr lang="en-US" sz="1800" dirty="0"/>
+            <a:endParaRPr lang="en-US" sz="1600" dirty="0"/>
           </a:p>
         </p:txBody>
       </p:sp>
@@ -6622,12 +6863,12 @@
         </p:nvSpPr>
         <p:spPr>
           <a:xfrm>
-            <a:off x="4328160" y="4315968"/>
-            <a:ext cx="1693164" cy="1234440"/>
+            <a:off x="4261104" y="5138928"/>
+            <a:ext cx="1714500" cy="932688"/>
           </a:xfrm>
           <a:prstGeom prst="roundRect">
             <a:avLst>
-              <a:gd name="adj" fmla="val 4444"/>
+              <a:gd name="adj" fmla="val 5882"/>
             </a:avLst>
           </a:prstGeom>
           <a:solidFill>
@@ -6651,8 +6892,8 @@
         </p:nvSpPr>
         <p:spPr>
           <a:xfrm>
-            <a:off x="4328160" y="4315968"/>
-            <a:ext cx="1693164" cy="1234440"/>
+            <a:off x="4261104" y="5138928"/>
+            <a:ext cx="1714500" cy="932688"/>
           </a:xfrm>
           <a:prstGeom prst="rect">
             <a:avLst/>
@@ -6668,7 +6909,7 @@
               <a:buNone/>
             </a:pPr>
             <a:r>
-              <a:rPr lang="en-US" sz="1800" b="1" dirty="0">
+              <a:rPr lang="en-US" sz="1600" b="1" dirty="0">
                 <a:solidFill>
                   <a:srgbClr val="FFFFFF"/>
                 </a:solidFill>
@@ -6683,7 +6924,7 @@
               <a:buNone/>
             </a:pPr>
             <a:r>
-              <a:rPr lang="en-US" sz="1150" b="1" dirty="0">
+              <a:rPr lang="en-US" sz="1100" b="1" dirty="0">
                 <a:solidFill>
                   <a:srgbClr val="FFFFFF"/>
                 </a:solidFill>
@@ -6698,7 +6939,7 @@
               <a:buNone/>
             </a:pPr>
             <a:r>
-              <a:rPr lang="en-US" sz="1000" dirty="0">
+              <a:rPr lang="en-US" sz="950" dirty="0">
                 <a:solidFill>
                   <a:srgbClr val="F2F2F2"/>
                 </a:solidFill>
@@ -6708,7 +6949,7 @@
               </a:rPr>
               <a:t>101–150</a:t>
             </a:r>
-            <a:endParaRPr lang="en-US" sz="1800" dirty="0"/>
+            <a:endParaRPr lang="en-US" sz="1600" dirty="0"/>
           </a:p>
         </p:txBody>
       </p:sp>
@@ -6720,12 +6961,12 @@
         </p:nvSpPr>
         <p:spPr>
           <a:xfrm>
-            <a:off x="6149340" y="4315968"/>
-            <a:ext cx="1693164" cy="1234440"/>
+            <a:off x="6094476" y="5138928"/>
+            <a:ext cx="1714500" cy="932688"/>
           </a:xfrm>
           <a:prstGeom prst="roundRect">
             <a:avLst>
-              <a:gd name="adj" fmla="val 4444"/>
+              <a:gd name="adj" fmla="val 5882"/>
             </a:avLst>
           </a:prstGeom>
           <a:solidFill>
@@ -6749,8 +6990,8 @@
         </p:nvSpPr>
         <p:spPr>
           <a:xfrm>
-            <a:off x="6149340" y="4315968"/>
-            <a:ext cx="1693164" cy="1234440"/>
+            <a:off x="6094476" y="5138928"/>
+            <a:ext cx="1714500" cy="932688"/>
           </a:xfrm>
           <a:prstGeom prst="rect">
             <a:avLst/>
@@ -6766,7 +7007,7 @@
               <a:buNone/>
             </a:pPr>
             <a:r>
-              <a:rPr lang="en-US" sz="1800" b="1" dirty="0">
+              <a:rPr lang="en-US" sz="1600" b="1" dirty="0">
                 <a:solidFill>
                   <a:srgbClr val="FFFFFF"/>
                 </a:solidFill>
@@ -6781,7 +7022,7 @@
               <a:buNone/>
             </a:pPr>
             <a:r>
-              <a:rPr lang="en-US" sz="1150" b="1" dirty="0">
+              <a:rPr lang="en-US" sz="1100" b="1" dirty="0">
                 <a:solidFill>
                   <a:srgbClr val="FFFFFF"/>
                 </a:solidFill>
@@ -6796,7 +7037,7 @@
               <a:buNone/>
             </a:pPr>
             <a:r>
-              <a:rPr lang="en-US" sz="1000" dirty="0">
+              <a:rPr lang="en-US" sz="950" dirty="0">
                 <a:solidFill>
                   <a:srgbClr val="F2F2F2"/>
                 </a:solidFill>
@@ -6806,7 +7047,7 @@
               </a:rPr>
               <a:t>151–200</a:t>
             </a:r>
-            <a:endParaRPr lang="en-US" sz="1800" dirty="0"/>
+            <a:endParaRPr lang="en-US" sz="1600" dirty="0"/>
           </a:p>
         </p:txBody>
       </p:sp>
@@ -6818,12 +7059,12 @@
         </p:nvSpPr>
         <p:spPr>
           <a:xfrm>
-            <a:off x="7970520" y="4315968"/>
-            <a:ext cx="1693164" cy="1234440"/>
+            <a:off x="7927848" y="5138928"/>
+            <a:ext cx="1714500" cy="932688"/>
           </a:xfrm>
           <a:prstGeom prst="roundRect">
             <a:avLst>
-              <a:gd name="adj" fmla="val 4444"/>
+              <a:gd name="adj" fmla="val 5882"/>
             </a:avLst>
           </a:prstGeom>
           <a:solidFill>
@@ -6847,8 +7088,8 @@
         </p:nvSpPr>
         <p:spPr>
           <a:xfrm>
-            <a:off x="7970520" y="4315968"/>
-            <a:ext cx="1693164" cy="1234440"/>
+            <a:off x="7927848" y="5138928"/>
+            <a:ext cx="1714500" cy="932688"/>
           </a:xfrm>
           <a:prstGeom prst="rect">
             <a:avLst/>
@@ -6864,7 +7105,7 @@
               <a:buNone/>
             </a:pPr>
             <a:r>
-              <a:rPr lang="en-US" sz="1800" b="1" dirty="0">
+              <a:rPr lang="en-US" sz="1600" b="1" dirty="0">
                 <a:solidFill>
                   <a:srgbClr val="FFFFFF"/>
                 </a:solidFill>
@@ -6879,7 +7120,7 @@
               <a:buNone/>
             </a:pPr>
             <a:r>
-              <a:rPr lang="en-US" sz="1150" b="1" dirty="0">
+              <a:rPr lang="en-US" sz="1100" b="1" dirty="0">
                 <a:solidFill>
                   <a:srgbClr val="FFFFFF"/>
                 </a:solidFill>
@@ -6894,7 +7135,7 @@
               <a:buNone/>
             </a:pPr>
             <a:r>
-              <a:rPr lang="en-US" sz="1000" dirty="0">
+              <a:rPr lang="en-US" sz="950" dirty="0">
                 <a:solidFill>
                   <a:srgbClr val="F2F2F2"/>
                 </a:solidFill>
@@ -6904,7 +7145,7 @@
               </a:rPr>
               <a:t>201–300</a:t>
             </a:r>
-            <a:endParaRPr lang="en-US" sz="1800" dirty="0"/>
+            <a:endParaRPr lang="en-US" sz="1600" dirty="0"/>
           </a:p>
         </p:txBody>
       </p:sp>
@@ -6916,12 +7157,12 @@
         </p:nvSpPr>
         <p:spPr>
           <a:xfrm>
-            <a:off x="9791700" y="4315968"/>
-            <a:ext cx="1693164" cy="1234440"/>
+            <a:off x="9761220" y="5138928"/>
+            <a:ext cx="1714500" cy="932688"/>
           </a:xfrm>
           <a:prstGeom prst="roundRect">
             <a:avLst>
-              <a:gd name="adj" fmla="val 4444"/>
+              <a:gd name="adj" fmla="val 5882"/>
             </a:avLst>
           </a:prstGeom>
           <a:solidFill>
@@ -6945,8 +7186,8 @@
         </p:nvSpPr>
         <p:spPr>
           <a:xfrm>
-            <a:off x="9791700" y="4315968"/>
-            <a:ext cx="1693164" cy="1234440"/>
+            <a:off x="9761220" y="5138928"/>
+            <a:ext cx="1714500" cy="932688"/>
           </a:xfrm>
           <a:prstGeom prst="rect">
             <a:avLst/>
@@ -6962,7 +7203,7 @@
               <a:buNone/>
             </a:pPr>
             <a:r>
-              <a:rPr lang="en-US" sz="1800" b="1" dirty="0">
+              <a:rPr lang="en-US" sz="1600" b="1" dirty="0">
                 <a:solidFill>
                   <a:srgbClr val="FFFFFF"/>
                 </a:solidFill>
@@ -6977,7 +7218,7 @@
               <a:buNone/>
             </a:pPr>
             <a:r>
-              <a:rPr lang="en-US" sz="1150" b="1" dirty="0">
+              <a:rPr lang="en-US" sz="1100" b="1" dirty="0">
                 <a:solidFill>
                   <a:srgbClr val="FFFFFF"/>
                 </a:solidFill>
@@ -6992,7 +7233,7 @@
               <a:buNone/>
             </a:pPr>
             <a:r>
-              <a:rPr lang="en-US" sz="1000" dirty="0">
+              <a:rPr lang="en-US" sz="950" dirty="0">
                 <a:solidFill>
                   <a:srgbClr val="F2F2F2"/>
                 </a:solidFill>
@@ -7002,7 +7243,7 @@
               </a:rPr>
               <a:t>301–500</a:t>
             </a:r>
-            <a:endParaRPr lang="en-US" sz="1800" dirty="0"/>
+            <a:endParaRPr lang="en-US" sz="1600" dirty="0"/>
           </a:p>
         </p:txBody>
       </p:sp>

</xml_diff>

<commit_message>
docs: slide 3.5 - viết lại phần lưu ý scalability bằng ngôn ngữ tự nhiên
Đổi ô 'Đọc & lưu ý' (một câu cô đọng, nhiều thuật ngữ) thành 3 gạch đầu
dòng dễ hiểu: dữ liệu nhỏ chia nhiều máy chậm hơn; gấp đôi máy không nhanh
gấp đôi (serialize + shuffle); mới chạy trên một máy nên là bằng chứng xu hướng.

Co-Authored-By: Claude Opus 4.8 <noreply@anthropic.com>
Claude-Session: https://claude.ai/code/session_01FrxD6iyiu71sw2RmUtSxFy
</commit_message>
<xml_diff>
--- a/docs/slides/Slide_Huyen_theo_mau.pptx
+++ b/docs/slides/Slide_Huyen_theo_mau.pptx
@@ -8911,12 +8911,12 @@
         </p:nvSpPr>
         <p:spPr>
           <a:xfrm>
-            <a:off x="640080" y="5029200"/>
-            <a:ext cx="10881360" cy="1051560"/>
+            <a:off x="640080" y="4892040"/>
+            <a:ext cx="10881360" cy="1371600"/>
           </a:xfrm>
           <a:prstGeom prst="roundRect">
             <a:avLst>
-              <a:gd name="adj" fmla="val 6087"/>
+              <a:gd name="adj" fmla="val 4667"/>
             </a:avLst>
           </a:prstGeom>
           <a:solidFill>
@@ -8945,8 +8945,8 @@
         </p:nvSpPr>
         <p:spPr>
           <a:xfrm>
-            <a:off x="640080" y="5029200"/>
-            <a:ext cx="109728" cy="1051560"/>
+            <a:off x="640080" y="4892040"/>
+            <a:ext cx="109728" cy="1371600"/>
           </a:xfrm>
           <a:prstGeom prst="roundRect">
             <a:avLst/>
@@ -8965,8 +8965,8 @@
         </p:nvSpPr>
         <p:spPr>
           <a:xfrm>
-            <a:off x="896112" y="5029200"/>
-            <a:ext cx="10469880" cy="1051560"/>
+            <a:off x="896112" y="4956048"/>
+            <a:ext cx="10424160" cy="274320"/>
           </a:xfrm>
           <a:prstGeom prst="rect">
             <a:avLst/>
@@ -8975,7 +8975,7 @@
           <a:ln/>
         </p:spPr>
         <p:txBody>
-          <a:bodyPr wrap="square" rtlCol="0" anchor="ctr"/>
+          <a:bodyPr wrap="square" lIns="0" tIns="0" rIns="0" bIns="0" rtlCol="0" anchor="ctr"/>
           <a:lstStyle/>
           <a:p>
             <a:pPr indent="0" marL="0">
@@ -8984,19 +8984,48 @@
             <a:r>
               <a:rPr lang="en-US" sz="1250" b="1" dirty="0">
                 <a:solidFill>
-                  <a:srgbClr val="E08A3C"/>
-                </a:solidFill>
-                <a:latin typeface="Arial" pitchFamily="34" charset="0"/>
-                <a:ea typeface="Arial" pitchFamily="34" charset="-122"/>
-                <a:cs typeface="Arial" pitchFamily="34" charset="-120"/>
-              </a:rPr>
-              <a:t>Đọc &amp; lưu ý  </a:t>
-            </a:r>
-            <a:pPr indent="0" marL="0">
-              <a:buNone/>
-            </a:pPr>
-            <a:r>
-              <a:rPr lang="en-US" sz="1250" dirty="0">
+                  <a:srgbClr val="C06A1E"/>
+                </a:solidFill>
+                <a:latin typeface="Arial" pitchFamily="34" charset="0"/>
+                <a:ea typeface="Arial" pitchFamily="34" charset="-122"/>
+                <a:cs typeface="Arial" pitchFamily="34" charset="-120"/>
+              </a:rPr>
+              <a:t>Vài điều rút ra</a:t>
+            </a:r>
+            <a:endParaRPr lang="en-US" sz="1250" dirty="0"/>
+          </a:p>
+        </p:txBody>
+      </p:sp>
+      <p:sp>
+        <p:nvSpPr>
+          <p:cNvPr id="13" name="Text 9"/>
+          <p:cNvSpPr txBox="1"/>
+          <p:nvPr/>
+        </p:nvSpPr>
+        <p:spPr>
+          <a:xfrm>
+            <a:off x="896112" y="5230368"/>
+            <a:ext cx="10424160" cy="987552"/>
+          </a:xfrm>
+          <a:prstGeom prst="rect">
+            <a:avLst/>
+          </a:prstGeom>
+          <a:noFill/>
+          <a:ln/>
+        </p:spPr>
+        <p:txBody>
+          <a:bodyPr wrap="square" lIns="0" tIns="0" rIns="0" bIns="0" rtlCol="0" anchor="t"/>
+          <a:lstStyle/>
+          <a:p>
+            <a:pPr marL="342900" indent="-342900">
+              <a:spcAft>
+                <a:spcPts val="500"/>
+              </a:spcAft>
+              <a:buSzPct val="100000"/>
+              <a:buChar char="•"/>
+            </a:pPr>
+            <a:r>
+              <a:rPr lang="en-US" sz="1150" dirty="0">
                 <a:solidFill>
                   <a:srgbClr val="253044"/>
                 </a:solidFill>
@@ -9004,9 +9033,48 @@
                 <a:ea typeface="Arial" pitchFamily="34" charset="-122"/>
                 <a:cs typeface="Arial" pitchFamily="34" charset="-120"/>
               </a:rPr>
-              <a:t>100K: 4 exec còn chậm hơn 2 exec (overhead lấn át). Dưới tuyến tính do Python UDF serialize + shuffle. Hạn chế: 4 worker trên MỘT máy Docker — chưa phải cụm nhiều node.</a:t>
-            </a:r>
-            <a:endParaRPr lang="en-US" sz="1250" dirty="0"/>
+              <a:t>Dữ liệu nhỏ (100K): chia cho 4 máy còn chậm hơn 2 máy — vì thời gian “chia việc và gom lại” nhiều hơn thời gian tính thật.</a:t>
+            </a:r>
+            <a:endParaRPr lang="en-US" sz="1150" dirty="0"/>
+          </a:p>
+          <a:p>
+            <a:pPr marL="342900" indent="-342900">
+              <a:spcAft>
+                <a:spcPts val="500"/>
+              </a:spcAft>
+              <a:buSzPct val="100000"/>
+              <a:buChar char="•"/>
+            </a:pPr>
+            <a:r>
+              <a:rPr lang="en-US" sz="1150" dirty="0">
+                <a:solidFill>
+                  <a:srgbClr val="253044"/>
+                </a:solidFill>
+                <a:latin typeface="Arial" pitchFamily="34" charset="0"/>
+                <a:ea typeface="Arial" pitchFamily="34" charset="-122"/>
+                <a:cs typeface="Arial" pitchFamily="34" charset="-120"/>
+              </a:rPr>
+              <a:t>Gấp đôi số máy không nhanh gấp đôi — dữ liệu phải chuyển qua lại giữa Spark (Java) và Python, cộng thêm bước gom dữ liệu (shuffle).</a:t>
+            </a:r>
+            <a:endParaRPr lang="en-US" sz="1150" dirty="0"/>
+          </a:p>
+          <a:p>
+            <a:pPr marL="342900" indent="-342900">
+              <a:buSzPct val="100000"/>
+              <a:buChar char="•"/>
+            </a:pPr>
+            <a:r>
+              <a:rPr lang="en-US" sz="1150" dirty="0">
+                <a:solidFill>
+                  <a:srgbClr val="253044"/>
+                </a:solidFill>
+                <a:latin typeface="Arial" pitchFamily="34" charset="0"/>
+                <a:ea typeface="Arial" pitchFamily="34" charset="-122"/>
+                <a:cs typeface="Arial" pitchFamily="34" charset="-120"/>
+              </a:rPr>
+              <a:t>Mới chạy 4 worker trên cùng một máy Docker, chưa phải nhiều máy thật — nên đây là bằng chứng về xu hướng, chưa phải đo trên cụm thật.</a:t>
+            </a:r>
+            <a:endParaRPr lang="en-US" sz="1150" dirty="0"/>
           </a:p>
         </p:txBody>
       </p:sp>

</xml_diff>

<commit_message>
docs: gộp 2 slide Pha1 + Pha2/3 thành 1 slide 3.2 'Chi tiết ba pha' (3 cột)
Giảm trùng với sơ đồ 3.1: một slide 3 cột ngắn gọn (điểm chính + đầu ra
mỗi pha) thay cho 2 slide mô tả quy trình. Đánh số lại 3.3 AQI, 3.4
scalability, 3.5 mở rộng. Deck còn 6 slide.

Co-Authored-By: Claude Opus 4.8 <noreply@anthropic.com>
Claude-Session: https://claude.ai/code/session_01FrxD6iyiu71sw2RmUtSxFy
</commit_message>
<xml_diff>
--- a/docs/slides/Slide_Huyen_theo_mau.pptx
+++ b/docs/slides/Slide_Huyen_theo_mau.pptx
@@ -11,10 +11,9 @@
     <p:sldId id="259" r:id="rId5"/>
     <p:sldId id="260" r:id="rId6"/>
     <p:sldId id="261" r:id="rId7"/>
-    <p:sldId id="262" r:id="rId8"/>
   </p:sldIdLst>
   <p:notesMasterIdLst>
-    <p:notesMasterId r:id="rId9"/>
+    <p:notesMasterId r:id="rId8"/>
   </p:notesMasterIdLst>
   <p:sldSz cx="12192000" cy="6858000"/>
   <p:notesSz cx="6858000" cy="12192000"/>
@@ -684,7 +683,7 @@
           <a:p>
             <a:r>
               <a:rPr lang="en-US" dirty="0"/>
-              <a:t>Pha 1 làm sạch 5 bước. Nhấn bước 3 (lưới giờ giải thích 8,7tr vs 8,5tr) và bước 4 (chỉ nội suy khe ≤3h nên tỉ lệ rất nhỏ, trung thực). 97,6% ngày đủ chuẩn. Ảnh là báo cáo chất lượng thật.</a:t>
+              <a:t>Ba pha chi tiết. Pha 1: khử trùng lặp, loại ngoại lai, lưới giờ đầy đủ, nội suy khe ≤3h, 97,6% ngày đạt. Pha 2: NowCast 12h→IAQI→AQI=max, dùng chung aqi_core, /aqi 593MB. Pha 3: gom (thành phố,ngày), đếm mức, xếp hạng, ghi HBase, /agg ~8,26 phút. Chốt: chung aqi_core; owm_aqi chỉ đối chiếu.</a:t>
             </a:r>
             <a:endParaRPr lang="en-US" dirty="0"/>
           </a:p>
@@ -772,7 +771,7 @@
           <a:p>
             <a:r>
               <a:rPr lang="en-US" dirty="0"/>
-              <a:t>Pha 2: NowCast 12h/trạm → IAQI → AQI=max → mức+chất trội. Pha 3: gom (thành phố,ngày), xếp hạng, ghi HBase. Chốt: dùng chung aqi_core; owm_aqi chỉ đối chiếu.</a:t>
+              <a:t>Đóng góp khoa học: IAQI nội suy tuyến tính theo breakpoint; AQI=max 6 chất; dominant=chất cho max. Ví dụ PM2.5 35,2→70,4. NowCast 12h (giờ) vs TB24h (ngày). Sáu mức QĐ1459.</a:t>
             </a:r>
             <a:endParaRPr lang="en-US" dirty="0"/>
           </a:p>
@@ -860,7 +859,7 @@
           <a:p>
             <a:r>
               <a:rPr lang="en-US" dirty="0"/>
-              <a:t>Đóng góp khoa học: IAQI nội suy tuyến tính theo breakpoint; AQI=max 6 chất; dominant=chất cho max. Ví dụ PM2.5 35,2→70,4. NowCast 12h (giờ) vs TB24h (ngày). Sáu mức QĐ1459.</a:t>
+              <a:t>Bảng thời gian Pha 2 theo 1/2/4 executor; ★ 8M speedup 2,43×. 100K overhead nên 4 exec chậm hơn 2. Dưới tuyến tính do UDF serialize+shuffle. Hạn chế: một máy. Chốt: dữ liệu lớn mới thấy lợi ích phân tán → cần Big Data.</a:t>
             </a:r>
             <a:endParaRPr lang="en-US" dirty="0"/>
           </a:p>
@@ -948,7 +947,7 @@
           <a:p>
             <a:r>
               <a:rPr lang="en-US" dirty="0"/>
-              <a:t>Bảng thời gian Pha 2 theo 1/2/4 executor; ★ 8M speedup 2,43×. 100K overhead nên 4 exec chậm hơn 2. Dưới tuyến tính do UDF serialize+shuffle. Hạn chế: một máy. Chốt: dữ liệu lớn mới thấy lợi ích phân tán → cần Big Data.</a:t>
+              <a:t>Nhánh mở rộng — máy tự chọn. Phân cụm: 5 thuật toán 3 tầng, chọn theo silhouette → K-means k=3 (0,3547), thắng sát Bisecting, HDBSCAN loại, cấu trúc yếu. Dự báo: 3 tầng SGD/Random Forest/CNN-LSTM, chọn theo RMSE/R² → Random Forest (20,10; 0,7297); SGD thắng MAE; CNN-LSTM ít mẫu test.</a:t>
             </a:r>
             <a:endParaRPr lang="en-US" dirty="0"/>
           </a:p>
@@ -972,94 +971,6 @@
             <a:fld id="{F7021451-1387-4CA6-816F-3879F97B5CBC}" type="slidenum">
               <a:rPr lang="en-US"/>
               <a:t>6</a:t>
-            </a:fld>
-            <a:endParaRPr lang="en-US"/>
-          </a:p>
-        </p:txBody>
-      </p:sp>
-    </p:spTree>
-    <p:extLst>
-      <p:ext uri="{BB962C8B-B14F-4D97-AF65-F5344CB8AC3E}">
-        <p14:creationId xmlns:p14="http://schemas.microsoft.com/office/powerpoint/2010/main" val="1024086991"/>
-      </p:ext>
-    </p:extLst>
-  </p:cSld>
-  <p:clrMapOvr>
-    <a:masterClrMapping/>
-  </p:clrMapOvr>
-</p:notes>
-</file>
-
-<file path=ppt/notesSlides/notesSlide7.xml><?xml version="1.0" encoding="utf-8"?>
-<p:notes xmlns:a="http://schemas.openxmlformats.org/drawingml/2006/main" xmlns:r="http://schemas.openxmlformats.org/officeDocument/2006/relationships" xmlns:p="http://schemas.openxmlformats.org/presentationml/2006/main">
-  <p:cSld>
-    <p:spTree>
-      <p:nvGrpSpPr>
-        <p:cNvPr id="1" name=""/>
-        <p:cNvGrpSpPr/>
-        <p:nvPr/>
-      </p:nvGrpSpPr>
-      <p:grpSpPr>
-        <a:xfrm>
-          <a:off x="0" y="0"/>
-          <a:ext cx="0" cy="0"/>
-          <a:chOff x="0" y="0"/>
-          <a:chExt cx="0" cy="0"/>
-        </a:xfrm>
-      </p:grpSpPr>
-      <p:sp>
-        <p:nvSpPr>
-          <p:cNvPr id="2" name="Slide Image Placeholder 1"/>
-          <p:cNvSpPr>
-            <a:spLocks noGrp="1" noRot="1" noChangeAspect="1"/>
-          </p:cNvSpPr>
-          <p:nvPr>
-            <p:ph type="sldImg"/>
-          </p:nvPr>
-        </p:nvSpPr>
-        <p:spPr/>
-      </p:sp>
-      <p:sp>
-        <p:nvSpPr>
-          <p:cNvPr id="3" name="Notes Placeholder 2"/>
-          <p:cNvSpPr>
-            <a:spLocks noGrp="1"/>
-          </p:cNvSpPr>
-          <p:nvPr>
-            <p:ph type="body" idx="1"/>
-          </p:nvPr>
-        </p:nvSpPr>
-        <p:spPr/>
-        <p:txBody>
-          <a:bodyPr/>
-          <a:lstStyle/>
-          <a:p>
-            <a:r>
-              <a:rPr lang="en-US" dirty="0"/>
-              <a:t>Nhánh mở rộng — máy tự chọn. Phân cụm: 5 thuật toán 3 tầng, chọn theo silhouette → K-means k=3 (0,3547), thắng sát Bisecting, HDBSCAN loại, cấu trúc yếu. Dự báo: 3 tầng SGD/Random Forest/CNN-LSTM, chọn theo RMSE/R² → Random Forest (20,10; 0,7297); SGD thắng MAE; CNN-LSTM ít mẫu test.</a:t>
-            </a:r>
-            <a:endParaRPr lang="en-US" dirty="0"/>
-          </a:p>
-        </p:txBody>
-      </p:sp>
-      <p:sp>
-        <p:nvSpPr>
-          <p:cNvPr id="4" name="Slide Number Placeholder 3"/>
-          <p:cNvSpPr>
-            <a:spLocks noGrp="1"/>
-          </p:cNvSpPr>
-          <p:nvPr>
-            <p:ph type="sldNum" sz="quarter" idx="10"/>
-          </p:nvPr>
-        </p:nvSpPr>
-        <p:spPr/>
-        <p:txBody>
-          <a:bodyPr/>
-          <a:lstStyle/>
-          <a:p>
-            <a:fld id="{F7021451-1387-4CA6-816F-3879F97B5CBC}" type="slidenum">
-              <a:rPr lang="en-US"/>
-              <a:t>7</a:t>
             </a:fld>
             <a:endParaRPr lang="en-US"/>
           </a:p>
@@ -4064,7 +3975,7 @@
                 <a:ea typeface="Arial" pitchFamily="34" charset="-122"/>
                 <a:cs typeface="Arial" pitchFamily="34" charset="-120"/>
               </a:rPr>
-              <a:t>Pha 1 — Làm sạch dữ liệu</a:t>
+              <a:t>Chi tiết ba pha xử lý</a:t>
             </a:r>
             <a:endParaRPr lang="en-US" sz="2300" dirty="0"/>
           </a:p>
@@ -4103,7 +4014,7 @@
                 <a:ea typeface="Arial" pitchFamily="34" charset="-122"/>
                 <a:cs typeface="Arial" pitchFamily="34" charset="-120"/>
               </a:rPr>
-              <a:t>Năm bước biến 8,5 triệu bản ghi thô thành lưới giờ sạch, có gắn cờ chất lượng.</a:t>
+              <a:t>Làm sạch → tính AQI → tổng hợp; mỗi pha thêm một lớp thông tin cho dữ liệu.</a:t>
             </a:r>
             <a:endParaRPr lang="en-US" sz="1350" dirty="0"/>
           </a:p>
@@ -4117,576 +4028,16 @@
         </p:nvSpPr>
         <p:spPr>
           <a:xfrm>
-            <a:off x="640080" y="1728216"/>
-            <a:ext cx="475488" cy="475488"/>
-          </a:xfrm>
-          <a:prstGeom prst="ellipse">
-            <a:avLst/>
-          </a:prstGeom>
-          <a:solidFill>
-            <a:srgbClr val="2E9BA6"/>
-          </a:solidFill>
-          <a:ln/>
-        </p:spPr>
-      </p:sp>
-      <p:sp>
-        <p:nvSpPr>
-          <p:cNvPr id="8" name="Text 6"/>
-          <p:cNvSpPr txBox="1"/>
-          <p:nvPr/>
-        </p:nvSpPr>
-        <p:spPr>
-          <a:xfrm>
-            <a:off x="640080" y="1728216"/>
-            <a:ext cx="475488" cy="475488"/>
-          </a:xfrm>
-          <a:prstGeom prst="rect">
-            <a:avLst/>
-          </a:prstGeom>
-          <a:noFill/>
-          <a:ln/>
-        </p:spPr>
-        <p:txBody>
-          <a:bodyPr wrap="square" lIns="0" tIns="0" rIns="0" bIns="0" rtlCol="0" anchor="ctr"/>
-          <a:lstStyle/>
-          <a:p>
-            <a:pPr algn="ctr" indent="0" marL="0">
-              <a:buNone/>
-            </a:pPr>
-            <a:r>
-              <a:rPr lang="en-US" sz="1300" b="1" dirty="0">
-                <a:solidFill>
-                  <a:srgbClr val="FFFFFF"/>
-                </a:solidFill>
-                <a:latin typeface="Arial" pitchFamily="34" charset="0"/>
-                <a:ea typeface="Arial" pitchFamily="34" charset="-122"/>
-                <a:cs typeface="Arial" pitchFamily="34" charset="-120"/>
-              </a:rPr>
-              <a:t>1</a:t>
-            </a:r>
-            <a:endParaRPr lang="en-US" sz="1300" dirty="0"/>
-          </a:p>
-        </p:txBody>
-      </p:sp>
-      <p:sp>
-        <p:nvSpPr>
-          <p:cNvPr id="9" name="Text 7"/>
-          <p:cNvSpPr txBox="1"/>
-          <p:nvPr/>
-        </p:nvSpPr>
-        <p:spPr>
-          <a:xfrm>
-            <a:off x="1280160" y="1691640"/>
-            <a:ext cx="4937760" cy="566928"/>
-          </a:xfrm>
-          <a:prstGeom prst="rect">
-            <a:avLst/>
-          </a:prstGeom>
-          <a:noFill/>
-          <a:ln/>
-        </p:spPr>
-        <p:txBody>
-          <a:bodyPr wrap="square" rtlCol="0" anchor="ctr"/>
-          <a:lstStyle/>
-          <a:p>
-            <a:pPr indent="0" marL="0">
-              <a:buNone/>
-            </a:pPr>
-            <a:r>
-              <a:rPr lang="en-US" sz="1400" b="1" dirty="0">
-                <a:solidFill>
-                  <a:srgbClr val="1F3864"/>
-                </a:solidFill>
-                <a:latin typeface="Arial" pitchFamily="34" charset="0"/>
-                <a:ea typeface="Arial" pitchFamily="34" charset="-122"/>
-                <a:cs typeface="Arial" pitchFamily="34" charset="-120"/>
-              </a:rPr>
-              <a:t>Khử trùng lặp  </a:t>
-            </a:r>
-            <a:pPr indent="0" marL="0">
-              <a:buNone/>
-            </a:pPr>
-            <a:r>
-              <a:rPr lang="en-US" sz="1200" dirty="0">
-                <a:solidFill>
-                  <a:srgbClr val="253044"/>
-                </a:solidFill>
-                <a:latin typeface="Arial" pitchFamily="34" charset="0"/>
-                <a:ea typeface="Arial" pitchFamily="34" charset="-122"/>
-                <a:cs typeface="Arial" pitchFamily="34" charset="-120"/>
-              </a:rPr>
-              <a:t>— theo (trạm, giờ)</a:t>
-            </a:r>
-            <a:endParaRPr lang="en-US" sz="1400" dirty="0"/>
-          </a:p>
-        </p:txBody>
-      </p:sp>
-      <p:sp>
-        <p:nvSpPr>
-          <p:cNvPr id="10" name="Shape 8"/>
-          <p:cNvSpPr/>
-          <p:nvPr/>
-        </p:nvSpPr>
-        <p:spPr>
-          <a:xfrm>
-            <a:off x="640080" y="2551176"/>
-            <a:ext cx="475488" cy="475488"/>
-          </a:xfrm>
-          <a:prstGeom prst="ellipse">
-            <a:avLst/>
-          </a:prstGeom>
-          <a:solidFill>
-            <a:srgbClr val="2E5AAC"/>
-          </a:solidFill>
-          <a:ln/>
-        </p:spPr>
-      </p:sp>
-      <p:sp>
-        <p:nvSpPr>
-          <p:cNvPr id="11" name="Text 9"/>
-          <p:cNvSpPr txBox="1"/>
-          <p:nvPr/>
-        </p:nvSpPr>
-        <p:spPr>
-          <a:xfrm>
-            <a:off x="640080" y="2551176"/>
-            <a:ext cx="475488" cy="475488"/>
-          </a:xfrm>
-          <a:prstGeom prst="rect">
-            <a:avLst/>
-          </a:prstGeom>
-          <a:noFill/>
-          <a:ln/>
-        </p:spPr>
-        <p:txBody>
-          <a:bodyPr wrap="square" lIns="0" tIns="0" rIns="0" bIns="0" rtlCol="0" anchor="ctr"/>
-          <a:lstStyle/>
-          <a:p>
-            <a:pPr algn="ctr" indent="0" marL="0">
-              <a:buNone/>
-            </a:pPr>
-            <a:r>
-              <a:rPr lang="en-US" sz="1300" b="1" dirty="0">
-                <a:solidFill>
-                  <a:srgbClr val="FFFFFF"/>
-                </a:solidFill>
-                <a:latin typeface="Arial" pitchFamily="34" charset="0"/>
-                <a:ea typeface="Arial" pitchFamily="34" charset="-122"/>
-                <a:cs typeface="Arial" pitchFamily="34" charset="-120"/>
-              </a:rPr>
-              <a:t>2</a:t>
-            </a:r>
-            <a:endParaRPr lang="en-US" sz="1300" dirty="0"/>
-          </a:p>
-        </p:txBody>
-      </p:sp>
-      <p:sp>
-        <p:nvSpPr>
-          <p:cNvPr id="12" name="Text 10"/>
-          <p:cNvSpPr txBox="1"/>
-          <p:nvPr/>
-        </p:nvSpPr>
-        <p:spPr>
-          <a:xfrm>
-            <a:off x="1280160" y="2514600"/>
-            <a:ext cx="4937760" cy="566928"/>
-          </a:xfrm>
-          <a:prstGeom prst="rect">
-            <a:avLst/>
-          </a:prstGeom>
-          <a:noFill/>
-          <a:ln/>
-        </p:spPr>
-        <p:txBody>
-          <a:bodyPr wrap="square" rtlCol="0" anchor="ctr"/>
-          <a:lstStyle/>
-          <a:p>
-            <a:pPr indent="0" marL="0">
-              <a:buNone/>
-            </a:pPr>
-            <a:r>
-              <a:rPr lang="en-US" sz="1400" b="1" dirty="0">
-                <a:solidFill>
-                  <a:srgbClr val="1F3864"/>
-                </a:solidFill>
-                <a:latin typeface="Arial" pitchFamily="34" charset="0"/>
-                <a:ea typeface="Arial" pitchFamily="34" charset="-122"/>
-                <a:cs typeface="Arial" pitchFamily="34" charset="-120"/>
-              </a:rPr>
-              <a:t>Loại giá trị lỗi  </a:t>
-            </a:r>
-            <a:pPr indent="0" marL="0">
-              <a:buNone/>
-            </a:pPr>
-            <a:r>
-              <a:rPr lang="en-US" sz="1200" dirty="0">
-                <a:solidFill>
-                  <a:srgbClr val="253044"/>
-                </a:solidFill>
-                <a:latin typeface="Arial" pitchFamily="34" charset="0"/>
-                <a:ea typeface="Arial" pitchFamily="34" charset="-122"/>
-                <a:cs typeface="Arial" pitchFamily="34" charset="-120"/>
-              </a:rPr>
-              <a:t>— âm / vượt trần vật lý → bỏ ô đó</a:t>
-            </a:r>
-            <a:endParaRPr lang="en-US" sz="1400" dirty="0"/>
-          </a:p>
-        </p:txBody>
-      </p:sp>
-      <p:sp>
-        <p:nvSpPr>
-          <p:cNvPr id="13" name="Shape 11"/>
-          <p:cNvSpPr/>
-          <p:nvPr/>
-        </p:nvSpPr>
-        <p:spPr>
-          <a:xfrm>
-            <a:off x="640080" y="3374136"/>
-            <a:ext cx="475488" cy="475488"/>
-          </a:xfrm>
-          <a:prstGeom prst="ellipse">
-            <a:avLst/>
-          </a:prstGeom>
-          <a:solidFill>
-            <a:srgbClr val="7A5BA6"/>
-          </a:solidFill>
-          <a:ln/>
-        </p:spPr>
-      </p:sp>
-      <p:sp>
-        <p:nvSpPr>
-          <p:cNvPr id="14" name="Text 12"/>
-          <p:cNvSpPr txBox="1"/>
-          <p:nvPr/>
-        </p:nvSpPr>
-        <p:spPr>
-          <a:xfrm>
-            <a:off x="640080" y="3374136"/>
-            <a:ext cx="475488" cy="475488"/>
-          </a:xfrm>
-          <a:prstGeom prst="rect">
-            <a:avLst/>
-          </a:prstGeom>
-          <a:noFill/>
-          <a:ln/>
-        </p:spPr>
-        <p:txBody>
-          <a:bodyPr wrap="square" lIns="0" tIns="0" rIns="0" bIns="0" rtlCol="0" anchor="ctr"/>
-          <a:lstStyle/>
-          <a:p>
-            <a:pPr algn="ctr" indent="0" marL="0">
-              <a:buNone/>
-            </a:pPr>
-            <a:r>
-              <a:rPr lang="en-US" sz="1300" b="1" dirty="0">
-                <a:solidFill>
-                  <a:srgbClr val="FFFFFF"/>
-                </a:solidFill>
-                <a:latin typeface="Arial" pitchFamily="34" charset="0"/>
-                <a:ea typeface="Arial" pitchFamily="34" charset="-122"/>
-                <a:cs typeface="Arial" pitchFamily="34" charset="-120"/>
-              </a:rPr>
-              <a:t>3</a:t>
-            </a:r>
-            <a:endParaRPr lang="en-US" sz="1300" dirty="0"/>
-          </a:p>
-        </p:txBody>
-      </p:sp>
-      <p:sp>
-        <p:nvSpPr>
-          <p:cNvPr id="15" name="Text 13"/>
-          <p:cNvSpPr txBox="1"/>
-          <p:nvPr/>
-        </p:nvSpPr>
-        <p:spPr>
-          <a:xfrm>
-            <a:off x="1280160" y="3337560"/>
-            <a:ext cx="4937760" cy="566928"/>
-          </a:xfrm>
-          <a:prstGeom prst="rect">
-            <a:avLst/>
-          </a:prstGeom>
-          <a:noFill/>
-          <a:ln/>
-        </p:spPr>
-        <p:txBody>
-          <a:bodyPr wrap="square" rtlCol="0" anchor="ctr"/>
-          <a:lstStyle/>
-          <a:p>
-            <a:pPr indent="0" marL="0">
-              <a:buNone/>
-            </a:pPr>
-            <a:r>
-              <a:rPr lang="en-US" sz="1400" b="1" dirty="0">
-                <a:solidFill>
-                  <a:srgbClr val="1F3864"/>
-                </a:solidFill>
-                <a:latin typeface="Arial" pitchFamily="34" charset="0"/>
-                <a:ea typeface="Arial" pitchFamily="34" charset="-122"/>
-                <a:cs typeface="Arial" pitchFamily="34" charset="-120"/>
-              </a:rPr>
-              <a:t>Dựng lưới giờ đầy đủ  </a:t>
-            </a:r>
-            <a:pPr indent="0" marL="0">
-              <a:buNone/>
-            </a:pPr>
-            <a:r>
-              <a:rPr lang="en-US" sz="1200" dirty="0">
-                <a:solidFill>
-                  <a:srgbClr val="253044"/>
-                </a:solidFill>
-                <a:latin typeface="Arial" pitchFamily="34" charset="0"/>
-                <a:ea typeface="Arial" pitchFamily="34" charset="-122"/>
-                <a:cs typeface="Arial" pitchFamily="34" charset="-120"/>
-              </a:rPr>
-              <a:t>— lộ giờ mất bản ghi (8.769.600 vs 8.576.904)</a:t>
-            </a:r>
-            <a:endParaRPr lang="en-US" sz="1400" dirty="0"/>
-          </a:p>
-        </p:txBody>
-      </p:sp>
-      <p:sp>
-        <p:nvSpPr>
-          <p:cNvPr id="16" name="Shape 14"/>
-          <p:cNvSpPr/>
-          <p:nvPr/>
-        </p:nvSpPr>
-        <p:spPr>
-          <a:xfrm>
-            <a:off x="640080" y="4197096"/>
-            <a:ext cx="475488" cy="475488"/>
-          </a:xfrm>
-          <a:prstGeom prst="ellipse">
-            <a:avLst/>
-          </a:prstGeom>
-          <a:solidFill>
-            <a:srgbClr val="E08A3C"/>
-          </a:solidFill>
-          <a:ln/>
-        </p:spPr>
-      </p:sp>
-      <p:sp>
-        <p:nvSpPr>
-          <p:cNvPr id="17" name="Text 15"/>
-          <p:cNvSpPr txBox="1"/>
-          <p:nvPr/>
-        </p:nvSpPr>
-        <p:spPr>
-          <a:xfrm>
-            <a:off x="640080" y="4197096"/>
-            <a:ext cx="475488" cy="475488"/>
-          </a:xfrm>
-          <a:prstGeom prst="rect">
-            <a:avLst/>
-          </a:prstGeom>
-          <a:noFill/>
-          <a:ln/>
-        </p:spPr>
-        <p:txBody>
-          <a:bodyPr wrap="square" lIns="0" tIns="0" rIns="0" bIns="0" rtlCol="0" anchor="ctr"/>
-          <a:lstStyle/>
-          <a:p>
-            <a:pPr algn="ctr" indent="0" marL="0">
-              <a:buNone/>
-            </a:pPr>
-            <a:r>
-              <a:rPr lang="en-US" sz="1300" b="1" dirty="0">
-                <a:solidFill>
-                  <a:srgbClr val="FFFFFF"/>
-                </a:solidFill>
-                <a:latin typeface="Arial" pitchFamily="34" charset="0"/>
-                <a:ea typeface="Arial" pitchFamily="34" charset="-122"/>
-                <a:cs typeface="Arial" pitchFamily="34" charset="-120"/>
-              </a:rPr>
-              <a:t>4</a:t>
-            </a:r>
-            <a:endParaRPr lang="en-US" sz="1300" dirty="0"/>
-          </a:p>
-        </p:txBody>
-      </p:sp>
-      <p:sp>
-        <p:nvSpPr>
-          <p:cNvPr id="18" name="Text 16"/>
-          <p:cNvSpPr txBox="1"/>
-          <p:nvPr/>
-        </p:nvSpPr>
-        <p:spPr>
-          <a:xfrm>
-            <a:off x="1280160" y="4160520"/>
-            <a:ext cx="4937760" cy="566928"/>
-          </a:xfrm>
-          <a:prstGeom prst="rect">
-            <a:avLst/>
-          </a:prstGeom>
-          <a:noFill/>
-          <a:ln/>
-        </p:spPr>
-        <p:txBody>
-          <a:bodyPr wrap="square" rtlCol="0" anchor="ctr"/>
-          <a:lstStyle/>
-          <a:p>
-            <a:pPr indent="0" marL="0">
-              <a:buNone/>
-            </a:pPr>
-            <a:r>
-              <a:rPr lang="en-US" sz="1400" b="1" dirty="0">
-                <a:solidFill>
-                  <a:srgbClr val="1F3864"/>
-                </a:solidFill>
-                <a:latin typeface="Arial" pitchFamily="34" charset="0"/>
-                <a:ea typeface="Arial" pitchFamily="34" charset="-122"/>
-                <a:cs typeface="Arial" pitchFamily="34" charset="-120"/>
-              </a:rPr>
-              <a:t>Nội suy khe ngắn  </a:t>
-            </a:r>
-            <a:pPr indent="0" marL="0">
-              <a:buNone/>
-            </a:pPr>
-            <a:r>
-              <a:rPr lang="en-US" sz="1200" dirty="0">
-                <a:solidFill>
-                  <a:srgbClr val="253044"/>
-                </a:solidFill>
-                <a:latin typeface="Arial" pitchFamily="34" charset="0"/>
-                <a:ea typeface="Arial" pitchFamily="34" charset="-122"/>
-                <a:cs typeface="Arial" pitchFamily="34" charset="-120"/>
-              </a:rPr>
-              <a:t>— thiếu ≤ 3 giờ; dài hơn → giữ trống</a:t>
-            </a:r>
-            <a:endParaRPr lang="en-US" sz="1400" dirty="0"/>
-          </a:p>
-        </p:txBody>
-      </p:sp>
-      <p:sp>
-        <p:nvSpPr>
-          <p:cNvPr id="19" name="Shape 17"/>
-          <p:cNvSpPr/>
-          <p:nvPr/>
-        </p:nvSpPr>
-        <p:spPr>
-          <a:xfrm>
-            <a:off x="640080" y="5020056"/>
-            <a:ext cx="475488" cy="475488"/>
-          </a:xfrm>
-          <a:prstGeom prst="ellipse">
-            <a:avLst/>
-          </a:prstGeom>
-          <a:solidFill>
-            <a:srgbClr val="4F9D5D"/>
-          </a:solidFill>
-          <a:ln/>
-        </p:spPr>
-      </p:sp>
-      <p:sp>
-        <p:nvSpPr>
-          <p:cNvPr id="20" name="Text 18"/>
-          <p:cNvSpPr txBox="1"/>
-          <p:nvPr/>
-        </p:nvSpPr>
-        <p:spPr>
-          <a:xfrm>
-            <a:off x="640080" y="5020056"/>
-            <a:ext cx="475488" cy="475488"/>
-          </a:xfrm>
-          <a:prstGeom prst="rect">
-            <a:avLst/>
-          </a:prstGeom>
-          <a:noFill/>
-          <a:ln/>
-        </p:spPr>
-        <p:txBody>
-          <a:bodyPr wrap="square" lIns="0" tIns="0" rIns="0" bIns="0" rtlCol="0" anchor="ctr"/>
-          <a:lstStyle/>
-          <a:p>
-            <a:pPr algn="ctr" indent="0" marL="0">
-              <a:buNone/>
-            </a:pPr>
-            <a:r>
-              <a:rPr lang="en-US" sz="1300" b="1" dirty="0">
-                <a:solidFill>
-                  <a:srgbClr val="FFFFFF"/>
-                </a:solidFill>
-                <a:latin typeface="Arial" pitchFamily="34" charset="0"/>
-                <a:ea typeface="Arial" pitchFamily="34" charset="-122"/>
-                <a:cs typeface="Arial" pitchFamily="34" charset="-120"/>
-              </a:rPr>
-              <a:t>5</a:t>
-            </a:r>
-            <a:endParaRPr lang="en-US" sz="1300" dirty="0"/>
-          </a:p>
-        </p:txBody>
-      </p:sp>
-      <p:sp>
-        <p:nvSpPr>
-          <p:cNvPr id="21" name="Text 19"/>
-          <p:cNvSpPr txBox="1"/>
-          <p:nvPr/>
-        </p:nvSpPr>
-        <p:spPr>
-          <a:xfrm>
-            <a:off x="1280160" y="4983480"/>
-            <a:ext cx="4937760" cy="566928"/>
-          </a:xfrm>
-          <a:prstGeom prst="rect">
-            <a:avLst/>
-          </a:prstGeom>
-          <a:noFill/>
-          <a:ln/>
-        </p:spPr>
-        <p:txBody>
-          <a:bodyPr wrap="square" rtlCol="0" anchor="ctr"/>
-          <a:lstStyle/>
-          <a:p>
-            <a:pPr indent="0" marL="0">
-              <a:buNone/>
-            </a:pPr>
-            <a:r>
-              <a:rPr lang="en-US" sz="1400" b="1" dirty="0">
-                <a:solidFill>
-                  <a:srgbClr val="1F3864"/>
-                </a:solidFill>
-                <a:latin typeface="Arial" pitchFamily="34" charset="0"/>
-                <a:ea typeface="Arial" pitchFamily="34" charset="-122"/>
-                <a:cs typeface="Arial" pitchFamily="34" charset="-120"/>
-              </a:rPr>
-              <a:t>Gộp theo ngày  </a:t>
-            </a:r>
-            <a:pPr indent="0" marL="0">
-              <a:buNone/>
-            </a:pPr>
-            <a:r>
-              <a:rPr lang="en-US" sz="1200" dirty="0">
-                <a:solidFill>
-                  <a:srgbClr val="253044"/>
-                </a:solidFill>
-                <a:latin typeface="Arial" pitchFamily="34" charset="0"/>
-                <a:ea typeface="Arial" pitchFamily="34" charset="-122"/>
-                <a:cs typeface="Arial" pitchFamily="34" charset="-120"/>
-              </a:rPr>
-              <a:t>— TB 24h; ngày đạt nếu ≥ 75% dữ liệu</a:t>
-            </a:r>
-            <a:endParaRPr lang="en-US" sz="1400" dirty="0"/>
-          </a:p>
-        </p:txBody>
-      </p:sp>
-      <p:sp>
-        <p:nvSpPr>
-          <p:cNvPr id="22" name="Shape 20"/>
-          <p:cNvSpPr/>
-          <p:nvPr/>
-        </p:nvSpPr>
-        <p:spPr>
-          <a:xfrm>
-            <a:off x="6446520" y="1737360"/>
-            <a:ext cx="5120640" cy="2148840"/>
+            <a:off x="502920" y="1481328"/>
+            <a:ext cx="3566160" cy="3977640"/>
           </a:xfrm>
           <a:prstGeom prst="roundRect">
             <a:avLst>
-              <a:gd name="adj" fmla="val 2553"/>
+              <a:gd name="adj" fmla="val 1795"/>
             </a:avLst>
           </a:prstGeom>
           <a:solidFill>
-            <a:srgbClr val="0C1526"/>
+            <a:srgbClr val="FFFFFF"/>
           </a:solidFill>
           <a:ln w="12700">
             <a:solidFill>
@@ -4703,40 +4054,77 @@
           </a:effectLst>
         </p:spPr>
       </p:sp>
-      <p:pic>
-        <p:nvPicPr>
-          <p:cNvPr id="23" name="Image 0" descr="fig_quality.png">    </p:cNvPr>
-          <p:cNvPicPr>
-            <a:picLocks noChangeAspect="1"/>
-          </p:cNvPicPr>
-          <p:nvPr/>
-        </p:nvPicPr>
-        <p:blipFill>
-          <a:blip r:embed="rId1"/>
-          <a:stretch>
-            <a:fillRect/>
-          </a:stretch>
-        </p:blipFill>
-        <p:spPr>
-          <a:xfrm>
-            <a:off x="6537960" y="1828800"/>
-            <a:ext cx="4937760" cy="1822052"/>
+      <p:sp>
+        <p:nvSpPr>
+          <p:cNvPr id="8" name="Shape 6"/>
+          <p:cNvSpPr/>
+          <p:nvPr/>
+        </p:nvSpPr>
+        <p:spPr>
+          <a:xfrm>
+            <a:off x="502920" y="1481328"/>
+            <a:ext cx="3566160" cy="457200"/>
+          </a:xfrm>
+          <a:prstGeom prst="roundRect">
+            <a:avLst>
+              <a:gd name="adj" fmla="val 14000"/>
+            </a:avLst>
+          </a:prstGeom>
+          <a:solidFill>
+            <a:srgbClr val="2E9BA6"/>
+          </a:solidFill>
+          <a:ln/>
+        </p:spPr>
+      </p:sp>
+      <p:sp>
+        <p:nvSpPr>
+          <p:cNvPr id="9" name="Text 7"/>
+          <p:cNvSpPr txBox="1"/>
+          <p:nvPr/>
+        </p:nvSpPr>
+        <p:spPr>
+          <a:xfrm>
+            <a:off x="502920" y="1481328"/>
+            <a:ext cx="3566160" cy="457200"/>
           </a:xfrm>
           <a:prstGeom prst="rect">
             <a:avLst/>
           </a:prstGeom>
-        </p:spPr>
-      </p:pic>
-      <p:sp>
-        <p:nvSpPr>
-          <p:cNvPr id="24" name="Text 21"/>
+          <a:noFill/>
+          <a:ln/>
+        </p:spPr>
+        <p:txBody>
+          <a:bodyPr wrap="square" lIns="25400" tIns="25400" rIns="25400" bIns="25400" rtlCol="0" anchor="ctr"/>
+          <a:lstStyle/>
+          <a:p>
+            <a:pPr algn="ctr" indent="0" marL="0">
+              <a:buNone/>
+            </a:pPr>
+            <a:r>
+              <a:rPr lang="en-US" sz="1350" b="1" dirty="0">
+                <a:solidFill>
+                  <a:srgbClr val="FFFFFF"/>
+                </a:solidFill>
+                <a:latin typeface="Arial" pitchFamily="34" charset="0"/>
+                <a:ea typeface="Arial" pitchFamily="34" charset="-122"/>
+                <a:cs typeface="Arial" pitchFamily="34" charset="-120"/>
+              </a:rPr>
+              <a:t>PHA 1 · Làm sạch</a:t>
+            </a:r>
+            <a:endParaRPr lang="en-US" sz="1350" dirty="0"/>
+          </a:p>
+        </p:txBody>
+      </p:sp>
+      <p:sp>
+        <p:nvSpPr>
+          <p:cNvPr id="10" name="Text 8"/>
           <p:cNvSpPr txBox="1"/>
           <p:nvPr/>
         </p:nvSpPr>
         <p:spPr>
           <a:xfrm>
-            <a:off x="6446520" y="3913632"/>
-            <a:ext cx="5120640" cy="274320"/>
+            <a:off x="704088" y="2084832"/>
+            <a:ext cx="3200400" cy="2697480"/>
           </a:xfrm>
           <a:prstGeom prst="rect">
             <a:avLst/>
@@ -4745,45 +4133,192 @@
           <a:ln/>
         </p:spPr>
         <p:txBody>
-          <a:bodyPr wrap="square" rtlCol="0" anchor="ctr"/>
+          <a:bodyPr wrap="square" rtlCol="0" anchor="t"/>
           <a:lstStyle/>
           <a:p>
-            <a:pPr algn="ctr" indent="0" marL="0">
-              <a:buNone/>
-            </a:pPr>
-            <a:r>
-              <a:rPr lang="en-US" sz="1000" i="1" dirty="0">
-                <a:solidFill>
-                  <a:srgbClr val="6B7280"/>
-                </a:solidFill>
-                <a:latin typeface="Arial" pitchFamily="34" charset="0"/>
-                <a:ea typeface="Arial" pitchFamily="34" charset="-122"/>
-                <a:cs typeface="Arial" pitchFamily="34" charset="-120"/>
-              </a:rPr>
-              <a:t>Hình 5.3 — báo cáo chất lượng dữ liệu sau Pha 1</a:t>
-            </a:r>
-            <a:endParaRPr lang="en-US" sz="1000" dirty="0"/>
+            <a:pPr marL="342900" indent="-342900">
+              <a:spcAft>
+                <a:spcPts val="800"/>
+              </a:spcAft>
+              <a:buSzPct val="100000"/>
+              <a:buChar char="•"/>
+            </a:pPr>
+            <a:r>
+              <a:rPr lang="en-US" sz="1200" dirty="0">
+                <a:solidFill>
+                  <a:srgbClr val="253044"/>
+                </a:solidFill>
+                <a:latin typeface="Arial" pitchFamily="34" charset="0"/>
+                <a:ea typeface="Arial" pitchFamily="34" charset="-122"/>
+                <a:cs typeface="Arial" pitchFamily="34" charset="-120"/>
+              </a:rPr>
+              <a:t>Khử trùng lặp theo (trạm, giờ)</a:t>
+            </a:r>
+            <a:endParaRPr lang="en-US" sz="1200" dirty="0"/>
+          </a:p>
+          <a:p>
+            <a:pPr marL="342900" indent="-342900">
+              <a:spcAft>
+                <a:spcPts val="800"/>
+              </a:spcAft>
+              <a:buSzPct val="100000"/>
+              <a:buChar char="•"/>
+            </a:pPr>
+            <a:r>
+              <a:rPr lang="en-US" sz="1200" dirty="0">
+                <a:solidFill>
+                  <a:srgbClr val="253044"/>
+                </a:solidFill>
+                <a:latin typeface="Arial" pitchFamily="34" charset="0"/>
+                <a:ea typeface="Arial" pitchFamily="34" charset="-122"/>
+                <a:cs typeface="Arial" pitchFamily="34" charset="-120"/>
+              </a:rPr>
+              <a:t>Loại giá trị âm / vượt trần vật lý</a:t>
+            </a:r>
+            <a:endParaRPr lang="en-US" sz="1200" dirty="0"/>
+          </a:p>
+          <a:p>
+            <a:pPr marL="342900" indent="-342900">
+              <a:spcAft>
+                <a:spcPts val="800"/>
+              </a:spcAft>
+              <a:buSzPct val="100000"/>
+              <a:buChar char="•"/>
+            </a:pPr>
+            <a:r>
+              <a:rPr lang="en-US" sz="1200" dirty="0">
+                <a:solidFill>
+                  <a:srgbClr val="253044"/>
+                </a:solidFill>
+                <a:latin typeface="Arial" pitchFamily="34" charset="0"/>
+                <a:ea typeface="Arial" pitchFamily="34" charset="-122"/>
+                <a:cs typeface="Arial" pitchFamily="34" charset="-120"/>
+              </a:rPr>
+              <a:t>Dựng lưới giờ đầy đủ → lộ giờ thiếu</a:t>
+            </a:r>
+            <a:endParaRPr lang="en-US" sz="1200" dirty="0"/>
+          </a:p>
+          <a:p>
+            <a:pPr marL="342900" indent="-342900">
+              <a:spcAft>
+                <a:spcPts val="800"/>
+              </a:spcAft>
+              <a:buSzPct val="100000"/>
+              <a:buChar char="•"/>
+            </a:pPr>
+            <a:r>
+              <a:rPr lang="en-US" sz="1200" dirty="0">
+                <a:solidFill>
+                  <a:srgbClr val="253044"/>
+                </a:solidFill>
+                <a:latin typeface="Arial" pitchFamily="34" charset="0"/>
+                <a:ea typeface="Arial" pitchFamily="34" charset="-122"/>
+                <a:cs typeface="Arial" pitchFamily="34" charset="-120"/>
+              </a:rPr>
+              <a:t>Nội suy khe ≤ 3h; dài hơn giữ trống</a:t>
+            </a:r>
+            <a:endParaRPr lang="en-US" sz="1200" dirty="0"/>
           </a:p>
         </p:txBody>
       </p:sp>
       <p:sp>
         <p:nvSpPr>
-          <p:cNvPr id="25" name="Shape 22"/>
+          <p:cNvPr id="11" name="Shape 9"/>
           <p:cNvSpPr/>
           <p:nvPr/>
         </p:nvSpPr>
         <p:spPr>
           <a:xfrm>
-            <a:off x="6446520" y="4343400"/>
-            <a:ext cx="5120640" cy="1417320"/>
+            <a:off x="612648" y="4892040"/>
+            <a:ext cx="3346704" cy="457200"/>
           </a:xfrm>
           <a:prstGeom prst="roundRect">
             <a:avLst>
-              <a:gd name="adj" fmla="val 4516"/>
+              <a:gd name="adj" fmla="val 10000"/>
             </a:avLst>
           </a:prstGeom>
           <a:solidFill>
-            <a:srgbClr val="E9F0FB"/>
+            <a:srgbClr val="F4F7FC"/>
+          </a:solidFill>
+          <a:ln w="12700">
+            <a:solidFill>
+              <a:srgbClr val="D6DEEA"/>
+            </a:solidFill>
+            <a:prstDash val="solid"/>
+          </a:ln>
+        </p:spPr>
+      </p:sp>
+      <p:sp>
+        <p:nvSpPr>
+          <p:cNvPr id="12" name="Text 10"/>
+          <p:cNvSpPr txBox="1"/>
+          <p:nvPr/>
+        </p:nvSpPr>
+        <p:spPr>
+          <a:xfrm>
+            <a:off x="612648" y="4892040"/>
+            <a:ext cx="3346704" cy="457200"/>
+          </a:xfrm>
+          <a:prstGeom prst="rect">
+            <a:avLst/>
+          </a:prstGeom>
+          <a:noFill/>
+          <a:ln/>
+        </p:spPr>
+        <p:txBody>
+          <a:bodyPr wrap="square" lIns="25400" tIns="25400" rIns="25400" bIns="25400" rtlCol="0" anchor="ctr"/>
+          <a:lstStyle/>
+          <a:p>
+            <a:pPr algn="ctr" indent="0" marL="0">
+              <a:buNone/>
+            </a:pPr>
+            <a:r>
+              <a:rPr lang="en-US" sz="1200" b="1" dirty="0">
+                <a:solidFill>
+                  <a:srgbClr val="2E9BA6"/>
+                </a:solidFill>
+                <a:latin typeface="Arial" pitchFamily="34" charset="0"/>
+                <a:ea typeface="Arial" pitchFamily="34" charset="-122"/>
+                <a:cs typeface="Arial" pitchFamily="34" charset="-120"/>
+              </a:rPr>
+              <a:t>→ </a:t>
+            </a:r>
+            <a:pPr algn="ctr" indent="0" marL="0">
+              <a:buNone/>
+            </a:pPr>
+            <a:r>
+              <a:rPr lang="en-US" sz="1150" b="1" dirty="0">
+                <a:solidFill>
+                  <a:srgbClr val="2E9BA6"/>
+                </a:solidFill>
+                <a:latin typeface="Arial" pitchFamily="34" charset="0"/>
+                <a:ea typeface="Arial" pitchFamily="34" charset="-122"/>
+                <a:cs typeface="Arial" pitchFamily="34" charset="-120"/>
+              </a:rPr>
+              <a:t>/clean · 97,6% ngày đạt chuẩn</a:t>
+            </a:r>
+            <a:endParaRPr lang="en-US" sz="1200" dirty="0"/>
+          </a:p>
+        </p:txBody>
+      </p:sp>
+      <p:sp>
+        <p:nvSpPr>
+          <p:cNvPr id="13" name="Shape 11"/>
+          <p:cNvSpPr/>
+          <p:nvPr/>
+        </p:nvSpPr>
+        <p:spPr>
+          <a:xfrm>
+            <a:off x="4251960" y="1481328"/>
+            <a:ext cx="3566160" cy="3977640"/>
+          </a:xfrm>
+          <a:prstGeom prst="roundRect">
+            <a:avLst>
+              <a:gd name="adj" fmla="val 1795"/>
+            </a:avLst>
+          </a:prstGeom>
+          <a:solidFill>
+            <a:srgbClr val="FFFFFF"/>
           </a:solidFill>
           <a:ln w="12700">
             <a:solidFill>
@@ -4802,14 +4337,36 @@
       </p:sp>
       <p:sp>
         <p:nvSpPr>
-          <p:cNvPr id="26" name="Text 23"/>
+          <p:cNvPr id="14" name="Shape 12"/>
+          <p:cNvSpPr/>
+          <p:nvPr/>
+        </p:nvSpPr>
+        <p:spPr>
+          <a:xfrm>
+            <a:off x="4251960" y="1481328"/>
+            <a:ext cx="3566160" cy="457200"/>
+          </a:xfrm>
+          <a:prstGeom prst="roundRect">
+            <a:avLst>
+              <a:gd name="adj" fmla="val 14000"/>
+            </a:avLst>
+          </a:prstGeom>
+          <a:solidFill>
+            <a:srgbClr val="2E5AAC"/>
+          </a:solidFill>
+          <a:ln/>
+        </p:spPr>
+      </p:sp>
+      <p:sp>
+        <p:nvSpPr>
+          <p:cNvPr id="15" name="Text 13"/>
           <p:cNvSpPr txBox="1"/>
           <p:nvPr/>
         </p:nvSpPr>
         <p:spPr>
           <a:xfrm>
-            <a:off x="6675120" y="4407408"/>
-            <a:ext cx="1691640" cy="658368"/>
+            <a:off x="4251960" y="1481328"/>
+            <a:ext cx="3566160" cy="457200"/>
           </a:xfrm>
           <a:prstGeom prst="rect">
             <a:avLst/>
@@ -4818,76 +4375,37 @@
           <a:ln/>
         </p:spPr>
         <p:txBody>
-          <a:bodyPr wrap="square" lIns="0" tIns="0" rIns="0" bIns="0" rtlCol="0" anchor="ctr"/>
+          <a:bodyPr wrap="square" lIns="25400" tIns="25400" rIns="25400" bIns="25400" rtlCol="0" anchor="ctr"/>
           <a:lstStyle/>
           <a:p>
-            <a:pPr indent="0" marL="0">
-              <a:buNone/>
-            </a:pPr>
-            <a:r>
-              <a:rPr lang="en-US" sz="2800" b="1" dirty="0">
-                <a:solidFill>
-                  <a:srgbClr val="2E5AAC"/>
-                </a:solidFill>
-                <a:latin typeface="Arial" pitchFamily="34" charset="0"/>
-                <a:ea typeface="Arial" pitchFamily="34" charset="-122"/>
-                <a:cs typeface="Arial" pitchFamily="34" charset="-120"/>
-              </a:rPr>
-              <a:t>97,6%</a:t>
-            </a:r>
-            <a:endParaRPr lang="en-US" sz="2800" dirty="0"/>
+            <a:pPr algn="ctr" indent="0" marL="0">
+              <a:buNone/>
+            </a:pPr>
+            <a:r>
+              <a:rPr lang="en-US" sz="1350" b="1" dirty="0">
+                <a:solidFill>
+                  <a:srgbClr val="FFFFFF"/>
+                </a:solidFill>
+                <a:latin typeface="Arial" pitchFamily="34" charset="0"/>
+                <a:ea typeface="Arial" pitchFamily="34" charset="-122"/>
+                <a:cs typeface="Arial" pitchFamily="34" charset="-120"/>
+              </a:rPr>
+              <a:t>PHA 2 · Tính AQI</a:t>
+            </a:r>
+            <a:endParaRPr lang="en-US" sz="1350" dirty="0"/>
           </a:p>
         </p:txBody>
       </p:sp>
       <p:sp>
         <p:nvSpPr>
-          <p:cNvPr id="27" name="Text 24"/>
+          <p:cNvPr id="16" name="Text 14"/>
           <p:cNvSpPr txBox="1"/>
           <p:nvPr/>
         </p:nvSpPr>
         <p:spPr>
           <a:xfrm>
-            <a:off x="8366760" y="4407408"/>
-            <a:ext cx="3063240" cy="658368"/>
-          </a:xfrm>
-          <a:prstGeom prst="rect">
-            <a:avLst/>
-          </a:prstGeom>
-          <a:noFill/>
-          <a:ln/>
-        </p:spPr>
-        <p:txBody>
-          <a:bodyPr wrap="square" lIns="0" tIns="0" rIns="0" bIns="0" rtlCol="0" anchor="ctr"/>
-          <a:lstStyle/>
-          <a:p>
-            <a:pPr indent="0" marL="0">
-              <a:buNone/>
-            </a:pPr>
-            <a:r>
-              <a:rPr lang="en-US" sz="1250" dirty="0">
-                <a:solidFill>
-                  <a:srgbClr val="253044"/>
-                </a:solidFill>
-                <a:latin typeface="Arial" pitchFamily="34" charset="0"/>
-                <a:ea typeface="Arial" pitchFamily="34" charset="-122"/>
-                <a:cs typeface="Arial" pitchFamily="34" charset="-120"/>
-              </a:rPr>
-              <a:t>số ngày đủ chuẩn tính AQI ngày (≥ 75% dữ liệu)</a:t>
-            </a:r>
-            <a:endParaRPr lang="en-US" sz="1250" dirty="0"/>
-          </a:p>
-        </p:txBody>
-      </p:sp>
-      <p:sp>
-        <p:nvSpPr>
-          <p:cNvPr id="28" name="Text 25"/>
-          <p:cNvSpPr txBox="1"/>
-          <p:nvPr/>
-        </p:nvSpPr>
-        <p:spPr>
-          <a:xfrm>
-            <a:off x="6675120" y="5102352"/>
-            <a:ext cx="4663440" cy="548640"/>
+            <a:off x="4453128" y="2084832"/>
+            <a:ext cx="3200400" cy="2697480"/>
           </a:xfrm>
           <a:prstGeom prst="rect">
             <a:avLst/>
@@ -4899,19 +4417,500 @@
           <a:bodyPr wrap="square" rtlCol="0" anchor="t"/>
           <a:lstStyle/>
           <a:p>
+            <a:pPr marL="342900" indent="-342900">
+              <a:spcAft>
+                <a:spcPts val="800"/>
+              </a:spcAft>
+              <a:buSzPct val="100000"/>
+              <a:buChar char="•"/>
+            </a:pPr>
+            <a:r>
+              <a:rPr lang="en-US" sz="1200" dirty="0">
+                <a:solidFill>
+                  <a:srgbClr val="253044"/>
+                </a:solidFill>
+                <a:latin typeface="Arial" pitchFamily="34" charset="0"/>
+                <a:ea typeface="Arial" pitchFamily="34" charset="-122"/>
+                <a:cs typeface="Arial" pitchFamily="34" charset="-120"/>
+              </a:rPr>
+              <a:t>NowCast 12h / trạm cho bụi PM</a:t>
+            </a:r>
+            <a:endParaRPr lang="en-US" sz="1200" dirty="0"/>
+          </a:p>
+          <a:p>
+            <a:pPr marL="342900" indent="-342900">
+              <a:spcAft>
+                <a:spcPts val="800"/>
+              </a:spcAft>
+              <a:buSzPct val="100000"/>
+              <a:buChar char="•"/>
+            </a:pPr>
+            <a:r>
+              <a:rPr lang="en-US" sz="1200" dirty="0">
+                <a:solidFill>
+                  <a:srgbClr val="253044"/>
+                </a:solidFill>
+                <a:latin typeface="Arial" pitchFamily="34" charset="0"/>
+                <a:ea typeface="Arial" pitchFamily="34" charset="-122"/>
+                <a:cs typeface="Arial" pitchFamily="34" charset="-120"/>
+              </a:rPr>
+              <a:t>IAQI từng chất (breakpoint QĐ 1459)</a:t>
+            </a:r>
+            <a:endParaRPr lang="en-US" sz="1200" dirty="0"/>
+          </a:p>
+          <a:p>
+            <a:pPr marL="342900" indent="-342900">
+              <a:spcAft>
+                <a:spcPts val="800"/>
+              </a:spcAft>
+              <a:buSzPct val="100000"/>
+              <a:buChar char="•"/>
+            </a:pPr>
+            <a:r>
+              <a:rPr lang="en-US" sz="1200" dirty="0">
+                <a:solidFill>
+                  <a:srgbClr val="253044"/>
+                </a:solidFill>
+                <a:latin typeface="Arial" pitchFamily="34" charset="0"/>
+                <a:ea typeface="Arial" pitchFamily="34" charset="-122"/>
+                <a:cs typeface="Arial" pitchFamily="34" charset="-120"/>
+              </a:rPr>
+              <a:t>AQI = max(IAQI) → mức + chất trội</a:t>
+            </a:r>
+            <a:endParaRPr lang="en-US" sz="1200" dirty="0"/>
+          </a:p>
+          <a:p>
+            <a:pPr marL="342900" indent="-342900">
+              <a:spcAft>
+                <a:spcPts val="800"/>
+              </a:spcAft>
+              <a:buSzPct val="100000"/>
+              <a:buChar char="•"/>
+            </a:pPr>
+            <a:r>
+              <a:rPr lang="en-US" sz="1200" dirty="0">
+                <a:solidFill>
+                  <a:srgbClr val="253044"/>
+                </a:solidFill>
+                <a:latin typeface="Arial" pitchFamily="34" charset="0"/>
+                <a:ea typeface="Arial" pitchFamily="34" charset="-122"/>
+                <a:cs typeface="Arial" pitchFamily="34" charset="-120"/>
+              </a:rPr>
+              <a:t>Batch &amp; streaming dùng chung aqi_core</a:t>
+            </a:r>
+            <a:endParaRPr lang="en-US" sz="1200" dirty="0"/>
+          </a:p>
+        </p:txBody>
+      </p:sp>
+      <p:sp>
+        <p:nvSpPr>
+          <p:cNvPr id="17" name="Shape 15"/>
+          <p:cNvSpPr/>
+          <p:nvPr/>
+        </p:nvSpPr>
+        <p:spPr>
+          <a:xfrm>
+            <a:off x="4361688" y="4892040"/>
+            <a:ext cx="3346704" cy="457200"/>
+          </a:xfrm>
+          <a:prstGeom prst="roundRect">
+            <a:avLst>
+              <a:gd name="adj" fmla="val 10000"/>
+            </a:avLst>
+          </a:prstGeom>
+          <a:solidFill>
+            <a:srgbClr val="F4F7FC"/>
+          </a:solidFill>
+          <a:ln w="12700">
+            <a:solidFill>
+              <a:srgbClr val="D6DEEA"/>
+            </a:solidFill>
+            <a:prstDash val="solid"/>
+          </a:ln>
+        </p:spPr>
+      </p:sp>
+      <p:sp>
+        <p:nvSpPr>
+          <p:cNvPr id="18" name="Text 16"/>
+          <p:cNvSpPr txBox="1"/>
+          <p:nvPr/>
+        </p:nvSpPr>
+        <p:spPr>
+          <a:xfrm>
+            <a:off x="4361688" y="4892040"/>
+            <a:ext cx="3346704" cy="457200"/>
+          </a:xfrm>
+          <a:prstGeom prst="rect">
+            <a:avLst/>
+          </a:prstGeom>
+          <a:noFill/>
+          <a:ln/>
+        </p:spPr>
+        <p:txBody>
+          <a:bodyPr wrap="square" lIns="25400" tIns="25400" rIns="25400" bIns="25400" rtlCol="0" anchor="ctr"/>
+          <a:lstStyle/>
+          <a:p>
+            <a:pPr algn="ctr" indent="0" marL="0">
+              <a:buNone/>
+            </a:pPr>
+            <a:r>
+              <a:rPr lang="en-US" sz="1200" b="1" dirty="0">
+                <a:solidFill>
+                  <a:srgbClr val="2E5AAC"/>
+                </a:solidFill>
+                <a:latin typeface="Arial" pitchFamily="34" charset="0"/>
+                <a:ea typeface="Arial" pitchFamily="34" charset="-122"/>
+                <a:cs typeface="Arial" pitchFamily="34" charset="-120"/>
+              </a:rPr>
+              <a:t>→ </a:t>
+            </a:r>
+            <a:pPr algn="ctr" indent="0" marL="0">
+              <a:buNone/>
+            </a:pPr>
+            <a:r>
+              <a:rPr lang="en-US" sz="1150" b="1" dirty="0">
+                <a:solidFill>
+                  <a:srgbClr val="2E5AAC"/>
+                </a:solidFill>
+                <a:latin typeface="Arial" pitchFamily="34" charset="0"/>
+                <a:ea typeface="Arial" pitchFamily="34" charset="-122"/>
+                <a:cs typeface="Arial" pitchFamily="34" charset="-120"/>
+              </a:rPr>
+              <a:t>/aqi · 593 MB</a:t>
+            </a:r>
+            <a:endParaRPr lang="en-US" sz="1200" dirty="0"/>
+          </a:p>
+        </p:txBody>
+      </p:sp>
+      <p:sp>
+        <p:nvSpPr>
+          <p:cNvPr id="19" name="Shape 17"/>
+          <p:cNvSpPr/>
+          <p:nvPr/>
+        </p:nvSpPr>
+        <p:spPr>
+          <a:xfrm>
+            <a:off x="8001000" y="1481328"/>
+            <a:ext cx="3566160" cy="3977640"/>
+          </a:xfrm>
+          <a:prstGeom prst="roundRect">
+            <a:avLst>
+              <a:gd name="adj" fmla="val 1795"/>
+            </a:avLst>
+          </a:prstGeom>
+          <a:solidFill>
+            <a:srgbClr val="FFFFFF"/>
+          </a:solidFill>
+          <a:ln w="12700">
+            <a:solidFill>
+              <a:srgbClr val="D6DEEA"/>
+            </a:solidFill>
+            <a:prstDash val="solid"/>
+          </a:ln>
+          <a:effectLst>
+            <a:outerShdw sx="100000" sy="100000" kx="0" ky="0" algn="bl" rotWithShape="0" blurRad="88900" dist="25400" dir="5400000">
+              <a:srgbClr val="9AA6B8">
+                <a:alpha val="32000"/>
+              </a:srgbClr>
+            </a:outerShdw>
+          </a:effectLst>
+        </p:spPr>
+      </p:sp>
+      <p:sp>
+        <p:nvSpPr>
+          <p:cNvPr id="20" name="Shape 18"/>
+          <p:cNvSpPr/>
+          <p:nvPr/>
+        </p:nvSpPr>
+        <p:spPr>
+          <a:xfrm>
+            <a:off x="8001000" y="1481328"/>
+            <a:ext cx="3566160" cy="457200"/>
+          </a:xfrm>
+          <a:prstGeom prst="roundRect">
+            <a:avLst>
+              <a:gd name="adj" fmla="val 14000"/>
+            </a:avLst>
+          </a:prstGeom>
+          <a:solidFill>
+            <a:srgbClr val="4F9D5D"/>
+          </a:solidFill>
+          <a:ln/>
+        </p:spPr>
+      </p:sp>
+      <p:sp>
+        <p:nvSpPr>
+          <p:cNvPr id="21" name="Text 19"/>
+          <p:cNvSpPr txBox="1"/>
+          <p:nvPr/>
+        </p:nvSpPr>
+        <p:spPr>
+          <a:xfrm>
+            <a:off x="8001000" y="1481328"/>
+            <a:ext cx="3566160" cy="457200"/>
+          </a:xfrm>
+          <a:prstGeom prst="rect">
+            <a:avLst/>
+          </a:prstGeom>
+          <a:noFill/>
+          <a:ln/>
+        </p:spPr>
+        <p:txBody>
+          <a:bodyPr wrap="square" lIns="25400" tIns="25400" rIns="25400" bIns="25400" rtlCol="0" anchor="ctr"/>
+          <a:lstStyle/>
+          <a:p>
+            <a:pPr algn="ctr" indent="0" marL="0">
+              <a:buNone/>
+            </a:pPr>
+            <a:r>
+              <a:rPr lang="en-US" sz="1350" b="1" dirty="0">
+                <a:solidFill>
+                  <a:srgbClr val="FFFFFF"/>
+                </a:solidFill>
+                <a:latin typeface="Arial" pitchFamily="34" charset="0"/>
+                <a:ea typeface="Arial" pitchFamily="34" charset="-122"/>
+                <a:cs typeface="Arial" pitchFamily="34" charset="-120"/>
+              </a:rPr>
+              <a:t>PHA 3 · Tổng hợp</a:t>
+            </a:r>
+            <a:endParaRPr lang="en-US" sz="1350" dirty="0"/>
+          </a:p>
+        </p:txBody>
+      </p:sp>
+      <p:sp>
+        <p:nvSpPr>
+          <p:cNvPr id="22" name="Text 20"/>
+          <p:cNvSpPr txBox="1"/>
+          <p:nvPr/>
+        </p:nvSpPr>
+        <p:spPr>
+          <a:xfrm>
+            <a:off x="8202168" y="2084832"/>
+            <a:ext cx="3200400" cy="2697480"/>
+          </a:xfrm>
+          <a:prstGeom prst="rect">
+            <a:avLst/>
+          </a:prstGeom>
+          <a:noFill/>
+          <a:ln/>
+        </p:spPr>
+        <p:txBody>
+          <a:bodyPr wrap="square" rtlCol="0" anchor="t"/>
+          <a:lstStyle/>
+          <a:p>
+            <a:pPr marL="342900" indent="-342900">
+              <a:spcAft>
+                <a:spcPts val="800"/>
+              </a:spcAft>
+              <a:buSzPct val="100000"/>
+              <a:buChar char="•"/>
+            </a:pPr>
+            <a:r>
+              <a:rPr lang="en-US" sz="1200" dirty="0">
+                <a:solidFill>
+                  <a:srgbClr val="253044"/>
+                </a:solidFill>
+                <a:latin typeface="Arial" pitchFamily="34" charset="0"/>
+                <a:ea typeface="Arial" pitchFamily="34" charset="-122"/>
+                <a:cs typeface="Arial" pitchFamily="34" charset="-120"/>
+              </a:rPr>
+              <a:t>Gom theo (thành phố, ngày): TB / max</a:t>
+            </a:r>
+            <a:endParaRPr lang="en-US" sz="1200" dirty="0"/>
+          </a:p>
+          <a:p>
+            <a:pPr marL="342900" indent="-342900">
+              <a:spcAft>
+                <a:spcPts val="800"/>
+              </a:spcAft>
+              <a:buSzPct val="100000"/>
+              <a:buChar char="•"/>
+            </a:pPr>
+            <a:r>
+              <a:rPr lang="en-US" sz="1200" dirty="0">
+                <a:solidFill>
+                  <a:srgbClr val="253044"/>
+                </a:solidFill>
+                <a:latin typeface="Arial" pitchFamily="34" charset="0"/>
+                <a:ea typeface="Arial" pitchFamily="34" charset="-122"/>
+                <a:cs typeface="Arial" pitchFamily="34" charset="-120"/>
+              </a:rPr>
+              <a:t>Đếm số giờ ở mỗi mức chất lượng</a:t>
+            </a:r>
+            <a:endParaRPr lang="en-US" sz="1200" dirty="0"/>
+          </a:p>
+          <a:p>
+            <a:pPr marL="342900" indent="-342900">
+              <a:spcAft>
+                <a:spcPts val="800"/>
+              </a:spcAft>
+              <a:buSzPct val="100000"/>
+              <a:buChar char="•"/>
+            </a:pPr>
+            <a:r>
+              <a:rPr lang="en-US" sz="1200" dirty="0">
+                <a:solidFill>
+                  <a:srgbClr val="253044"/>
+                </a:solidFill>
+                <a:latin typeface="Arial" pitchFamily="34" charset="0"/>
+                <a:ea typeface="Arial" pitchFamily="34" charset="-122"/>
+                <a:cs typeface="Arial" pitchFamily="34" charset="-120"/>
+              </a:rPr>
+              <a:t>Xếp hạng thành phố — hạng 1 = bẩn nhất</a:t>
+            </a:r>
+            <a:endParaRPr lang="en-US" sz="1200" dirty="0"/>
+          </a:p>
+          <a:p>
+            <a:pPr marL="342900" indent="-342900">
+              <a:spcAft>
+                <a:spcPts val="800"/>
+              </a:spcAft>
+              <a:buSzPct val="100000"/>
+              <a:buChar char="•"/>
+            </a:pPr>
+            <a:r>
+              <a:rPr lang="en-US" sz="1200" dirty="0">
+                <a:solidFill>
+                  <a:srgbClr val="253044"/>
+                </a:solidFill>
+                <a:latin typeface="Arial" pitchFamily="34" charset="0"/>
+                <a:ea typeface="Arial" pitchFamily="34" charset="-122"/>
+                <a:cs typeface="Arial" pitchFamily="34" charset="-120"/>
+              </a:rPr>
+              <a:t>Ghi HBase cho dashboard đọc nhanh</a:t>
+            </a:r>
+            <a:endParaRPr lang="en-US" sz="1200" dirty="0"/>
+          </a:p>
+        </p:txBody>
+      </p:sp>
+      <p:sp>
+        <p:nvSpPr>
+          <p:cNvPr id="23" name="Shape 21"/>
+          <p:cNvSpPr/>
+          <p:nvPr/>
+        </p:nvSpPr>
+        <p:spPr>
+          <a:xfrm>
+            <a:off x="8110728" y="4892040"/>
+            <a:ext cx="3346704" cy="457200"/>
+          </a:xfrm>
+          <a:prstGeom prst="roundRect">
+            <a:avLst>
+              <a:gd name="adj" fmla="val 10000"/>
+            </a:avLst>
+          </a:prstGeom>
+          <a:solidFill>
+            <a:srgbClr val="F4F7FC"/>
+          </a:solidFill>
+          <a:ln w="12700">
+            <a:solidFill>
+              <a:srgbClr val="D6DEEA"/>
+            </a:solidFill>
+            <a:prstDash val="solid"/>
+          </a:ln>
+        </p:spPr>
+      </p:sp>
+      <p:sp>
+        <p:nvSpPr>
+          <p:cNvPr id="24" name="Text 22"/>
+          <p:cNvSpPr txBox="1"/>
+          <p:nvPr/>
+        </p:nvSpPr>
+        <p:spPr>
+          <a:xfrm>
+            <a:off x="8110728" y="4892040"/>
+            <a:ext cx="3346704" cy="457200"/>
+          </a:xfrm>
+          <a:prstGeom prst="rect">
+            <a:avLst/>
+          </a:prstGeom>
+          <a:noFill/>
+          <a:ln/>
+        </p:spPr>
+        <p:txBody>
+          <a:bodyPr wrap="square" lIns="25400" tIns="25400" rIns="25400" bIns="25400" rtlCol="0" anchor="ctr"/>
+          <a:lstStyle/>
+          <a:p>
+            <a:pPr algn="ctr" indent="0" marL="0">
+              <a:buNone/>
+            </a:pPr>
+            <a:r>
+              <a:rPr lang="en-US" sz="1200" b="1" dirty="0">
+                <a:solidFill>
+                  <a:srgbClr val="4F9D5D"/>
+                </a:solidFill>
+                <a:latin typeface="Arial" pitchFamily="34" charset="0"/>
+                <a:ea typeface="Arial" pitchFamily="34" charset="-122"/>
+                <a:cs typeface="Arial" pitchFamily="34" charset="-120"/>
+              </a:rPr>
+              <a:t>→ </a:t>
+            </a:r>
+            <a:pPr algn="ctr" indent="0" marL="0">
+              <a:buNone/>
+            </a:pPr>
+            <a:r>
+              <a:rPr lang="en-US" sz="1150" b="1" dirty="0">
+                <a:solidFill>
+                  <a:srgbClr val="4F9D5D"/>
+                </a:solidFill>
+                <a:latin typeface="Arial" pitchFamily="34" charset="0"/>
+                <a:ea typeface="Arial" pitchFamily="34" charset="-122"/>
+                <a:cs typeface="Arial" pitchFamily="34" charset="-120"/>
+              </a:rPr>
+              <a:t>/agg + HBase · ~8,26′</a:t>
+            </a:r>
+            <a:endParaRPr lang="en-US" sz="1200" dirty="0"/>
+          </a:p>
+        </p:txBody>
+      </p:sp>
+      <p:sp>
+        <p:nvSpPr>
+          <p:cNvPr id="25" name="Text 23"/>
+          <p:cNvSpPr txBox="1"/>
+          <p:nvPr/>
+        </p:nvSpPr>
+        <p:spPr>
+          <a:xfrm>
+            <a:off x="502920" y="5623560"/>
+            <a:ext cx="11064240" cy="548640"/>
+          </a:xfrm>
+          <a:prstGeom prst="rect">
+            <a:avLst/>
+          </a:prstGeom>
+          <a:noFill/>
+          <a:ln/>
+        </p:spPr>
+        <p:txBody>
+          <a:bodyPr wrap="square" rtlCol="0" anchor="ctr"/>
+          <a:lstStyle/>
+          <a:p>
             <a:pPr indent="0" marL="0">
               <a:buNone/>
             </a:pPr>
             <a:r>
+              <a:rPr lang="en-US" sz="1200" b="1" dirty="0">
+                <a:solidFill>
+                  <a:srgbClr val="1F3864"/>
+                </a:solidFill>
+                <a:latin typeface="Arial" pitchFamily="34" charset="0"/>
+                <a:ea typeface="Arial" pitchFamily="34" charset="-122"/>
+                <a:cs typeface="Arial" pitchFamily="34" charset="-120"/>
+              </a:rPr>
+              <a:t>Điểm cốt lõi:  </a:t>
+            </a:r>
+            <a:pPr indent="0" marL="0">
+              <a:buNone/>
+            </a:pPr>
+            <a:r>
               <a:rPr lang="en-US" sz="1200" dirty="0">
                 <a:solidFill>
-                  <a:srgbClr val="6B7280"/>
-                </a:solidFill>
-                <a:latin typeface="Arial" pitchFamily="34" charset="0"/>
-                <a:ea typeface="Arial" pitchFamily="34" charset="-122"/>
-                <a:cs typeface="Arial" pitchFamily="34" charset="-120"/>
-              </a:rPr>
-              <a:t>Tỉ lệ nội suy &lt; 0,02% (chỉ khe ≤ 3h) → giữ tính trung thực của dữ liệu.</a:t>
+                  <a:srgbClr val="253044"/>
+                </a:solidFill>
+                <a:latin typeface="Arial" pitchFamily="34" charset="0"/>
+                <a:ea typeface="Arial" pitchFamily="34" charset="-122"/>
+                <a:cs typeface="Arial" pitchFamily="34" charset="-120"/>
+              </a:rPr>
+              <a:t>batch &amp; streaming gọi CHUNG một lõi aqi_core nên không lệch kết quả; owm_aqi chỉ để đối chiếu, không đưa vào công thức.</a:t>
             </a:r>
             <a:endParaRPr lang="en-US" sz="1200" dirty="0"/>
           </a:p>
@@ -5094,7 +5093,7 @@
                 <a:ea typeface="Arial" pitchFamily="34" charset="-122"/>
                 <a:cs typeface="Arial" pitchFamily="34" charset="-120"/>
               </a:rPr>
-              <a:t>Pha 2 tính AQI · Pha 3 tổng hợp &amp; xếp hạng</a:t>
+              <a:t>Thuật toán AQI — đóng góp khoa học</a:t>
             </a:r>
             <a:endParaRPr lang="en-US" sz="2300" dirty="0"/>
           </a:p>
@@ -5133,7 +5132,7 @@
                 <a:ea typeface="Arial" pitchFamily="34" charset="-122"/>
                 <a:cs typeface="Arial" pitchFamily="34" charset="-120"/>
               </a:rPr>
-              <a:t>Tính AQI từng giờ cho mỗi trạm, rồi tổng hợp theo thành phố để phục vụ dashboard.</a:t>
+              <a:t>Tự tính AQI chuẩn Việt Nam từ nồng độ, thay vì dùng chỉ số 1–5 có sẵn của OpenWeather.</a:t>
             </a:r>
             <a:endParaRPr lang="en-US" sz="1350" dirty="0"/>
           </a:p>
@@ -5147,12 +5146,158 @@
         </p:nvSpPr>
         <p:spPr>
           <a:xfrm>
-            <a:off x="640080" y="1783080"/>
-            <a:ext cx="5440680" cy="2788920"/>
+            <a:off x="548640" y="1463040"/>
+            <a:ext cx="11091672" cy="1234440"/>
           </a:xfrm>
           <a:prstGeom prst="roundRect">
             <a:avLst>
-              <a:gd name="adj" fmla="val 2295"/>
+              <a:gd name="adj" fmla="val 5185"/>
+            </a:avLst>
+          </a:prstGeom>
+          <a:solidFill>
+            <a:srgbClr val="1F3864"/>
+          </a:solidFill>
+          <a:ln/>
+          <a:effectLst>
+            <a:outerShdw sx="100000" sy="100000" kx="0" ky="0" algn="bl" rotWithShape="0" blurRad="88900" dist="25400" dir="5400000">
+              <a:srgbClr val="9AA6B8">
+                <a:alpha val="32000"/>
+              </a:srgbClr>
+            </a:outerShdw>
+          </a:effectLst>
+        </p:spPr>
+      </p:sp>
+      <p:sp>
+        <p:nvSpPr>
+          <p:cNvPr id="8" name="Text 6"/>
+          <p:cNvSpPr txBox="1"/>
+          <p:nvPr/>
+        </p:nvSpPr>
+        <p:spPr>
+          <a:xfrm>
+            <a:off x="822960" y="1517904"/>
+            <a:ext cx="10515600" cy="292608"/>
+          </a:xfrm>
+          <a:prstGeom prst="rect">
+            <a:avLst/>
+          </a:prstGeom>
+          <a:noFill/>
+          <a:ln/>
+        </p:spPr>
+        <p:txBody>
+          <a:bodyPr wrap="square" rtlCol="0" anchor="ctr"/>
+          <a:lstStyle/>
+          <a:p>
+            <a:pPr indent="0" marL="0">
+              <a:buNone/>
+            </a:pPr>
+            <a:r>
+              <a:rPr lang="en-US" sz="1250" b="1" dirty="0">
+                <a:solidFill>
+                  <a:srgbClr val="9DB8E6"/>
+                </a:solidFill>
+                <a:latin typeface="Arial" pitchFamily="34" charset="0"/>
+                <a:ea typeface="Arial" pitchFamily="34" charset="-122"/>
+                <a:cs typeface="Arial" pitchFamily="34" charset="-120"/>
+              </a:rPr>
+              <a:t>Công thức — nội suy tuyến tính theo bảng breakpoint (QĐ 1459)</a:t>
+            </a:r>
+            <a:endParaRPr lang="en-US" sz="1250" dirty="0"/>
+          </a:p>
+        </p:txBody>
+      </p:sp>
+      <p:sp>
+        <p:nvSpPr>
+          <p:cNvPr id="9" name="Text 7"/>
+          <p:cNvSpPr txBox="1"/>
+          <p:nvPr/>
+        </p:nvSpPr>
+        <p:spPr>
+          <a:xfrm>
+            <a:off x="822960" y="1865376"/>
+            <a:ext cx="10515600" cy="384048"/>
+          </a:xfrm>
+          <a:prstGeom prst="rect">
+            <a:avLst/>
+          </a:prstGeom>
+          <a:noFill/>
+          <a:ln/>
+        </p:spPr>
+        <p:txBody>
+          <a:bodyPr wrap="square" rtlCol="0" anchor="ctr"/>
+          <a:lstStyle/>
+          <a:p>
+            <a:pPr indent="0" marL="0">
+              <a:buNone/>
+            </a:pPr>
+            <a:r>
+              <a:rPr lang="en-US" sz="1300" dirty="0">
+                <a:solidFill>
+                  <a:srgbClr val="FFFFFF"/>
+                </a:solidFill>
+                <a:latin typeface="Courier New" pitchFamily="34" charset="0"/>
+                <a:ea typeface="Courier New" pitchFamily="34" charset="-122"/>
+                <a:cs typeface="Courier New" pitchFamily="34" charset="-120"/>
+              </a:rPr>
+              <a:t>IAQIₓ = (I_high − I_low) / (BP_high − BP_low) × (Cₓ − BP_low) + I_low</a:t>
+            </a:r>
+            <a:endParaRPr lang="en-US" sz="1300" dirty="0"/>
+          </a:p>
+        </p:txBody>
+      </p:sp>
+      <p:sp>
+        <p:nvSpPr>
+          <p:cNvPr id="10" name="Text 8"/>
+          <p:cNvSpPr txBox="1"/>
+          <p:nvPr/>
+        </p:nvSpPr>
+        <p:spPr>
+          <a:xfrm>
+            <a:off x="822960" y="2286000"/>
+            <a:ext cx="10515600" cy="384048"/>
+          </a:xfrm>
+          <a:prstGeom prst="rect">
+            <a:avLst/>
+          </a:prstGeom>
+          <a:noFill/>
+          <a:ln/>
+        </p:spPr>
+        <p:txBody>
+          <a:bodyPr wrap="square" rtlCol="0" anchor="ctr"/>
+          <a:lstStyle/>
+          <a:p>
+            <a:pPr indent="0" marL="0">
+              <a:buNone/>
+            </a:pPr>
+            <a:r>
+              <a:rPr lang="en-US" sz="1300" dirty="0">
+                <a:solidFill>
+                  <a:srgbClr val="FFFFFF"/>
+                </a:solidFill>
+                <a:latin typeface="Courier New" pitchFamily="34" charset="0"/>
+                <a:ea typeface="Courier New" pitchFamily="34" charset="-122"/>
+                <a:cs typeface="Courier New" pitchFamily="34" charset="-120"/>
+              </a:rPr>
+              <a:t>AQI = max( IAQIₓ )   ·   x ∈ {PM2.5, PM10, O₃, NO₂, SO₂, CO}</a:t>
+            </a:r>
+            <a:endParaRPr lang="en-US" sz="1300" dirty="0"/>
+          </a:p>
+        </p:txBody>
+      </p:sp>
+      <p:sp>
+        <p:nvSpPr>
+          <p:cNvPr id="11" name="Shape 9"/>
+          <p:cNvSpPr/>
+          <p:nvPr/>
+        </p:nvSpPr>
+        <p:spPr>
+          <a:xfrm>
+            <a:off x="548640" y="2788920"/>
+            <a:ext cx="5486400" cy="1874520"/>
+          </a:xfrm>
+          <a:prstGeom prst="roundRect">
+            <a:avLst>
+              <a:gd name="adj" fmla="val 3415"/>
             </a:avLst>
           </a:prstGeom>
           <a:solidFill>
@@ -5175,14 +5320,14 @@
       </p:sp>
       <p:sp>
         <p:nvSpPr>
-          <p:cNvPr id="8" name="Text 6"/>
+          <p:cNvPr id="12" name="Text 10"/>
           <p:cNvSpPr txBox="1"/>
           <p:nvPr/>
         </p:nvSpPr>
         <p:spPr>
           <a:xfrm>
-            <a:off x="868680" y="1901952"/>
-            <a:ext cx="4937760" cy="365760"/>
+            <a:off x="777240" y="2926080"/>
+            <a:ext cx="5029200" cy="292608"/>
           </a:xfrm>
           <a:prstGeom prst="rect">
             <a:avLst/>
@@ -5198,7 +5343,7 @@
               <a:buNone/>
             </a:pPr>
             <a:r>
-              <a:rPr lang="en-US" sz="1500" b="1" dirty="0">
+              <a:rPr lang="en-US" sz="1300" b="1" dirty="0">
                 <a:solidFill>
                   <a:srgbClr val="2E5AAC"/>
                 </a:solidFill>
@@ -5206,34 +5351,245 @@
                 <a:ea typeface="Arial" pitchFamily="34" charset="-122"/>
                 <a:cs typeface="Arial" pitchFamily="34" charset="-120"/>
               </a:rPr>
-              <a:t>Pha 2 — Tính AQI</a:t>
-            </a:r>
-            <a:endParaRPr lang="en-US" sz="1500" dirty="0"/>
+              <a:t>Ý nghĩa ký hiệu</a:t>
+            </a:r>
+            <a:endParaRPr lang="en-US" sz="1300" dirty="0"/>
           </a:p>
         </p:txBody>
       </p:sp>
       <p:sp>
         <p:nvSpPr>
-          <p:cNvPr id="9" name="Shape 7"/>
+          <p:cNvPr id="13" name="Text 11"/>
+          <p:cNvSpPr txBox="1"/>
+          <p:nvPr/>
+        </p:nvSpPr>
+        <p:spPr>
+          <a:xfrm>
+            <a:off x="777240" y="3218688"/>
+            <a:ext cx="5074920" cy="1417320"/>
+          </a:xfrm>
+          <a:prstGeom prst="rect">
+            <a:avLst/>
+          </a:prstGeom>
+          <a:noFill/>
+          <a:ln/>
+        </p:spPr>
+        <p:txBody>
+          <a:bodyPr wrap="square" rtlCol="0" anchor="t"/>
+          <a:lstStyle/>
+          <a:p>
+            <a:pPr indent="0" marL="0">
+              <a:lnSpc>
+                <a:spcPct val="106000"/>
+              </a:lnSpc>
+              <a:buNone/>
+            </a:pPr>
+            <a:r>
+              <a:rPr lang="en-US" sz="1100" b="1" dirty="0">
+                <a:solidFill>
+                  <a:srgbClr val="1F3864"/>
+                </a:solidFill>
+                <a:latin typeface="Arial" pitchFamily="34" charset="0"/>
+                <a:ea typeface="Arial" pitchFamily="34" charset="-122"/>
+                <a:cs typeface="Arial" pitchFamily="34" charset="-120"/>
+              </a:rPr>
+              <a:t>Cₓ</a:t>
+            </a:r>
+            <a:pPr indent="0" marL="0">
+              <a:lnSpc>
+                <a:spcPct val="106000"/>
+              </a:lnSpc>
+              <a:buNone/>
+            </a:pPr>
+            <a:r>
+              <a:rPr lang="en-US" sz="1100" dirty="0">
+                <a:solidFill>
+                  <a:srgbClr val="253044"/>
+                </a:solidFill>
+                <a:latin typeface="Arial" pitchFamily="34" charset="0"/>
+                <a:ea typeface="Arial" pitchFamily="34" charset="-122"/>
+                <a:cs typeface="Arial" pitchFamily="34" charset="-120"/>
+              </a:rPr>
+              <a:t> — nồng độ đo được (đã đúng cửa sổ)
+</a:t>
+            </a:r>
+            <a:endParaRPr lang="en-US" sz="1100" dirty="0"/>
+          </a:p>
+          <a:p>
+            <a:pPr indent="0" marL="0">
+              <a:lnSpc>
+                <a:spcPct val="106000"/>
+              </a:lnSpc>
+              <a:buNone/>
+            </a:pPr>
+            <a:r>
+              <a:rPr lang="en-US" sz="1100" b="1" dirty="0">
+                <a:solidFill>
+                  <a:srgbClr val="1F3864"/>
+                </a:solidFill>
+                <a:latin typeface="Arial" pitchFamily="34" charset="0"/>
+                <a:ea typeface="Arial" pitchFamily="34" charset="-122"/>
+                <a:cs typeface="Arial" pitchFamily="34" charset="-120"/>
+              </a:rPr>
+              <a:t>[BP_low, BP_high]</a:t>
+            </a:r>
+            <a:pPr indent="0" marL="0">
+              <a:lnSpc>
+                <a:spcPct val="106000"/>
+              </a:lnSpc>
+              <a:buNone/>
+            </a:pPr>
+            <a:r>
+              <a:rPr lang="en-US" sz="1100" dirty="0">
+                <a:solidFill>
+                  <a:srgbClr val="253044"/>
+                </a:solidFill>
+                <a:latin typeface="Arial" pitchFamily="34" charset="0"/>
+                <a:ea typeface="Arial" pitchFamily="34" charset="-122"/>
+                <a:cs typeface="Arial" pitchFamily="34" charset="-120"/>
+              </a:rPr>
+              <a:t> — khoảng nồng độ chứa Cₓ
+</a:t>
+            </a:r>
+            <a:endParaRPr lang="en-US" sz="1100" dirty="0"/>
+          </a:p>
+          <a:p>
+            <a:pPr indent="0" marL="0">
+              <a:lnSpc>
+                <a:spcPct val="106000"/>
+              </a:lnSpc>
+              <a:buNone/>
+            </a:pPr>
+            <a:r>
+              <a:rPr lang="en-US" sz="1100" b="1" dirty="0">
+                <a:solidFill>
+                  <a:srgbClr val="1F3864"/>
+                </a:solidFill>
+                <a:latin typeface="Arial" pitchFamily="34" charset="0"/>
+                <a:ea typeface="Arial" pitchFamily="34" charset="-122"/>
+                <a:cs typeface="Arial" pitchFamily="34" charset="-120"/>
+              </a:rPr>
+              <a:t>[I_low, I_high]</a:t>
+            </a:r>
+            <a:pPr indent="0" marL="0">
+              <a:lnSpc>
+                <a:spcPct val="106000"/>
+              </a:lnSpc>
+              <a:buNone/>
+            </a:pPr>
+            <a:r>
+              <a:rPr lang="en-US" sz="1100" dirty="0">
+                <a:solidFill>
+                  <a:srgbClr val="253044"/>
+                </a:solidFill>
+                <a:latin typeface="Arial" pitchFamily="34" charset="0"/>
+                <a:ea typeface="Arial" pitchFamily="34" charset="-122"/>
+                <a:cs typeface="Arial" pitchFamily="34" charset="-120"/>
+              </a:rPr>
+              <a:t> — khoảng điểm AQI tương ứng
+</a:t>
+            </a:r>
+            <a:endParaRPr lang="en-US" sz="1100" dirty="0"/>
+          </a:p>
+          <a:p>
+            <a:pPr indent="0" marL="0">
+              <a:lnSpc>
+                <a:spcPct val="106000"/>
+              </a:lnSpc>
+              <a:buNone/>
+            </a:pPr>
+            <a:r>
+              <a:rPr lang="en-US" sz="1100" b="1" dirty="0">
+                <a:solidFill>
+                  <a:srgbClr val="1F3864"/>
+                </a:solidFill>
+                <a:latin typeface="Arial" pitchFamily="34" charset="0"/>
+                <a:ea typeface="Arial" pitchFamily="34" charset="-122"/>
+                <a:cs typeface="Arial" pitchFamily="34" charset="-120"/>
+              </a:rPr>
+              <a:t>phân số đầu</a:t>
+            </a:r>
+            <a:pPr indent="0" marL="0">
+              <a:lnSpc>
+                <a:spcPct val="106000"/>
+              </a:lnSpc>
+              <a:buNone/>
+            </a:pPr>
+            <a:r>
+              <a:rPr lang="en-US" sz="1100" dirty="0">
+                <a:solidFill>
+                  <a:srgbClr val="253044"/>
+                </a:solidFill>
+                <a:latin typeface="Arial" pitchFamily="34" charset="0"/>
+                <a:ea typeface="Arial" pitchFamily="34" charset="-122"/>
+                <a:cs typeface="Arial" pitchFamily="34" charset="-120"/>
+              </a:rPr>
+              <a:t> = độ dốc (1 đơn vị nồng độ → mấy điểm)
+</a:t>
+            </a:r>
+            <a:endParaRPr lang="en-US" sz="1100" dirty="0"/>
+          </a:p>
+          <a:p>
+            <a:pPr indent="0" marL="0">
+              <a:lnSpc>
+                <a:spcPct val="106000"/>
+              </a:lnSpc>
+              <a:buNone/>
+            </a:pPr>
+            <a:r>
+              <a:rPr lang="en-US" sz="1100" b="1" dirty="0">
+                <a:solidFill>
+                  <a:srgbClr val="1F3864"/>
+                </a:solidFill>
+                <a:latin typeface="Arial" pitchFamily="34" charset="0"/>
+                <a:ea typeface="Arial" pitchFamily="34" charset="-122"/>
+                <a:cs typeface="Arial" pitchFamily="34" charset="-120"/>
+              </a:rPr>
+              <a:t>max</a:t>
+            </a:r>
+            <a:pPr indent="0" marL="0">
+              <a:lnSpc>
+                <a:spcPct val="106000"/>
+              </a:lnSpc>
+              <a:buNone/>
+            </a:pPr>
+            <a:r>
+              <a:rPr lang="en-US" sz="1100" dirty="0">
+                <a:solidFill>
+                  <a:srgbClr val="253044"/>
+                </a:solidFill>
+                <a:latin typeface="Arial" pitchFamily="34" charset="0"/>
+                <a:ea typeface="Arial" pitchFamily="34" charset="-122"/>
+                <a:cs typeface="Arial" pitchFamily="34" charset="-120"/>
+              </a:rPr>
+              <a:t> — lấy chất tệ nhất (= chất trội)</a:t>
+            </a:r>
+            <a:endParaRPr lang="en-US" sz="1100" dirty="0"/>
+          </a:p>
+        </p:txBody>
+      </p:sp>
+      <p:sp>
+        <p:nvSpPr>
+          <p:cNvPr id="14" name="Shape 12"/>
           <p:cNvSpPr/>
           <p:nvPr/>
         </p:nvSpPr>
         <p:spPr>
           <a:xfrm>
-            <a:off x="868680" y="2286000"/>
-            <a:ext cx="4983480" cy="603504"/>
+            <a:off x="6172200" y="2788920"/>
+            <a:ext cx="5468112" cy="1874520"/>
           </a:xfrm>
           <a:prstGeom prst="roundRect">
             <a:avLst>
-              <a:gd name="adj" fmla="val 7576"/>
+              <a:gd name="adj" fmla="val 3415"/>
             </a:avLst>
           </a:prstGeom>
           <a:solidFill>
-            <a:srgbClr val="E9F0FB"/>
+            <a:srgbClr val="EAF3EC"/>
           </a:solidFill>
-          <a:ln w="12700">
+          <a:ln w="15240">
             <a:solidFill>
-              <a:srgbClr val="D6DEEA"/>
+              <a:srgbClr val="4F9D5D"/>
             </a:solidFill>
             <a:prstDash val="solid"/>
           </a:ln>
@@ -5241,14 +5597,14 @@
       </p:sp>
       <p:sp>
         <p:nvSpPr>
-          <p:cNvPr id="10" name="Text 8"/>
+          <p:cNvPr id="15" name="Text 13"/>
           <p:cNvSpPr txBox="1"/>
           <p:nvPr/>
         </p:nvSpPr>
         <p:spPr>
           <a:xfrm>
-            <a:off x="1005840" y="2286000"/>
-            <a:ext cx="4709160" cy="603504"/>
+            <a:off x="6400800" y="2926080"/>
+            <a:ext cx="5029200" cy="292608"/>
           </a:xfrm>
           <a:prstGeom prst="rect">
             <a:avLst/>
@@ -5264,21 +5620,131 @@
               <a:buNone/>
             </a:pPr>
             <a:r>
-              <a:rPr lang="en-US" sz="1250" b="1" dirty="0">
-                <a:solidFill>
-                  <a:srgbClr val="1F3864"/>
-                </a:solidFill>
-                <a:latin typeface="Arial" pitchFamily="34" charset="0"/>
-                <a:ea typeface="Arial" pitchFamily="34" charset="-122"/>
-                <a:cs typeface="Arial" pitchFamily="34" charset="-120"/>
-              </a:rPr>
-              <a:t>NowCast 12 giờ / trạm  </a:t>
-            </a:r>
+              <a:rPr lang="en-US" sz="1300" b="1" dirty="0">
+                <a:solidFill>
+                  <a:srgbClr val="2F7D3A"/>
+                </a:solidFill>
+                <a:latin typeface="Arial" pitchFamily="34" charset="0"/>
+                <a:ea typeface="Arial" pitchFamily="34" charset="-122"/>
+                <a:cs typeface="Arial" pitchFamily="34" charset="-120"/>
+              </a:rPr>
+              <a:t>Ví dụ — PM2.5 (TB 24h) = 35,2</a:t>
+            </a:r>
+            <a:endParaRPr lang="en-US" sz="1300" dirty="0"/>
+          </a:p>
+        </p:txBody>
+      </p:sp>
+      <p:sp>
+        <p:nvSpPr>
+          <p:cNvPr id="16" name="Text 14"/>
+          <p:cNvSpPr txBox="1"/>
+          <p:nvPr/>
+        </p:nvSpPr>
+        <p:spPr>
+          <a:xfrm>
+            <a:off x="6400800" y="3218688"/>
+            <a:ext cx="5074920" cy="1417320"/>
+          </a:xfrm>
+          <a:prstGeom prst="rect">
+            <a:avLst/>
+          </a:prstGeom>
+          <a:noFill/>
+          <a:ln/>
+        </p:spPr>
+        <p:txBody>
+          <a:bodyPr wrap="square" rtlCol="0" anchor="t"/>
+          <a:lstStyle/>
+          <a:p>
             <a:pPr indent="0" marL="0">
-              <a:buNone/>
-            </a:pPr>
-            <a:r>
-              <a:rPr lang="en-US" sz="1100" dirty="0">
+              <a:lnSpc>
+                <a:spcPct val="106000"/>
+              </a:lnSpc>
+              <a:spcAft>
+                <a:spcPts val="500"/>
+              </a:spcAft>
+              <a:buNone/>
+            </a:pPr>
+            <a:r>
+              <a:rPr lang="en-US" sz="1150" dirty="0">
+                <a:solidFill>
+                  <a:srgbClr val="253044"/>
+                </a:solidFill>
+                <a:latin typeface="Arial" pitchFamily="34" charset="0"/>
+                <a:ea typeface="Arial" pitchFamily="34" charset="-122"/>
+                <a:cs typeface="Arial" pitchFamily="34" charset="-120"/>
+              </a:rPr>
+              <a:t>35,2 rơi vào khoảng [25 ; 50] → điểm [50 ; 100]
+</a:t>
+            </a:r>
+            <a:endParaRPr lang="en-US" sz="1150" dirty="0"/>
+          </a:p>
+          <a:p>
+            <a:pPr indent="0" marL="0">
+              <a:lnSpc>
+                <a:spcPct val="106000"/>
+              </a:lnSpc>
+              <a:buNone/>
+            </a:pPr>
+            <a:r>
+              <a:rPr lang="en-US" sz="1150" dirty="0">
+                <a:solidFill>
+                  <a:srgbClr val="253044"/>
+                </a:solidFill>
+                <a:latin typeface="Courier New" pitchFamily="34" charset="0"/>
+                <a:ea typeface="Courier New" pitchFamily="34" charset="-122"/>
+                <a:cs typeface="Courier New" pitchFamily="34" charset="-120"/>
+              </a:rPr>
+              <a:t>IAQI = (100−50)/(50−25) × (35,2−25) + 50
+</a:t>
+            </a:r>
+            <a:endParaRPr lang="en-US" sz="1150" dirty="0"/>
+          </a:p>
+          <a:p>
+            <a:pPr indent="0" marL="0">
+              <a:lnSpc>
+                <a:spcPct val="106000"/>
+              </a:lnSpc>
+              <a:buNone/>
+            </a:pPr>
+            <a:r>
+              <a:rPr lang="en-US" sz="1150" dirty="0">
+                <a:solidFill>
+                  <a:srgbClr val="253044"/>
+                </a:solidFill>
+                <a:latin typeface="Courier New" pitchFamily="34" charset="0"/>
+                <a:ea typeface="Courier New" pitchFamily="34" charset="-122"/>
+                <a:cs typeface="Courier New" pitchFamily="34" charset="-120"/>
+              </a:rPr>
+              <a:t>       = 2 × 10,2 + 50 = </a:t>
+            </a:r>
+            <a:pPr indent="0" marL="0">
+              <a:lnSpc>
+                <a:spcPct val="106000"/>
+              </a:lnSpc>
+              <a:buNone/>
+            </a:pPr>
+            <a:r>
+              <a:rPr lang="en-US" sz="1300" b="1" dirty="0">
+                <a:solidFill>
+                  <a:srgbClr val="2F7D3A"/>
+                </a:solidFill>
+                <a:latin typeface="Arial" pitchFamily="34" charset="0"/>
+                <a:ea typeface="Arial" pitchFamily="34" charset="-122"/>
+                <a:cs typeface="Arial" pitchFamily="34" charset="-120"/>
+              </a:rPr>
+              <a:t>70,4</a:t>
+            </a:r>
+            <a:endParaRPr lang="en-US" sz="1150" dirty="0"/>
+          </a:p>
+          <a:p>
+            <a:pPr indent="0" marL="0">
+              <a:lnSpc>
+                <a:spcPct val="106000"/>
+              </a:lnSpc>
+              <a:buNone/>
+            </a:pPr>
+            <a:r>
+              <a:rPr lang="en-US" sz="1100" i="1" dirty="0">
                 <a:solidFill>
                   <a:srgbClr val="6B7280"/>
                 </a:solidFill>
@@ -5286,69 +5752,22 @@
                 <a:ea typeface="Arial" pitchFamily="34" charset="-122"/>
                 <a:cs typeface="Arial" pitchFamily="34" charset="-120"/>
               </a:rPr>
-              <a:t>· trung bình có trọng số cho PM</a:t>
-            </a:r>
-            <a:endParaRPr lang="en-US" sz="1250" dirty="0"/>
+              <a:t>→ 35,2 nằm ~40% đoạn nồng độ nên điểm cũng ~40% đoạn AQI.</a:t>
+            </a:r>
+            <a:endParaRPr lang="en-US" sz="1150" dirty="0"/>
           </a:p>
         </p:txBody>
       </p:sp>
       <p:sp>
         <p:nvSpPr>
-          <p:cNvPr id="11" name="Shape 9"/>
-          <p:cNvSpPr/>
-          <p:nvPr/>
-        </p:nvSpPr>
-        <p:spPr>
-          <a:xfrm>
-            <a:off x="3200400" y="2889504"/>
-            <a:ext cx="201168" cy="128016"/>
-          </a:xfrm>
-          <a:prstGeom prst="downArrow">
-            <a:avLst/>
-          </a:prstGeom>
-          <a:solidFill>
-            <a:srgbClr val="AEBCD2"/>
-          </a:solidFill>
-          <a:ln/>
-        </p:spPr>
-      </p:sp>
-      <p:sp>
-        <p:nvSpPr>
-          <p:cNvPr id="12" name="Shape 10"/>
-          <p:cNvSpPr/>
-          <p:nvPr/>
-        </p:nvSpPr>
-        <p:spPr>
-          <a:xfrm>
-            <a:off x="868680" y="3017520"/>
-            <a:ext cx="4983480" cy="603504"/>
-          </a:xfrm>
-          <a:prstGeom prst="roundRect">
-            <a:avLst>
-              <a:gd name="adj" fmla="val 7576"/>
-            </a:avLst>
-          </a:prstGeom>
-          <a:solidFill>
-            <a:srgbClr val="E9F0FB"/>
-          </a:solidFill>
-          <a:ln w="12700">
-            <a:solidFill>
-              <a:srgbClr val="D6DEEA"/>
-            </a:solidFill>
-            <a:prstDash val="solid"/>
-          </a:ln>
-        </p:spPr>
-      </p:sp>
-      <p:sp>
-        <p:nvSpPr>
-          <p:cNvPr id="13" name="Text 11"/>
+          <p:cNvPr id="17" name="Text 15"/>
           <p:cNvSpPr txBox="1"/>
           <p:nvPr/>
         </p:nvSpPr>
         <p:spPr>
           <a:xfrm>
-            <a:off x="1005840" y="3017520"/>
-            <a:ext cx="4709160" cy="603504"/>
+            <a:off x="548640" y="4828032"/>
+            <a:ext cx="11091672" cy="274320"/>
           </a:xfrm>
           <a:prstGeom prst="rect">
             <a:avLst/>
@@ -5372,21 +5791,7 @@
                 <a:ea typeface="Arial" pitchFamily="34" charset="-122"/>
                 <a:cs typeface="Arial" pitchFamily="34" charset="-120"/>
               </a:rPr>
-              <a:t>IAQI từng chất  </a:t>
-            </a:r>
-            <a:pPr indent="0" marL="0">
-              <a:buNone/>
-            </a:pPr>
-            <a:r>
-              <a:rPr lang="en-US" sz="1100" dirty="0">
-                <a:solidFill>
-                  <a:srgbClr val="6B7280"/>
-                </a:solidFill>
-                <a:latin typeface="Arial" pitchFamily="34" charset="0"/>
-                <a:ea typeface="Arial" pitchFamily="34" charset="-122"/>
-                <a:cs typeface="Arial" pitchFamily="34" charset="-120"/>
-              </a:rPr>
-              <a:t>· tra bảng breakpoint QĐ 1459</a:t>
+              <a:t>Sáu mức AQI theo QĐ 1459 — tra nhãn/màu từ giá trị AQI cuối</a:t>
             </a:r>
             <a:endParaRPr lang="en-US" sz="1250" dirty="0"/>
           </a:p>
@@ -5394,129 +5799,24 @@
       </p:sp>
       <p:sp>
         <p:nvSpPr>
-          <p:cNvPr id="14" name="Shape 12"/>
+          <p:cNvPr id="18" name="Shape 16"/>
           <p:cNvSpPr/>
           <p:nvPr/>
         </p:nvSpPr>
         <p:spPr>
           <a:xfrm>
-            <a:off x="3200400" y="3621024"/>
-            <a:ext cx="201168" cy="128016"/>
-          </a:xfrm>
-          <a:prstGeom prst="downArrow">
-            <a:avLst/>
+            <a:off x="594360" y="5138928"/>
+            <a:ext cx="1714500" cy="932688"/>
+          </a:xfrm>
+          <a:prstGeom prst="roundRect">
+            <a:avLst>
+              <a:gd name="adj" fmla="val 5882"/>
+            </a:avLst>
           </a:prstGeom>
           <a:solidFill>
-            <a:srgbClr val="AEBCD2"/>
+            <a:srgbClr val="4CAF50"/>
           </a:solidFill>
           <a:ln/>
-        </p:spPr>
-      </p:sp>
-      <p:sp>
-        <p:nvSpPr>
-          <p:cNvPr id="15" name="Shape 13"/>
-          <p:cNvSpPr/>
-          <p:nvPr/>
-        </p:nvSpPr>
-        <p:spPr>
-          <a:xfrm>
-            <a:off x="868680" y="3749040"/>
-            <a:ext cx="4983480" cy="603504"/>
-          </a:xfrm>
-          <a:prstGeom prst="roundRect">
-            <a:avLst>
-              <a:gd name="adj" fmla="val 7576"/>
-            </a:avLst>
-          </a:prstGeom>
-          <a:solidFill>
-            <a:srgbClr val="E9F0FB"/>
-          </a:solidFill>
-          <a:ln w="12700">
-            <a:solidFill>
-              <a:srgbClr val="D6DEEA"/>
-            </a:solidFill>
-            <a:prstDash val="solid"/>
-          </a:ln>
-        </p:spPr>
-      </p:sp>
-      <p:sp>
-        <p:nvSpPr>
-          <p:cNvPr id="16" name="Text 14"/>
-          <p:cNvSpPr txBox="1"/>
-          <p:nvPr/>
-        </p:nvSpPr>
-        <p:spPr>
-          <a:xfrm>
-            <a:off x="1005840" y="3749040"/>
-            <a:ext cx="4709160" cy="603504"/>
-          </a:xfrm>
-          <a:prstGeom prst="rect">
-            <a:avLst/>
-          </a:prstGeom>
-          <a:noFill/>
-          <a:ln/>
-        </p:spPr>
-        <p:txBody>
-          <a:bodyPr wrap="square" rtlCol="0" anchor="ctr"/>
-          <a:lstStyle/>
-          <a:p>
-            <a:pPr indent="0" marL="0">
-              <a:buNone/>
-            </a:pPr>
-            <a:r>
-              <a:rPr lang="en-US" sz="1250" b="1" dirty="0">
-                <a:solidFill>
-                  <a:srgbClr val="1F3864"/>
-                </a:solidFill>
-                <a:latin typeface="Arial" pitchFamily="34" charset="0"/>
-                <a:ea typeface="Arial" pitchFamily="34" charset="-122"/>
-                <a:cs typeface="Arial" pitchFamily="34" charset="-120"/>
-              </a:rPr>
-              <a:t>AQI = max(IAQI)  </a:t>
-            </a:r>
-            <a:pPr indent="0" marL="0">
-              <a:buNone/>
-            </a:pPr>
-            <a:r>
-              <a:rPr lang="en-US" sz="1100" dirty="0">
-                <a:solidFill>
-                  <a:srgbClr val="6B7280"/>
-                </a:solidFill>
-                <a:latin typeface="Arial" pitchFamily="34" charset="0"/>
-                <a:ea typeface="Arial" pitchFamily="34" charset="-122"/>
-                <a:cs typeface="Arial" pitchFamily="34" charset="-120"/>
-              </a:rPr>
-              <a:t>· gán mức + chất trội (dominant)</a:t>
-            </a:r>
-            <a:endParaRPr lang="en-US" sz="1250" dirty="0"/>
-          </a:p>
-        </p:txBody>
-      </p:sp>
-      <p:sp>
-        <p:nvSpPr>
-          <p:cNvPr id="17" name="Shape 15"/>
-          <p:cNvSpPr/>
-          <p:nvPr/>
-        </p:nvSpPr>
-        <p:spPr>
-          <a:xfrm>
-            <a:off x="6263640" y="1783080"/>
-            <a:ext cx="5257800" cy="2788920"/>
-          </a:xfrm>
-          <a:prstGeom prst="roundRect">
-            <a:avLst>
-              <a:gd name="adj" fmla="val 2295"/>
-            </a:avLst>
-          </a:prstGeom>
-          <a:solidFill>
-            <a:srgbClr val="F4F7FC"/>
-          </a:solidFill>
-          <a:ln w="12700">
-            <a:solidFill>
-              <a:srgbClr val="D6DEEA"/>
-            </a:solidFill>
-            <a:prstDash val="solid"/>
-          </a:ln>
           <a:effectLst>
             <a:outerShdw sx="100000" sy="100000" kx="0" ky="0" algn="bl" rotWithShape="0" blurRad="88900" dist="25400" dir="5400000">
               <a:srgbClr val="9AA6B8">
@@ -5528,14 +5828,14 @@
       </p:sp>
       <p:sp>
         <p:nvSpPr>
-          <p:cNvPr id="18" name="Text 16"/>
+          <p:cNvPr id="19" name="Text 17"/>
           <p:cNvSpPr txBox="1"/>
           <p:nvPr/>
         </p:nvSpPr>
         <p:spPr>
           <a:xfrm>
-            <a:off x="6492240" y="1901952"/>
-            <a:ext cx="4846320" cy="365760"/>
+            <a:off x="594360" y="5138928"/>
+            <a:ext cx="1714500" cy="932688"/>
           </a:xfrm>
           <a:prstGeom prst="rect">
             <a:avLst/>
@@ -5544,130 +5844,54 @@
           <a:ln/>
         </p:spPr>
         <p:txBody>
-          <a:bodyPr wrap="square" rtlCol="0" anchor="ctr"/>
+          <a:bodyPr wrap="square" lIns="25400" tIns="25400" rIns="25400" bIns="25400" rtlCol="0" anchor="ctr"/>
           <a:lstStyle/>
           <a:p>
-            <a:pPr indent="0" marL="0">
-              <a:buNone/>
-            </a:pPr>
-            <a:r>
-              <a:rPr lang="en-US" sz="1500" b="1" dirty="0">
-                <a:solidFill>
-                  <a:srgbClr val="4F9D5D"/>
-                </a:solidFill>
-                <a:latin typeface="Arial" pitchFamily="34" charset="0"/>
-                <a:ea typeface="Arial" pitchFamily="34" charset="-122"/>
-                <a:cs typeface="Arial" pitchFamily="34" charset="-120"/>
-              </a:rPr>
-              <a:t>Pha 3 — Tổng hợp &amp; xếp hạng</a:t>
-            </a:r>
-            <a:endParaRPr lang="en-US" sz="1500" dirty="0"/>
-          </a:p>
-        </p:txBody>
-      </p:sp>
-      <p:sp>
-        <p:nvSpPr>
-          <p:cNvPr id="19" name="Text 17"/>
-          <p:cNvSpPr txBox="1"/>
-          <p:nvPr/>
-        </p:nvSpPr>
-        <p:spPr>
-          <a:xfrm>
-            <a:off x="6492240" y="2286000"/>
-            <a:ext cx="4846320" cy="2194560"/>
-          </a:xfrm>
-          <a:prstGeom prst="rect">
-            <a:avLst/>
-          </a:prstGeom>
-          <a:noFill/>
-          <a:ln/>
-        </p:spPr>
-        <p:txBody>
-          <a:bodyPr wrap="square" rtlCol="0" anchor="t"/>
-          <a:lstStyle/>
-          <a:p>
-            <a:pPr marL="342900" indent="-342900">
-              <a:spcAft>
-                <a:spcPts val="700"/>
-              </a:spcAft>
-              <a:buSzPct val="100000"/>
-              <a:buChar char="•"/>
-            </a:pPr>
-            <a:r>
-              <a:rPr lang="en-US" sz="1250" dirty="0">
-                <a:solidFill>
-                  <a:srgbClr val="253044"/>
-                </a:solidFill>
-                <a:latin typeface="Arial" pitchFamily="34" charset="0"/>
-                <a:ea typeface="Arial" pitchFamily="34" charset="-122"/>
-                <a:cs typeface="Arial" pitchFamily="34" charset="-120"/>
-              </a:rPr>
-              <a:t>Gom theo (thành phố, ngày): trung bình / max AQI</a:t>
-            </a:r>
-            <a:endParaRPr lang="en-US" sz="1250" dirty="0"/>
-          </a:p>
-          <a:p>
-            <a:pPr marL="342900" indent="-342900">
-              <a:spcAft>
-                <a:spcPts val="700"/>
-              </a:spcAft>
-              <a:buSzPct val="100000"/>
-              <a:buChar char="•"/>
-            </a:pPr>
-            <a:r>
-              <a:rPr lang="en-US" sz="1250" dirty="0">
-                <a:solidFill>
-                  <a:srgbClr val="253044"/>
-                </a:solidFill>
-                <a:latin typeface="Arial" pitchFamily="34" charset="0"/>
-                <a:ea typeface="Arial" pitchFamily="34" charset="-122"/>
-                <a:cs typeface="Arial" pitchFamily="34" charset="-120"/>
-              </a:rPr>
-              <a:t>Đếm số giờ ở mỗi mức chất lượng</a:t>
-            </a:r>
-            <a:endParaRPr lang="en-US" sz="1250" dirty="0"/>
-          </a:p>
-          <a:p>
-            <a:pPr marL="342900" indent="-342900">
-              <a:spcAft>
-                <a:spcPts val="700"/>
-              </a:spcAft>
-              <a:buSzPct val="100000"/>
-              <a:buChar char="•"/>
-            </a:pPr>
-            <a:r>
-              <a:rPr lang="en-US" sz="1250" dirty="0">
-                <a:solidFill>
-                  <a:srgbClr val="253044"/>
-                </a:solidFill>
-                <a:latin typeface="Arial" pitchFamily="34" charset="0"/>
-                <a:ea typeface="Arial" pitchFamily="34" charset="-122"/>
-                <a:cs typeface="Arial" pitchFamily="34" charset="-120"/>
-              </a:rPr>
-              <a:t>Xếp hạng thành phố — hạng 1 = ô nhiễm nhất</a:t>
-            </a:r>
-            <a:endParaRPr lang="en-US" sz="1250" dirty="0"/>
-          </a:p>
-          <a:p>
-            <a:pPr marL="342900" indent="-342900">
-              <a:spcAft>
-                <a:spcPts val="700"/>
-              </a:spcAft>
-              <a:buSzPct val="100000"/>
-              <a:buChar char="•"/>
-            </a:pPr>
-            <a:r>
-              <a:rPr lang="en-US" sz="1250" dirty="0">
-                <a:solidFill>
-                  <a:srgbClr val="253044"/>
-                </a:solidFill>
-                <a:latin typeface="Arial" pitchFamily="34" charset="0"/>
-                <a:ea typeface="Arial" pitchFamily="34" charset="-122"/>
-                <a:cs typeface="Arial" pitchFamily="34" charset="-120"/>
-              </a:rPr>
-              <a:t>Ghi kết quả vào HBase để dashboard đọc nhanh</a:t>
-            </a:r>
-            <a:endParaRPr lang="en-US" sz="1250" dirty="0"/>
+            <a:pPr algn="ctr" indent="0" marL="0">
+              <a:buNone/>
+            </a:pPr>
+            <a:r>
+              <a:rPr lang="en-US" sz="1600" b="1" dirty="0">
+                <a:solidFill>
+                  <a:srgbClr val="1F2A37"/>
+                </a:solidFill>
+                <a:latin typeface="Arial" pitchFamily="34" charset="0"/>
+                <a:ea typeface="Arial" pitchFamily="34" charset="-122"/>
+                <a:cs typeface="Arial" pitchFamily="34" charset="-120"/>
+              </a:rPr>
+              <a:t>1
+</a:t>
+            </a:r>
+            <a:pPr algn="ctr" indent="0" marL="0">
+              <a:buNone/>
+            </a:pPr>
+            <a:r>
+              <a:rPr lang="en-US" sz="1100" b="1" dirty="0">
+                <a:solidFill>
+                  <a:srgbClr val="1F2A37"/>
+                </a:solidFill>
+                <a:latin typeface="Arial" pitchFamily="34" charset="0"/>
+                <a:ea typeface="Arial" pitchFamily="34" charset="-122"/>
+                <a:cs typeface="Arial" pitchFamily="34" charset="-120"/>
+              </a:rPr>
+              <a:t>Tốt
+</a:t>
+            </a:r>
+            <a:pPr algn="ctr" indent="0" marL="0">
+              <a:buNone/>
+            </a:pPr>
+            <a:r>
+              <a:rPr lang="en-US" sz="950" dirty="0">
+                <a:solidFill>
+                  <a:srgbClr val="33404D"/>
+                </a:solidFill>
+                <a:latin typeface="Arial" pitchFamily="34" charset="0"/>
+                <a:ea typeface="Arial" pitchFamily="34" charset="-122"/>
+                <a:cs typeface="Arial" pitchFamily="34" charset="-120"/>
+              </a:rPr>
+              <a:t>0–50</a:t>
+            </a:r>
+            <a:endParaRPr lang="en-US" sz="1600" dirty="0"/>
           </a:p>
         </p:txBody>
       </p:sp>
@@ -5679,23 +5903,18 @@
         </p:nvSpPr>
         <p:spPr>
           <a:xfrm>
-            <a:off x="640080" y="4754880"/>
-            <a:ext cx="10881360" cy="960120"/>
+            <a:off x="2427732" y="5138928"/>
+            <a:ext cx="1714500" cy="932688"/>
           </a:xfrm>
           <a:prstGeom prst="roundRect">
             <a:avLst>
-              <a:gd name="adj" fmla="val 6667"/>
+              <a:gd name="adj" fmla="val 5882"/>
             </a:avLst>
           </a:prstGeom>
           <a:solidFill>
-            <a:srgbClr val="FFFFFF"/>
+            <a:srgbClr val="F4C430"/>
           </a:solidFill>
-          <a:ln w="12700">
-            <a:solidFill>
-              <a:srgbClr val="D6DEEA"/>
-            </a:solidFill>
-            <a:prstDash val="solid"/>
-          </a:ln>
+          <a:ln/>
           <a:effectLst>
             <a:outerShdw sx="100000" sy="100000" kx="0" ky="0" algn="bl" rotWithShape="0" blurRad="88900" dist="25400" dir="5400000">
               <a:srgbClr val="9AA6B8">
@@ -5707,34 +5926,112 @@
       </p:sp>
       <p:sp>
         <p:nvSpPr>
-          <p:cNvPr id="21" name="Shape 19"/>
+          <p:cNvPr id="21" name="Text 19"/>
+          <p:cNvSpPr txBox="1"/>
+          <p:nvPr/>
+        </p:nvSpPr>
+        <p:spPr>
+          <a:xfrm>
+            <a:off x="2427732" y="5138928"/>
+            <a:ext cx="1714500" cy="932688"/>
+          </a:xfrm>
+          <a:prstGeom prst="rect">
+            <a:avLst/>
+          </a:prstGeom>
+          <a:noFill/>
+          <a:ln/>
+        </p:spPr>
+        <p:txBody>
+          <a:bodyPr wrap="square" lIns="25400" tIns="25400" rIns="25400" bIns="25400" rtlCol="0" anchor="ctr"/>
+          <a:lstStyle/>
+          <a:p>
+            <a:pPr algn="ctr" indent="0" marL="0">
+              <a:buNone/>
+            </a:pPr>
+            <a:r>
+              <a:rPr lang="en-US" sz="1600" b="1" dirty="0">
+                <a:solidFill>
+                  <a:srgbClr val="1F2A37"/>
+                </a:solidFill>
+                <a:latin typeface="Arial" pitchFamily="34" charset="0"/>
+                <a:ea typeface="Arial" pitchFamily="34" charset="-122"/>
+                <a:cs typeface="Arial" pitchFamily="34" charset="-120"/>
+              </a:rPr>
+              <a:t>2
+</a:t>
+            </a:r>
+            <a:pPr algn="ctr" indent="0" marL="0">
+              <a:buNone/>
+            </a:pPr>
+            <a:r>
+              <a:rPr lang="en-US" sz="1100" b="1" dirty="0">
+                <a:solidFill>
+                  <a:srgbClr val="1F2A37"/>
+                </a:solidFill>
+                <a:latin typeface="Arial" pitchFamily="34" charset="0"/>
+                <a:ea typeface="Arial" pitchFamily="34" charset="-122"/>
+                <a:cs typeface="Arial" pitchFamily="34" charset="-120"/>
+              </a:rPr>
+              <a:t>Trung bình
+</a:t>
+            </a:r>
+            <a:pPr algn="ctr" indent="0" marL="0">
+              <a:buNone/>
+            </a:pPr>
+            <a:r>
+              <a:rPr lang="en-US" sz="950" dirty="0">
+                <a:solidFill>
+                  <a:srgbClr val="33404D"/>
+                </a:solidFill>
+                <a:latin typeface="Arial" pitchFamily="34" charset="0"/>
+                <a:ea typeface="Arial" pitchFamily="34" charset="-122"/>
+                <a:cs typeface="Arial" pitchFamily="34" charset="-120"/>
+              </a:rPr>
+              <a:t>51–100</a:t>
+            </a:r>
+            <a:endParaRPr lang="en-US" sz="1600" dirty="0"/>
+          </a:p>
+        </p:txBody>
+      </p:sp>
+      <p:sp>
+        <p:nvSpPr>
+          <p:cNvPr id="22" name="Shape 20"/>
           <p:cNvSpPr/>
           <p:nvPr/>
         </p:nvSpPr>
         <p:spPr>
           <a:xfrm>
-            <a:off x="640080" y="4754880"/>
-            <a:ext cx="109728" cy="960120"/>
+            <a:off x="4261104" y="5138928"/>
+            <a:ext cx="1714500" cy="932688"/>
           </a:xfrm>
           <a:prstGeom prst="roundRect">
-            <a:avLst/>
+            <a:avLst>
+              <a:gd name="adj" fmla="val 5882"/>
+            </a:avLst>
           </a:prstGeom>
           <a:solidFill>
-            <a:srgbClr val="2E5AAC"/>
+            <a:srgbClr val="F3722C"/>
           </a:solidFill>
           <a:ln/>
-        </p:spPr>
-      </p:sp>
-      <p:sp>
-        <p:nvSpPr>
-          <p:cNvPr id="22" name="Text 20"/>
+          <a:effectLst>
+            <a:outerShdw sx="100000" sy="100000" kx="0" ky="0" algn="bl" rotWithShape="0" blurRad="88900" dist="25400" dir="5400000">
+              <a:srgbClr val="9AA6B8">
+                <a:alpha val="32000"/>
+              </a:srgbClr>
+            </a:outerShdw>
+          </a:effectLst>
+        </p:spPr>
+      </p:sp>
+      <p:sp>
+        <p:nvSpPr>
+          <p:cNvPr id="23" name="Text 21"/>
           <p:cNvSpPr txBox="1"/>
           <p:nvPr/>
         </p:nvSpPr>
         <p:spPr>
           <a:xfrm>
-            <a:off x="896112" y="4754880"/>
-            <a:ext cx="10469880" cy="960120"/>
+            <a:off x="4261104" y="5138928"/>
+            <a:ext cx="1714500" cy="932688"/>
           </a:xfrm>
           <a:prstGeom prst="rect">
             <a:avLst/>
@@ -5743,38 +6040,348 @@
           <a:ln/>
         </p:spPr>
         <p:txBody>
-          <a:bodyPr wrap="square" rtlCol="0" anchor="ctr"/>
+          <a:bodyPr wrap="square" lIns="25400" tIns="25400" rIns="25400" bIns="25400" rtlCol="0" anchor="ctr"/>
           <a:lstStyle/>
           <a:p>
-            <a:pPr indent="0" marL="0">
-              <a:buNone/>
-            </a:pPr>
-            <a:r>
-              <a:rPr lang="en-US" sz="1250" b="1" dirty="0">
-                <a:solidFill>
-                  <a:srgbClr val="2E5AAC"/>
-                </a:solidFill>
-                <a:latin typeface="Arial" pitchFamily="34" charset="0"/>
-                <a:ea typeface="Arial" pitchFamily="34" charset="-122"/>
-                <a:cs typeface="Arial" pitchFamily="34" charset="-120"/>
-              </a:rPr>
-              <a:t>Điểm cốt lõi  </a:t>
-            </a:r>
-            <a:pPr indent="0" marL="0">
-              <a:buNone/>
-            </a:pPr>
-            <a:r>
-              <a:rPr lang="en-US" sz="1250" dirty="0">
-                <a:solidFill>
-                  <a:srgbClr val="253044"/>
-                </a:solidFill>
-                <a:latin typeface="Arial" pitchFamily="34" charset="0"/>
-                <a:ea typeface="Arial" pitchFamily="34" charset="-122"/>
-                <a:cs typeface="Arial" pitchFamily="34" charset="-120"/>
-              </a:rPr>
-              <a:t>Cả batch và streaming gọi CHUNG module aqi_core → hai làn không thể cho kết quả khác nhau. owm_aqi chỉ để đối chiếu, không đưa vào công thức.</a:t>
-            </a:r>
-            <a:endParaRPr lang="en-US" sz="1250" dirty="0"/>
+            <a:pPr algn="ctr" indent="0" marL="0">
+              <a:buNone/>
+            </a:pPr>
+            <a:r>
+              <a:rPr lang="en-US" sz="1600" b="1" dirty="0">
+                <a:solidFill>
+                  <a:srgbClr val="FFFFFF"/>
+                </a:solidFill>
+                <a:latin typeface="Arial" pitchFamily="34" charset="0"/>
+                <a:ea typeface="Arial" pitchFamily="34" charset="-122"/>
+                <a:cs typeface="Arial" pitchFamily="34" charset="-120"/>
+              </a:rPr>
+              <a:t>3
+</a:t>
+            </a:r>
+            <a:pPr algn="ctr" indent="0" marL="0">
+              <a:buNone/>
+            </a:pPr>
+            <a:r>
+              <a:rPr lang="en-US" sz="1100" b="1" dirty="0">
+                <a:solidFill>
+                  <a:srgbClr val="FFFFFF"/>
+                </a:solidFill>
+                <a:latin typeface="Arial" pitchFamily="34" charset="0"/>
+                <a:ea typeface="Arial" pitchFamily="34" charset="-122"/>
+                <a:cs typeface="Arial" pitchFamily="34" charset="-120"/>
+              </a:rPr>
+              <a:t>Kém
+</a:t>
+            </a:r>
+            <a:pPr algn="ctr" indent="0" marL="0">
+              <a:buNone/>
+            </a:pPr>
+            <a:r>
+              <a:rPr lang="en-US" sz="950" dirty="0">
+                <a:solidFill>
+                  <a:srgbClr val="F2F2F2"/>
+                </a:solidFill>
+                <a:latin typeface="Arial" pitchFamily="34" charset="0"/>
+                <a:ea typeface="Arial" pitchFamily="34" charset="-122"/>
+                <a:cs typeface="Arial" pitchFamily="34" charset="-120"/>
+              </a:rPr>
+              <a:t>101–150</a:t>
+            </a:r>
+            <a:endParaRPr lang="en-US" sz="1600" dirty="0"/>
+          </a:p>
+        </p:txBody>
+      </p:sp>
+      <p:sp>
+        <p:nvSpPr>
+          <p:cNvPr id="24" name="Shape 22"/>
+          <p:cNvSpPr/>
+          <p:nvPr/>
+        </p:nvSpPr>
+        <p:spPr>
+          <a:xfrm>
+            <a:off x="6094476" y="5138928"/>
+            <a:ext cx="1714500" cy="932688"/>
+          </a:xfrm>
+          <a:prstGeom prst="roundRect">
+            <a:avLst>
+              <a:gd name="adj" fmla="val 5882"/>
+            </a:avLst>
+          </a:prstGeom>
+          <a:solidFill>
+            <a:srgbClr val="D62828"/>
+          </a:solidFill>
+          <a:ln/>
+          <a:effectLst>
+            <a:outerShdw sx="100000" sy="100000" kx="0" ky="0" algn="bl" rotWithShape="0" blurRad="88900" dist="25400" dir="5400000">
+              <a:srgbClr val="9AA6B8">
+                <a:alpha val="32000"/>
+              </a:srgbClr>
+            </a:outerShdw>
+          </a:effectLst>
+        </p:spPr>
+      </p:sp>
+      <p:sp>
+        <p:nvSpPr>
+          <p:cNvPr id="25" name="Text 23"/>
+          <p:cNvSpPr txBox="1"/>
+          <p:nvPr/>
+        </p:nvSpPr>
+        <p:spPr>
+          <a:xfrm>
+            <a:off x="6094476" y="5138928"/>
+            <a:ext cx="1714500" cy="932688"/>
+          </a:xfrm>
+          <a:prstGeom prst="rect">
+            <a:avLst/>
+          </a:prstGeom>
+          <a:noFill/>
+          <a:ln/>
+        </p:spPr>
+        <p:txBody>
+          <a:bodyPr wrap="square" lIns="25400" tIns="25400" rIns="25400" bIns="25400" rtlCol="0" anchor="ctr"/>
+          <a:lstStyle/>
+          <a:p>
+            <a:pPr algn="ctr" indent="0" marL="0">
+              <a:buNone/>
+            </a:pPr>
+            <a:r>
+              <a:rPr lang="en-US" sz="1600" b="1" dirty="0">
+                <a:solidFill>
+                  <a:srgbClr val="FFFFFF"/>
+                </a:solidFill>
+                <a:latin typeface="Arial" pitchFamily="34" charset="0"/>
+                <a:ea typeface="Arial" pitchFamily="34" charset="-122"/>
+                <a:cs typeface="Arial" pitchFamily="34" charset="-120"/>
+              </a:rPr>
+              <a:t>4
+</a:t>
+            </a:r>
+            <a:pPr algn="ctr" indent="0" marL="0">
+              <a:buNone/>
+            </a:pPr>
+            <a:r>
+              <a:rPr lang="en-US" sz="1100" b="1" dirty="0">
+                <a:solidFill>
+                  <a:srgbClr val="FFFFFF"/>
+                </a:solidFill>
+                <a:latin typeface="Arial" pitchFamily="34" charset="0"/>
+                <a:ea typeface="Arial" pitchFamily="34" charset="-122"/>
+                <a:cs typeface="Arial" pitchFamily="34" charset="-120"/>
+              </a:rPr>
+              <a:t>Xấu
+</a:t>
+            </a:r>
+            <a:pPr algn="ctr" indent="0" marL="0">
+              <a:buNone/>
+            </a:pPr>
+            <a:r>
+              <a:rPr lang="en-US" sz="950" dirty="0">
+                <a:solidFill>
+                  <a:srgbClr val="F2F2F2"/>
+                </a:solidFill>
+                <a:latin typeface="Arial" pitchFamily="34" charset="0"/>
+                <a:ea typeface="Arial" pitchFamily="34" charset="-122"/>
+                <a:cs typeface="Arial" pitchFamily="34" charset="-120"/>
+              </a:rPr>
+              <a:t>151–200</a:t>
+            </a:r>
+            <a:endParaRPr lang="en-US" sz="1600" dirty="0"/>
+          </a:p>
+        </p:txBody>
+      </p:sp>
+      <p:sp>
+        <p:nvSpPr>
+          <p:cNvPr id="26" name="Shape 24"/>
+          <p:cNvSpPr/>
+          <p:nvPr/>
+        </p:nvSpPr>
+        <p:spPr>
+          <a:xfrm>
+            <a:off x="7927848" y="5138928"/>
+            <a:ext cx="1714500" cy="932688"/>
+          </a:xfrm>
+          <a:prstGeom prst="roundRect">
+            <a:avLst>
+              <a:gd name="adj" fmla="val 5882"/>
+            </a:avLst>
+          </a:prstGeom>
+          <a:solidFill>
+            <a:srgbClr val="8E44AD"/>
+          </a:solidFill>
+          <a:ln/>
+          <a:effectLst>
+            <a:outerShdw sx="100000" sy="100000" kx="0" ky="0" algn="bl" rotWithShape="0" blurRad="88900" dist="25400" dir="5400000">
+              <a:srgbClr val="9AA6B8">
+                <a:alpha val="32000"/>
+              </a:srgbClr>
+            </a:outerShdw>
+          </a:effectLst>
+        </p:spPr>
+      </p:sp>
+      <p:sp>
+        <p:nvSpPr>
+          <p:cNvPr id="27" name="Text 25"/>
+          <p:cNvSpPr txBox="1"/>
+          <p:nvPr/>
+        </p:nvSpPr>
+        <p:spPr>
+          <a:xfrm>
+            <a:off x="7927848" y="5138928"/>
+            <a:ext cx="1714500" cy="932688"/>
+          </a:xfrm>
+          <a:prstGeom prst="rect">
+            <a:avLst/>
+          </a:prstGeom>
+          <a:noFill/>
+          <a:ln/>
+        </p:spPr>
+        <p:txBody>
+          <a:bodyPr wrap="square" lIns="25400" tIns="25400" rIns="25400" bIns="25400" rtlCol="0" anchor="ctr"/>
+          <a:lstStyle/>
+          <a:p>
+            <a:pPr algn="ctr" indent="0" marL="0">
+              <a:buNone/>
+            </a:pPr>
+            <a:r>
+              <a:rPr lang="en-US" sz="1600" b="1" dirty="0">
+                <a:solidFill>
+                  <a:srgbClr val="FFFFFF"/>
+                </a:solidFill>
+                <a:latin typeface="Arial" pitchFamily="34" charset="0"/>
+                <a:ea typeface="Arial" pitchFamily="34" charset="-122"/>
+                <a:cs typeface="Arial" pitchFamily="34" charset="-120"/>
+              </a:rPr>
+              <a:t>5
+</a:t>
+            </a:r>
+            <a:pPr algn="ctr" indent="0" marL="0">
+              <a:buNone/>
+            </a:pPr>
+            <a:r>
+              <a:rPr lang="en-US" sz="1100" b="1" dirty="0">
+                <a:solidFill>
+                  <a:srgbClr val="FFFFFF"/>
+                </a:solidFill>
+                <a:latin typeface="Arial" pitchFamily="34" charset="0"/>
+                <a:ea typeface="Arial" pitchFamily="34" charset="-122"/>
+                <a:cs typeface="Arial" pitchFamily="34" charset="-120"/>
+              </a:rPr>
+              <a:t>Rất xấu
+</a:t>
+            </a:r>
+            <a:pPr algn="ctr" indent="0" marL="0">
+              <a:buNone/>
+            </a:pPr>
+            <a:r>
+              <a:rPr lang="en-US" sz="950" dirty="0">
+                <a:solidFill>
+                  <a:srgbClr val="F2F2F2"/>
+                </a:solidFill>
+                <a:latin typeface="Arial" pitchFamily="34" charset="0"/>
+                <a:ea typeface="Arial" pitchFamily="34" charset="-122"/>
+                <a:cs typeface="Arial" pitchFamily="34" charset="-120"/>
+              </a:rPr>
+              <a:t>201–300</a:t>
+            </a:r>
+            <a:endParaRPr lang="en-US" sz="1600" dirty="0"/>
+          </a:p>
+        </p:txBody>
+      </p:sp>
+      <p:sp>
+        <p:nvSpPr>
+          <p:cNvPr id="28" name="Shape 26"/>
+          <p:cNvSpPr/>
+          <p:nvPr/>
+        </p:nvSpPr>
+        <p:spPr>
+          <a:xfrm>
+            <a:off x="9761220" y="5138928"/>
+            <a:ext cx="1714500" cy="932688"/>
+          </a:xfrm>
+          <a:prstGeom prst="roundRect">
+            <a:avLst>
+              <a:gd name="adj" fmla="val 5882"/>
+            </a:avLst>
+          </a:prstGeom>
+          <a:solidFill>
+            <a:srgbClr val="7B2410"/>
+          </a:solidFill>
+          <a:ln/>
+          <a:effectLst>
+            <a:outerShdw sx="100000" sy="100000" kx="0" ky="0" algn="bl" rotWithShape="0" blurRad="88900" dist="25400" dir="5400000">
+              <a:srgbClr val="9AA6B8">
+                <a:alpha val="32000"/>
+              </a:srgbClr>
+            </a:outerShdw>
+          </a:effectLst>
+        </p:spPr>
+      </p:sp>
+      <p:sp>
+        <p:nvSpPr>
+          <p:cNvPr id="29" name="Text 27"/>
+          <p:cNvSpPr txBox="1"/>
+          <p:nvPr/>
+        </p:nvSpPr>
+        <p:spPr>
+          <a:xfrm>
+            <a:off x="9761220" y="5138928"/>
+            <a:ext cx="1714500" cy="932688"/>
+          </a:xfrm>
+          <a:prstGeom prst="rect">
+            <a:avLst/>
+          </a:prstGeom>
+          <a:noFill/>
+          <a:ln/>
+        </p:spPr>
+        <p:txBody>
+          <a:bodyPr wrap="square" lIns="25400" tIns="25400" rIns="25400" bIns="25400" rtlCol="0" anchor="ctr"/>
+          <a:lstStyle/>
+          <a:p>
+            <a:pPr algn="ctr" indent="0" marL="0">
+              <a:buNone/>
+            </a:pPr>
+            <a:r>
+              <a:rPr lang="en-US" sz="1600" b="1" dirty="0">
+                <a:solidFill>
+                  <a:srgbClr val="FFFFFF"/>
+                </a:solidFill>
+                <a:latin typeface="Arial" pitchFamily="34" charset="0"/>
+                <a:ea typeface="Arial" pitchFamily="34" charset="-122"/>
+                <a:cs typeface="Arial" pitchFamily="34" charset="-120"/>
+              </a:rPr>
+              <a:t>6
+</a:t>
+            </a:r>
+            <a:pPr algn="ctr" indent="0" marL="0">
+              <a:buNone/>
+            </a:pPr>
+            <a:r>
+              <a:rPr lang="en-US" sz="1100" b="1" dirty="0">
+                <a:solidFill>
+                  <a:srgbClr val="FFFFFF"/>
+                </a:solidFill>
+                <a:latin typeface="Arial" pitchFamily="34" charset="0"/>
+                <a:ea typeface="Arial" pitchFamily="34" charset="-122"/>
+                <a:cs typeface="Arial" pitchFamily="34" charset="-120"/>
+              </a:rPr>
+              <a:t>Nguy hại
+</a:t>
+            </a:r>
+            <a:pPr algn="ctr" indent="0" marL="0">
+              <a:buNone/>
+            </a:pPr>
+            <a:r>
+              <a:rPr lang="en-US" sz="950" dirty="0">
+                <a:solidFill>
+                  <a:srgbClr val="F2F2F2"/>
+                </a:solidFill>
+                <a:latin typeface="Arial" pitchFamily="34" charset="0"/>
+                <a:ea typeface="Arial" pitchFamily="34" charset="-122"/>
+                <a:cs typeface="Arial" pitchFamily="34" charset="-120"/>
+              </a:rPr>
+              <a:t>301–500</a:t>
+            </a:r>
+            <a:endParaRPr lang="en-US" sz="1600" dirty="0"/>
           </a:p>
         </p:txBody>
       </p:sp>
@@ -5955,7 +6562,7 @@
                 <a:ea typeface="Arial" pitchFamily="34" charset="-122"/>
                 <a:cs typeface="Arial" pitchFamily="34" charset="-120"/>
               </a:rPr>
-              <a:t>Thuật toán AQI — đóng góp khoa học</a:t>
+              <a:t>Thực nghiệm scalability</a:t>
             </a:r>
             <a:endParaRPr lang="en-US" sz="2300" dirty="0"/>
           </a:p>
@@ -5994,1475 +6601,6 @@
                 <a:ea typeface="Arial" pitchFamily="34" charset="-122"/>
                 <a:cs typeface="Arial" pitchFamily="34" charset="-120"/>
               </a:rPr>
-              <a:t>Tự tính AQI chuẩn Việt Nam từ nồng độ, thay vì dùng chỉ số 1–5 có sẵn của OpenWeather.</a:t>
-            </a:r>
-            <a:endParaRPr lang="en-US" sz="1350" dirty="0"/>
-          </a:p>
-        </p:txBody>
-      </p:sp>
-      <p:sp>
-        <p:nvSpPr>
-          <p:cNvPr id="7" name="Shape 5"/>
-          <p:cNvSpPr/>
-          <p:nvPr/>
-        </p:nvSpPr>
-        <p:spPr>
-          <a:xfrm>
-            <a:off x="548640" y="1463040"/>
-            <a:ext cx="11091672" cy="1234440"/>
-          </a:xfrm>
-          <a:prstGeom prst="roundRect">
-            <a:avLst>
-              <a:gd name="adj" fmla="val 5185"/>
-            </a:avLst>
-          </a:prstGeom>
-          <a:solidFill>
-            <a:srgbClr val="1F3864"/>
-          </a:solidFill>
-          <a:ln/>
-          <a:effectLst>
-            <a:outerShdw sx="100000" sy="100000" kx="0" ky="0" algn="bl" rotWithShape="0" blurRad="88900" dist="25400" dir="5400000">
-              <a:srgbClr val="9AA6B8">
-                <a:alpha val="32000"/>
-              </a:srgbClr>
-            </a:outerShdw>
-          </a:effectLst>
-        </p:spPr>
-      </p:sp>
-      <p:sp>
-        <p:nvSpPr>
-          <p:cNvPr id="8" name="Text 6"/>
-          <p:cNvSpPr txBox="1"/>
-          <p:nvPr/>
-        </p:nvSpPr>
-        <p:spPr>
-          <a:xfrm>
-            <a:off x="822960" y="1517904"/>
-            <a:ext cx="10515600" cy="292608"/>
-          </a:xfrm>
-          <a:prstGeom prst="rect">
-            <a:avLst/>
-          </a:prstGeom>
-          <a:noFill/>
-          <a:ln/>
-        </p:spPr>
-        <p:txBody>
-          <a:bodyPr wrap="square" rtlCol="0" anchor="ctr"/>
-          <a:lstStyle/>
-          <a:p>
-            <a:pPr indent="0" marL="0">
-              <a:buNone/>
-            </a:pPr>
-            <a:r>
-              <a:rPr lang="en-US" sz="1250" b="1" dirty="0">
-                <a:solidFill>
-                  <a:srgbClr val="9DB8E6"/>
-                </a:solidFill>
-                <a:latin typeface="Arial" pitchFamily="34" charset="0"/>
-                <a:ea typeface="Arial" pitchFamily="34" charset="-122"/>
-                <a:cs typeface="Arial" pitchFamily="34" charset="-120"/>
-              </a:rPr>
-              <a:t>Công thức — nội suy tuyến tính theo bảng breakpoint (QĐ 1459)</a:t>
-            </a:r>
-            <a:endParaRPr lang="en-US" sz="1250" dirty="0"/>
-          </a:p>
-        </p:txBody>
-      </p:sp>
-      <p:sp>
-        <p:nvSpPr>
-          <p:cNvPr id="9" name="Text 7"/>
-          <p:cNvSpPr txBox="1"/>
-          <p:nvPr/>
-        </p:nvSpPr>
-        <p:spPr>
-          <a:xfrm>
-            <a:off x="822960" y="1865376"/>
-            <a:ext cx="10515600" cy="384048"/>
-          </a:xfrm>
-          <a:prstGeom prst="rect">
-            <a:avLst/>
-          </a:prstGeom>
-          <a:noFill/>
-          <a:ln/>
-        </p:spPr>
-        <p:txBody>
-          <a:bodyPr wrap="square" rtlCol="0" anchor="ctr"/>
-          <a:lstStyle/>
-          <a:p>
-            <a:pPr indent="0" marL="0">
-              <a:buNone/>
-            </a:pPr>
-            <a:r>
-              <a:rPr lang="en-US" sz="1300" dirty="0">
-                <a:solidFill>
-                  <a:srgbClr val="FFFFFF"/>
-                </a:solidFill>
-                <a:latin typeface="Courier New" pitchFamily="34" charset="0"/>
-                <a:ea typeface="Courier New" pitchFamily="34" charset="-122"/>
-                <a:cs typeface="Courier New" pitchFamily="34" charset="-120"/>
-              </a:rPr>
-              <a:t>IAQIₓ = (I_high − I_low) / (BP_high − BP_low) × (Cₓ − BP_low) + I_low</a:t>
-            </a:r>
-            <a:endParaRPr lang="en-US" sz="1300" dirty="0"/>
-          </a:p>
-        </p:txBody>
-      </p:sp>
-      <p:sp>
-        <p:nvSpPr>
-          <p:cNvPr id="10" name="Text 8"/>
-          <p:cNvSpPr txBox="1"/>
-          <p:nvPr/>
-        </p:nvSpPr>
-        <p:spPr>
-          <a:xfrm>
-            <a:off x="822960" y="2286000"/>
-            <a:ext cx="10515600" cy="384048"/>
-          </a:xfrm>
-          <a:prstGeom prst="rect">
-            <a:avLst/>
-          </a:prstGeom>
-          <a:noFill/>
-          <a:ln/>
-        </p:spPr>
-        <p:txBody>
-          <a:bodyPr wrap="square" rtlCol="0" anchor="ctr"/>
-          <a:lstStyle/>
-          <a:p>
-            <a:pPr indent="0" marL="0">
-              <a:buNone/>
-            </a:pPr>
-            <a:r>
-              <a:rPr lang="en-US" sz="1300" dirty="0">
-                <a:solidFill>
-                  <a:srgbClr val="FFFFFF"/>
-                </a:solidFill>
-                <a:latin typeface="Courier New" pitchFamily="34" charset="0"/>
-                <a:ea typeface="Courier New" pitchFamily="34" charset="-122"/>
-                <a:cs typeface="Courier New" pitchFamily="34" charset="-120"/>
-              </a:rPr>
-              <a:t>AQI = max( IAQIₓ )   ·   x ∈ {PM2.5, PM10, O₃, NO₂, SO₂, CO}</a:t>
-            </a:r>
-            <a:endParaRPr lang="en-US" sz="1300" dirty="0"/>
-          </a:p>
-        </p:txBody>
-      </p:sp>
-      <p:sp>
-        <p:nvSpPr>
-          <p:cNvPr id="11" name="Shape 9"/>
-          <p:cNvSpPr/>
-          <p:nvPr/>
-        </p:nvSpPr>
-        <p:spPr>
-          <a:xfrm>
-            <a:off x="548640" y="2788920"/>
-            <a:ext cx="5486400" cy="1874520"/>
-          </a:xfrm>
-          <a:prstGeom prst="roundRect">
-            <a:avLst>
-              <a:gd name="adj" fmla="val 3415"/>
-            </a:avLst>
-          </a:prstGeom>
-          <a:solidFill>
-            <a:srgbClr val="F4F7FC"/>
-          </a:solidFill>
-          <a:ln w="12700">
-            <a:solidFill>
-              <a:srgbClr val="D6DEEA"/>
-            </a:solidFill>
-            <a:prstDash val="solid"/>
-          </a:ln>
-          <a:effectLst>
-            <a:outerShdw sx="100000" sy="100000" kx="0" ky="0" algn="bl" rotWithShape="0" blurRad="88900" dist="25400" dir="5400000">
-              <a:srgbClr val="9AA6B8">
-                <a:alpha val="32000"/>
-              </a:srgbClr>
-            </a:outerShdw>
-          </a:effectLst>
-        </p:spPr>
-      </p:sp>
-      <p:sp>
-        <p:nvSpPr>
-          <p:cNvPr id="12" name="Text 10"/>
-          <p:cNvSpPr txBox="1"/>
-          <p:nvPr/>
-        </p:nvSpPr>
-        <p:spPr>
-          <a:xfrm>
-            <a:off x="777240" y="2926080"/>
-            <a:ext cx="5029200" cy="292608"/>
-          </a:xfrm>
-          <a:prstGeom prst="rect">
-            <a:avLst/>
-          </a:prstGeom>
-          <a:noFill/>
-          <a:ln/>
-        </p:spPr>
-        <p:txBody>
-          <a:bodyPr wrap="square" rtlCol="0" anchor="ctr"/>
-          <a:lstStyle/>
-          <a:p>
-            <a:pPr indent="0" marL="0">
-              <a:buNone/>
-            </a:pPr>
-            <a:r>
-              <a:rPr lang="en-US" sz="1300" b="1" dirty="0">
-                <a:solidFill>
-                  <a:srgbClr val="2E5AAC"/>
-                </a:solidFill>
-                <a:latin typeface="Arial" pitchFamily="34" charset="0"/>
-                <a:ea typeface="Arial" pitchFamily="34" charset="-122"/>
-                <a:cs typeface="Arial" pitchFamily="34" charset="-120"/>
-              </a:rPr>
-              <a:t>Ý nghĩa ký hiệu</a:t>
-            </a:r>
-            <a:endParaRPr lang="en-US" sz="1300" dirty="0"/>
-          </a:p>
-        </p:txBody>
-      </p:sp>
-      <p:sp>
-        <p:nvSpPr>
-          <p:cNvPr id="13" name="Text 11"/>
-          <p:cNvSpPr txBox="1"/>
-          <p:nvPr/>
-        </p:nvSpPr>
-        <p:spPr>
-          <a:xfrm>
-            <a:off x="777240" y="3218688"/>
-            <a:ext cx="5074920" cy="1417320"/>
-          </a:xfrm>
-          <a:prstGeom prst="rect">
-            <a:avLst/>
-          </a:prstGeom>
-          <a:noFill/>
-          <a:ln/>
-        </p:spPr>
-        <p:txBody>
-          <a:bodyPr wrap="square" rtlCol="0" anchor="t"/>
-          <a:lstStyle/>
-          <a:p>
-            <a:pPr indent="0" marL="0">
-              <a:lnSpc>
-                <a:spcPct val="106000"/>
-              </a:lnSpc>
-              <a:buNone/>
-            </a:pPr>
-            <a:r>
-              <a:rPr lang="en-US" sz="1100" b="1" dirty="0">
-                <a:solidFill>
-                  <a:srgbClr val="1F3864"/>
-                </a:solidFill>
-                <a:latin typeface="Arial" pitchFamily="34" charset="0"/>
-                <a:ea typeface="Arial" pitchFamily="34" charset="-122"/>
-                <a:cs typeface="Arial" pitchFamily="34" charset="-120"/>
-              </a:rPr>
-              <a:t>Cₓ</a:t>
-            </a:r>
-            <a:pPr indent="0" marL="0">
-              <a:lnSpc>
-                <a:spcPct val="106000"/>
-              </a:lnSpc>
-              <a:buNone/>
-            </a:pPr>
-            <a:r>
-              <a:rPr lang="en-US" sz="1100" dirty="0">
-                <a:solidFill>
-                  <a:srgbClr val="253044"/>
-                </a:solidFill>
-                <a:latin typeface="Arial" pitchFamily="34" charset="0"/>
-                <a:ea typeface="Arial" pitchFamily="34" charset="-122"/>
-                <a:cs typeface="Arial" pitchFamily="34" charset="-120"/>
-              </a:rPr>
-              <a:t> — nồng độ đo được (đã đúng cửa sổ)
-</a:t>
-            </a:r>
-            <a:endParaRPr lang="en-US" sz="1100" dirty="0"/>
-          </a:p>
-          <a:p>
-            <a:pPr indent="0" marL="0">
-              <a:lnSpc>
-                <a:spcPct val="106000"/>
-              </a:lnSpc>
-              <a:buNone/>
-            </a:pPr>
-            <a:r>
-              <a:rPr lang="en-US" sz="1100" b="1" dirty="0">
-                <a:solidFill>
-                  <a:srgbClr val="1F3864"/>
-                </a:solidFill>
-                <a:latin typeface="Arial" pitchFamily="34" charset="0"/>
-                <a:ea typeface="Arial" pitchFamily="34" charset="-122"/>
-                <a:cs typeface="Arial" pitchFamily="34" charset="-120"/>
-              </a:rPr>
-              <a:t>[BP_low, BP_high]</a:t>
-            </a:r>
-            <a:pPr indent="0" marL="0">
-              <a:lnSpc>
-                <a:spcPct val="106000"/>
-              </a:lnSpc>
-              <a:buNone/>
-            </a:pPr>
-            <a:r>
-              <a:rPr lang="en-US" sz="1100" dirty="0">
-                <a:solidFill>
-                  <a:srgbClr val="253044"/>
-                </a:solidFill>
-                <a:latin typeface="Arial" pitchFamily="34" charset="0"/>
-                <a:ea typeface="Arial" pitchFamily="34" charset="-122"/>
-                <a:cs typeface="Arial" pitchFamily="34" charset="-120"/>
-              </a:rPr>
-              <a:t> — khoảng nồng độ chứa Cₓ
-</a:t>
-            </a:r>
-            <a:endParaRPr lang="en-US" sz="1100" dirty="0"/>
-          </a:p>
-          <a:p>
-            <a:pPr indent="0" marL="0">
-              <a:lnSpc>
-                <a:spcPct val="106000"/>
-              </a:lnSpc>
-              <a:buNone/>
-            </a:pPr>
-            <a:r>
-              <a:rPr lang="en-US" sz="1100" b="1" dirty="0">
-                <a:solidFill>
-                  <a:srgbClr val="1F3864"/>
-                </a:solidFill>
-                <a:latin typeface="Arial" pitchFamily="34" charset="0"/>
-                <a:ea typeface="Arial" pitchFamily="34" charset="-122"/>
-                <a:cs typeface="Arial" pitchFamily="34" charset="-120"/>
-              </a:rPr>
-              <a:t>[I_low, I_high]</a:t>
-            </a:r>
-            <a:pPr indent="0" marL="0">
-              <a:lnSpc>
-                <a:spcPct val="106000"/>
-              </a:lnSpc>
-              <a:buNone/>
-            </a:pPr>
-            <a:r>
-              <a:rPr lang="en-US" sz="1100" dirty="0">
-                <a:solidFill>
-                  <a:srgbClr val="253044"/>
-                </a:solidFill>
-                <a:latin typeface="Arial" pitchFamily="34" charset="0"/>
-                <a:ea typeface="Arial" pitchFamily="34" charset="-122"/>
-                <a:cs typeface="Arial" pitchFamily="34" charset="-120"/>
-              </a:rPr>
-              <a:t> — khoảng điểm AQI tương ứng
-</a:t>
-            </a:r>
-            <a:endParaRPr lang="en-US" sz="1100" dirty="0"/>
-          </a:p>
-          <a:p>
-            <a:pPr indent="0" marL="0">
-              <a:lnSpc>
-                <a:spcPct val="106000"/>
-              </a:lnSpc>
-              <a:buNone/>
-            </a:pPr>
-            <a:r>
-              <a:rPr lang="en-US" sz="1100" b="1" dirty="0">
-                <a:solidFill>
-                  <a:srgbClr val="1F3864"/>
-                </a:solidFill>
-                <a:latin typeface="Arial" pitchFamily="34" charset="0"/>
-                <a:ea typeface="Arial" pitchFamily="34" charset="-122"/>
-                <a:cs typeface="Arial" pitchFamily="34" charset="-120"/>
-              </a:rPr>
-              <a:t>phân số đầu</a:t>
-            </a:r>
-            <a:pPr indent="0" marL="0">
-              <a:lnSpc>
-                <a:spcPct val="106000"/>
-              </a:lnSpc>
-              <a:buNone/>
-            </a:pPr>
-            <a:r>
-              <a:rPr lang="en-US" sz="1100" dirty="0">
-                <a:solidFill>
-                  <a:srgbClr val="253044"/>
-                </a:solidFill>
-                <a:latin typeface="Arial" pitchFamily="34" charset="0"/>
-                <a:ea typeface="Arial" pitchFamily="34" charset="-122"/>
-                <a:cs typeface="Arial" pitchFamily="34" charset="-120"/>
-              </a:rPr>
-              <a:t> = độ dốc (1 đơn vị nồng độ → mấy điểm)
-</a:t>
-            </a:r>
-            <a:endParaRPr lang="en-US" sz="1100" dirty="0"/>
-          </a:p>
-          <a:p>
-            <a:pPr indent="0" marL="0">
-              <a:lnSpc>
-                <a:spcPct val="106000"/>
-              </a:lnSpc>
-              <a:buNone/>
-            </a:pPr>
-            <a:r>
-              <a:rPr lang="en-US" sz="1100" b="1" dirty="0">
-                <a:solidFill>
-                  <a:srgbClr val="1F3864"/>
-                </a:solidFill>
-                <a:latin typeface="Arial" pitchFamily="34" charset="0"/>
-                <a:ea typeface="Arial" pitchFamily="34" charset="-122"/>
-                <a:cs typeface="Arial" pitchFamily="34" charset="-120"/>
-              </a:rPr>
-              <a:t>max</a:t>
-            </a:r>
-            <a:pPr indent="0" marL="0">
-              <a:lnSpc>
-                <a:spcPct val="106000"/>
-              </a:lnSpc>
-              <a:buNone/>
-            </a:pPr>
-            <a:r>
-              <a:rPr lang="en-US" sz="1100" dirty="0">
-                <a:solidFill>
-                  <a:srgbClr val="253044"/>
-                </a:solidFill>
-                <a:latin typeface="Arial" pitchFamily="34" charset="0"/>
-                <a:ea typeface="Arial" pitchFamily="34" charset="-122"/>
-                <a:cs typeface="Arial" pitchFamily="34" charset="-120"/>
-              </a:rPr>
-              <a:t> — lấy chất tệ nhất (= chất trội)</a:t>
-            </a:r>
-            <a:endParaRPr lang="en-US" sz="1100" dirty="0"/>
-          </a:p>
-        </p:txBody>
-      </p:sp>
-      <p:sp>
-        <p:nvSpPr>
-          <p:cNvPr id="14" name="Shape 12"/>
-          <p:cNvSpPr/>
-          <p:nvPr/>
-        </p:nvSpPr>
-        <p:spPr>
-          <a:xfrm>
-            <a:off x="6172200" y="2788920"/>
-            <a:ext cx="5468112" cy="1874520"/>
-          </a:xfrm>
-          <a:prstGeom prst="roundRect">
-            <a:avLst>
-              <a:gd name="adj" fmla="val 3415"/>
-            </a:avLst>
-          </a:prstGeom>
-          <a:solidFill>
-            <a:srgbClr val="EAF3EC"/>
-          </a:solidFill>
-          <a:ln w="15240">
-            <a:solidFill>
-              <a:srgbClr val="4F9D5D"/>
-            </a:solidFill>
-            <a:prstDash val="solid"/>
-          </a:ln>
-        </p:spPr>
-      </p:sp>
-      <p:sp>
-        <p:nvSpPr>
-          <p:cNvPr id="15" name="Text 13"/>
-          <p:cNvSpPr txBox="1"/>
-          <p:nvPr/>
-        </p:nvSpPr>
-        <p:spPr>
-          <a:xfrm>
-            <a:off x="6400800" y="2926080"/>
-            <a:ext cx="5029200" cy="292608"/>
-          </a:xfrm>
-          <a:prstGeom prst="rect">
-            <a:avLst/>
-          </a:prstGeom>
-          <a:noFill/>
-          <a:ln/>
-        </p:spPr>
-        <p:txBody>
-          <a:bodyPr wrap="square" rtlCol="0" anchor="ctr"/>
-          <a:lstStyle/>
-          <a:p>
-            <a:pPr indent="0" marL="0">
-              <a:buNone/>
-            </a:pPr>
-            <a:r>
-              <a:rPr lang="en-US" sz="1300" b="1" dirty="0">
-                <a:solidFill>
-                  <a:srgbClr val="2F7D3A"/>
-                </a:solidFill>
-                <a:latin typeface="Arial" pitchFamily="34" charset="0"/>
-                <a:ea typeface="Arial" pitchFamily="34" charset="-122"/>
-                <a:cs typeface="Arial" pitchFamily="34" charset="-120"/>
-              </a:rPr>
-              <a:t>Ví dụ — PM2.5 (TB 24h) = 35,2</a:t>
-            </a:r>
-            <a:endParaRPr lang="en-US" sz="1300" dirty="0"/>
-          </a:p>
-        </p:txBody>
-      </p:sp>
-      <p:sp>
-        <p:nvSpPr>
-          <p:cNvPr id="16" name="Text 14"/>
-          <p:cNvSpPr txBox="1"/>
-          <p:nvPr/>
-        </p:nvSpPr>
-        <p:spPr>
-          <a:xfrm>
-            <a:off x="6400800" y="3218688"/>
-            <a:ext cx="5074920" cy="1417320"/>
-          </a:xfrm>
-          <a:prstGeom prst="rect">
-            <a:avLst/>
-          </a:prstGeom>
-          <a:noFill/>
-          <a:ln/>
-        </p:spPr>
-        <p:txBody>
-          <a:bodyPr wrap="square" rtlCol="0" anchor="t"/>
-          <a:lstStyle/>
-          <a:p>
-            <a:pPr indent="0" marL="0">
-              <a:lnSpc>
-                <a:spcPct val="106000"/>
-              </a:lnSpc>
-              <a:spcAft>
-                <a:spcPts val="500"/>
-              </a:spcAft>
-              <a:buNone/>
-            </a:pPr>
-            <a:r>
-              <a:rPr lang="en-US" sz="1150" dirty="0">
-                <a:solidFill>
-                  <a:srgbClr val="253044"/>
-                </a:solidFill>
-                <a:latin typeface="Arial" pitchFamily="34" charset="0"/>
-                <a:ea typeface="Arial" pitchFamily="34" charset="-122"/>
-                <a:cs typeface="Arial" pitchFamily="34" charset="-120"/>
-              </a:rPr>
-              <a:t>35,2 rơi vào khoảng [25 ; 50] → điểm [50 ; 100]
-</a:t>
-            </a:r>
-            <a:endParaRPr lang="en-US" sz="1150" dirty="0"/>
-          </a:p>
-          <a:p>
-            <a:pPr indent="0" marL="0">
-              <a:lnSpc>
-                <a:spcPct val="106000"/>
-              </a:lnSpc>
-              <a:buNone/>
-            </a:pPr>
-            <a:r>
-              <a:rPr lang="en-US" sz="1150" dirty="0">
-                <a:solidFill>
-                  <a:srgbClr val="253044"/>
-                </a:solidFill>
-                <a:latin typeface="Courier New" pitchFamily="34" charset="0"/>
-                <a:ea typeface="Courier New" pitchFamily="34" charset="-122"/>
-                <a:cs typeface="Courier New" pitchFamily="34" charset="-120"/>
-              </a:rPr>
-              <a:t>IAQI = (100−50)/(50−25) × (35,2−25) + 50
-</a:t>
-            </a:r>
-            <a:endParaRPr lang="en-US" sz="1150" dirty="0"/>
-          </a:p>
-          <a:p>
-            <a:pPr indent="0" marL="0">
-              <a:lnSpc>
-                <a:spcPct val="106000"/>
-              </a:lnSpc>
-              <a:buNone/>
-            </a:pPr>
-            <a:r>
-              <a:rPr lang="en-US" sz="1150" dirty="0">
-                <a:solidFill>
-                  <a:srgbClr val="253044"/>
-                </a:solidFill>
-                <a:latin typeface="Courier New" pitchFamily="34" charset="0"/>
-                <a:ea typeface="Courier New" pitchFamily="34" charset="-122"/>
-                <a:cs typeface="Courier New" pitchFamily="34" charset="-120"/>
-              </a:rPr>
-              <a:t>       = 2 × 10,2 + 50 = </a:t>
-            </a:r>
-            <a:pPr indent="0" marL="0">
-              <a:lnSpc>
-                <a:spcPct val="106000"/>
-              </a:lnSpc>
-              <a:buNone/>
-            </a:pPr>
-            <a:r>
-              <a:rPr lang="en-US" sz="1300" b="1" dirty="0">
-                <a:solidFill>
-                  <a:srgbClr val="2F7D3A"/>
-                </a:solidFill>
-                <a:latin typeface="Arial" pitchFamily="34" charset="0"/>
-                <a:ea typeface="Arial" pitchFamily="34" charset="-122"/>
-                <a:cs typeface="Arial" pitchFamily="34" charset="-120"/>
-              </a:rPr>
-              <a:t>70,4</a:t>
-            </a:r>
-            <a:endParaRPr lang="en-US" sz="1150" dirty="0"/>
-          </a:p>
-          <a:p>
-            <a:pPr indent="0" marL="0">
-              <a:lnSpc>
-                <a:spcPct val="106000"/>
-              </a:lnSpc>
-              <a:buNone/>
-            </a:pPr>
-            <a:r>
-              <a:rPr lang="en-US" sz="1100" i="1" dirty="0">
-                <a:solidFill>
-                  <a:srgbClr val="6B7280"/>
-                </a:solidFill>
-                <a:latin typeface="Arial" pitchFamily="34" charset="0"/>
-                <a:ea typeface="Arial" pitchFamily="34" charset="-122"/>
-                <a:cs typeface="Arial" pitchFamily="34" charset="-120"/>
-              </a:rPr>
-              <a:t>→ 35,2 nằm ~40% đoạn nồng độ nên điểm cũng ~40% đoạn AQI.</a:t>
-            </a:r>
-            <a:endParaRPr lang="en-US" sz="1150" dirty="0"/>
-          </a:p>
-        </p:txBody>
-      </p:sp>
-      <p:sp>
-        <p:nvSpPr>
-          <p:cNvPr id="17" name="Text 15"/>
-          <p:cNvSpPr txBox="1"/>
-          <p:nvPr/>
-        </p:nvSpPr>
-        <p:spPr>
-          <a:xfrm>
-            <a:off x="548640" y="4828032"/>
-            <a:ext cx="11091672" cy="274320"/>
-          </a:xfrm>
-          <a:prstGeom prst="rect">
-            <a:avLst/>
-          </a:prstGeom>
-          <a:noFill/>
-          <a:ln/>
-        </p:spPr>
-        <p:txBody>
-          <a:bodyPr wrap="square" rtlCol="0" anchor="ctr"/>
-          <a:lstStyle/>
-          <a:p>
-            <a:pPr indent="0" marL="0">
-              <a:buNone/>
-            </a:pPr>
-            <a:r>
-              <a:rPr lang="en-US" sz="1250" b="1" dirty="0">
-                <a:solidFill>
-                  <a:srgbClr val="1F3864"/>
-                </a:solidFill>
-                <a:latin typeface="Arial" pitchFamily="34" charset="0"/>
-                <a:ea typeface="Arial" pitchFamily="34" charset="-122"/>
-                <a:cs typeface="Arial" pitchFamily="34" charset="-120"/>
-              </a:rPr>
-              <a:t>Sáu mức AQI theo QĐ 1459 — tra nhãn/màu từ giá trị AQI cuối</a:t>
-            </a:r>
-            <a:endParaRPr lang="en-US" sz="1250" dirty="0"/>
-          </a:p>
-        </p:txBody>
-      </p:sp>
-      <p:sp>
-        <p:nvSpPr>
-          <p:cNvPr id="18" name="Shape 16"/>
-          <p:cNvSpPr/>
-          <p:nvPr/>
-        </p:nvSpPr>
-        <p:spPr>
-          <a:xfrm>
-            <a:off x="594360" y="5138928"/>
-            <a:ext cx="1714500" cy="932688"/>
-          </a:xfrm>
-          <a:prstGeom prst="roundRect">
-            <a:avLst>
-              <a:gd name="adj" fmla="val 5882"/>
-            </a:avLst>
-          </a:prstGeom>
-          <a:solidFill>
-            <a:srgbClr val="4CAF50"/>
-          </a:solidFill>
-          <a:ln/>
-          <a:effectLst>
-            <a:outerShdw sx="100000" sy="100000" kx="0" ky="0" algn="bl" rotWithShape="0" blurRad="88900" dist="25400" dir="5400000">
-              <a:srgbClr val="9AA6B8">
-                <a:alpha val="32000"/>
-              </a:srgbClr>
-            </a:outerShdw>
-          </a:effectLst>
-        </p:spPr>
-      </p:sp>
-      <p:sp>
-        <p:nvSpPr>
-          <p:cNvPr id="19" name="Text 17"/>
-          <p:cNvSpPr txBox="1"/>
-          <p:nvPr/>
-        </p:nvSpPr>
-        <p:spPr>
-          <a:xfrm>
-            <a:off x="594360" y="5138928"/>
-            <a:ext cx="1714500" cy="932688"/>
-          </a:xfrm>
-          <a:prstGeom prst="rect">
-            <a:avLst/>
-          </a:prstGeom>
-          <a:noFill/>
-          <a:ln/>
-        </p:spPr>
-        <p:txBody>
-          <a:bodyPr wrap="square" lIns="25400" tIns="25400" rIns="25400" bIns="25400" rtlCol="0" anchor="ctr"/>
-          <a:lstStyle/>
-          <a:p>
-            <a:pPr algn="ctr" indent="0" marL="0">
-              <a:buNone/>
-            </a:pPr>
-            <a:r>
-              <a:rPr lang="en-US" sz="1600" b="1" dirty="0">
-                <a:solidFill>
-                  <a:srgbClr val="1F2A37"/>
-                </a:solidFill>
-                <a:latin typeface="Arial" pitchFamily="34" charset="0"/>
-                <a:ea typeface="Arial" pitchFamily="34" charset="-122"/>
-                <a:cs typeface="Arial" pitchFamily="34" charset="-120"/>
-              </a:rPr>
-              <a:t>1
-</a:t>
-            </a:r>
-            <a:pPr algn="ctr" indent="0" marL="0">
-              <a:buNone/>
-            </a:pPr>
-            <a:r>
-              <a:rPr lang="en-US" sz="1100" b="1" dirty="0">
-                <a:solidFill>
-                  <a:srgbClr val="1F2A37"/>
-                </a:solidFill>
-                <a:latin typeface="Arial" pitchFamily="34" charset="0"/>
-                <a:ea typeface="Arial" pitchFamily="34" charset="-122"/>
-                <a:cs typeface="Arial" pitchFamily="34" charset="-120"/>
-              </a:rPr>
-              <a:t>Tốt
-</a:t>
-            </a:r>
-            <a:pPr algn="ctr" indent="0" marL="0">
-              <a:buNone/>
-            </a:pPr>
-            <a:r>
-              <a:rPr lang="en-US" sz="950" dirty="0">
-                <a:solidFill>
-                  <a:srgbClr val="33404D"/>
-                </a:solidFill>
-                <a:latin typeface="Arial" pitchFamily="34" charset="0"/>
-                <a:ea typeface="Arial" pitchFamily="34" charset="-122"/>
-                <a:cs typeface="Arial" pitchFamily="34" charset="-120"/>
-              </a:rPr>
-              <a:t>0–50</a:t>
-            </a:r>
-            <a:endParaRPr lang="en-US" sz="1600" dirty="0"/>
-          </a:p>
-        </p:txBody>
-      </p:sp>
-      <p:sp>
-        <p:nvSpPr>
-          <p:cNvPr id="20" name="Shape 18"/>
-          <p:cNvSpPr/>
-          <p:nvPr/>
-        </p:nvSpPr>
-        <p:spPr>
-          <a:xfrm>
-            <a:off x="2427732" y="5138928"/>
-            <a:ext cx="1714500" cy="932688"/>
-          </a:xfrm>
-          <a:prstGeom prst="roundRect">
-            <a:avLst>
-              <a:gd name="adj" fmla="val 5882"/>
-            </a:avLst>
-          </a:prstGeom>
-          <a:solidFill>
-            <a:srgbClr val="F4C430"/>
-          </a:solidFill>
-          <a:ln/>
-          <a:effectLst>
-            <a:outerShdw sx="100000" sy="100000" kx="0" ky="0" algn="bl" rotWithShape="0" blurRad="88900" dist="25400" dir="5400000">
-              <a:srgbClr val="9AA6B8">
-                <a:alpha val="32000"/>
-              </a:srgbClr>
-            </a:outerShdw>
-          </a:effectLst>
-        </p:spPr>
-      </p:sp>
-      <p:sp>
-        <p:nvSpPr>
-          <p:cNvPr id="21" name="Text 19"/>
-          <p:cNvSpPr txBox="1"/>
-          <p:nvPr/>
-        </p:nvSpPr>
-        <p:spPr>
-          <a:xfrm>
-            <a:off x="2427732" y="5138928"/>
-            <a:ext cx="1714500" cy="932688"/>
-          </a:xfrm>
-          <a:prstGeom prst="rect">
-            <a:avLst/>
-          </a:prstGeom>
-          <a:noFill/>
-          <a:ln/>
-        </p:spPr>
-        <p:txBody>
-          <a:bodyPr wrap="square" lIns="25400" tIns="25400" rIns="25400" bIns="25400" rtlCol="0" anchor="ctr"/>
-          <a:lstStyle/>
-          <a:p>
-            <a:pPr algn="ctr" indent="0" marL="0">
-              <a:buNone/>
-            </a:pPr>
-            <a:r>
-              <a:rPr lang="en-US" sz="1600" b="1" dirty="0">
-                <a:solidFill>
-                  <a:srgbClr val="1F2A37"/>
-                </a:solidFill>
-                <a:latin typeface="Arial" pitchFamily="34" charset="0"/>
-                <a:ea typeface="Arial" pitchFamily="34" charset="-122"/>
-                <a:cs typeface="Arial" pitchFamily="34" charset="-120"/>
-              </a:rPr>
-              <a:t>2
-</a:t>
-            </a:r>
-            <a:pPr algn="ctr" indent="0" marL="0">
-              <a:buNone/>
-            </a:pPr>
-            <a:r>
-              <a:rPr lang="en-US" sz="1100" b="1" dirty="0">
-                <a:solidFill>
-                  <a:srgbClr val="1F2A37"/>
-                </a:solidFill>
-                <a:latin typeface="Arial" pitchFamily="34" charset="0"/>
-                <a:ea typeface="Arial" pitchFamily="34" charset="-122"/>
-                <a:cs typeface="Arial" pitchFamily="34" charset="-120"/>
-              </a:rPr>
-              <a:t>Trung bình
-</a:t>
-            </a:r>
-            <a:pPr algn="ctr" indent="0" marL="0">
-              <a:buNone/>
-            </a:pPr>
-            <a:r>
-              <a:rPr lang="en-US" sz="950" dirty="0">
-                <a:solidFill>
-                  <a:srgbClr val="33404D"/>
-                </a:solidFill>
-                <a:latin typeface="Arial" pitchFamily="34" charset="0"/>
-                <a:ea typeface="Arial" pitchFamily="34" charset="-122"/>
-                <a:cs typeface="Arial" pitchFamily="34" charset="-120"/>
-              </a:rPr>
-              <a:t>51–100</a:t>
-            </a:r>
-            <a:endParaRPr lang="en-US" sz="1600" dirty="0"/>
-          </a:p>
-        </p:txBody>
-      </p:sp>
-      <p:sp>
-        <p:nvSpPr>
-          <p:cNvPr id="22" name="Shape 20"/>
-          <p:cNvSpPr/>
-          <p:nvPr/>
-        </p:nvSpPr>
-        <p:spPr>
-          <a:xfrm>
-            <a:off x="4261104" y="5138928"/>
-            <a:ext cx="1714500" cy="932688"/>
-          </a:xfrm>
-          <a:prstGeom prst="roundRect">
-            <a:avLst>
-              <a:gd name="adj" fmla="val 5882"/>
-            </a:avLst>
-          </a:prstGeom>
-          <a:solidFill>
-            <a:srgbClr val="F3722C"/>
-          </a:solidFill>
-          <a:ln/>
-          <a:effectLst>
-            <a:outerShdw sx="100000" sy="100000" kx="0" ky="0" algn="bl" rotWithShape="0" blurRad="88900" dist="25400" dir="5400000">
-              <a:srgbClr val="9AA6B8">
-                <a:alpha val="32000"/>
-              </a:srgbClr>
-            </a:outerShdw>
-          </a:effectLst>
-        </p:spPr>
-      </p:sp>
-      <p:sp>
-        <p:nvSpPr>
-          <p:cNvPr id="23" name="Text 21"/>
-          <p:cNvSpPr txBox="1"/>
-          <p:nvPr/>
-        </p:nvSpPr>
-        <p:spPr>
-          <a:xfrm>
-            <a:off x="4261104" y="5138928"/>
-            <a:ext cx="1714500" cy="932688"/>
-          </a:xfrm>
-          <a:prstGeom prst="rect">
-            <a:avLst/>
-          </a:prstGeom>
-          <a:noFill/>
-          <a:ln/>
-        </p:spPr>
-        <p:txBody>
-          <a:bodyPr wrap="square" lIns="25400" tIns="25400" rIns="25400" bIns="25400" rtlCol="0" anchor="ctr"/>
-          <a:lstStyle/>
-          <a:p>
-            <a:pPr algn="ctr" indent="0" marL="0">
-              <a:buNone/>
-            </a:pPr>
-            <a:r>
-              <a:rPr lang="en-US" sz="1600" b="1" dirty="0">
-                <a:solidFill>
-                  <a:srgbClr val="FFFFFF"/>
-                </a:solidFill>
-                <a:latin typeface="Arial" pitchFamily="34" charset="0"/>
-                <a:ea typeface="Arial" pitchFamily="34" charset="-122"/>
-                <a:cs typeface="Arial" pitchFamily="34" charset="-120"/>
-              </a:rPr>
-              <a:t>3
-</a:t>
-            </a:r>
-            <a:pPr algn="ctr" indent="0" marL="0">
-              <a:buNone/>
-            </a:pPr>
-            <a:r>
-              <a:rPr lang="en-US" sz="1100" b="1" dirty="0">
-                <a:solidFill>
-                  <a:srgbClr val="FFFFFF"/>
-                </a:solidFill>
-                <a:latin typeface="Arial" pitchFamily="34" charset="0"/>
-                <a:ea typeface="Arial" pitchFamily="34" charset="-122"/>
-                <a:cs typeface="Arial" pitchFamily="34" charset="-120"/>
-              </a:rPr>
-              <a:t>Kém
-</a:t>
-            </a:r>
-            <a:pPr algn="ctr" indent="0" marL="0">
-              <a:buNone/>
-            </a:pPr>
-            <a:r>
-              <a:rPr lang="en-US" sz="950" dirty="0">
-                <a:solidFill>
-                  <a:srgbClr val="F2F2F2"/>
-                </a:solidFill>
-                <a:latin typeface="Arial" pitchFamily="34" charset="0"/>
-                <a:ea typeface="Arial" pitchFamily="34" charset="-122"/>
-                <a:cs typeface="Arial" pitchFamily="34" charset="-120"/>
-              </a:rPr>
-              <a:t>101–150</a:t>
-            </a:r>
-            <a:endParaRPr lang="en-US" sz="1600" dirty="0"/>
-          </a:p>
-        </p:txBody>
-      </p:sp>
-      <p:sp>
-        <p:nvSpPr>
-          <p:cNvPr id="24" name="Shape 22"/>
-          <p:cNvSpPr/>
-          <p:nvPr/>
-        </p:nvSpPr>
-        <p:spPr>
-          <a:xfrm>
-            <a:off x="6094476" y="5138928"/>
-            <a:ext cx="1714500" cy="932688"/>
-          </a:xfrm>
-          <a:prstGeom prst="roundRect">
-            <a:avLst>
-              <a:gd name="adj" fmla="val 5882"/>
-            </a:avLst>
-          </a:prstGeom>
-          <a:solidFill>
-            <a:srgbClr val="D62828"/>
-          </a:solidFill>
-          <a:ln/>
-          <a:effectLst>
-            <a:outerShdw sx="100000" sy="100000" kx="0" ky="0" algn="bl" rotWithShape="0" blurRad="88900" dist="25400" dir="5400000">
-              <a:srgbClr val="9AA6B8">
-                <a:alpha val="32000"/>
-              </a:srgbClr>
-            </a:outerShdw>
-          </a:effectLst>
-        </p:spPr>
-      </p:sp>
-      <p:sp>
-        <p:nvSpPr>
-          <p:cNvPr id="25" name="Text 23"/>
-          <p:cNvSpPr txBox="1"/>
-          <p:nvPr/>
-        </p:nvSpPr>
-        <p:spPr>
-          <a:xfrm>
-            <a:off x="6094476" y="5138928"/>
-            <a:ext cx="1714500" cy="932688"/>
-          </a:xfrm>
-          <a:prstGeom prst="rect">
-            <a:avLst/>
-          </a:prstGeom>
-          <a:noFill/>
-          <a:ln/>
-        </p:spPr>
-        <p:txBody>
-          <a:bodyPr wrap="square" lIns="25400" tIns="25400" rIns="25400" bIns="25400" rtlCol="0" anchor="ctr"/>
-          <a:lstStyle/>
-          <a:p>
-            <a:pPr algn="ctr" indent="0" marL="0">
-              <a:buNone/>
-            </a:pPr>
-            <a:r>
-              <a:rPr lang="en-US" sz="1600" b="1" dirty="0">
-                <a:solidFill>
-                  <a:srgbClr val="FFFFFF"/>
-                </a:solidFill>
-                <a:latin typeface="Arial" pitchFamily="34" charset="0"/>
-                <a:ea typeface="Arial" pitchFamily="34" charset="-122"/>
-                <a:cs typeface="Arial" pitchFamily="34" charset="-120"/>
-              </a:rPr>
-              <a:t>4
-</a:t>
-            </a:r>
-            <a:pPr algn="ctr" indent="0" marL="0">
-              <a:buNone/>
-            </a:pPr>
-            <a:r>
-              <a:rPr lang="en-US" sz="1100" b="1" dirty="0">
-                <a:solidFill>
-                  <a:srgbClr val="FFFFFF"/>
-                </a:solidFill>
-                <a:latin typeface="Arial" pitchFamily="34" charset="0"/>
-                <a:ea typeface="Arial" pitchFamily="34" charset="-122"/>
-                <a:cs typeface="Arial" pitchFamily="34" charset="-120"/>
-              </a:rPr>
-              <a:t>Xấu
-</a:t>
-            </a:r>
-            <a:pPr algn="ctr" indent="0" marL="0">
-              <a:buNone/>
-            </a:pPr>
-            <a:r>
-              <a:rPr lang="en-US" sz="950" dirty="0">
-                <a:solidFill>
-                  <a:srgbClr val="F2F2F2"/>
-                </a:solidFill>
-                <a:latin typeface="Arial" pitchFamily="34" charset="0"/>
-                <a:ea typeface="Arial" pitchFamily="34" charset="-122"/>
-                <a:cs typeface="Arial" pitchFamily="34" charset="-120"/>
-              </a:rPr>
-              <a:t>151–200</a:t>
-            </a:r>
-            <a:endParaRPr lang="en-US" sz="1600" dirty="0"/>
-          </a:p>
-        </p:txBody>
-      </p:sp>
-      <p:sp>
-        <p:nvSpPr>
-          <p:cNvPr id="26" name="Shape 24"/>
-          <p:cNvSpPr/>
-          <p:nvPr/>
-        </p:nvSpPr>
-        <p:spPr>
-          <a:xfrm>
-            <a:off x="7927848" y="5138928"/>
-            <a:ext cx="1714500" cy="932688"/>
-          </a:xfrm>
-          <a:prstGeom prst="roundRect">
-            <a:avLst>
-              <a:gd name="adj" fmla="val 5882"/>
-            </a:avLst>
-          </a:prstGeom>
-          <a:solidFill>
-            <a:srgbClr val="8E44AD"/>
-          </a:solidFill>
-          <a:ln/>
-          <a:effectLst>
-            <a:outerShdw sx="100000" sy="100000" kx="0" ky="0" algn="bl" rotWithShape="0" blurRad="88900" dist="25400" dir="5400000">
-              <a:srgbClr val="9AA6B8">
-                <a:alpha val="32000"/>
-              </a:srgbClr>
-            </a:outerShdw>
-          </a:effectLst>
-        </p:spPr>
-      </p:sp>
-      <p:sp>
-        <p:nvSpPr>
-          <p:cNvPr id="27" name="Text 25"/>
-          <p:cNvSpPr txBox="1"/>
-          <p:nvPr/>
-        </p:nvSpPr>
-        <p:spPr>
-          <a:xfrm>
-            <a:off x="7927848" y="5138928"/>
-            <a:ext cx="1714500" cy="932688"/>
-          </a:xfrm>
-          <a:prstGeom prst="rect">
-            <a:avLst/>
-          </a:prstGeom>
-          <a:noFill/>
-          <a:ln/>
-        </p:spPr>
-        <p:txBody>
-          <a:bodyPr wrap="square" lIns="25400" tIns="25400" rIns="25400" bIns="25400" rtlCol="0" anchor="ctr"/>
-          <a:lstStyle/>
-          <a:p>
-            <a:pPr algn="ctr" indent="0" marL="0">
-              <a:buNone/>
-            </a:pPr>
-            <a:r>
-              <a:rPr lang="en-US" sz="1600" b="1" dirty="0">
-                <a:solidFill>
-                  <a:srgbClr val="FFFFFF"/>
-                </a:solidFill>
-                <a:latin typeface="Arial" pitchFamily="34" charset="0"/>
-                <a:ea typeface="Arial" pitchFamily="34" charset="-122"/>
-                <a:cs typeface="Arial" pitchFamily="34" charset="-120"/>
-              </a:rPr>
-              <a:t>5
-</a:t>
-            </a:r>
-            <a:pPr algn="ctr" indent="0" marL="0">
-              <a:buNone/>
-            </a:pPr>
-            <a:r>
-              <a:rPr lang="en-US" sz="1100" b="1" dirty="0">
-                <a:solidFill>
-                  <a:srgbClr val="FFFFFF"/>
-                </a:solidFill>
-                <a:latin typeface="Arial" pitchFamily="34" charset="0"/>
-                <a:ea typeface="Arial" pitchFamily="34" charset="-122"/>
-                <a:cs typeface="Arial" pitchFamily="34" charset="-120"/>
-              </a:rPr>
-              <a:t>Rất xấu
-</a:t>
-            </a:r>
-            <a:pPr algn="ctr" indent="0" marL="0">
-              <a:buNone/>
-            </a:pPr>
-            <a:r>
-              <a:rPr lang="en-US" sz="950" dirty="0">
-                <a:solidFill>
-                  <a:srgbClr val="F2F2F2"/>
-                </a:solidFill>
-                <a:latin typeface="Arial" pitchFamily="34" charset="0"/>
-                <a:ea typeface="Arial" pitchFamily="34" charset="-122"/>
-                <a:cs typeface="Arial" pitchFamily="34" charset="-120"/>
-              </a:rPr>
-              <a:t>201–300</a:t>
-            </a:r>
-            <a:endParaRPr lang="en-US" sz="1600" dirty="0"/>
-          </a:p>
-        </p:txBody>
-      </p:sp>
-      <p:sp>
-        <p:nvSpPr>
-          <p:cNvPr id="28" name="Shape 26"/>
-          <p:cNvSpPr/>
-          <p:nvPr/>
-        </p:nvSpPr>
-        <p:spPr>
-          <a:xfrm>
-            <a:off x="9761220" y="5138928"/>
-            <a:ext cx="1714500" cy="932688"/>
-          </a:xfrm>
-          <a:prstGeom prst="roundRect">
-            <a:avLst>
-              <a:gd name="adj" fmla="val 5882"/>
-            </a:avLst>
-          </a:prstGeom>
-          <a:solidFill>
-            <a:srgbClr val="7B2410"/>
-          </a:solidFill>
-          <a:ln/>
-          <a:effectLst>
-            <a:outerShdw sx="100000" sy="100000" kx="0" ky="0" algn="bl" rotWithShape="0" blurRad="88900" dist="25400" dir="5400000">
-              <a:srgbClr val="9AA6B8">
-                <a:alpha val="32000"/>
-              </a:srgbClr>
-            </a:outerShdw>
-          </a:effectLst>
-        </p:spPr>
-      </p:sp>
-      <p:sp>
-        <p:nvSpPr>
-          <p:cNvPr id="29" name="Text 27"/>
-          <p:cNvSpPr txBox="1"/>
-          <p:nvPr/>
-        </p:nvSpPr>
-        <p:spPr>
-          <a:xfrm>
-            <a:off x="9761220" y="5138928"/>
-            <a:ext cx="1714500" cy="932688"/>
-          </a:xfrm>
-          <a:prstGeom prst="rect">
-            <a:avLst/>
-          </a:prstGeom>
-          <a:noFill/>
-          <a:ln/>
-        </p:spPr>
-        <p:txBody>
-          <a:bodyPr wrap="square" lIns="25400" tIns="25400" rIns="25400" bIns="25400" rtlCol="0" anchor="ctr"/>
-          <a:lstStyle/>
-          <a:p>
-            <a:pPr algn="ctr" indent="0" marL="0">
-              <a:buNone/>
-            </a:pPr>
-            <a:r>
-              <a:rPr lang="en-US" sz="1600" b="1" dirty="0">
-                <a:solidFill>
-                  <a:srgbClr val="FFFFFF"/>
-                </a:solidFill>
-                <a:latin typeface="Arial" pitchFamily="34" charset="0"/>
-                <a:ea typeface="Arial" pitchFamily="34" charset="-122"/>
-                <a:cs typeface="Arial" pitchFamily="34" charset="-120"/>
-              </a:rPr>
-              <a:t>6
-</a:t>
-            </a:r>
-            <a:pPr algn="ctr" indent="0" marL="0">
-              <a:buNone/>
-            </a:pPr>
-            <a:r>
-              <a:rPr lang="en-US" sz="1100" b="1" dirty="0">
-                <a:solidFill>
-                  <a:srgbClr val="FFFFFF"/>
-                </a:solidFill>
-                <a:latin typeface="Arial" pitchFamily="34" charset="0"/>
-                <a:ea typeface="Arial" pitchFamily="34" charset="-122"/>
-                <a:cs typeface="Arial" pitchFamily="34" charset="-120"/>
-              </a:rPr>
-              <a:t>Nguy hại
-</a:t>
-            </a:r>
-            <a:pPr algn="ctr" indent="0" marL="0">
-              <a:buNone/>
-            </a:pPr>
-            <a:r>
-              <a:rPr lang="en-US" sz="950" dirty="0">
-                <a:solidFill>
-                  <a:srgbClr val="F2F2F2"/>
-                </a:solidFill>
-                <a:latin typeface="Arial" pitchFamily="34" charset="0"/>
-                <a:ea typeface="Arial" pitchFamily="34" charset="-122"/>
-                <a:cs typeface="Arial" pitchFamily="34" charset="-120"/>
-              </a:rPr>
-              <a:t>301–500</a:t>
-            </a:r>
-            <a:endParaRPr lang="en-US" sz="1600" dirty="0"/>
-          </a:p>
-        </p:txBody>
-      </p:sp>
-    </p:spTree>
-  </p:cSld>
-  <p:clrMapOvr>
-    <a:masterClrMapping/>
-  </p:clrMapOvr>
-</p:sld>
-</file>
-
-<file path=ppt/slides/slide6.xml><?xml version="1.0" encoding="utf-8"?>
-<p:sld xmlns:a="http://schemas.openxmlformats.org/drawingml/2006/main" xmlns:r="http://schemas.openxmlformats.org/officeDocument/2006/relationships" xmlns:p="http://schemas.openxmlformats.org/presentationml/2006/main">
-  <p:cSld name="Slide 6">
-    <p:bg>
-      <p:bgPr>
-        <a:solidFill>
-          <a:srgbClr val="FFFFFF"/>
-        </a:solidFill>
-      </p:bgPr>
-    </p:bg>
-    <p:spTree>
-      <p:nvGrpSpPr>
-        <p:cNvPr id="1" name=""/>
-        <p:cNvGrpSpPr/>
-        <p:nvPr/>
-      </p:nvGrpSpPr>
-      <p:grpSpPr>
-        <a:xfrm>
-          <a:off x="0" y="0"/>
-          <a:ext cx="0" cy="0"/>
-          <a:chOff x="0" y="0"/>
-          <a:chExt cx="0" cy="0"/>
-        </a:xfrm>
-      </p:grpSpPr>
-      <p:sp>
-        <p:nvSpPr>
-          <p:cNvPr id="2" name="Text 0"/>
-          <p:cNvSpPr txBox="1"/>
-          <p:nvPr/>
-        </p:nvSpPr>
-        <p:spPr>
-          <a:xfrm>
-            <a:off x="457200" y="6492240"/>
-            <a:ext cx="8229600" cy="274320"/>
-          </a:xfrm>
-          <a:prstGeom prst="rect">
-            <a:avLst/>
-          </a:prstGeom>
-          <a:noFill/>
-          <a:ln/>
-        </p:spPr>
-        <p:txBody>
-          <a:bodyPr wrap="square" lIns="0" tIns="0" rIns="0" bIns="0" rtlCol="0" anchor="ctr"/>
-          <a:lstStyle/>
-          <a:p>
-            <a:pPr indent="0" marL="0">
-              <a:buNone/>
-            </a:pPr>
-            <a:r>
-              <a:rPr lang="en-US" sz="900" dirty="0">
-                <a:solidFill>
-                  <a:srgbClr val="9AA6B8"/>
-                </a:solidFill>
-                <a:latin typeface="Arial" pitchFamily="34" charset="0"/>
-                <a:ea typeface="Arial" pitchFamily="34" charset="-122"/>
-                <a:cs typeface="Arial" pitchFamily="34" charset="-120"/>
-              </a:rPr>
-              <a:t>Trường Đại học Công nghệ Thông tin, ĐHQG-HCM</a:t>
-            </a:r>
-            <a:endParaRPr lang="en-US" sz="900" dirty="0"/>
-          </a:p>
-        </p:txBody>
-      </p:sp>
-      <p:sp>
-        <p:nvSpPr>
-          <p:cNvPr id="3" name="Text 1"/>
-          <p:cNvSpPr txBox="1"/>
-          <p:nvPr/>
-        </p:nvSpPr>
-        <p:spPr>
-          <a:xfrm>
-            <a:off x="11368735" y="6492240"/>
-            <a:ext cx="365760" cy="274320"/>
-          </a:xfrm>
-          <a:prstGeom prst="rect">
-            <a:avLst/>
-          </a:prstGeom>
-          <a:noFill/>
-          <a:ln/>
-        </p:spPr>
-        <p:txBody>
-          <a:bodyPr wrap="square" lIns="0" tIns="0" rIns="0" bIns="0" rtlCol="0" anchor="ctr"/>
-          <a:lstStyle/>
-          <a:p>
-            <a:pPr algn="r" indent="0" marL="0">
-              <a:buNone/>
-            </a:pPr>
-            <a:r>
-              <a:rPr lang="en-US" sz="900" dirty="0">
-                <a:solidFill>
-                  <a:srgbClr val="9AA6B8"/>
-                </a:solidFill>
-                <a:latin typeface="Arial" pitchFamily="34" charset="0"/>
-                <a:ea typeface="Arial" pitchFamily="34" charset="-122"/>
-                <a:cs typeface="Arial" pitchFamily="34" charset="-120"/>
-              </a:rPr>
-              <a:t>6</a:t>
-            </a:r>
-            <a:endParaRPr lang="en-US" sz="900" dirty="0"/>
-          </a:p>
-        </p:txBody>
-      </p:sp>
-      <p:sp>
-        <p:nvSpPr>
-          <p:cNvPr id="4" name="Shape 2"/>
-          <p:cNvSpPr/>
-          <p:nvPr/>
-        </p:nvSpPr>
-        <p:spPr>
-          <a:xfrm>
-            <a:off x="548640" y="457200"/>
-            <a:ext cx="128016" cy="566928"/>
-          </a:xfrm>
-          <a:prstGeom prst="rect">
-            <a:avLst/>
-          </a:prstGeom>
-          <a:solidFill>
-            <a:srgbClr val="2E5AAC"/>
-          </a:solidFill>
-          <a:ln/>
-        </p:spPr>
-      </p:sp>
-      <p:sp>
-        <p:nvSpPr>
-          <p:cNvPr id="5" name="Text 3"/>
-          <p:cNvSpPr txBox="1"/>
-          <p:nvPr/>
-        </p:nvSpPr>
-        <p:spPr>
-          <a:xfrm>
-            <a:off x="777240" y="402336"/>
-            <a:ext cx="10881360" cy="566928"/>
-          </a:xfrm>
-          <a:prstGeom prst="rect">
-            <a:avLst/>
-          </a:prstGeom>
-          <a:noFill/>
-          <a:ln/>
-        </p:spPr>
-        <p:txBody>
-          <a:bodyPr wrap="square" rtlCol="0" anchor="ctr"/>
-          <a:lstStyle/>
-          <a:p>
-            <a:pPr indent="0" marL="0">
-              <a:buNone/>
-            </a:pPr>
-            <a:r>
-              <a:rPr lang="en-US" sz="2300" b="1" dirty="0">
-                <a:solidFill>
-                  <a:srgbClr val="2E5AAC"/>
-                </a:solidFill>
-                <a:latin typeface="Arial" pitchFamily="34" charset="0"/>
-                <a:ea typeface="Arial" pitchFamily="34" charset="-122"/>
-                <a:cs typeface="Arial" pitchFamily="34" charset="-120"/>
-              </a:rPr>
-              <a:t>3.5   </a:t>
-            </a:r>
-            <a:pPr indent="0" marL="0">
-              <a:buNone/>
-            </a:pPr>
-            <a:r>
-              <a:rPr lang="en-US" sz="2300" b="1" dirty="0">
-                <a:solidFill>
-                  <a:srgbClr val="1F3864"/>
-                </a:solidFill>
-                <a:latin typeface="Arial" pitchFamily="34" charset="0"/>
-                <a:ea typeface="Arial" pitchFamily="34" charset="-122"/>
-                <a:cs typeface="Arial" pitchFamily="34" charset="-120"/>
-              </a:rPr>
-              <a:t>Thực nghiệm scalability</a:t>
-            </a:r>
-            <a:endParaRPr lang="en-US" sz="2300" dirty="0"/>
-          </a:p>
-        </p:txBody>
-      </p:sp>
-      <p:sp>
-        <p:nvSpPr>
-          <p:cNvPr id="6" name="Text 4"/>
-          <p:cNvSpPr txBox="1"/>
-          <p:nvPr/>
-        </p:nvSpPr>
-        <p:spPr>
-          <a:xfrm>
-            <a:off x="777240" y="1024128"/>
-            <a:ext cx="10881360" cy="365760"/>
-          </a:xfrm>
-          <a:prstGeom prst="rect">
-            <a:avLst/>
-          </a:prstGeom>
-          <a:noFill/>
-          <a:ln/>
-        </p:spPr>
-        <p:txBody>
-          <a:bodyPr wrap="square" rtlCol="0" anchor="ctr"/>
-          <a:lstStyle/>
-          <a:p>
-            <a:pPr indent="0" marL="0">
-              <a:buNone/>
-            </a:pPr>
-            <a:r>
-              <a:rPr lang="en-US" sz="1350" i="1" dirty="0">
-                <a:solidFill>
-                  <a:srgbClr val="6B7280"/>
-                </a:solidFill>
-                <a:latin typeface="Arial" pitchFamily="34" charset="0"/>
-                <a:ea typeface="Arial" pitchFamily="34" charset="-122"/>
-                <a:cs typeface="Arial" pitchFamily="34" charset="-120"/>
-              </a:rPr>
               <a:t>Đo riêng Pha 2 trên dữ liệu tổng hợp — chứng minh: dữ liệu càng lớn, phân tán càng lợi.</a:t>
             </a:r>
             <a:endParaRPr lang="en-US" sz="1350" dirty="0"/>
@@ -7471,7 +6609,7 @@
       </p:sp>
       <p:graphicFrame>
         <p:nvGraphicFramePr>
-          <p:cNvPr id="7" name="Table 0"/>
+          <p:cNvPr id="6" name="Table 0"/>
           <p:cNvGraphicFramePr>
             <a:graphicFrameLocks noGrp="1"/>
           </p:cNvGraphicFramePr>
@@ -9086,9 +8224,9 @@
 </p:sld>
 </file>
 
-<file path=ppt/slides/slide7.xml><?xml version="1.0" encoding="utf-8"?>
+<file path=ppt/slides/slide6.xml><?xml version="1.0" encoding="utf-8"?>
 <p:sld xmlns:a="http://schemas.openxmlformats.org/drawingml/2006/main" xmlns:r="http://schemas.openxmlformats.org/officeDocument/2006/relationships" xmlns:p="http://schemas.openxmlformats.org/presentationml/2006/main">
-  <p:cSld name="Slide 7">
+  <p:cSld name="Slide 6">
     <p:bg>
       <p:bgPr>
         <a:solidFill>
@@ -9182,7 +8320,7 @@
                 <a:ea typeface="Arial" pitchFamily="34" charset="-122"/>
                 <a:cs typeface="Arial" pitchFamily="34" charset="-120"/>
               </a:rPr>
-              <a:t>7</a:t>
+              <a:t>6</a:t>
             </a:r>
             <a:endParaRPr lang="en-US" sz="900" dirty="0"/>
           </a:p>
@@ -9241,7 +8379,7 @@
                 <a:ea typeface="Arial" pitchFamily="34" charset="-122"/>
                 <a:cs typeface="Arial" pitchFamily="34" charset="-120"/>
               </a:rPr>
-              <a:t>3.6   </a:t>
+              <a:t>3.5   </a:t>
             </a:r>
             <a:pPr indent="0" marL="0">
               <a:buNone/>
@@ -9355,7 +8493,7 @@
       </p:sp>
       <p:graphicFrame>
         <p:nvGraphicFramePr>
-          <p:cNvPr id="8" name="Table 0"/>
+          <p:cNvPr id="7" name="Table 0"/>
           <p:cNvGraphicFramePr>
             <a:graphicFrameLocks noGrp="1"/>
           </p:cNvGraphicFramePr>
@@ -11143,7 +10281,7 @@
       </p:sp>
       <p:graphicFrame>
         <p:nvGraphicFramePr>
-          <p:cNvPr id="15" name="Table 1"/>
+          <p:cNvPr id="13" name="Table 1"/>
           <p:cNvGraphicFramePr>
             <a:graphicFrameLocks noGrp="1"/>
           </p:cNvGraphicFramePr>

</xml_diff>

<commit_message>
docs: tách speaker notes 3.1 (toàn cảnh) và 3.2 (chi tiết từng pha) tránh nói trùng
Co-Authored-By: Claude Opus 4.8 <noreply@anthropic.com>
Claude-Session: https://claude.ai/code/session_01FrxD6iyiu71sw2RmUtSxFy
</commit_message>
<xml_diff>
--- a/docs/slides/Slide_Huyen_theo_mau.pptx
+++ b/docs/slides/Slide_Huyen_theo_mau.pptx
@@ -595,7 +595,7 @@
           <a:p>
             <a:r>
               <a:rPr lang="en-US" dirty="0"/>
-              <a:t>Sơ đồ: ĐẦU VÀO → Pha1(/clean) → Pha2(/aqi) → Pha3(/agg,HBase) → PHỤC VỤ. Hai NHÁNH MỞ RỘNG chạy NGOÀI lõi, lấy đầu vào từ /aqi (sau Pha 2): (1) Phân cụm vùng — 5 thuật toán, chọn theo silhouette, K-means k=3; (2) Dự báo AQI 24h — SGD/Random Forest/CNN-LSTM, Random Forest thắng. Kết quả cũng đổ về HBase/Dashboard. Đây là phần Khôi/Diệp trình bày sâu; Huyền chỉ giới thiệu vị trí.</a:t>
+              <a:t>TOÀN CẢNH pipeline — nói theo dòng chảy, chưa đi sâu (chi tiết để slide 3.2). Dữ liệu vào từ hai nguồn: HDFS /raw (lịch sử, làn batch) và Kafka (live, làn stream), cả hai cùng đổ vào Spark. Ba pha nối tiếp: làm sạch → tính AQI → tổng hợp, mỗi pha thêm một lớp thông tin (/clean → /aqi → /agg), rồi vào HBase phục vụ dashboard. Ngoài lõi còn hai nhánh Phân cụm và Dự báo chạy trên /aqi (Khôi/Diệp trình bày sâu). Ba ý cần nắm: (1) key-value và đổi khoá giữa các pha; (2) Mapper = biến đổi từng dòng, Reducer = gom theo khoá rồi tính; (3) là mô hình MapReduce cài bằng Spark, không phải Hadoop MapReduce thật.</a:t>
             </a:r>
             <a:endParaRPr lang="en-US" dirty="0"/>
           </a:p>
@@ -683,7 +683,7 @@
           <a:p>
             <a:r>
               <a:rPr lang="en-US" dirty="0"/>
-              <a:t>Ba pha chi tiết. Pha 1: khử trùng lặp, loại ngoại lai, lưới giờ đầy đủ, nội suy khe ≤3h, 97,6% ngày đạt. Pha 2: NowCast 12h→IAQI→AQI=max, dùng chung aqi_core, /aqi 593MB. Pha 3: gom (thành phố,ngày), đếm mức, xếp hạng, ghi HBase, /agg ~8,26 phút. Chốt: chung aqi_core; owm_aqi chỉ đối chiếu.</a:t>
+              <a:t>Slide này ĐI SÂU từng pha. PHA 1 — Làm sạch: Mapper gắn mỗi bản ghi khoá (trạm, giờ) như dán mã phân loại; Reducer làm 3 việc — bỏ bản ghi trùng; loại giá trị vô lý (âm hoặc vượt ngưỡng vật lý, chỉ bỏ riêng ô đó chứ không xoá cả dòng); nội suy các khoảng thiếu ngắn dưới 3 giờ, thiếu dài thì để trống và đánh dấu. Ghi ra /clean dạng Parquet kèm cờ chất lượng measured/interpolated/missing; 97,6% ngày đủ chuẩn. PHA 2 — Tính AQI (đóng góp khoa học): Mapper quy đổi nồng độ từng chất thành IAQI bằng nội suy theo bảng breakpoint QĐ 1459, riêng bụi PM dùng NowCast (trung bình 12 giờ, giờ gần tính nặng hơn); Reducer lấy AQI = max của 6 chất (lấy chất tệ nhất, không lấy trung bình), gán mức và chất trội. Không dùng owm_aqi thang 1–5 mà tự tính thang 0–500; owm_aqi chỉ để đối chiếu. Đầu ra /aqi (schema C3). PHA 3 — Tổng hợp và xếp hạng: Mapper đổi khoá sang (thành phố, ngày) — đây là bước shuffle; Reducer tính trung bình/max/min AQI mỗi thành phố–ngày, đếm số giờ mỗi mức, xếp hạng (hạng 1 = ô nhiễm nhất); ghi ra /agg và nạp HBase, khoảng 8,26 phút. Chốt: batch và streaming dùng chung lõi aqi_core nên không lệch kết quả; toàn bộ là mô hình MapReduce cài bằng Spark, không phải Hadoop MapReduce thật.</a:t>
             </a:r>
             <a:endParaRPr lang="en-US" dirty="0"/>
           </a:p>

</xml_diff>

<commit_message>
docs: viết lại câu "nội suy khe" cho dễ hiểu (điền chỗ thiếu ngắn / vá chỗ thiếu)
Co-Authored-By: Claude Opus 4.8 <noreply@anthropic.com>
Claude-Session: https://claude.ai/code/session_01FrxD6iyiu71sw2RmUtSxFy
</commit_message>
<xml_diff>
--- a/docs/slides/Slide_Huyen_theo_mau.pptx
+++ b/docs/slides/Slide_Huyen_theo_mau.pptx
@@ -2545,7 +2545,7 @@
                 <a:ea typeface="Arial" pitchFamily="34" charset="-122"/>
                 <a:cs typeface="Arial" pitchFamily="34" charset="-120"/>
               </a:rPr>
-              <a:t>khử trùng lặp · loại ngoại lai · nội suy ≤3h</a:t>
+              <a:t>khử trùng lặp · loại giá trị lỗi · vá chỗ thiếu ≤ 3h</a:t>
             </a:r>
             <a:endParaRPr lang="en-US" sz="850" dirty="0"/>
           </a:p>
@@ -4215,7 +4215,7 @@
                 <a:ea typeface="Arial" pitchFamily="34" charset="-122"/>
                 <a:cs typeface="Arial" pitchFamily="34" charset="-120"/>
               </a:rPr>
-              <a:t>Nội suy khe ≤ 3h; dài hơn giữ trống</a:t>
+              <a:t>Điền chỗ thiếu ngắn (≤ 3 giờ); dài hơn để trống</a:t>
             </a:r>
             <a:endParaRPr lang="en-US" sz="1200" dirty="0"/>
           </a:p>

</xml_diff>

<commit_message>
docs: viết lại 12 bullet slide 3.2 cho dễ hiểu (bỏ ký hiệu khó, diễn đạt tự nhiên)
Co-Authored-By: Claude Opus 4.8 <noreply@anthropic.com>
Claude-Session: https://claude.ai/code/session_01FrxD6iyiu71sw2RmUtSxFy
</commit_message>
<xml_diff>
--- a/docs/slides/Slide_Huyen_theo_mau.pptx
+++ b/docs/slides/Slide_Huyen_theo_mau.pptx
@@ -4152,7 +4152,7 @@
                 <a:ea typeface="Arial" pitchFamily="34" charset="-122"/>
                 <a:cs typeface="Arial" pitchFamily="34" charset="-120"/>
               </a:rPr>
-              <a:t>Khử trùng lặp theo (trạm, giờ)</a:t>
+              <a:t>Bỏ bản ghi trùng (cùng trạm, cùng giờ)</a:t>
             </a:r>
             <a:endParaRPr lang="en-US" sz="1200" dirty="0"/>
           </a:p>
@@ -4173,7 +4173,7 @@
                 <a:ea typeface="Arial" pitchFamily="34" charset="-122"/>
                 <a:cs typeface="Arial" pitchFamily="34" charset="-120"/>
               </a:rPr>
-              <a:t>Loại giá trị âm / vượt trần vật lý</a:t>
+              <a:t>Bỏ số vô lý: âm hoặc cao bất thường</a:t>
             </a:r>
             <a:endParaRPr lang="en-US" sz="1200" dirty="0"/>
           </a:p>
@@ -4194,7 +4194,7 @@
                 <a:ea typeface="Arial" pitchFamily="34" charset="-122"/>
                 <a:cs typeface="Arial" pitchFamily="34" charset="-120"/>
               </a:rPr>
-              <a:t>Dựng lưới giờ đầy đủ → lộ giờ thiếu</a:t>
+              <a:t>Dựng đủ mọi giờ → lộ ra giờ bị thiếu</a:t>
             </a:r>
             <a:endParaRPr lang="en-US" sz="1200" dirty="0"/>
           </a:p>
@@ -4215,7 +4215,7 @@
                 <a:ea typeface="Arial" pitchFamily="34" charset="-122"/>
                 <a:cs typeface="Arial" pitchFamily="34" charset="-120"/>
               </a:rPr>
-              <a:t>Điền chỗ thiếu ngắn (≤ 3 giờ); dài hơn để trống</a:t>
+              <a:t>Điền chỗ thiếu ngắn ≤ 3 giờ; thiếu lâu thì để trống</a:t>
             </a:r>
             <a:endParaRPr lang="en-US" sz="1200" dirty="0"/>
           </a:p>
@@ -4433,7 +4433,7 @@
                 <a:ea typeface="Arial" pitchFamily="34" charset="-122"/>
                 <a:cs typeface="Arial" pitchFamily="34" charset="-120"/>
               </a:rPr>
-              <a:t>NowCast 12h / trạm cho bụi PM</a:t>
+              <a:t>Bụi PM: trung bình 12 giờ (giờ gần tính nặng hơn)</a:t>
             </a:r>
             <a:endParaRPr lang="en-US" sz="1200" dirty="0"/>
           </a:p>
@@ -4454,7 +4454,7 @@
                 <a:ea typeface="Arial" pitchFamily="34" charset="-122"/>
                 <a:cs typeface="Arial" pitchFamily="34" charset="-120"/>
               </a:rPr>
-              <a:t>IAQI từng chất (breakpoint QĐ 1459)</a:t>
+              <a:t>Đổi nồng độ mỗi chất thành điểm IAQI (QĐ 1459)</a:t>
             </a:r>
             <a:endParaRPr lang="en-US" sz="1200" dirty="0"/>
           </a:p>
@@ -4475,7 +4475,7 @@
                 <a:ea typeface="Arial" pitchFamily="34" charset="-122"/>
                 <a:cs typeface="Arial" pitchFamily="34" charset="-120"/>
               </a:rPr>
-              <a:t>AQI = max(IAQI) → mức + chất trội</a:t>
+              <a:t>AQI = điểm cao nhất trong 6 chất → gán mức + chất trội</a:t>
             </a:r>
             <a:endParaRPr lang="en-US" sz="1200" dirty="0"/>
           </a:p>
@@ -4496,7 +4496,7 @@
                 <a:ea typeface="Arial" pitchFamily="34" charset="-122"/>
                 <a:cs typeface="Arial" pitchFamily="34" charset="-120"/>
               </a:rPr>
-              <a:t>Batch &amp; streaming dùng chung aqi_core</a:t>
+              <a:t>Hai làn lịch sử &amp; realtime dùng chung một công thức</a:t>
             </a:r>
             <a:endParaRPr lang="en-US" sz="1200" dirty="0"/>
           </a:p>
@@ -4714,7 +4714,7 @@
                 <a:ea typeface="Arial" pitchFamily="34" charset="-122"/>
                 <a:cs typeface="Arial" pitchFamily="34" charset="-120"/>
               </a:rPr>
-              <a:t>Gom theo (thành phố, ngày): TB / max</a:t>
+              <a:t>Gộp theo thành phố &amp; ngày: AQI trung bình / cao nhất</a:t>
             </a:r>
             <a:endParaRPr lang="en-US" sz="1200" dirty="0"/>
           </a:p>
@@ -4735,7 +4735,7 @@
                 <a:ea typeface="Arial" pitchFamily="34" charset="-122"/>
                 <a:cs typeface="Arial" pitchFamily="34" charset="-120"/>
               </a:rPr>
-              <a:t>Đếm số giờ ở mỗi mức chất lượng</a:t>
+              <a:t>Đếm số giờ ở từng mức trong ngày</a:t>
             </a:r>
             <a:endParaRPr lang="en-US" sz="1200" dirty="0"/>
           </a:p>
@@ -4756,7 +4756,7 @@
                 <a:ea typeface="Arial" pitchFamily="34" charset="-122"/>
                 <a:cs typeface="Arial" pitchFamily="34" charset="-120"/>
               </a:rPr>
-              <a:t>Xếp hạng thành phố — hạng 1 = bẩn nhất</a:t>
+              <a:t>Xếp hạng thành phố (hạng 1 = ô nhiễm nhất)</a:t>
             </a:r>
             <a:endParaRPr lang="en-US" sz="1200" dirty="0"/>
           </a:p>
@@ -4777,7 +4777,7 @@
                 <a:ea typeface="Arial" pitchFamily="34" charset="-122"/>
                 <a:cs typeface="Arial" pitchFamily="34" charset="-120"/>
               </a:rPr>
-              <a:t>Ghi HBase cho dashboard đọc nhanh</a:t>
+              <a:t>Lưu vào HBase để dashboard đọc nhanh</a:t>
             </a:r>
             <a:endParaRPr lang="en-US" sz="1200" dirty="0"/>
           </a:p>

</xml_diff>